<commit_message>
Add the 10% channel-partner revenue share across the cost model
Partner share scales with revenue like Stripe, so it lands in the cost
stack, the per-company cost table (Launch RM10 / Scale RM60 / Elite
RM140), credit top-up margins, and the blended figure. All-in plan
margins are now 56% / 61% / 61%; blended ~62%. ARR stays gross with a
note that the 10% is captured in margins.

Co-Authored-By: Claude Opus 4.8 <noreply@anthropic.com>
Claude-Session: https://claude.ai/code/session_0176R35qPk2mhGFwXaB3Lv9s
</commit_message>
<xml_diff>
--- a/docs/aster-pricing.pptx
+++ b/docs/aster-pricing.pptx
@@ -2552,7 +2552,7 @@
           </p:nvPr>
         </p:nvGraphicFramePr>
         <p:xfrm>
-          <a:off x="548640" y="1874520"/>
+          <a:off x="548640" y="1847088"/>
           <a:ext cx="7680960" cy="914400"/>
         </p:xfrm>
         <a:graphic>
@@ -2565,7 +2565,7 @@
                 <a:gridCol w="1645920"/>
                 <a:gridCol w="1645920"/>
               </a:tblGrid>
-              <a:tr h="411480">
+              <a:tr h="384048">
                 <a:tc>
                   <a:txBody>
                     <a:bodyPr/>
@@ -2839,7 +2839,7 @@
                   </a:tcPr>
                 </a:tc>
               </a:tr>
-              <a:tr h="384048">
+              <a:tr h="347472">
                 <a:tc>
                   <a:txBody>
                     <a:bodyPr/>
@@ -3113,7 +3113,7 @@
                   </a:tcPr>
                 </a:tc>
               </a:tr>
-              <a:tr h="384048">
+              <a:tr h="347472">
                 <a:tc>
                   <a:txBody>
                     <a:bodyPr/>
@@ -3387,7 +3387,7 @@
                   </a:tcPr>
                 </a:tc>
               </a:tr>
-              <a:tr h="384048">
+              <a:tr h="347472">
                 <a:tc>
                   <a:txBody>
                     <a:bodyPr/>
@@ -3661,7 +3661,7 @@
                   </a:tcPr>
                 </a:tc>
               </a:tr>
-              <a:tr h="384048">
+              <a:tr h="347472">
                 <a:tc>
                   <a:txBody>
                     <a:bodyPr/>
@@ -3935,7 +3935,281 @@
                   </a:tcPr>
                 </a:tc>
               </a:tr>
-              <a:tr h="384048">
+              <a:tr h="347472">
+                <a:tc>
+                  <a:txBody>
+                    <a:bodyPr/>
+                    <a:lstStyle/>
+                    <a:p>
+                      <a:pPr algn="l" indent="0" marL="0">
+                        <a:buNone/>
+                      </a:pPr>
+                      <a:r>
+                        <a:rPr lang="en-US" sz="1250" b="1" dirty="0">
+                          <a:solidFill>
+                            <a:srgbClr val="12132A"/>
+                          </a:solidFill>
+                          <a:latin typeface="Calibri" pitchFamily="34" charset="0"/>
+                          <a:ea typeface="Calibri" pitchFamily="34" charset="-122"/>
+                          <a:cs typeface="Calibri" pitchFamily="34" charset="-120"/>
+                        </a:rPr>
+                        <a:t>Partner share (10%)</a:t>
+                      </a:r>
+                      <a:endParaRPr lang="en-US" sz="1250" dirty="0">
+                        <a:latin typeface="Calibri" charset="0"/>
+                        <a:ea typeface="Calibri" charset="0"/>
+                        <a:cs typeface="Calibri" charset="0"/>
+                      </a:endParaRPr>
+                    </a:p>
+                  </a:txBody>
+                  <a:tcPr marL="101600" marR="101600" marT="25400" marB="25400" anchor="ctr">
+                    <a:lnL w="6350" cap="flat" cmpd="sng" algn="ctr">
+                      <a:solidFill>
+                        <a:srgbClr val="E6E8F0"/>
+                      </a:solidFill>
+                      <a:prstDash val="solid"/>
+                      <a:round/>
+                      <a:headEnd type="none" w="med" len="med"/>
+                      <a:tailEnd type="none" w="med" len="med"/>
+                    </a:lnL>
+                    <a:lnR w="6350" cap="flat" cmpd="sng" algn="ctr">
+                      <a:solidFill>
+                        <a:srgbClr val="E6E8F0"/>
+                      </a:solidFill>
+                      <a:prstDash val="solid"/>
+                      <a:round/>
+                      <a:headEnd type="none" w="med" len="med"/>
+                      <a:tailEnd type="none" w="med" len="med"/>
+                    </a:lnR>
+                    <a:lnT w="6350" cap="flat" cmpd="sng" algn="ctr">
+                      <a:solidFill>
+                        <a:srgbClr val="E6E8F0"/>
+                      </a:solidFill>
+                      <a:prstDash val="solid"/>
+                      <a:round/>
+                      <a:headEnd type="none" w="med" len="med"/>
+                      <a:tailEnd type="none" w="med" len="med"/>
+                    </a:lnT>
+                    <a:lnB w="6350" cap="flat" cmpd="sng" algn="ctr">
+                      <a:solidFill>
+                        <a:srgbClr val="E6E8F0"/>
+                      </a:solidFill>
+                      <a:prstDash val="solid"/>
+                      <a:round/>
+                      <a:headEnd type="none" w="med" len="med"/>
+                      <a:tailEnd type="none" w="med" len="med"/>
+                    </a:lnB>
+                    <a:solidFill>
+                      <a:srgbClr val="FFFFFF"/>
+                    </a:solidFill>
+                  </a:tcPr>
+                </a:tc>
+                <a:tc>
+                  <a:txBody>
+                    <a:bodyPr/>
+                    <a:lstStyle/>
+                    <a:p>
+                      <a:pPr algn="ctr" indent="0" marL="0">
+                        <a:buNone/>
+                      </a:pPr>
+                      <a:r>
+                        <a:rPr lang="en-US" sz="1250" dirty="0">
+                          <a:solidFill>
+                            <a:srgbClr val="4A5568"/>
+                          </a:solidFill>
+                          <a:latin typeface="Calibri" pitchFamily="34" charset="0"/>
+                          <a:ea typeface="Calibri" pitchFamily="34" charset="-122"/>
+                          <a:cs typeface="Calibri" pitchFamily="34" charset="-120"/>
+                        </a:rPr>
+                        <a:t>RM10</a:t>
+                      </a:r>
+                      <a:endParaRPr lang="en-US" sz="1250" dirty="0">
+                        <a:latin typeface="Calibri" charset="0"/>
+                        <a:ea typeface="Calibri" charset="0"/>
+                        <a:cs typeface="Calibri" charset="0"/>
+                      </a:endParaRPr>
+                    </a:p>
+                  </a:txBody>
+                  <a:tcPr marL="101600" marR="101600" marT="25400" marB="25400" anchor="ctr">
+                    <a:lnL w="6350" cap="flat" cmpd="sng" algn="ctr">
+                      <a:solidFill>
+                        <a:srgbClr val="E6E8F0"/>
+                      </a:solidFill>
+                      <a:prstDash val="solid"/>
+                      <a:round/>
+                      <a:headEnd type="none" w="med" len="med"/>
+                      <a:tailEnd type="none" w="med" len="med"/>
+                    </a:lnL>
+                    <a:lnR w="6350" cap="flat" cmpd="sng" algn="ctr">
+                      <a:solidFill>
+                        <a:srgbClr val="E6E8F0"/>
+                      </a:solidFill>
+                      <a:prstDash val="solid"/>
+                      <a:round/>
+                      <a:headEnd type="none" w="med" len="med"/>
+                      <a:tailEnd type="none" w="med" len="med"/>
+                    </a:lnR>
+                    <a:lnT w="6350" cap="flat" cmpd="sng" algn="ctr">
+                      <a:solidFill>
+                        <a:srgbClr val="E6E8F0"/>
+                      </a:solidFill>
+                      <a:prstDash val="solid"/>
+                      <a:round/>
+                      <a:headEnd type="none" w="med" len="med"/>
+                      <a:tailEnd type="none" w="med" len="med"/>
+                    </a:lnT>
+                    <a:lnB w="6350" cap="flat" cmpd="sng" algn="ctr">
+                      <a:solidFill>
+                        <a:srgbClr val="E6E8F0"/>
+                      </a:solidFill>
+                      <a:prstDash val="solid"/>
+                      <a:round/>
+                      <a:headEnd type="none" w="med" len="med"/>
+                      <a:tailEnd type="none" w="med" len="med"/>
+                    </a:lnB>
+                    <a:solidFill>
+                      <a:srgbClr val="FFFFFF"/>
+                    </a:solidFill>
+                  </a:tcPr>
+                </a:tc>
+                <a:tc>
+                  <a:txBody>
+                    <a:bodyPr/>
+                    <a:lstStyle/>
+                    <a:p>
+                      <a:pPr algn="ctr" indent="0" marL="0">
+                        <a:buNone/>
+                      </a:pPr>
+                      <a:r>
+                        <a:rPr lang="en-US" sz="1250" dirty="0">
+                          <a:solidFill>
+                            <a:srgbClr val="4A5568"/>
+                          </a:solidFill>
+                          <a:latin typeface="Calibri" pitchFamily="34" charset="0"/>
+                          <a:ea typeface="Calibri" pitchFamily="34" charset="-122"/>
+                          <a:cs typeface="Calibri" pitchFamily="34" charset="-120"/>
+                        </a:rPr>
+                        <a:t>RM60</a:t>
+                      </a:r>
+                      <a:endParaRPr lang="en-US" sz="1250" dirty="0">
+                        <a:latin typeface="Calibri" charset="0"/>
+                        <a:ea typeface="Calibri" charset="0"/>
+                        <a:cs typeface="Calibri" charset="0"/>
+                      </a:endParaRPr>
+                    </a:p>
+                  </a:txBody>
+                  <a:tcPr marL="101600" marR="101600" marT="25400" marB="25400" anchor="ctr">
+                    <a:lnL w="6350" cap="flat" cmpd="sng" algn="ctr">
+                      <a:solidFill>
+                        <a:srgbClr val="E6E8F0"/>
+                      </a:solidFill>
+                      <a:prstDash val="solid"/>
+                      <a:round/>
+                      <a:headEnd type="none" w="med" len="med"/>
+                      <a:tailEnd type="none" w="med" len="med"/>
+                    </a:lnL>
+                    <a:lnR w="6350" cap="flat" cmpd="sng" algn="ctr">
+                      <a:solidFill>
+                        <a:srgbClr val="E6E8F0"/>
+                      </a:solidFill>
+                      <a:prstDash val="solid"/>
+                      <a:round/>
+                      <a:headEnd type="none" w="med" len="med"/>
+                      <a:tailEnd type="none" w="med" len="med"/>
+                    </a:lnR>
+                    <a:lnT w="6350" cap="flat" cmpd="sng" algn="ctr">
+                      <a:solidFill>
+                        <a:srgbClr val="E6E8F0"/>
+                      </a:solidFill>
+                      <a:prstDash val="solid"/>
+                      <a:round/>
+                      <a:headEnd type="none" w="med" len="med"/>
+                      <a:tailEnd type="none" w="med" len="med"/>
+                    </a:lnT>
+                    <a:lnB w="6350" cap="flat" cmpd="sng" algn="ctr">
+                      <a:solidFill>
+                        <a:srgbClr val="E6E8F0"/>
+                      </a:solidFill>
+                      <a:prstDash val="solid"/>
+                      <a:round/>
+                      <a:headEnd type="none" w="med" len="med"/>
+                      <a:tailEnd type="none" w="med" len="med"/>
+                    </a:lnB>
+                    <a:solidFill>
+                      <a:srgbClr val="FFFFFF"/>
+                    </a:solidFill>
+                  </a:tcPr>
+                </a:tc>
+                <a:tc>
+                  <a:txBody>
+                    <a:bodyPr/>
+                    <a:lstStyle/>
+                    <a:p>
+                      <a:pPr algn="ctr" indent="0" marL="0">
+                        <a:buNone/>
+                      </a:pPr>
+                      <a:r>
+                        <a:rPr lang="en-US" sz="1250" dirty="0">
+                          <a:solidFill>
+                            <a:srgbClr val="4A5568"/>
+                          </a:solidFill>
+                          <a:latin typeface="Calibri" pitchFamily="34" charset="0"/>
+                          <a:ea typeface="Calibri" pitchFamily="34" charset="-122"/>
+                          <a:cs typeface="Calibri" pitchFamily="34" charset="-120"/>
+                        </a:rPr>
+                        <a:t>RM140</a:t>
+                      </a:r>
+                      <a:endParaRPr lang="en-US" sz="1250" dirty="0">
+                        <a:latin typeface="Calibri" charset="0"/>
+                        <a:ea typeface="Calibri" charset="0"/>
+                        <a:cs typeface="Calibri" charset="0"/>
+                      </a:endParaRPr>
+                    </a:p>
+                  </a:txBody>
+                  <a:tcPr marL="101600" marR="101600" marT="25400" marB="25400" anchor="ctr">
+                    <a:lnL w="6350" cap="flat" cmpd="sng" algn="ctr">
+                      <a:solidFill>
+                        <a:srgbClr val="E6E8F0"/>
+                      </a:solidFill>
+                      <a:prstDash val="solid"/>
+                      <a:round/>
+                      <a:headEnd type="none" w="med" len="med"/>
+                      <a:tailEnd type="none" w="med" len="med"/>
+                    </a:lnL>
+                    <a:lnR w="6350" cap="flat" cmpd="sng" algn="ctr">
+                      <a:solidFill>
+                        <a:srgbClr val="E6E8F0"/>
+                      </a:solidFill>
+                      <a:prstDash val="solid"/>
+                      <a:round/>
+                      <a:headEnd type="none" w="med" len="med"/>
+                      <a:tailEnd type="none" w="med" len="med"/>
+                    </a:lnR>
+                    <a:lnT w="6350" cap="flat" cmpd="sng" algn="ctr">
+                      <a:solidFill>
+                        <a:srgbClr val="E6E8F0"/>
+                      </a:solidFill>
+                      <a:prstDash val="solid"/>
+                      <a:round/>
+                      <a:headEnd type="none" w="med" len="med"/>
+                      <a:tailEnd type="none" w="med" len="med"/>
+                    </a:lnT>
+                    <a:lnB w="6350" cap="flat" cmpd="sng" algn="ctr">
+                      <a:solidFill>
+                        <a:srgbClr val="E6E8F0"/>
+                      </a:solidFill>
+                      <a:prstDash val="solid"/>
+                      <a:round/>
+                      <a:headEnd type="none" w="med" len="med"/>
+                      <a:tailEnd type="none" w="med" len="med"/>
+                    </a:lnB>
+                    <a:solidFill>
+                      <a:srgbClr val="FFFFFF"/>
+                    </a:solidFill>
+                  </a:tcPr>
+                </a:tc>
+              </a:tr>
+              <a:tr h="347472">
                 <a:tc>
                   <a:txBody>
                     <a:bodyPr/>
@@ -4209,7 +4483,7 @@
                   </a:tcPr>
                 </a:tc>
               </a:tr>
-              <a:tr h="384048">
+              <a:tr h="347472">
                 <a:tc>
                   <a:txBody>
                     <a:bodyPr/>
@@ -4483,7 +4757,7 @@
                   </a:tcPr>
                 </a:tc>
               </a:tr>
-              <a:tr h="457200">
+              <a:tr h="402336">
                 <a:tc>
                   <a:txBody>
                     <a:bodyPr/>
@@ -4569,7 +4843,7 @@
                           <a:ea typeface="Calibri" pitchFamily="34" charset="-122"/>
                           <a:cs typeface="Calibri" pitchFamily="34" charset="-120"/>
                         </a:rPr>
-                        <a:t>RM34</a:t>
+                        <a:t>RM44</a:t>
                       </a:r>
                       <a:endParaRPr lang="en-US" sz="1250" dirty="0">
                         <a:latin typeface="Calibri" charset="0"/>
@@ -4637,7 +4911,7 @@
                           <a:ea typeface="Calibri" pitchFamily="34" charset="-122"/>
                           <a:cs typeface="Calibri" pitchFamily="34" charset="-120"/>
                         </a:rPr>
-                        <a:t>RM171</a:t>
+                        <a:t>RM231</a:t>
                       </a:r>
                       <a:endParaRPr lang="en-US" sz="1250" dirty="0">
                         <a:latin typeface="Calibri" charset="0"/>
@@ -4705,7 +4979,7 @@
                           <a:ea typeface="Calibri" pitchFamily="34" charset="-122"/>
                           <a:cs typeface="Calibri" pitchFamily="34" charset="-120"/>
                         </a:rPr>
-                        <a:t>RM401</a:t>
+                        <a:t>RM541</a:t>
                       </a:r>
                       <a:endParaRPr lang="en-US" sz="1250" dirty="0">
                         <a:latin typeface="Calibri" charset="0"/>
@@ -4757,7 +5031,7 @@
                   </a:tcPr>
                 </a:tc>
               </a:tr>
-              <a:tr h="457200">
+              <a:tr h="402336">
                 <a:tc>
                   <a:txBody>
                     <a:bodyPr/>
@@ -5031,7 +5305,7 @@
                   </a:tcPr>
                 </a:tc>
               </a:tr>
-              <a:tr h="502920">
+              <a:tr h="438912">
                 <a:tc>
                   <a:txBody>
                     <a:bodyPr/>
@@ -5117,7 +5391,7 @@
                           <a:ea typeface="Calibri" pitchFamily="34" charset="-122"/>
                           <a:cs typeface="Calibri" pitchFamily="34" charset="-120"/>
                         </a:rPr>
-                        <a:t>66%</a:t>
+                        <a:t>56%</a:t>
                       </a:r>
                       <a:endParaRPr lang="en-US" sz="1400" dirty="0">
                         <a:latin typeface="Calibri" charset="0"/>
@@ -5185,7 +5459,7 @@
                           <a:ea typeface="Calibri" pitchFamily="34" charset="-122"/>
                           <a:cs typeface="Calibri" pitchFamily="34" charset="-120"/>
                         </a:rPr>
-                        <a:t>71%</a:t>
+                        <a:t>61%</a:t>
                       </a:r>
                       <a:endParaRPr lang="en-US" sz="1400" dirty="0">
                         <a:latin typeface="Calibri" charset="0"/>
@@ -5253,7 +5527,7 @@
                           <a:ea typeface="Calibri" pitchFamily="34" charset="-122"/>
                           <a:cs typeface="Calibri" pitchFamily="34" charset="-120"/>
                         </a:rPr>
-                        <a:t>71%</a:t>
+                        <a:t>61%</a:t>
                       </a:r>
                       <a:endParaRPr lang="en-US" sz="1400" dirty="0">
                         <a:latin typeface="Calibri" charset="0"/>
@@ -5454,7 +5728,7 @@
                 <a:ea typeface="Calibri" pitchFamily="34" charset="-122"/>
                 <a:cs typeface="Calibri" pitchFamily="34" charset="-120"/>
               </a:rPr>
-              <a:t>66%</a:t>
+              <a:t>56%</a:t>
             </a:r>
             <a:endParaRPr lang="en-US" sz="3000" dirty="0"/>
           </a:p>
@@ -5605,7 +5879,7 @@
                 <a:ea typeface="Calibri" pitchFamily="34" charset="-122"/>
                 <a:cs typeface="Calibri" pitchFamily="34" charset="-120"/>
               </a:rPr>
-              <a:t>71%</a:t>
+              <a:t>61%</a:t>
             </a:r>
             <a:endParaRPr lang="en-US" sz="3000" dirty="0"/>
           </a:p>
@@ -5756,7 +6030,7 @@
                 <a:ea typeface="Calibri" pitchFamily="34" charset="-122"/>
                 <a:cs typeface="Calibri" pitchFamily="34" charset="-120"/>
               </a:rPr>
-              <a:t>71%</a:t>
+              <a:t>61%</a:t>
             </a:r>
             <a:endParaRPr lang="en-US" sz="3000" dirty="0"/>
           </a:p>
@@ -5795,7 +6069,7 @@
                 <a:ea typeface="Calibri" pitchFamily="34" charset="-122"/>
                 <a:cs typeface="Calibri" pitchFamily="34" charset="-120"/>
               </a:rPr>
-              <a:t>Assumes typical AI usage at the plan allowance and ~5 / 25 / 70 video interviews per month. Monthly card billing (annual lowers the Stripe fee). Platform share amortises toward zero with scale. Realistic usage runs lower, so margins run higher.</a:t>
+              <a:t>Partner share = 10% of every sale. Assumes typical AI usage at the plan allowance and ~5 / 25 / 70 video interviews/mo; monthly card billing (annual lowers the Stripe fee). Platform share amortises toward zero with scale. Realistic usage runs lower, so margins run higher.</a:t>
             </a:r>
             <a:endParaRPr lang="en-US" sz="950" dirty="0"/>
           </a:p>
@@ -6022,7 +6296,7 @@
                 <a:ea typeface="Calibri" pitchFamily="34" charset="-122"/>
                 <a:cs typeface="Calibri" pitchFamily="34" charset="-120"/>
               </a:rPr>
-              <a:t>Once an account exhausts its allowance, every extra action sells at the list rate. Cost here includes both AI inference and the one-time Stripe fee, spread across a minimum 20-credit top-up. Growth accounts that buy top-ups lift blended margin.</a:t>
+              <a:t>Once an account exhausts its allowance, every extra action sells at the list rate. Cost here includes AI inference, the one-time Stripe fee (min 20-credit top-up) and the 10% partner share. Growth accounts that buy top-ups lift blended margin.</a:t>
             </a:r>
             <a:endParaRPr lang="en-US" sz="1400" dirty="0"/>
           </a:p>
@@ -6134,7 +6408,7 @@
                 <a:ea typeface="Calibri" pitchFamily="34" charset="-122"/>
                 <a:cs typeface="Calibri" pitchFamily="34" charset="-120"/>
               </a:rPr>
-              <a:t>92%</a:t>
+              <a:t>82%</a:t>
             </a:r>
             <a:endParaRPr lang="en-US" sz="4600" dirty="0"/>
           </a:p>
@@ -6277,7 +6551,7 @@
                 <a:ea typeface="Calibri" pitchFamily="34" charset="-122"/>
                 <a:cs typeface="Calibri" pitchFamily="34" charset="-120"/>
               </a:rPr>
-              <a:t>RM0.33</a:t>
+              <a:t>RM0.74</a:t>
             </a:r>
             <a:endParaRPr lang="en-US" sz="1300" dirty="0"/>
           </a:p>
@@ -6389,7 +6663,7 @@
                 <a:ea typeface="Calibri" pitchFamily="34" charset="-122"/>
                 <a:cs typeface="Calibri" pitchFamily="34" charset="-120"/>
               </a:rPr>
-              <a:t>82%</a:t>
+              <a:t>72%</a:t>
             </a:r>
             <a:endParaRPr lang="en-US" sz="4600" dirty="0"/>
           </a:p>
@@ -6532,7 +6806,7 @@
                 <a:ea typeface="Calibri" pitchFamily="34" charset="-122"/>
                 <a:cs typeface="Calibri" pitchFamily="34" charset="-120"/>
               </a:rPr>
-              <a:t>RM0.30</a:t>
+              <a:t>RM0.46</a:t>
             </a:r>
             <a:endParaRPr lang="en-US" sz="1300" dirty="0"/>
           </a:p>
@@ -6644,7 +6918,7 @@
                 <a:ea typeface="Calibri" pitchFamily="34" charset="-122"/>
                 <a:cs typeface="Calibri" pitchFamily="34" charset="-120"/>
               </a:rPr>
-              <a:t>91%</a:t>
+              <a:t>81%</a:t>
             </a:r>
             <a:endParaRPr lang="en-US" sz="4600" dirty="0"/>
           </a:p>
@@ -6787,7 +7061,7 @@
                 <a:ea typeface="Calibri" pitchFamily="34" charset="-122"/>
                 <a:cs typeface="Calibri" pitchFamily="34" charset="-120"/>
               </a:rPr>
-              <a:t>RM0.18</a:t>
+              <a:t>RM0.39</a:t>
             </a:r>
             <a:endParaRPr lang="en-US" sz="1300" dirty="0"/>
           </a:p>
@@ -6826,7 +7100,7 @@
                 <a:ea typeface="Calibri" pitchFamily="34" charset="-122"/>
                 <a:cs typeface="Calibri" pitchFamily="34" charset="-120"/>
               </a:rPr>
-              <a:t>Cost = AI inference + Stripe (3% + RM1 per top-up, min 20 credits). The fixed fee amortises across the batch, so per-credit processing is a few sen and margin stays in the 80s+.</a:t>
+              <a:t>Cost = AI inference + Stripe (3% + RM1 per top-up, min 20 credits) + 10% partner share. Even after all three, top-ups stay the highest-margin revenue at 70%+.</a:t>
             </a:r>
             <a:endParaRPr lang="en-US" sz="1100" dirty="0"/>
           </a:p>
@@ -9820,7 +10094,7 @@
                 <a:ea typeface="Calibri" pitchFamily="34" charset="-122"/>
                 <a:cs typeface="Calibri" pitchFamily="34" charset="-120"/>
               </a:rPr>
-              <a:t>~72% </a:t>
+              <a:t>~62% </a:t>
             </a:r>
             <a:pPr algn="l" indent="0" marL="0">
               <a:buNone/>
@@ -9912,7 +10186,7 @@
                 <a:ea typeface="Calibri" pitchFamily="34" charset="-122"/>
                 <a:cs typeface="Calibri" pitchFamily="34" charset="-120"/>
               </a:rPr>
-              <a:t>Illustrative. Enterprise is a custom plan with no list price; modelled here at an assumed ~RM6,000/mo for the scenario only. Adjust mix, Enterprise deal size, and top-up rate as pricing is finalised.</a:t>
+              <a:t>Illustrative. Enterprise is a custom plan with no list price; modelled here at an assumed ~RM6,000/mo for the scenario only. ARR is gross revenue; the 10% partner share is captured in the margins on slide 10. Adjust mix, Enterprise deal size, and top-up rate as pricing is finalised.</a:t>
             </a:r>
             <a:endParaRPr lang="en-US" sz="1000" dirty="0"/>
           </a:p>
@@ -11585,7 +11859,7 @@
                 <a:ea typeface="Calibri" pitchFamily="34" charset="-122"/>
                 <a:cs typeface="Calibri" pitchFamily="34" charset="-120"/>
               </a:rPr>
-              <a:t>66–71%</a:t>
+              <a:t>56–61%</a:t>
             </a:r>
             <a:endParaRPr lang="en-US" sz="3000" dirty="0"/>
           </a:p>
@@ -26150,7 +26424,7 @@
           </p:nvPr>
         </p:nvGraphicFramePr>
         <p:xfrm>
-          <a:off x="548640" y="2011680"/>
+          <a:off x="548640" y="1965960"/>
           <a:ext cx="7863840" cy="914400"/>
         </p:xfrm>
         <a:graphic>
@@ -26163,7 +26437,7 @@
                 <a:gridCol w="2514600"/>
                 <a:gridCol w="1371600"/>
               </a:tblGrid>
-              <a:tr h="457200">
+              <a:tr h="402336">
                 <a:tc>
                   <a:txBody>
                     <a:bodyPr/>
@@ -26437,7 +26711,7 @@
                   </a:tcPr>
                 </a:tc>
               </a:tr>
-              <a:tr h="457200">
+              <a:tr h="402336">
                 <a:tc>
                   <a:txBody>
                     <a:bodyPr/>
@@ -26711,7 +26985,7 @@
                   </a:tcPr>
                 </a:tc>
               </a:tr>
-              <a:tr h="457200">
+              <a:tr h="402336">
                 <a:tc>
                   <a:txBody>
                     <a:bodyPr/>
@@ -26985,7 +27259,7 @@
                   </a:tcPr>
                 </a:tc>
               </a:tr>
-              <a:tr h="457200">
+              <a:tr h="402336">
                 <a:tc>
                   <a:txBody>
                     <a:bodyPr/>
@@ -27259,7 +27533,7 @@
                   </a:tcPr>
                 </a:tc>
               </a:tr>
-              <a:tr h="457200">
+              <a:tr h="402336">
                 <a:tc>
                   <a:txBody>
                     <a:bodyPr/>
@@ -27533,7 +27807,7 @@
                   </a:tcPr>
                 </a:tc>
               </a:tr>
-              <a:tr h="457200">
+              <a:tr h="402336">
                 <a:tc>
                   <a:txBody>
                     <a:bodyPr/>
@@ -27807,7 +28081,7 @@
                   </a:tcPr>
                 </a:tc>
               </a:tr>
-              <a:tr h="457200">
+              <a:tr h="402336">
                 <a:tc>
                   <a:txBody>
                     <a:bodyPr/>
@@ -28081,7 +28355,281 @@
                   </a:tcPr>
                 </a:tc>
               </a:tr>
-              <a:tr h="457200">
+              <a:tr h="402336">
+                <a:tc>
+                  <a:txBody>
+                    <a:bodyPr/>
+                    <a:lstStyle/>
+                    <a:p>
+                      <a:pPr algn="l" indent="0" marL="0">
+                        <a:buNone/>
+                      </a:pPr>
+                      <a:r>
+                        <a:rPr lang="en-US" sz="1200" b="1" dirty="0">
+                          <a:solidFill>
+                            <a:srgbClr val="12132A"/>
+                          </a:solidFill>
+                          <a:latin typeface="Calibri" pitchFamily="34" charset="0"/>
+                          <a:ea typeface="Calibri" pitchFamily="34" charset="-122"/>
+                          <a:cs typeface="Calibri" pitchFamily="34" charset="-120"/>
+                        </a:rPr>
+                        <a:t>Partner revenue share</a:t>
+                      </a:r>
+                      <a:endParaRPr lang="en-US" sz="1200" dirty="0">
+                        <a:latin typeface="Calibri" charset="0"/>
+                        <a:ea typeface="Calibri" charset="0"/>
+                        <a:cs typeface="Calibri" charset="0"/>
+                      </a:endParaRPr>
+                    </a:p>
+                  </a:txBody>
+                  <a:tcPr marL="76200" marR="76200" marT="25400" marB="25400" anchor="ctr">
+                    <a:lnL w="6350" cap="flat" cmpd="sng" algn="ctr">
+                      <a:solidFill>
+                        <a:srgbClr val="E6E8F0"/>
+                      </a:solidFill>
+                      <a:prstDash val="solid"/>
+                      <a:round/>
+                      <a:headEnd type="none" w="med" len="med"/>
+                      <a:tailEnd type="none" w="med" len="med"/>
+                    </a:lnL>
+                    <a:lnR w="6350" cap="flat" cmpd="sng" algn="ctr">
+                      <a:solidFill>
+                        <a:srgbClr val="E6E8F0"/>
+                      </a:solidFill>
+                      <a:prstDash val="solid"/>
+                      <a:round/>
+                      <a:headEnd type="none" w="med" len="med"/>
+                      <a:tailEnd type="none" w="med" len="med"/>
+                    </a:lnR>
+                    <a:lnT w="6350" cap="flat" cmpd="sng" algn="ctr">
+                      <a:solidFill>
+                        <a:srgbClr val="E6E8F0"/>
+                      </a:solidFill>
+                      <a:prstDash val="solid"/>
+                      <a:round/>
+                      <a:headEnd type="none" w="med" len="med"/>
+                      <a:tailEnd type="none" w="med" len="med"/>
+                    </a:lnT>
+                    <a:lnB w="6350" cap="flat" cmpd="sng" algn="ctr">
+                      <a:solidFill>
+                        <a:srgbClr val="E6E8F0"/>
+                      </a:solidFill>
+                      <a:prstDash val="solid"/>
+                      <a:round/>
+                      <a:headEnd type="none" w="med" len="med"/>
+                      <a:tailEnd type="none" w="med" len="med"/>
+                    </a:lnB>
+                    <a:solidFill>
+                      <a:srgbClr val="FFFFFF"/>
+                    </a:solidFill>
+                  </a:tcPr>
+                </a:tc>
+                <a:tc>
+                  <a:txBody>
+                    <a:bodyPr/>
+                    <a:lstStyle/>
+                    <a:p>
+                      <a:pPr algn="l" indent="0" marL="0">
+                        <a:buNone/>
+                      </a:pPr>
+                      <a:r>
+                        <a:rPr lang="en-US" sz="1200" dirty="0">
+                          <a:solidFill>
+                            <a:srgbClr val="4A5568"/>
+                          </a:solidFill>
+                          <a:latin typeface="Calibri" pitchFamily="34" charset="0"/>
+                          <a:ea typeface="Calibri" pitchFamily="34" charset="-122"/>
+                          <a:cs typeface="Calibri" pitchFamily="34" charset="-120"/>
+                        </a:rPr>
+                        <a:t>Channel partner</a:t>
+                      </a:r>
+                      <a:endParaRPr lang="en-US" sz="1200" dirty="0">
+                        <a:latin typeface="Calibri" charset="0"/>
+                        <a:ea typeface="Calibri" charset="0"/>
+                        <a:cs typeface="Calibri" charset="0"/>
+                      </a:endParaRPr>
+                    </a:p>
+                  </a:txBody>
+                  <a:tcPr marL="76200" marR="76200" marT="25400" marB="25400" anchor="ctr">
+                    <a:lnL w="6350" cap="flat" cmpd="sng" algn="ctr">
+                      <a:solidFill>
+                        <a:srgbClr val="E6E8F0"/>
+                      </a:solidFill>
+                      <a:prstDash val="solid"/>
+                      <a:round/>
+                      <a:headEnd type="none" w="med" len="med"/>
+                      <a:tailEnd type="none" w="med" len="med"/>
+                    </a:lnL>
+                    <a:lnR w="6350" cap="flat" cmpd="sng" algn="ctr">
+                      <a:solidFill>
+                        <a:srgbClr val="E6E8F0"/>
+                      </a:solidFill>
+                      <a:prstDash val="solid"/>
+                      <a:round/>
+                      <a:headEnd type="none" w="med" len="med"/>
+                      <a:tailEnd type="none" w="med" len="med"/>
+                    </a:lnR>
+                    <a:lnT w="6350" cap="flat" cmpd="sng" algn="ctr">
+                      <a:solidFill>
+                        <a:srgbClr val="E6E8F0"/>
+                      </a:solidFill>
+                      <a:prstDash val="solid"/>
+                      <a:round/>
+                      <a:headEnd type="none" w="med" len="med"/>
+                      <a:tailEnd type="none" w="med" len="med"/>
+                    </a:lnT>
+                    <a:lnB w="6350" cap="flat" cmpd="sng" algn="ctr">
+                      <a:solidFill>
+                        <a:srgbClr val="E6E8F0"/>
+                      </a:solidFill>
+                      <a:prstDash val="solid"/>
+                      <a:round/>
+                      <a:headEnd type="none" w="med" len="med"/>
+                      <a:tailEnd type="none" w="med" len="med"/>
+                    </a:lnB>
+                    <a:solidFill>
+                      <a:srgbClr val="FFFFFF"/>
+                    </a:solidFill>
+                  </a:tcPr>
+                </a:tc>
+                <a:tc>
+                  <a:txBody>
+                    <a:bodyPr/>
+                    <a:lstStyle/>
+                    <a:p>
+                      <a:pPr algn="l" indent="0" marL="0">
+                        <a:buNone/>
+                      </a:pPr>
+                      <a:r>
+                        <a:rPr lang="en-US" sz="1200" dirty="0">
+                          <a:solidFill>
+                            <a:srgbClr val="4A5568"/>
+                          </a:solidFill>
+                          <a:latin typeface="Calibri" pitchFamily="34" charset="0"/>
+                          <a:ea typeface="Calibri" pitchFamily="34" charset="-122"/>
+                          <a:cs typeface="Calibri" pitchFamily="34" charset="-120"/>
+                        </a:rPr>
+                        <a:t>10% of each sale</a:t>
+                      </a:r>
+                      <a:endParaRPr lang="en-US" sz="1200" dirty="0">
+                        <a:latin typeface="Calibri" charset="0"/>
+                        <a:ea typeface="Calibri" charset="0"/>
+                        <a:cs typeface="Calibri" charset="0"/>
+                      </a:endParaRPr>
+                    </a:p>
+                  </a:txBody>
+                  <a:tcPr marL="76200" marR="76200" marT="25400" marB="25400" anchor="ctr">
+                    <a:lnL w="6350" cap="flat" cmpd="sng" algn="ctr">
+                      <a:solidFill>
+                        <a:srgbClr val="E6E8F0"/>
+                      </a:solidFill>
+                      <a:prstDash val="solid"/>
+                      <a:round/>
+                      <a:headEnd type="none" w="med" len="med"/>
+                      <a:tailEnd type="none" w="med" len="med"/>
+                    </a:lnL>
+                    <a:lnR w="6350" cap="flat" cmpd="sng" algn="ctr">
+                      <a:solidFill>
+                        <a:srgbClr val="E6E8F0"/>
+                      </a:solidFill>
+                      <a:prstDash val="solid"/>
+                      <a:round/>
+                      <a:headEnd type="none" w="med" len="med"/>
+                      <a:tailEnd type="none" w="med" len="med"/>
+                    </a:lnR>
+                    <a:lnT w="6350" cap="flat" cmpd="sng" algn="ctr">
+                      <a:solidFill>
+                        <a:srgbClr val="E6E8F0"/>
+                      </a:solidFill>
+                      <a:prstDash val="solid"/>
+                      <a:round/>
+                      <a:headEnd type="none" w="med" len="med"/>
+                      <a:tailEnd type="none" w="med" len="med"/>
+                    </a:lnT>
+                    <a:lnB w="6350" cap="flat" cmpd="sng" algn="ctr">
+                      <a:solidFill>
+                        <a:srgbClr val="E6E8F0"/>
+                      </a:solidFill>
+                      <a:prstDash val="solid"/>
+                      <a:round/>
+                      <a:headEnd type="none" w="med" len="med"/>
+                      <a:tailEnd type="none" w="med" len="med"/>
+                    </a:lnB>
+                    <a:solidFill>
+                      <a:srgbClr val="FFFFFF"/>
+                    </a:solidFill>
+                  </a:tcPr>
+                </a:tc>
+                <a:tc>
+                  <a:txBody>
+                    <a:bodyPr/>
+                    <a:lstStyle/>
+                    <a:p>
+                      <a:pPr algn="ctr" indent="0" marL="0">
+                        <a:buNone/>
+                      </a:pPr>
+                      <a:r>
+                        <a:rPr lang="en-US" sz="1200" dirty="0">
+                          <a:solidFill>
+                            <a:srgbClr val="4A5568"/>
+                          </a:solidFill>
+                          <a:latin typeface="Calibri" pitchFamily="34" charset="0"/>
+                          <a:ea typeface="Calibri" pitchFamily="34" charset="-122"/>
+                          <a:cs typeface="Calibri" pitchFamily="34" charset="-120"/>
+                        </a:rPr>
+                        <a:t>Aster</a:t>
+                      </a:r>
+                      <a:endParaRPr lang="en-US" sz="1200" dirty="0">
+                        <a:latin typeface="Calibri" charset="0"/>
+                        <a:ea typeface="Calibri" charset="0"/>
+                        <a:cs typeface="Calibri" charset="0"/>
+                      </a:endParaRPr>
+                    </a:p>
+                  </a:txBody>
+                  <a:tcPr marL="76200" marR="76200" marT="25400" marB="25400" anchor="ctr">
+                    <a:lnL w="6350" cap="flat" cmpd="sng" algn="ctr">
+                      <a:solidFill>
+                        <a:srgbClr val="E6E8F0"/>
+                      </a:solidFill>
+                      <a:prstDash val="solid"/>
+                      <a:round/>
+                      <a:headEnd type="none" w="med" len="med"/>
+                      <a:tailEnd type="none" w="med" len="med"/>
+                    </a:lnL>
+                    <a:lnR w="6350" cap="flat" cmpd="sng" algn="ctr">
+                      <a:solidFill>
+                        <a:srgbClr val="E6E8F0"/>
+                      </a:solidFill>
+                      <a:prstDash val="solid"/>
+                      <a:round/>
+                      <a:headEnd type="none" w="med" len="med"/>
+                      <a:tailEnd type="none" w="med" len="med"/>
+                    </a:lnR>
+                    <a:lnT w="6350" cap="flat" cmpd="sng" algn="ctr">
+                      <a:solidFill>
+                        <a:srgbClr val="E6E8F0"/>
+                      </a:solidFill>
+                      <a:prstDash val="solid"/>
+                      <a:round/>
+                      <a:headEnd type="none" w="med" len="med"/>
+                      <a:tailEnd type="none" w="med" len="med"/>
+                    </a:lnT>
+                    <a:lnB w="6350" cap="flat" cmpd="sng" algn="ctr">
+                      <a:solidFill>
+                        <a:srgbClr val="E6E8F0"/>
+                      </a:solidFill>
+                      <a:prstDash val="solid"/>
+                      <a:round/>
+                      <a:headEnd type="none" w="med" len="med"/>
+                      <a:tailEnd type="none" w="med" len="med"/>
+                    </a:lnB>
+                    <a:solidFill>
+                      <a:srgbClr val="FFFFFF"/>
+                    </a:solidFill>
+                  </a:tcPr>
+                </a:tc>
+              </a:tr>
+              <a:tr h="402336">
                 <a:tc>
                   <a:txBody>
                     <a:bodyPr/>
@@ -28146,7 +28694,7 @@
                       <a:tailEnd type="none" w="med" len="med"/>
                     </a:lnB>
                     <a:solidFill>
-                      <a:srgbClr val="FFFFFF"/>
+                      <a:srgbClr val="F5F7FE"/>
                     </a:solidFill>
                   </a:tcPr>
                 </a:tc>
@@ -28214,7 +28762,7 @@
                       <a:tailEnd type="none" w="med" len="med"/>
                     </a:lnB>
                     <a:solidFill>
-                      <a:srgbClr val="FFFFFF"/>
+                      <a:srgbClr val="F5F7FE"/>
                     </a:solidFill>
                   </a:tcPr>
                 </a:tc>
@@ -28282,7 +28830,7 @@
                       <a:tailEnd type="none" w="med" len="med"/>
                     </a:lnB>
                     <a:solidFill>
-                      <a:srgbClr val="FFFFFF"/>
+                      <a:srgbClr val="F5F7FE"/>
                     </a:solidFill>
                   </a:tcPr>
                 </a:tc>
@@ -28350,7 +28898,7 @@
                       <a:tailEnd type="none" w="med" len="med"/>
                     </a:lnB>
                     <a:solidFill>
-                      <a:srgbClr val="FFFFFF"/>
+                      <a:srgbClr val="F5F7FE"/>
                     </a:solidFill>
                   </a:tcPr>
                 </a:tc>

</xml_diff>

<commit_message>
Update credit top-up prices and per-item minimums
New retail credit prices: screening RM2.85 (min 10), AI Rank RM2.45
(min 10), interview questions RM0.40 (min 50), job draft RM2.25
(min 10). Removes AI Insight from the sellable credit menu (still an
included plan allowance). Recomputes per-credit max margins (80-90%),
top-up all-in margins (69-78% after AI + Stripe + partner), and the
included-value multiples (2-3x).

Co-Authored-By: Claude Opus 4.8 <noreply@anthropic.com>
Claude-Session: https://claude.ai/code/session_0176R35qPk2mhGFwXaB3Lv9s
</commit_message>
<xml_diff>
--- a/docs/aster-pricing.pptx
+++ b/docs/aster-pricing.pptx
@@ -6296,7 +6296,7 @@
                 <a:ea typeface="Calibri" pitchFamily="34" charset="-122"/>
                 <a:cs typeface="Calibri" pitchFamily="34" charset="-120"/>
               </a:rPr>
-              <a:t>Once an account exhausts its allowance, every extra action sells at the list rate. Cost here includes AI inference, the one-time Stripe fee (min 20-credit top-up) and the 10% partner share. Growth accounts that buy top-ups lift blended margin.</a:t>
+              <a:t>Once an account exhausts its allowance, every extra action sells at the list rate. Cost here includes AI inference, the one-time Stripe fee (on each credit's minimum top-up) and the 10% partner share. Growth accounts that buy top-ups lift blended margin.</a:t>
             </a:r>
             <a:endParaRPr lang="en-US" sz="1400" dirty="0"/>
           </a:p>
@@ -6310,12 +6310,12 @@
         </p:nvSpPr>
         <p:spPr>
           <a:xfrm>
-            <a:off x="868680" y="2468880"/>
-            <a:ext cx="3383280" cy="2788920"/>
+            <a:off x="548640" y="2468880"/>
+            <a:ext cx="2651760" cy="2788920"/>
           </a:xfrm>
           <a:prstGeom prst="roundRect">
             <a:avLst>
-              <a:gd name="adj" fmla="val 3934"/>
+              <a:gd name="adj" fmla="val 4138"/>
             </a:avLst>
           </a:prstGeom>
           <a:solidFill>
@@ -6344,8 +6344,8 @@
         </p:nvSpPr>
         <p:spPr>
           <a:xfrm>
-            <a:off x="1124712" y="2697480"/>
-            <a:ext cx="2926080" cy="457200"/>
+            <a:off x="768096" y="2697480"/>
+            <a:ext cx="2249424" cy="457200"/>
           </a:xfrm>
           <a:prstGeom prst="rect">
             <a:avLst/>
@@ -6361,7 +6361,7 @@
               <a:buNone/>
             </a:pPr>
             <a:r>
-              <a:rPr lang="en-US" sz="1550" b="1" dirty="0">
+              <a:rPr lang="en-US" sz="1500" b="1" dirty="0">
                 <a:solidFill>
                   <a:srgbClr val="12132A"/>
                 </a:solidFill>
@@ -6371,7 +6371,7 @@
               </a:rPr>
               <a:t>Screening</a:t>
             </a:r>
-            <a:endParaRPr lang="en-US" sz="1550" dirty="0"/>
+            <a:endParaRPr lang="en-US" sz="1500" dirty="0"/>
           </a:p>
         </p:txBody>
       </p:sp>
@@ -6383,8 +6383,8 @@
         </p:nvSpPr>
         <p:spPr>
           <a:xfrm>
-            <a:off x="1124712" y="3200400"/>
-            <a:ext cx="2871216" cy="777240"/>
+            <a:off x="768096" y="3218688"/>
+            <a:ext cx="2212848" cy="731520"/>
           </a:xfrm>
           <a:prstGeom prst="rect">
             <a:avLst/>
@@ -6400,7 +6400,7 @@
               <a:buNone/>
             </a:pPr>
             <a:r>
-              <a:rPr lang="en-US" sz="4600" b="1" dirty="0">
+              <a:rPr lang="en-US" sz="4000" b="1" dirty="0">
                 <a:solidFill>
                   <a:srgbClr val="16A34A"/>
                 </a:solidFill>
@@ -6408,9 +6408,9 @@
                 <a:ea typeface="Calibri" pitchFamily="34" charset="-122"/>
                 <a:cs typeface="Calibri" pitchFamily="34" charset="-120"/>
               </a:rPr>
-              <a:t>82%</a:t>
+              <a:t>78%</a:t>
             </a:r>
-            <a:endParaRPr lang="en-US" sz="4600" dirty="0"/>
+            <a:endParaRPr lang="en-US" sz="4000" dirty="0"/>
           </a:p>
         </p:txBody>
       </p:sp>
@@ -6422,8 +6422,8 @@
         </p:nvSpPr>
         <p:spPr>
           <a:xfrm>
-            <a:off x="1124712" y="4005072"/>
-            <a:ext cx="2871216" cy="274320"/>
+            <a:off x="768096" y="3986784"/>
+            <a:ext cx="2212848" cy="274320"/>
           </a:xfrm>
           <a:prstGeom prst="rect">
             <a:avLst/>
@@ -6439,7 +6439,7 @@
               <a:buNone/>
             </a:pPr>
             <a:r>
-              <a:rPr lang="en-US" sz="1100" dirty="0">
+              <a:rPr lang="en-US" sz="1050" dirty="0">
                 <a:solidFill>
                   <a:srgbClr val="6B7280"/>
                 </a:solidFill>
@@ -6449,7 +6449,7 @@
               </a:rPr>
               <a:t>gross margin at list</a:t>
             </a:r>
-            <a:endParaRPr lang="en-US" sz="1100" dirty="0"/>
+            <a:endParaRPr lang="en-US" sz="1050" dirty="0"/>
           </a:p>
         </p:txBody>
       </p:sp>
@@ -6461,8 +6461,8 @@
         </p:nvSpPr>
         <p:spPr>
           <a:xfrm>
-            <a:off x="1124712" y="4370832"/>
-            <a:ext cx="2871216" cy="0"/>
+            <a:off x="768096" y="4352544"/>
+            <a:ext cx="2212848" cy="0"/>
           </a:xfrm>
           <a:prstGeom prst="line">
             <a:avLst/>
@@ -6484,8 +6484,8 @@
         </p:nvSpPr>
         <p:spPr>
           <a:xfrm>
-            <a:off x="1124712" y="4480560"/>
-            <a:ext cx="2926080" cy="457200"/>
+            <a:off x="768096" y="4462272"/>
+            <a:ext cx="2249424" cy="640080"/>
           </a:xfrm>
           <a:prstGeom prst="rect">
             <a:avLst/>
@@ -6494,14 +6494,17 @@
           <a:ln/>
         </p:spPr>
         <p:txBody>
-          <a:bodyPr wrap="square" lIns="0" tIns="0" rIns="0" bIns="0" rtlCol="0" anchor="ctr"/>
+          <a:bodyPr wrap="square" lIns="0" tIns="0" rIns="0" bIns="0" rtlCol="0" anchor="t"/>
           <a:lstStyle/>
           <a:p>
             <a:pPr algn="l" indent="0" marL="0">
+              <a:lnSpc>
+                <a:spcPct val="110000"/>
+              </a:lnSpc>
               <a:buNone/>
             </a:pPr>
             <a:r>
-              <a:rPr lang="en-US" sz="1300" dirty="0">
+              <a:rPr lang="en-US" sz="1250" dirty="0">
                 <a:solidFill>
                   <a:srgbClr val="4A5568"/>
                 </a:solidFill>
@@ -6512,10 +6515,13 @@
               <a:t>Price </a:t>
             </a:r>
             <a:pPr algn="l" indent="0" marL="0">
+              <a:lnSpc>
+                <a:spcPct val="110000"/>
+              </a:lnSpc>
               <a:buNone/>
             </a:pPr>
             <a:r>
-              <a:rPr lang="en-US" sz="1300" b="1" dirty="0">
+              <a:rPr lang="en-US" sz="1250" b="1" dirty="0">
                 <a:solidFill>
                   <a:srgbClr val="12132A"/>
                 </a:solidFill>
@@ -6523,13 +6529,34 @@
                 <a:ea typeface="Calibri" pitchFamily="34" charset="-122"/>
                 <a:cs typeface="Calibri" pitchFamily="34" charset="-120"/>
               </a:rPr>
-              <a:t>RM4.09   </a:t>
+              <a:t>RM2.85</a:t>
             </a:r>
             <a:pPr algn="l" indent="0" marL="0">
+              <a:lnSpc>
+                <a:spcPct val="110000"/>
+              </a:lnSpc>
               <a:buNone/>
             </a:pPr>
             <a:r>
-              <a:rPr lang="en-US" sz="1300" dirty="0">
+              <a:rPr lang="en-US" sz="1250" dirty="0">
+                <a:solidFill>
+                  <a:srgbClr val="000000"/>
+                </a:solidFill>
+                <a:latin typeface="Calibri" pitchFamily="34" charset="0"/>
+                <a:ea typeface="Calibri" pitchFamily="34" charset="-122"/>
+                <a:cs typeface="Calibri" pitchFamily="34" charset="-120"/>
+              </a:rPr>
+              <a:t>
+</a:t>
+            </a:r>
+            <a:pPr algn="l" indent="0" marL="0">
+              <a:lnSpc>
+                <a:spcPct val="110000"/>
+              </a:lnSpc>
+              <a:buNone/>
+            </a:pPr>
+            <a:r>
+              <a:rPr lang="en-US" sz="1250" dirty="0">
                 <a:solidFill>
                   <a:srgbClr val="4A5568"/>
                 </a:solidFill>
@@ -6540,10 +6567,13 @@
               <a:t>Cost </a:t>
             </a:r>
             <a:pPr algn="l" indent="0" marL="0">
+              <a:lnSpc>
+                <a:spcPct val="110000"/>
+              </a:lnSpc>
               <a:buNone/>
             </a:pPr>
             <a:r>
-              <a:rPr lang="en-US" sz="1300" b="1" dirty="0">
+              <a:rPr lang="en-US" sz="1250" b="1" dirty="0">
                 <a:solidFill>
                   <a:srgbClr val="12132A"/>
                 </a:solidFill>
@@ -6551,9 +6581,9 @@
                 <a:ea typeface="Calibri" pitchFamily="34" charset="-122"/>
                 <a:cs typeface="Calibri" pitchFamily="34" charset="-120"/>
               </a:rPr>
-              <a:t>RM0.74</a:t>
+              <a:t>RM0.64</a:t>
             </a:r>
-            <a:endParaRPr lang="en-US" sz="1300" dirty="0"/>
+            <a:endParaRPr lang="en-US" sz="1250" dirty="0"/>
           </a:p>
         </p:txBody>
       </p:sp>
@@ -6565,12 +6595,12 @@
         </p:nvSpPr>
         <p:spPr>
           <a:xfrm>
-            <a:off x="4572000" y="2468880"/>
-            <a:ext cx="3383280" cy="2788920"/>
+            <a:off x="3392424" y="2468880"/>
+            <a:ext cx="2651760" cy="2788920"/>
           </a:xfrm>
           <a:prstGeom prst="roundRect">
             <a:avLst>
-              <a:gd name="adj" fmla="val 3934"/>
+              <a:gd name="adj" fmla="val 4138"/>
             </a:avLst>
           </a:prstGeom>
           <a:solidFill>
@@ -6599,8 +6629,8 @@
         </p:nvSpPr>
         <p:spPr>
           <a:xfrm>
-            <a:off x="4828032" y="2697480"/>
-            <a:ext cx="2926080" cy="457200"/>
+            <a:off x="3611880" y="2697480"/>
+            <a:ext cx="2249424" cy="457200"/>
           </a:xfrm>
           <a:prstGeom prst="rect">
             <a:avLst/>
@@ -6616,7 +6646,7 @@
               <a:buNone/>
             </a:pPr>
             <a:r>
-              <a:rPr lang="en-US" sz="1550" b="1" dirty="0">
+              <a:rPr lang="en-US" sz="1500" b="1" dirty="0">
                 <a:solidFill>
                   <a:srgbClr val="12132A"/>
                 </a:solidFill>
@@ -6624,9 +6654,9 @@
                 <a:ea typeface="Calibri" pitchFamily="34" charset="-122"/>
                 <a:cs typeface="Calibri" pitchFamily="34" charset="-120"/>
               </a:rPr>
-              <a:t>AI Rank / Insight / Q</a:t>
+              <a:t>AI Rank</a:t>
             </a:r>
-            <a:endParaRPr lang="en-US" sz="1550" dirty="0"/>
+            <a:endParaRPr lang="en-US" sz="1500" dirty="0"/>
           </a:p>
         </p:txBody>
       </p:sp>
@@ -6638,8 +6668,8 @@
         </p:nvSpPr>
         <p:spPr>
           <a:xfrm>
-            <a:off x="4828032" y="3200400"/>
-            <a:ext cx="2871216" cy="777240"/>
+            <a:off x="3611880" y="3218688"/>
+            <a:ext cx="2212848" cy="731520"/>
           </a:xfrm>
           <a:prstGeom prst="rect">
             <a:avLst/>
@@ -6655,7 +6685,7 @@
               <a:buNone/>
             </a:pPr>
             <a:r>
-              <a:rPr lang="en-US" sz="4600" b="1" dirty="0">
+              <a:rPr lang="en-US" sz="4000" b="1" dirty="0">
                 <a:solidFill>
                   <a:srgbClr val="16A34A"/>
                 </a:solidFill>
@@ -6663,9 +6693,9 @@
                 <a:ea typeface="Calibri" pitchFamily="34" charset="-122"/>
                 <a:cs typeface="Calibri" pitchFamily="34" charset="-120"/>
               </a:rPr>
-              <a:t>72%</a:t>
+              <a:t>75%</a:t>
             </a:r>
-            <a:endParaRPr lang="en-US" sz="4600" dirty="0"/>
+            <a:endParaRPr lang="en-US" sz="4000" dirty="0"/>
           </a:p>
         </p:txBody>
       </p:sp>
@@ -6677,8 +6707,8 @@
         </p:nvSpPr>
         <p:spPr>
           <a:xfrm>
-            <a:off x="4828032" y="4005072"/>
-            <a:ext cx="2871216" cy="274320"/>
+            <a:off x="3611880" y="3986784"/>
+            <a:ext cx="2212848" cy="274320"/>
           </a:xfrm>
           <a:prstGeom prst="rect">
             <a:avLst/>
@@ -6694,7 +6724,7 @@
               <a:buNone/>
             </a:pPr>
             <a:r>
-              <a:rPr lang="en-US" sz="1100" dirty="0">
+              <a:rPr lang="en-US" sz="1050" dirty="0">
                 <a:solidFill>
                   <a:srgbClr val="6B7280"/>
                 </a:solidFill>
@@ -6704,7 +6734,7 @@
               </a:rPr>
               <a:t>gross margin at list</a:t>
             </a:r>
-            <a:endParaRPr lang="en-US" sz="1100" dirty="0"/>
+            <a:endParaRPr lang="en-US" sz="1050" dirty="0"/>
           </a:p>
         </p:txBody>
       </p:sp>
@@ -6716,8 +6746,8 @@
         </p:nvSpPr>
         <p:spPr>
           <a:xfrm>
-            <a:off x="4828032" y="4370832"/>
-            <a:ext cx="2871216" cy="0"/>
+            <a:off x="3611880" y="4352544"/>
+            <a:ext cx="2212848" cy="0"/>
           </a:xfrm>
           <a:prstGeom prst="line">
             <a:avLst/>
@@ -6739,8 +6769,8 @@
         </p:nvSpPr>
         <p:spPr>
           <a:xfrm>
-            <a:off x="4828032" y="4480560"/>
-            <a:ext cx="2926080" cy="457200"/>
+            <a:off x="3611880" y="4462272"/>
+            <a:ext cx="2249424" cy="640080"/>
           </a:xfrm>
           <a:prstGeom prst="rect">
             <a:avLst/>
@@ -6749,14 +6779,17 @@
           <a:ln/>
         </p:spPr>
         <p:txBody>
-          <a:bodyPr wrap="square" lIns="0" tIns="0" rIns="0" bIns="0" rtlCol="0" anchor="ctr"/>
+          <a:bodyPr wrap="square" lIns="0" tIns="0" rIns="0" bIns="0" rtlCol="0" anchor="t"/>
           <a:lstStyle/>
           <a:p>
             <a:pPr algn="l" indent="0" marL="0">
+              <a:lnSpc>
+                <a:spcPct val="110000"/>
+              </a:lnSpc>
               <a:buNone/>
             </a:pPr>
             <a:r>
-              <a:rPr lang="en-US" sz="1300" dirty="0">
+              <a:rPr lang="en-US" sz="1250" dirty="0">
                 <a:solidFill>
                   <a:srgbClr val="4A5568"/>
                 </a:solidFill>
@@ -6767,10 +6800,13 @@
               <a:t>Price </a:t>
             </a:r>
             <a:pPr algn="l" indent="0" marL="0">
+              <a:lnSpc>
+                <a:spcPct val="110000"/>
+              </a:lnSpc>
               <a:buNone/>
             </a:pPr>
             <a:r>
-              <a:rPr lang="en-US" sz="1300" b="1" dirty="0">
+              <a:rPr lang="en-US" sz="1250" b="1" dirty="0">
                 <a:solidFill>
                   <a:srgbClr val="12132A"/>
                 </a:solidFill>
@@ -6778,13 +6814,34 @@
                 <a:ea typeface="Calibri" pitchFamily="34" charset="-122"/>
                 <a:cs typeface="Calibri" pitchFamily="34" charset="-120"/>
               </a:rPr>
-              <a:t>RM1.64   </a:t>
+              <a:t>RM2.45</a:t>
             </a:r>
             <a:pPr algn="l" indent="0" marL="0">
+              <a:lnSpc>
+                <a:spcPct val="110000"/>
+              </a:lnSpc>
               <a:buNone/>
             </a:pPr>
             <a:r>
-              <a:rPr lang="en-US" sz="1300" dirty="0">
+              <a:rPr lang="en-US" sz="1250" dirty="0">
+                <a:solidFill>
+                  <a:srgbClr val="000000"/>
+                </a:solidFill>
+                <a:latin typeface="Calibri" pitchFamily="34" charset="0"/>
+                <a:ea typeface="Calibri" pitchFamily="34" charset="-122"/>
+                <a:cs typeface="Calibri" pitchFamily="34" charset="-120"/>
+              </a:rPr>
+              <a:t>
+</a:t>
+            </a:r>
+            <a:pPr algn="l" indent="0" marL="0">
+              <a:lnSpc>
+                <a:spcPct val="110000"/>
+              </a:lnSpc>
+              <a:buNone/>
+            </a:pPr>
+            <a:r>
+              <a:rPr lang="en-US" sz="1250" dirty="0">
                 <a:solidFill>
                   <a:srgbClr val="4A5568"/>
                 </a:solidFill>
@@ -6795,10 +6852,13 @@
               <a:t>Cost </a:t>
             </a:r>
             <a:pPr algn="l" indent="0" marL="0">
+              <a:lnSpc>
+                <a:spcPct val="110000"/>
+              </a:lnSpc>
               <a:buNone/>
             </a:pPr>
             <a:r>
-              <a:rPr lang="en-US" sz="1300" b="1" dirty="0">
+              <a:rPr lang="en-US" sz="1250" b="1" dirty="0">
                 <a:solidFill>
                   <a:srgbClr val="12132A"/>
                 </a:solidFill>
@@ -6806,9 +6866,9 @@
                 <a:ea typeface="Calibri" pitchFamily="34" charset="-122"/>
                 <a:cs typeface="Calibri" pitchFamily="34" charset="-120"/>
               </a:rPr>
-              <a:t>RM0.46</a:t>
+              <a:t>RM0.62</a:t>
             </a:r>
-            <a:endParaRPr lang="en-US" sz="1300" dirty="0"/>
+            <a:endParaRPr lang="en-US" sz="1250" dirty="0"/>
           </a:p>
         </p:txBody>
       </p:sp>
@@ -6820,12 +6880,12 @@
         </p:nvSpPr>
         <p:spPr>
           <a:xfrm>
-            <a:off x="8275320" y="2468880"/>
-            <a:ext cx="3383280" cy="2788920"/>
+            <a:off x="6236208" y="2468880"/>
+            <a:ext cx="2651760" cy="2788920"/>
           </a:xfrm>
           <a:prstGeom prst="roundRect">
             <a:avLst>
-              <a:gd name="adj" fmla="val 3934"/>
+              <a:gd name="adj" fmla="val 4138"/>
             </a:avLst>
           </a:prstGeom>
           <a:solidFill>
@@ -6854,8 +6914,8 @@
         </p:nvSpPr>
         <p:spPr>
           <a:xfrm>
-            <a:off x="8531352" y="2697480"/>
-            <a:ext cx="2926080" cy="457200"/>
+            <a:off x="6455664" y="2697480"/>
+            <a:ext cx="2249424" cy="457200"/>
           </a:xfrm>
           <a:prstGeom prst="rect">
             <a:avLst/>
@@ -6871,7 +6931,7 @@
               <a:buNone/>
             </a:pPr>
             <a:r>
-              <a:rPr lang="en-US" sz="1550" b="1" dirty="0">
+              <a:rPr lang="en-US" sz="1500" b="1" dirty="0">
                 <a:solidFill>
                   <a:srgbClr val="12132A"/>
                 </a:solidFill>
@@ -6879,9 +6939,9 @@
                 <a:ea typeface="Calibri" pitchFamily="34" charset="-122"/>
                 <a:cs typeface="Calibri" pitchFamily="34" charset="-120"/>
               </a:rPr>
-              <a:t>Job draft (Opus)</a:t>
+              <a:t>Interview Q</a:t>
             </a:r>
-            <a:endParaRPr lang="en-US" sz="1550" dirty="0"/>
+            <a:endParaRPr lang="en-US" sz="1500" dirty="0"/>
           </a:p>
         </p:txBody>
       </p:sp>
@@ -6893,8 +6953,8 @@
         </p:nvSpPr>
         <p:spPr>
           <a:xfrm>
-            <a:off x="8531352" y="3200400"/>
-            <a:ext cx="2871216" cy="777240"/>
+            <a:off x="6455664" y="3218688"/>
+            <a:ext cx="2212848" cy="731520"/>
           </a:xfrm>
           <a:prstGeom prst="rect">
             <a:avLst/>
@@ -6910,7 +6970,7 @@
               <a:buNone/>
             </a:pPr>
             <a:r>
-              <a:rPr lang="en-US" sz="4600" b="1" dirty="0">
+              <a:rPr lang="en-US" sz="4000" b="1" dirty="0">
                 <a:solidFill>
                   <a:srgbClr val="16A34A"/>
                 </a:solidFill>
@@ -6918,9 +6978,9 @@
                 <a:ea typeface="Calibri" pitchFamily="34" charset="-122"/>
                 <a:cs typeface="Calibri" pitchFamily="34" charset="-120"/>
               </a:rPr>
-              <a:t>81%</a:t>
+              <a:t>73%</a:t>
             </a:r>
-            <a:endParaRPr lang="en-US" sz="4600" dirty="0"/>
+            <a:endParaRPr lang="en-US" sz="4000" dirty="0"/>
           </a:p>
         </p:txBody>
       </p:sp>
@@ -6932,8 +6992,8 @@
         </p:nvSpPr>
         <p:spPr>
           <a:xfrm>
-            <a:off x="8531352" y="4005072"/>
-            <a:ext cx="2871216" cy="274320"/>
+            <a:off x="6455664" y="3986784"/>
+            <a:ext cx="2212848" cy="274320"/>
           </a:xfrm>
           <a:prstGeom prst="rect">
             <a:avLst/>
@@ -6949,7 +7009,7 @@
               <a:buNone/>
             </a:pPr>
             <a:r>
-              <a:rPr lang="en-US" sz="1100" dirty="0">
+              <a:rPr lang="en-US" sz="1050" dirty="0">
                 <a:solidFill>
                   <a:srgbClr val="6B7280"/>
                 </a:solidFill>
@@ -6959,7 +7019,7 @@
               </a:rPr>
               <a:t>gross margin at list</a:t>
             </a:r>
-            <a:endParaRPr lang="en-US" sz="1100" dirty="0"/>
+            <a:endParaRPr lang="en-US" sz="1050" dirty="0"/>
           </a:p>
         </p:txBody>
       </p:sp>
@@ -6971,8 +7031,8 @@
         </p:nvSpPr>
         <p:spPr>
           <a:xfrm>
-            <a:off x="8531352" y="4370832"/>
-            <a:ext cx="2871216" cy="0"/>
+            <a:off x="6455664" y="4352544"/>
+            <a:ext cx="2212848" cy="0"/>
           </a:xfrm>
           <a:prstGeom prst="line">
             <a:avLst/>
@@ -6994,8 +7054,153 @@
         </p:nvSpPr>
         <p:spPr>
           <a:xfrm>
-            <a:off x="8531352" y="4480560"/>
-            <a:ext cx="2926080" cy="457200"/>
+            <a:off x="6455664" y="4462272"/>
+            <a:ext cx="2249424" cy="640080"/>
+          </a:xfrm>
+          <a:prstGeom prst="rect">
+            <a:avLst/>
+          </a:prstGeom>
+          <a:noFill/>
+          <a:ln/>
+        </p:spPr>
+        <p:txBody>
+          <a:bodyPr wrap="square" lIns="0" tIns="0" rIns="0" bIns="0" rtlCol="0" anchor="t"/>
+          <a:lstStyle/>
+          <a:p>
+            <a:pPr algn="l" indent="0" marL="0">
+              <a:lnSpc>
+                <a:spcPct val="110000"/>
+              </a:lnSpc>
+              <a:buNone/>
+            </a:pPr>
+            <a:r>
+              <a:rPr lang="en-US" sz="1250" dirty="0">
+                <a:solidFill>
+                  <a:srgbClr val="4A5568"/>
+                </a:solidFill>
+                <a:latin typeface="Calibri" pitchFamily="34" charset="0"/>
+                <a:ea typeface="Calibri" pitchFamily="34" charset="-122"/>
+                <a:cs typeface="Calibri" pitchFamily="34" charset="-120"/>
+              </a:rPr>
+              <a:t>Price </a:t>
+            </a:r>
+            <a:pPr algn="l" indent="0" marL="0">
+              <a:lnSpc>
+                <a:spcPct val="110000"/>
+              </a:lnSpc>
+              <a:buNone/>
+            </a:pPr>
+            <a:r>
+              <a:rPr lang="en-US" sz="1250" b="1" dirty="0">
+                <a:solidFill>
+                  <a:srgbClr val="12132A"/>
+                </a:solidFill>
+                <a:latin typeface="Calibri" pitchFamily="34" charset="0"/>
+                <a:ea typeface="Calibri" pitchFamily="34" charset="-122"/>
+                <a:cs typeface="Calibri" pitchFamily="34" charset="-120"/>
+              </a:rPr>
+              <a:t>RM0.40</a:t>
+            </a:r>
+            <a:pPr algn="l" indent="0" marL="0">
+              <a:lnSpc>
+                <a:spcPct val="110000"/>
+              </a:lnSpc>
+              <a:buNone/>
+            </a:pPr>
+            <a:r>
+              <a:rPr lang="en-US" sz="1250" dirty="0">
+                <a:solidFill>
+                  <a:srgbClr val="000000"/>
+                </a:solidFill>
+                <a:latin typeface="Calibri" pitchFamily="34" charset="0"/>
+                <a:ea typeface="Calibri" pitchFamily="34" charset="-122"/>
+                <a:cs typeface="Calibri" pitchFamily="34" charset="-120"/>
+              </a:rPr>
+              <a:t>
+</a:t>
+            </a:r>
+            <a:pPr algn="l" indent="0" marL="0">
+              <a:lnSpc>
+                <a:spcPct val="110000"/>
+              </a:lnSpc>
+              <a:buNone/>
+            </a:pPr>
+            <a:r>
+              <a:rPr lang="en-US" sz="1250" dirty="0">
+                <a:solidFill>
+                  <a:srgbClr val="4A5568"/>
+                </a:solidFill>
+                <a:latin typeface="Calibri" pitchFamily="34" charset="0"/>
+                <a:ea typeface="Calibri" pitchFamily="34" charset="-122"/>
+                <a:cs typeface="Calibri" pitchFamily="34" charset="-120"/>
+              </a:rPr>
+              <a:t>Cost </a:t>
+            </a:r>
+            <a:pPr algn="l" indent="0" marL="0">
+              <a:lnSpc>
+                <a:spcPct val="110000"/>
+              </a:lnSpc>
+              <a:buNone/>
+            </a:pPr>
+            <a:r>
+              <a:rPr lang="en-US" sz="1250" b="1" dirty="0">
+                <a:solidFill>
+                  <a:srgbClr val="12132A"/>
+                </a:solidFill>
+                <a:latin typeface="Calibri" pitchFamily="34" charset="0"/>
+                <a:ea typeface="Calibri" pitchFamily="34" charset="-122"/>
+                <a:cs typeface="Calibri" pitchFamily="34" charset="-120"/>
+              </a:rPr>
+              <a:t>RM0.11</a:t>
+            </a:r>
+            <a:endParaRPr lang="en-US" sz="1250" dirty="0"/>
+          </a:p>
+        </p:txBody>
+      </p:sp>
+      <p:sp>
+        <p:nvSpPr>
+          <p:cNvPr id="23" name="Shape 21"/>
+          <p:cNvSpPr/>
+          <p:nvPr/>
+        </p:nvSpPr>
+        <p:spPr>
+          <a:xfrm>
+            <a:off x="9079992" y="2468880"/>
+            <a:ext cx="2651760" cy="2788920"/>
+          </a:xfrm>
+          <a:prstGeom prst="roundRect">
+            <a:avLst>
+              <a:gd name="adj" fmla="val 4138"/>
+            </a:avLst>
+          </a:prstGeom>
+          <a:solidFill>
+            <a:srgbClr val="FFFFFF"/>
+          </a:solidFill>
+          <a:ln w="12700">
+            <a:solidFill>
+              <a:srgbClr val="DEDEE3"/>
+            </a:solidFill>
+            <a:prstDash val="solid"/>
+          </a:ln>
+          <a:effectLst>
+            <a:outerShdw sx="100000" sy="100000" kx="0" ky="0" algn="bl" rotWithShape="0" blurRad="101600" dist="25400" dir="5400000">
+              <a:srgbClr val="9AA0B5">
+                <a:alpha val="18000"/>
+              </a:srgbClr>
+            </a:outerShdw>
+          </a:effectLst>
+        </p:spPr>
+      </p:sp>
+      <p:sp>
+        <p:nvSpPr>
+          <p:cNvPr id="24" name="Text 22"/>
+          <p:cNvSpPr/>
+          <p:nvPr/>
+        </p:nvSpPr>
+        <p:spPr>
+          <a:xfrm>
+            <a:off x="9299448" y="2697480"/>
+            <a:ext cx="2249424" cy="457200"/>
           </a:xfrm>
           <a:prstGeom prst="rect">
             <a:avLst/>
@@ -7011,7 +7216,150 @@
               <a:buNone/>
             </a:pPr>
             <a:r>
-              <a:rPr lang="en-US" sz="1300" dirty="0">
+              <a:rPr lang="en-US" sz="1500" b="1" dirty="0">
+                <a:solidFill>
+                  <a:srgbClr val="12132A"/>
+                </a:solidFill>
+                <a:latin typeface="Calibri" pitchFamily="34" charset="0"/>
+                <a:ea typeface="Calibri" pitchFamily="34" charset="-122"/>
+                <a:cs typeface="Calibri" pitchFamily="34" charset="-120"/>
+              </a:rPr>
+              <a:t>Job draft</a:t>
+            </a:r>
+            <a:endParaRPr lang="en-US" sz="1500" dirty="0"/>
+          </a:p>
+        </p:txBody>
+      </p:sp>
+      <p:sp>
+        <p:nvSpPr>
+          <p:cNvPr id="25" name="Text 23"/>
+          <p:cNvSpPr/>
+          <p:nvPr/>
+        </p:nvSpPr>
+        <p:spPr>
+          <a:xfrm>
+            <a:off x="9299448" y="3218688"/>
+            <a:ext cx="2212848" cy="731520"/>
+          </a:xfrm>
+          <a:prstGeom prst="rect">
+            <a:avLst/>
+          </a:prstGeom>
+          <a:noFill/>
+          <a:ln/>
+        </p:spPr>
+        <p:txBody>
+          <a:bodyPr wrap="square" lIns="0" tIns="0" rIns="0" bIns="0" rtlCol="0" anchor="ctr"/>
+          <a:lstStyle/>
+          <a:p>
+            <a:pPr algn="l" indent="0" marL="0">
+              <a:buNone/>
+            </a:pPr>
+            <a:r>
+              <a:rPr lang="en-US" sz="4000" b="1" dirty="0">
+                <a:solidFill>
+                  <a:srgbClr val="16A34A"/>
+                </a:solidFill>
+                <a:latin typeface="Calibri" pitchFamily="34" charset="0"/>
+                <a:ea typeface="Calibri" pitchFamily="34" charset="-122"/>
+                <a:cs typeface="Calibri" pitchFamily="34" charset="-120"/>
+              </a:rPr>
+              <a:t>69%</a:t>
+            </a:r>
+            <a:endParaRPr lang="en-US" sz="4000" dirty="0"/>
+          </a:p>
+        </p:txBody>
+      </p:sp>
+      <p:sp>
+        <p:nvSpPr>
+          <p:cNvPr id="26" name="Text 24"/>
+          <p:cNvSpPr/>
+          <p:nvPr/>
+        </p:nvSpPr>
+        <p:spPr>
+          <a:xfrm>
+            <a:off x="9299448" y="3986784"/>
+            <a:ext cx="2212848" cy="274320"/>
+          </a:xfrm>
+          <a:prstGeom prst="rect">
+            <a:avLst/>
+          </a:prstGeom>
+          <a:noFill/>
+          <a:ln/>
+        </p:spPr>
+        <p:txBody>
+          <a:bodyPr wrap="square" lIns="0" tIns="0" rIns="0" bIns="0" rtlCol="0" anchor="ctr"/>
+          <a:lstStyle/>
+          <a:p>
+            <a:pPr algn="l" indent="0" marL="0">
+              <a:buNone/>
+            </a:pPr>
+            <a:r>
+              <a:rPr lang="en-US" sz="1050" dirty="0">
+                <a:solidFill>
+                  <a:srgbClr val="6B7280"/>
+                </a:solidFill>
+                <a:latin typeface="Calibri" pitchFamily="34" charset="0"/>
+                <a:ea typeface="Calibri" pitchFamily="34" charset="-122"/>
+                <a:cs typeface="Calibri" pitchFamily="34" charset="-120"/>
+              </a:rPr>
+              <a:t>gross margin at list</a:t>
+            </a:r>
+            <a:endParaRPr lang="en-US" sz="1050" dirty="0"/>
+          </a:p>
+        </p:txBody>
+      </p:sp>
+      <p:sp>
+        <p:nvSpPr>
+          <p:cNvPr id="27" name="Shape 25"/>
+          <p:cNvSpPr/>
+          <p:nvPr/>
+        </p:nvSpPr>
+        <p:spPr>
+          <a:xfrm>
+            <a:off x="9299448" y="4352544"/>
+            <a:ext cx="2212848" cy="0"/>
+          </a:xfrm>
+          <a:prstGeom prst="line">
+            <a:avLst/>
+          </a:prstGeom>
+          <a:noFill/>
+          <a:ln w="12700">
+            <a:solidFill>
+              <a:srgbClr val="DEDEE3"/>
+            </a:solidFill>
+            <a:prstDash val="solid"/>
+          </a:ln>
+        </p:spPr>
+      </p:sp>
+      <p:sp>
+        <p:nvSpPr>
+          <p:cNvPr id="28" name="Text 26"/>
+          <p:cNvSpPr/>
+          <p:nvPr/>
+        </p:nvSpPr>
+        <p:spPr>
+          <a:xfrm>
+            <a:off x="9299448" y="4462272"/>
+            <a:ext cx="2249424" cy="640080"/>
+          </a:xfrm>
+          <a:prstGeom prst="rect">
+            <a:avLst/>
+          </a:prstGeom>
+          <a:noFill/>
+          <a:ln/>
+        </p:spPr>
+        <p:txBody>
+          <a:bodyPr wrap="square" lIns="0" tIns="0" rIns="0" bIns="0" rtlCol="0" anchor="t"/>
+          <a:lstStyle/>
+          <a:p>
+            <a:pPr algn="l" indent="0" marL="0">
+              <a:lnSpc>
+                <a:spcPct val="110000"/>
+              </a:lnSpc>
+              <a:buNone/>
+            </a:pPr>
+            <a:r>
+              <a:rPr lang="en-US" sz="1250" dirty="0">
                 <a:solidFill>
                   <a:srgbClr val="4A5568"/>
                 </a:solidFill>
@@ -7022,10 +7370,13 @@
               <a:t>Price </a:t>
             </a:r>
             <a:pPr algn="l" indent="0" marL="0">
+              <a:lnSpc>
+                <a:spcPct val="110000"/>
+              </a:lnSpc>
               <a:buNone/>
             </a:pPr>
             <a:r>
-              <a:rPr lang="en-US" sz="1300" b="1" dirty="0">
+              <a:rPr lang="en-US" sz="1250" b="1" dirty="0">
                 <a:solidFill>
                   <a:srgbClr val="12132A"/>
                 </a:solidFill>
@@ -7033,13 +7384,34 @@
                 <a:ea typeface="Calibri" pitchFamily="34" charset="-122"/>
                 <a:cs typeface="Calibri" pitchFamily="34" charset="-120"/>
               </a:rPr>
-              <a:t>RM2.05   </a:t>
+              <a:t>RM2.25</a:t>
             </a:r>
             <a:pPr algn="l" indent="0" marL="0">
+              <a:lnSpc>
+                <a:spcPct val="110000"/>
+              </a:lnSpc>
               <a:buNone/>
             </a:pPr>
             <a:r>
-              <a:rPr lang="en-US" sz="1300" dirty="0">
+              <a:rPr lang="en-US" sz="1250" dirty="0">
+                <a:solidFill>
+                  <a:srgbClr val="000000"/>
+                </a:solidFill>
+                <a:latin typeface="Calibri" pitchFamily="34" charset="0"/>
+                <a:ea typeface="Calibri" pitchFamily="34" charset="-122"/>
+                <a:cs typeface="Calibri" pitchFamily="34" charset="-120"/>
+              </a:rPr>
+              <a:t>
+</a:t>
+            </a:r>
+            <a:pPr algn="l" indent="0" marL="0">
+              <a:lnSpc>
+                <a:spcPct val="110000"/>
+              </a:lnSpc>
+              <a:buNone/>
+            </a:pPr>
+            <a:r>
+              <a:rPr lang="en-US" sz="1250" dirty="0">
                 <a:solidFill>
                   <a:srgbClr val="4A5568"/>
                 </a:solidFill>
@@ -7050,10 +7422,13 @@
               <a:t>Cost </a:t>
             </a:r>
             <a:pPr algn="l" indent="0" marL="0">
+              <a:lnSpc>
+                <a:spcPct val="110000"/>
+              </a:lnSpc>
               <a:buNone/>
             </a:pPr>
             <a:r>
-              <a:rPr lang="en-US" sz="1300" b="1" dirty="0">
+              <a:rPr lang="en-US" sz="1250" b="1" dirty="0">
                 <a:solidFill>
                   <a:srgbClr val="12132A"/>
                 </a:solidFill>
@@ -7061,15 +7436,15 @@
                 <a:ea typeface="Calibri" pitchFamily="34" charset="-122"/>
                 <a:cs typeface="Calibri" pitchFamily="34" charset="-120"/>
               </a:rPr>
-              <a:t>RM0.39</a:t>
+              <a:t>RM0.69</a:t>
             </a:r>
-            <a:endParaRPr lang="en-US" sz="1300" dirty="0"/>
+            <a:endParaRPr lang="en-US" sz="1250" dirty="0"/>
           </a:p>
         </p:txBody>
       </p:sp>
       <p:sp>
         <p:nvSpPr>
-          <p:cNvPr id="23" name="Text 21"/>
+          <p:cNvPr id="29" name="Text 27"/>
           <p:cNvSpPr/>
           <p:nvPr/>
         </p:nvSpPr>
@@ -7100,7 +7475,7 @@
                 <a:ea typeface="Calibri" pitchFamily="34" charset="-122"/>
                 <a:cs typeface="Calibri" pitchFamily="34" charset="-120"/>
               </a:rPr>
-              <a:t>Cost = AI inference + Stripe (3% + RM1 per top-up, min 20 credits) + 10% partner share. Even after all three, top-ups stay the highest-margin revenue at 70%+.</a:t>
+              <a:t>Cost = AI inference + Stripe (3% + RM1 per top-up) + 10% partner share, on each credit's minimum top-up. Even after all three, top-ups clear ~70% margin.</a:t>
             </a:r>
             <a:endParaRPr lang="en-US" sz="1100" dirty="0"/>
           </a:p>
@@ -7108,7 +7483,7 @@
       </p:sp>
       <p:sp>
         <p:nvSpPr>
-          <p:cNvPr id="24" name="Text 22"/>
+          <p:cNvPr id="30" name="Text 28"/>
           <p:cNvSpPr/>
           <p:nvPr/>
         </p:nvSpPr>
@@ -7147,7 +7522,7 @@
       </p:sp>
       <p:sp>
         <p:nvSpPr>
-          <p:cNvPr id="25" name="Text 23"/>
+          <p:cNvPr id="31" name="Text 29"/>
           <p:cNvSpPr/>
           <p:nvPr/>
         </p:nvSpPr>
@@ -11971,7 +12346,7 @@
                 <a:ea typeface="Calibri" pitchFamily="34" charset="-122"/>
                 <a:cs typeface="Calibri" pitchFamily="34" charset="-120"/>
               </a:rPr>
-              <a:t>70–97%</a:t>
+              <a:t>80–90%</a:t>
             </a:r>
             <a:endParaRPr lang="en-US" sz="3000" dirty="0"/>
           </a:p>
@@ -12147,7 +12522,7 @@
                 <a:ea typeface="Calibri" pitchFamily="34" charset="-122"/>
                 <a:cs typeface="Calibri" pitchFamily="34" charset="-120"/>
               </a:rPr>
-              <a:t>Each tier bundles enough screening and AI credits to run its open roles. The bundle is worth 4–5× the plan price at list credit rates, which anchors upgrades.</a:t>
+              <a:t>Each tier bundles enough screening and AI credits to run its open roles. The bundle is worth 2–3× the plan price at list credit rates, which anchors upgrades.</a:t>
             </a:r>
             <a:endParaRPr lang="en-US" sz="1250" dirty="0"/>
           </a:p>
@@ -12284,7 +12659,7 @@
                 <a:ea typeface="Calibri" pitchFamily="34" charset="-122"/>
                 <a:cs typeface="Calibri" pitchFamily="34" charset="-120"/>
               </a:rPr>
-              <a:t>Overage sells at RM4.09 / RM1.64 / RM2.05 per action against an AI cost of a few sen. This is where blended margin expands as accounts grow.</a:t>
+              <a:t>Overage sells at RM0.40–RM2.85 per action against a few sen of AI cost. This is where blended margin expands as accounts grow.</a:t>
             </a:r>
             <a:endParaRPr lang="en-US" sz="1250" dirty="0"/>
           </a:p>
@@ -20147,7 +20522,7 @@
                 <a:ea typeface="Calibri" pitchFamily="34" charset="-122"/>
                 <a:cs typeface="Calibri" pitchFamily="34" charset="-120"/>
               </a:rPr>
-              <a:t>The included AI is worth 4–5× the plan price</a:t>
+              <a:t>The included AI is worth 2–3× the plan price</a:t>
             </a:r>
             <a:endParaRPr lang="en-US" sz="3400" dirty="0"/>
           </a:p>
@@ -20298,7 +20673,7 @@
                 <a:ea typeface="Calibri" pitchFamily="34" charset="-122"/>
                 <a:cs typeface="Calibri" pitchFamily="34" charset="-120"/>
               </a:rPr>
-              <a:t>4.8×</a:t>
+              <a:t>3.3×</a:t>
             </a:r>
             <a:endParaRPr lang="en-US" sz="2400" dirty="0"/>
           </a:p>
@@ -20415,7 +20790,7 @@
                 <a:ea typeface="Calibri" pitchFamily="34" charset="-122"/>
                 <a:cs typeface="Calibri" pitchFamily="34" charset="-120"/>
               </a:rPr>
-              <a:t>RM474</a:t>
+              <a:t>RM328</a:t>
             </a:r>
             <a:endParaRPr lang="en-US" sz="2800" dirty="0"/>
           </a:p>
@@ -20628,7 +21003,7 @@
                 <a:ea typeface="Calibri" pitchFamily="34" charset="-122"/>
                 <a:cs typeface="Calibri" pitchFamily="34" charset="-120"/>
               </a:rPr>
-              <a:t>4.2×</a:t>
+              <a:t>2.8×</a:t>
             </a:r>
             <a:endParaRPr lang="en-US" sz="2400" dirty="0"/>
           </a:p>
@@ -20745,7 +21120,7 @@
                 <a:ea typeface="Calibri" pitchFamily="34" charset="-122"/>
                 <a:cs typeface="Calibri" pitchFamily="34" charset="-120"/>
               </a:rPr>
-              <a:t>RM2,511</a:t>
+              <a:t>RM1,653</a:t>
             </a:r>
             <a:endParaRPr lang="en-US" sz="2800" dirty="0"/>
           </a:p>
@@ -20958,7 +21333,7 @@
                 <a:ea typeface="Calibri" pitchFamily="34" charset="-122"/>
                 <a:cs typeface="Calibri" pitchFamily="34" charset="-120"/>
               </a:rPr>
-              <a:t>3.8×</a:t>
+              <a:t>2.4×</a:t>
             </a:r>
             <a:endParaRPr lang="en-US" sz="2400" dirty="0"/>
           </a:p>
@@ -21075,7 +21450,7 @@
                 <a:ea typeface="Calibri" pitchFamily="34" charset="-122"/>
                 <a:cs typeface="Calibri" pitchFamily="34" charset="-120"/>
               </a:rPr>
-              <a:t>RM5,317</a:t>
+              <a:t>RM3,420</a:t>
             </a:r>
             <a:endParaRPr lang="en-US" sz="2800" dirty="0"/>
           </a:p>
@@ -21215,7 +21590,7 @@
                 <a:ea typeface="Calibri" pitchFamily="34" charset="-122"/>
                 <a:cs typeface="Calibri" pitchFamily="34" charset="-120"/>
               </a:rPr>
-              <a:t>Included value = monthly allowance priced at list credit rates (RM4.09 screening · RM1.64 AI Rank / Insight / Questions).</a:t>
+              <a:t>Included value = monthly allowance priced at list credit rates (RM2.85 screening · RM2.45 AI Rank · RM0.40 questions). AI Insight allowance not valued here.</a:t>
             </a:r>
             <a:endParaRPr lang="en-US" sz="1050" dirty="0"/>
           </a:p>
@@ -21432,10 +21807,11 @@
             <a:tbl>
               <a:tblPr/>
               <a:tblGrid>
-                <a:gridCol w="3749040"/>
-                <a:gridCol w="2011680"/>
+                <a:gridCol w="3017520"/>
+                <a:gridCol w="1371600"/>
+                <a:gridCol w="1371600"/>
               </a:tblGrid>
-              <a:tr h="475488">
+              <a:tr h="512064">
                 <a:tc>
                   <a:txBody>
                     <a:bodyPr/>
@@ -21445,7 +21821,7 @@
                         <a:buNone/>
                       </a:pPr>
                       <a:r>
-                        <a:rPr lang="en-US" sz="1300" b="1" dirty="0">
+                        <a:rPr lang="en-US" sz="1250" b="1" dirty="0">
                           <a:solidFill>
                             <a:srgbClr val="FFFFFF"/>
                           </a:solidFill>
@@ -21455,7 +21831,7 @@
                         </a:rPr>
                         <a:t>Credit</a:t>
                       </a:r>
-                      <a:endParaRPr lang="en-US" sz="1300" dirty="0">
+                      <a:endParaRPr lang="en-US" sz="1250" dirty="0">
                         <a:latin typeface="Calibri" charset="0"/>
                         <a:ea typeface="Calibri" charset="0"/>
                         <a:cs typeface="Calibri" charset="0"/>
@@ -21513,7 +21889,7 @@
                         <a:buNone/>
                       </a:pPr>
                       <a:r>
-                        <a:rPr lang="en-US" sz="1300" b="1" dirty="0">
+                        <a:rPr lang="en-US" sz="1250" b="1" dirty="0">
                           <a:solidFill>
                             <a:srgbClr val="FFFFFF"/>
                           </a:solidFill>
@@ -21521,9 +21897,9 @@
                           <a:ea typeface="Calibri" pitchFamily="34" charset="-122"/>
                           <a:cs typeface="Calibri" pitchFamily="34" charset="-120"/>
                         </a:rPr>
-                        <a:t>List price (MYR)</a:t>
+                        <a:t>Price (MYR)</a:t>
                       </a:r>
-                      <a:endParaRPr lang="en-US" sz="1300" dirty="0">
+                      <a:endParaRPr lang="en-US" sz="1250" dirty="0">
                         <a:latin typeface="Calibri" charset="0"/>
                         <a:ea typeface="Calibri" charset="0"/>
                         <a:cs typeface="Calibri" charset="0"/>
@@ -21572,8 +21948,76 @@
                     </a:solidFill>
                   </a:tcPr>
                 </a:tc>
+                <a:tc>
+                  <a:txBody>
+                    <a:bodyPr/>
+                    <a:lstStyle/>
+                    <a:p>
+                      <a:pPr algn="ctr" indent="0" marL="0">
+                        <a:buNone/>
+                      </a:pPr>
+                      <a:r>
+                        <a:rPr lang="en-US" sz="1250" b="1" dirty="0">
+                          <a:solidFill>
+                            <a:srgbClr val="FFFFFF"/>
+                          </a:solidFill>
+                          <a:latin typeface="Calibri" pitchFamily="34" charset="0"/>
+                          <a:ea typeface="Calibri" pitchFamily="34" charset="-122"/>
+                          <a:cs typeface="Calibri" pitchFamily="34" charset="-120"/>
+                        </a:rPr>
+                        <a:t>Min top-up</a:t>
+                      </a:r>
+                      <a:endParaRPr lang="en-US" sz="1250" dirty="0">
+                        <a:latin typeface="Calibri" charset="0"/>
+                        <a:ea typeface="Calibri" charset="0"/>
+                        <a:cs typeface="Calibri" charset="0"/>
+                      </a:endParaRPr>
+                    </a:p>
+                  </a:txBody>
+                  <a:tcPr marL="101600" marR="101600" marT="25400" marB="25400" anchor="ctr">
+                    <a:lnL w="6350" cap="flat" cmpd="sng" algn="ctr">
+                      <a:solidFill>
+                        <a:srgbClr val="E6E8F0"/>
+                      </a:solidFill>
+                      <a:prstDash val="solid"/>
+                      <a:round/>
+                      <a:headEnd type="none" w="med" len="med"/>
+                      <a:tailEnd type="none" w="med" len="med"/>
+                    </a:lnL>
+                    <a:lnR w="6350" cap="flat" cmpd="sng" algn="ctr">
+                      <a:solidFill>
+                        <a:srgbClr val="E6E8F0"/>
+                      </a:solidFill>
+                      <a:prstDash val="solid"/>
+                      <a:round/>
+                      <a:headEnd type="none" w="med" len="med"/>
+                      <a:tailEnd type="none" w="med" len="med"/>
+                    </a:lnR>
+                    <a:lnT w="6350" cap="flat" cmpd="sng" algn="ctr">
+                      <a:solidFill>
+                        <a:srgbClr val="E6E8F0"/>
+                      </a:solidFill>
+                      <a:prstDash val="solid"/>
+                      <a:round/>
+                      <a:headEnd type="none" w="med" len="med"/>
+                      <a:tailEnd type="none" w="med" len="med"/>
+                    </a:lnT>
+                    <a:lnB w="6350" cap="flat" cmpd="sng" algn="ctr">
+                      <a:solidFill>
+                        <a:srgbClr val="E6E8F0"/>
+                      </a:solidFill>
+                      <a:prstDash val="solid"/>
+                      <a:round/>
+                      <a:headEnd type="none" w="med" len="med"/>
+                      <a:tailEnd type="none" w="med" len="med"/>
+                    </a:lnB>
+                    <a:solidFill>
+                      <a:srgbClr val="0A1FC2"/>
+                    </a:solidFill>
+                  </a:tcPr>
+                </a:tc>
               </a:tr>
-              <a:tr h="475488">
+              <a:tr h="512064">
                 <a:tc>
                   <a:txBody>
                     <a:bodyPr/>
@@ -21583,7 +22027,7 @@
                         <a:buNone/>
                       </a:pPr>
                       <a:r>
-                        <a:rPr lang="en-US" sz="1300" dirty="0">
+                        <a:rPr lang="en-US" sz="1250" dirty="0">
                           <a:solidFill>
                             <a:srgbClr val="12132A"/>
                           </a:solidFill>
@@ -21593,7 +22037,7 @@
                         </a:rPr>
                         <a:t>Applicant / resume screening</a:t>
                       </a:r>
-                      <a:endParaRPr lang="en-US" sz="1300" dirty="0">
+                      <a:endParaRPr lang="en-US" sz="1250" dirty="0">
                         <a:latin typeface="Calibri" charset="0"/>
                         <a:ea typeface="Calibri" charset="0"/>
                         <a:cs typeface="Calibri" charset="0"/>
@@ -21651,7 +22095,7 @@
                         <a:buNone/>
                       </a:pPr>
                       <a:r>
-                        <a:rPr lang="en-US" sz="1300" b="1" dirty="0">
+                        <a:rPr lang="en-US" sz="1250" b="1" dirty="0">
                           <a:solidFill>
                             <a:srgbClr val="0B2AE0"/>
                           </a:solidFill>
@@ -21659,9 +22103,9 @@
                           <a:ea typeface="Calibri" pitchFamily="34" charset="-122"/>
                           <a:cs typeface="Calibri" pitchFamily="34" charset="-120"/>
                         </a:rPr>
-                        <a:t>RM4.09</a:t>
+                        <a:t>RM2.85</a:t>
                       </a:r>
-                      <a:endParaRPr lang="en-US" sz="1300" dirty="0">
+                      <a:endParaRPr lang="en-US" sz="1250" dirty="0">
                         <a:latin typeface="Calibri" charset="0"/>
                         <a:ea typeface="Calibri" charset="0"/>
                         <a:cs typeface="Calibri" charset="0"/>
@@ -21710,8 +22154,76 @@
                     </a:solidFill>
                   </a:tcPr>
                 </a:tc>
+                <a:tc>
+                  <a:txBody>
+                    <a:bodyPr/>
+                    <a:lstStyle/>
+                    <a:p>
+                      <a:pPr algn="ctr" indent="0" marL="0">
+                        <a:buNone/>
+                      </a:pPr>
+                      <a:r>
+                        <a:rPr lang="en-US" sz="1250" dirty="0">
+                          <a:solidFill>
+                            <a:srgbClr val="12132A"/>
+                          </a:solidFill>
+                          <a:latin typeface="Calibri" pitchFamily="34" charset="0"/>
+                          <a:ea typeface="Calibri" pitchFamily="34" charset="-122"/>
+                          <a:cs typeface="Calibri" pitchFamily="34" charset="-120"/>
+                        </a:rPr>
+                        <a:t>10</a:t>
+                      </a:r>
+                      <a:endParaRPr lang="en-US" sz="1250" dirty="0">
+                        <a:latin typeface="Calibri" charset="0"/>
+                        <a:ea typeface="Calibri" charset="0"/>
+                        <a:cs typeface="Calibri" charset="0"/>
+                      </a:endParaRPr>
+                    </a:p>
+                  </a:txBody>
+                  <a:tcPr marL="101600" marR="101600" marT="25400" marB="25400" anchor="ctr">
+                    <a:lnL w="6350" cap="flat" cmpd="sng" algn="ctr">
+                      <a:solidFill>
+                        <a:srgbClr val="E6E8F0"/>
+                      </a:solidFill>
+                      <a:prstDash val="solid"/>
+                      <a:round/>
+                      <a:headEnd type="none" w="med" len="med"/>
+                      <a:tailEnd type="none" w="med" len="med"/>
+                    </a:lnL>
+                    <a:lnR w="6350" cap="flat" cmpd="sng" algn="ctr">
+                      <a:solidFill>
+                        <a:srgbClr val="E6E8F0"/>
+                      </a:solidFill>
+                      <a:prstDash val="solid"/>
+                      <a:round/>
+                      <a:headEnd type="none" w="med" len="med"/>
+                      <a:tailEnd type="none" w="med" len="med"/>
+                    </a:lnR>
+                    <a:lnT w="6350" cap="flat" cmpd="sng" algn="ctr">
+                      <a:solidFill>
+                        <a:srgbClr val="E6E8F0"/>
+                      </a:solidFill>
+                      <a:prstDash val="solid"/>
+                      <a:round/>
+                      <a:headEnd type="none" w="med" len="med"/>
+                      <a:tailEnd type="none" w="med" len="med"/>
+                    </a:lnT>
+                    <a:lnB w="6350" cap="flat" cmpd="sng" algn="ctr">
+                      <a:solidFill>
+                        <a:srgbClr val="E6E8F0"/>
+                      </a:solidFill>
+                      <a:prstDash val="solid"/>
+                      <a:round/>
+                      <a:headEnd type="none" w="med" len="med"/>
+                      <a:tailEnd type="none" w="med" len="med"/>
+                    </a:lnB>
+                    <a:solidFill>
+                      <a:srgbClr val="FFFFFF"/>
+                    </a:solidFill>
+                  </a:tcPr>
+                </a:tc>
               </a:tr>
-              <a:tr h="475488">
+              <a:tr h="512064">
                 <a:tc>
                   <a:txBody>
                     <a:bodyPr/>
@@ -21721,7 +22233,7 @@
                         <a:buNone/>
                       </a:pPr>
                       <a:r>
-                        <a:rPr lang="en-US" sz="1300" dirty="0">
+                        <a:rPr lang="en-US" sz="1250" dirty="0">
                           <a:solidFill>
                             <a:srgbClr val="12132A"/>
                           </a:solidFill>
@@ -21731,7 +22243,7 @@
                         </a:rPr>
                         <a:t>AI Rank</a:t>
                       </a:r>
-                      <a:endParaRPr lang="en-US" sz="1300" dirty="0">
+                      <a:endParaRPr lang="en-US" sz="1250" dirty="0">
                         <a:latin typeface="Calibri" charset="0"/>
                         <a:ea typeface="Calibri" charset="0"/>
                         <a:cs typeface="Calibri" charset="0"/>
@@ -21789,7 +22301,7 @@
                         <a:buNone/>
                       </a:pPr>
                       <a:r>
-                        <a:rPr lang="en-US" sz="1300" b="1" dirty="0">
+                        <a:rPr lang="en-US" sz="1250" b="1" dirty="0">
                           <a:solidFill>
                             <a:srgbClr val="0B2AE0"/>
                           </a:solidFill>
@@ -21797,9 +22309,9 @@
                           <a:ea typeface="Calibri" pitchFamily="34" charset="-122"/>
                           <a:cs typeface="Calibri" pitchFamily="34" charset="-120"/>
                         </a:rPr>
-                        <a:t>RM1.64</a:t>
+                        <a:t>RM2.45</a:t>
                       </a:r>
-                      <a:endParaRPr lang="en-US" sz="1300" dirty="0">
+                      <a:endParaRPr lang="en-US" sz="1250" dirty="0">
                         <a:latin typeface="Calibri" charset="0"/>
                         <a:ea typeface="Calibri" charset="0"/>
                         <a:cs typeface="Calibri" charset="0"/>
@@ -21848,8 +22360,76 @@
                     </a:solidFill>
                   </a:tcPr>
                 </a:tc>
+                <a:tc>
+                  <a:txBody>
+                    <a:bodyPr/>
+                    <a:lstStyle/>
+                    <a:p>
+                      <a:pPr algn="ctr" indent="0" marL="0">
+                        <a:buNone/>
+                      </a:pPr>
+                      <a:r>
+                        <a:rPr lang="en-US" sz="1250" dirty="0">
+                          <a:solidFill>
+                            <a:srgbClr val="12132A"/>
+                          </a:solidFill>
+                          <a:latin typeface="Calibri" pitchFamily="34" charset="0"/>
+                          <a:ea typeface="Calibri" pitchFamily="34" charset="-122"/>
+                          <a:cs typeface="Calibri" pitchFamily="34" charset="-120"/>
+                        </a:rPr>
+                        <a:t>10</a:t>
+                      </a:r>
+                      <a:endParaRPr lang="en-US" sz="1250" dirty="0">
+                        <a:latin typeface="Calibri" charset="0"/>
+                        <a:ea typeface="Calibri" charset="0"/>
+                        <a:cs typeface="Calibri" charset="0"/>
+                      </a:endParaRPr>
+                    </a:p>
+                  </a:txBody>
+                  <a:tcPr marL="101600" marR="101600" marT="25400" marB="25400" anchor="ctr">
+                    <a:lnL w="6350" cap="flat" cmpd="sng" algn="ctr">
+                      <a:solidFill>
+                        <a:srgbClr val="E6E8F0"/>
+                      </a:solidFill>
+                      <a:prstDash val="solid"/>
+                      <a:round/>
+                      <a:headEnd type="none" w="med" len="med"/>
+                      <a:tailEnd type="none" w="med" len="med"/>
+                    </a:lnL>
+                    <a:lnR w="6350" cap="flat" cmpd="sng" algn="ctr">
+                      <a:solidFill>
+                        <a:srgbClr val="E6E8F0"/>
+                      </a:solidFill>
+                      <a:prstDash val="solid"/>
+                      <a:round/>
+                      <a:headEnd type="none" w="med" len="med"/>
+                      <a:tailEnd type="none" w="med" len="med"/>
+                    </a:lnR>
+                    <a:lnT w="6350" cap="flat" cmpd="sng" algn="ctr">
+                      <a:solidFill>
+                        <a:srgbClr val="E6E8F0"/>
+                      </a:solidFill>
+                      <a:prstDash val="solid"/>
+                      <a:round/>
+                      <a:headEnd type="none" w="med" len="med"/>
+                      <a:tailEnd type="none" w="med" len="med"/>
+                    </a:lnT>
+                    <a:lnB w="6350" cap="flat" cmpd="sng" algn="ctr">
+                      <a:solidFill>
+                        <a:srgbClr val="E6E8F0"/>
+                      </a:solidFill>
+                      <a:prstDash val="solid"/>
+                      <a:round/>
+                      <a:headEnd type="none" w="med" len="med"/>
+                      <a:tailEnd type="none" w="med" len="med"/>
+                    </a:lnB>
+                    <a:solidFill>
+                      <a:srgbClr val="F5F7FE"/>
+                    </a:solidFill>
+                  </a:tcPr>
+                </a:tc>
               </a:tr>
-              <a:tr h="475488">
+              <a:tr h="512064">
                 <a:tc>
                   <a:txBody>
                     <a:bodyPr/>
@@ -21859,7 +22439,7 @@
                         <a:buNone/>
                       </a:pPr>
                       <a:r>
-                        <a:rPr lang="en-US" sz="1300" dirty="0">
+                        <a:rPr lang="en-US" sz="1250" dirty="0">
                           <a:solidFill>
                             <a:srgbClr val="12132A"/>
                           </a:solidFill>
@@ -21867,9 +22447,9 @@
                           <a:ea typeface="Calibri" pitchFamily="34" charset="-122"/>
                           <a:cs typeface="Calibri" pitchFamily="34" charset="-120"/>
                         </a:rPr>
-                        <a:t>AI Insight</a:t>
+                        <a:t>Interview questions</a:t>
                       </a:r>
-                      <a:endParaRPr lang="en-US" sz="1300" dirty="0">
+                      <a:endParaRPr lang="en-US" sz="1250" dirty="0">
                         <a:latin typeface="Calibri" charset="0"/>
                         <a:ea typeface="Calibri" charset="0"/>
                         <a:cs typeface="Calibri" charset="0"/>
@@ -21927,7 +22507,7 @@
                         <a:buNone/>
                       </a:pPr>
                       <a:r>
-                        <a:rPr lang="en-US" sz="1300" b="1" dirty="0">
+                        <a:rPr lang="en-US" sz="1250" b="1" dirty="0">
                           <a:solidFill>
                             <a:srgbClr val="0B2AE0"/>
                           </a:solidFill>
@@ -21935,9 +22515,9 @@
                           <a:ea typeface="Calibri" pitchFamily="34" charset="-122"/>
                           <a:cs typeface="Calibri" pitchFamily="34" charset="-120"/>
                         </a:rPr>
-                        <a:t>RM1.64</a:t>
+                        <a:t>RM0.40</a:t>
                       </a:r>
-                      <a:endParaRPr lang="en-US" sz="1300" dirty="0">
+                      <a:endParaRPr lang="en-US" sz="1250" dirty="0">
                         <a:latin typeface="Calibri" charset="0"/>
                         <a:ea typeface="Calibri" charset="0"/>
                         <a:cs typeface="Calibri" charset="0"/>
@@ -21986,8 +22566,76 @@
                     </a:solidFill>
                   </a:tcPr>
                 </a:tc>
+                <a:tc>
+                  <a:txBody>
+                    <a:bodyPr/>
+                    <a:lstStyle/>
+                    <a:p>
+                      <a:pPr algn="ctr" indent="0" marL="0">
+                        <a:buNone/>
+                      </a:pPr>
+                      <a:r>
+                        <a:rPr lang="en-US" sz="1250" dirty="0">
+                          <a:solidFill>
+                            <a:srgbClr val="12132A"/>
+                          </a:solidFill>
+                          <a:latin typeface="Calibri" pitchFamily="34" charset="0"/>
+                          <a:ea typeface="Calibri" pitchFamily="34" charset="-122"/>
+                          <a:cs typeface="Calibri" pitchFamily="34" charset="-120"/>
+                        </a:rPr>
+                        <a:t>50</a:t>
+                      </a:r>
+                      <a:endParaRPr lang="en-US" sz="1250" dirty="0">
+                        <a:latin typeface="Calibri" charset="0"/>
+                        <a:ea typeface="Calibri" charset="0"/>
+                        <a:cs typeface="Calibri" charset="0"/>
+                      </a:endParaRPr>
+                    </a:p>
+                  </a:txBody>
+                  <a:tcPr marL="101600" marR="101600" marT="25400" marB="25400" anchor="ctr">
+                    <a:lnL w="6350" cap="flat" cmpd="sng" algn="ctr">
+                      <a:solidFill>
+                        <a:srgbClr val="E6E8F0"/>
+                      </a:solidFill>
+                      <a:prstDash val="solid"/>
+                      <a:round/>
+                      <a:headEnd type="none" w="med" len="med"/>
+                      <a:tailEnd type="none" w="med" len="med"/>
+                    </a:lnL>
+                    <a:lnR w="6350" cap="flat" cmpd="sng" algn="ctr">
+                      <a:solidFill>
+                        <a:srgbClr val="E6E8F0"/>
+                      </a:solidFill>
+                      <a:prstDash val="solid"/>
+                      <a:round/>
+                      <a:headEnd type="none" w="med" len="med"/>
+                      <a:tailEnd type="none" w="med" len="med"/>
+                    </a:lnR>
+                    <a:lnT w="6350" cap="flat" cmpd="sng" algn="ctr">
+                      <a:solidFill>
+                        <a:srgbClr val="E6E8F0"/>
+                      </a:solidFill>
+                      <a:prstDash val="solid"/>
+                      <a:round/>
+                      <a:headEnd type="none" w="med" len="med"/>
+                      <a:tailEnd type="none" w="med" len="med"/>
+                    </a:lnT>
+                    <a:lnB w="6350" cap="flat" cmpd="sng" algn="ctr">
+                      <a:solidFill>
+                        <a:srgbClr val="E6E8F0"/>
+                      </a:solidFill>
+                      <a:prstDash val="solid"/>
+                      <a:round/>
+                      <a:headEnd type="none" w="med" len="med"/>
+                      <a:tailEnd type="none" w="med" len="med"/>
+                    </a:lnB>
+                    <a:solidFill>
+                      <a:srgbClr val="FFFFFF"/>
+                    </a:solidFill>
+                  </a:tcPr>
+                </a:tc>
               </a:tr>
-              <a:tr h="475488">
+              <a:tr h="512064">
                 <a:tc>
                   <a:txBody>
                     <a:bodyPr/>
@@ -21997,7 +22645,7 @@
                         <a:buNone/>
                       </a:pPr>
                       <a:r>
-                        <a:rPr lang="en-US" sz="1300" dirty="0">
+                        <a:rPr lang="en-US" sz="1250" dirty="0">
                           <a:solidFill>
                             <a:srgbClr val="12132A"/>
                           </a:solidFill>
@@ -22005,9 +22653,9 @@
                           <a:ea typeface="Calibri" pitchFamily="34" charset="-122"/>
                           <a:cs typeface="Calibri" pitchFamily="34" charset="-120"/>
                         </a:rPr>
-                        <a:t>Interview questions</a:t>
+                        <a:t>Job draft (Opus)</a:t>
                       </a:r>
-                      <a:endParaRPr lang="en-US" sz="1300" dirty="0">
+                      <a:endParaRPr lang="en-US" sz="1250" dirty="0">
                         <a:latin typeface="Calibri" charset="0"/>
                         <a:ea typeface="Calibri" charset="0"/>
                         <a:cs typeface="Calibri" charset="0"/>
@@ -22065,7 +22713,7 @@
                         <a:buNone/>
                       </a:pPr>
                       <a:r>
-                        <a:rPr lang="en-US" sz="1300" b="1" dirty="0">
+                        <a:rPr lang="en-US" sz="1250" b="1" dirty="0">
                           <a:solidFill>
                             <a:srgbClr val="0B2AE0"/>
                           </a:solidFill>
@@ -22073,9 +22721,9 @@
                           <a:ea typeface="Calibri" pitchFamily="34" charset="-122"/>
                           <a:cs typeface="Calibri" pitchFamily="34" charset="-120"/>
                         </a:rPr>
-                        <a:t>RM1.64</a:t>
+                        <a:t>RM2.25</a:t>
                       </a:r>
-                      <a:endParaRPr lang="en-US" sz="1300" dirty="0">
+                      <a:endParaRPr lang="en-US" sz="1250" dirty="0">
                         <a:latin typeface="Calibri" charset="0"/>
                         <a:ea typeface="Calibri" charset="0"/>
                         <a:cs typeface="Calibri" charset="0"/>
@@ -22124,18 +22772,16 @@
                     </a:solidFill>
                   </a:tcPr>
                 </a:tc>
-              </a:tr>
-              <a:tr h="475488">
                 <a:tc>
                   <a:txBody>
                     <a:bodyPr/>
                     <a:lstStyle/>
                     <a:p>
-                      <a:pPr algn="l" indent="0" marL="0">
+                      <a:pPr algn="ctr" indent="0" marL="0">
                         <a:buNone/>
                       </a:pPr>
                       <a:r>
-                        <a:rPr lang="en-US" sz="1300" dirty="0">
+                        <a:rPr lang="en-US" sz="1250" dirty="0">
                           <a:solidFill>
                             <a:srgbClr val="12132A"/>
                           </a:solidFill>
@@ -22143,9 +22789,9 @@
                           <a:ea typeface="Calibri" pitchFamily="34" charset="-122"/>
                           <a:cs typeface="Calibri" pitchFamily="34" charset="-120"/>
                         </a:rPr>
-                        <a:t>Job draft (Opus)</a:t>
+                        <a:t>10</a:t>
                       </a:r>
-                      <a:endParaRPr lang="en-US" sz="1300" dirty="0">
+                      <a:endParaRPr lang="en-US" sz="1250" dirty="0">
                         <a:latin typeface="Calibri" charset="0"/>
                         <a:ea typeface="Calibri" charset="0"/>
                         <a:cs typeface="Calibri" charset="0"/>
@@ -22190,75 +22836,7 @@
                       <a:tailEnd type="none" w="med" len="med"/>
                     </a:lnB>
                     <a:solidFill>
-                      <a:srgbClr val="FFFFFF"/>
-                    </a:solidFill>
-                  </a:tcPr>
-                </a:tc>
-                <a:tc>
-                  <a:txBody>
-                    <a:bodyPr/>
-                    <a:lstStyle/>
-                    <a:p>
-                      <a:pPr algn="r" indent="0" marL="0">
-                        <a:buNone/>
-                      </a:pPr>
-                      <a:r>
-                        <a:rPr lang="en-US" sz="1300" b="1" dirty="0">
-                          <a:solidFill>
-                            <a:srgbClr val="0B2AE0"/>
-                          </a:solidFill>
-                          <a:latin typeface="Calibri" pitchFamily="34" charset="0"/>
-                          <a:ea typeface="Calibri" pitchFamily="34" charset="-122"/>
-                          <a:cs typeface="Calibri" pitchFamily="34" charset="-120"/>
-                        </a:rPr>
-                        <a:t>RM2.05</a:t>
-                      </a:r>
-                      <a:endParaRPr lang="en-US" sz="1300" dirty="0">
-                        <a:latin typeface="Calibri" charset="0"/>
-                        <a:ea typeface="Calibri" charset="0"/>
-                        <a:cs typeface="Calibri" charset="0"/>
-                      </a:endParaRPr>
-                    </a:p>
-                  </a:txBody>
-                  <a:tcPr marL="101600" marR="101600" marT="25400" marB="25400" anchor="ctr">
-                    <a:lnL w="6350" cap="flat" cmpd="sng" algn="ctr">
-                      <a:solidFill>
-                        <a:srgbClr val="E6E8F0"/>
-                      </a:solidFill>
-                      <a:prstDash val="solid"/>
-                      <a:round/>
-                      <a:headEnd type="none" w="med" len="med"/>
-                      <a:tailEnd type="none" w="med" len="med"/>
-                    </a:lnL>
-                    <a:lnR w="6350" cap="flat" cmpd="sng" algn="ctr">
-                      <a:solidFill>
-                        <a:srgbClr val="E6E8F0"/>
-                      </a:solidFill>
-                      <a:prstDash val="solid"/>
-                      <a:round/>
-                      <a:headEnd type="none" w="med" len="med"/>
-                      <a:tailEnd type="none" w="med" len="med"/>
-                    </a:lnR>
-                    <a:lnT w="6350" cap="flat" cmpd="sng" algn="ctr">
-                      <a:solidFill>
-                        <a:srgbClr val="E6E8F0"/>
-                      </a:solidFill>
-                      <a:prstDash val="solid"/>
-                      <a:round/>
-                      <a:headEnd type="none" w="med" len="med"/>
-                      <a:tailEnd type="none" w="med" len="med"/>
-                    </a:lnT>
-                    <a:lnB w="6350" cap="flat" cmpd="sng" algn="ctr">
-                      <a:solidFill>
-                        <a:srgbClr val="E6E8F0"/>
-                      </a:solidFill>
-                      <a:prstDash val="solid"/>
-                      <a:round/>
-                      <a:headEnd type="none" w="med" len="med"/>
-                      <a:tailEnd type="none" w="med" len="med"/>
-                    </a:lnB>
-                    <a:solidFill>
-                      <a:srgbClr val="FFFFFF"/>
+                      <a:srgbClr val="F5F7FE"/>
                     </a:solidFill>
                   </a:tcPr>
                 </a:tc>
@@ -22366,7 +22944,7 @@
                 <a:ea typeface="Calibri" pitchFamily="34" charset="-122"/>
                 <a:cs typeface="Calibri" pitchFamily="34" charset="-120"/>
               </a:rPr>
-              <a:t>price  =  base USD  ×  FX rate  ×  (1 − plan discount)</a:t>
+              <a:t>charged  =  list price  ×  (1 − plan discount)</a:t>
             </a:r>
             <a:endParaRPr lang="en-US" sz="1400" dirty="0"/>
           </a:p>
@@ -23019,7 +23597,7 @@
                 <a:ea typeface="Calibri" pitchFamily="34" charset="-122"/>
                 <a:cs typeface="Calibri" pitchFamily="34" charset="-120"/>
               </a:rPr>
-              <a:t>Top-ups are sold in a minimum of 20 credits, billed as one Stripe charge. That processing fee is folded into the credit margins on slide 11.</a:t>
+              <a:t>Minimum top-up per credit is shown above. Each top-up is one Stripe charge; that fee is folded into the credit margins on slide 11.</a:t>
             </a:r>
             <a:endParaRPr lang="en-US" sz="1000" dirty="0"/>
           </a:p>
@@ -23846,7 +24424,7 @@
                           <a:ea typeface="Calibri" pitchFamily="34" charset="-122"/>
                           <a:cs typeface="Calibri" pitchFamily="34" charset="-120"/>
                         </a:rPr>
-                        <a:t>RM4.09</a:t>
+                        <a:t>RM2.85</a:t>
                       </a:r>
                       <a:endParaRPr lang="en-US" sz="1250" dirty="0">
                         <a:latin typeface="Calibri" charset="0"/>
@@ -24050,7 +24628,7 @@
                           <a:ea typeface="Calibri" pitchFamily="34" charset="-122"/>
                           <a:cs typeface="Calibri" pitchFamily="34" charset="-120"/>
                         </a:rPr>
-                        <a:t>86%</a:t>
+                        <a:t>80%</a:t>
                       </a:r>
                       <a:endParaRPr lang="en-US" sz="1250" dirty="0">
                         <a:latin typeface="Calibri" charset="0"/>
@@ -24256,7 +24834,7 @@
                           <a:ea typeface="Calibri" pitchFamily="34" charset="-122"/>
                           <a:cs typeface="Calibri" pitchFamily="34" charset="-120"/>
                         </a:rPr>
-                        <a:t>RM1.64</a:t>
+                        <a:t>RM2.45</a:t>
                       </a:r>
                       <a:endParaRPr lang="en-US" sz="1250" dirty="0">
                         <a:latin typeface="Calibri" charset="0"/>
@@ -24460,7 +25038,7 @@
                           <a:ea typeface="Calibri" pitchFamily="34" charset="-122"/>
                           <a:cs typeface="Calibri" pitchFamily="34" charset="-120"/>
                         </a:rPr>
-                        <a:t>70%</a:t>
+                        <a:t>80%</a:t>
                       </a:r>
                       <a:endParaRPr lang="en-US" sz="1250" dirty="0">
                         <a:latin typeface="Calibri" charset="0"/>
@@ -24530,7 +25108,7 @@
                           <a:ea typeface="Calibri" pitchFamily="34" charset="-122"/>
                           <a:cs typeface="Calibri" pitchFamily="34" charset="-120"/>
                         </a:rPr>
-                        <a:t>AI Insight</a:t>
+                        <a:t>Interview questions</a:t>
                       </a:r>
                       <a:endParaRPr lang="en-US" sz="1250" dirty="0">
                         <a:latin typeface="Calibri" charset="0"/>
@@ -24666,7 +25244,7 @@
                           <a:ea typeface="Calibri" pitchFamily="34" charset="-122"/>
                           <a:cs typeface="Calibri" pitchFamily="34" charset="-120"/>
                         </a:rPr>
-                        <a:t>RM1.64</a:t>
+                        <a:t>RM0.40</a:t>
                       </a:r>
                       <a:endParaRPr lang="en-US" sz="1250" dirty="0">
                         <a:latin typeface="Calibri" charset="0"/>
@@ -24802,7 +25380,7 @@
                           <a:ea typeface="Calibri" pitchFamily="34" charset="-122"/>
                           <a:cs typeface="Calibri" pitchFamily="34" charset="-120"/>
                         </a:rPr>
-                        <a:t>~RM0.05</a:t>
+                        <a:t>~RM0.04</a:t>
                       </a:r>
                       <a:endParaRPr lang="en-US" sz="1250" dirty="0">
                         <a:latin typeface="Calibri" charset="0"/>
@@ -24870,7 +25448,7 @@
                           <a:ea typeface="Calibri" pitchFamily="34" charset="-122"/>
                           <a:cs typeface="Calibri" pitchFamily="34" charset="-120"/>
                         </a:rPr>
-                        <a:t>97%</a:t>
+                        <a:t>90%</a:t>
                       </a:r>
                       <a:endParaRPr lang="en-US" sz="1250" dirty="0">
                         <a:latin typeface="Calibri" charset="0"/>
@@ -24918,416 +25496,6 @@
                     </a:lnB>
                     <a:solidFill>
                       <a:srgbClr val="FFFFFF"/>
-                    </a:solidFill>
-                  </a:tcPr>
-                </a:tc>
-              </a:tr>
-              <a:tr h="457200">
-                <a:tc>
-                  <a:txBody>
-                    <a:bodyPr/>
-                    <a:lstStyle/>
-                    <a:p>
-                      <a:pPr algn="l" indent="0" marL="0">
-                        <a:buNone/>
-                      </a:pPr>
-                      <a:r>
-                        <a:rPr lang="en-US" sz="1250" b="1" dirty="0">
-                          <a:solidFill>
-                            <a:srgbClr val="12132A"/>
-                          </a:solidFill>
-                          <a:latin typeface="Calibri" pitchFamily="34" charset="0"/>
-                          <a:ea typeface="Calibri" pitchFamily="34" charset="-122"/>
-                          <a:cs typeface="Calibri" pitchFamily="34" charset="-120"/>
-                        </a:rPr>
-                        <a:t>Interview questions</a:t>
-                      </a:r>
-                      <a:endParaRPr lang="en-US" sz="1250" dirty="0">
-                        <a:latin typeface="Calibri" charset="0"/>
-                        <a:ea typeface="Calibri" charset="0"/>
-                        <a:cs typeface="Calibri" charset="0"/>
-                      </a:endParaRPr>
-                    </a:p>
-                  </a:txBody>
-                  <a:tcPr marL="76200" marR="76200" marT="25400" marB="25400" anchor="ctr">
-                    <a:lnL w="6350" cap="flat" cmpd="sng" algn="ctr">
-                      <a:solidFill>
-                        <a:srgbClr val="E6E8F0"/>
-                      </a:solidFill>
-                      <a:prstDash val="solid"/>
-                      <a:round/>
-                      <a:headEnd type="none" w="med" len="med"/>
-                      <a:tailEnd type="none" w="med" len="med"/>
-                    </a:lnL>
-                    <a:lnR w="6350" cap="flat" cmpd="sng" algn="ctr">
-                      <a:solidFill>
-                        <a:srgbClr val="E6E8F0"/>
-                      </a:solidFill>
-                      <a:prstDash val="solid"/>
-                      <a:round/>
-                      <a:headEnd type="none" w="med" len="med"/>
-                      <a:tailEnd type="none" w="med" len="med"/>
-                    </a:lnR>
-                    <a:lnT w="6350" cap="flat" cmpd="sng" algn="ctr">
-                      <a:solidFill>
-                        <a:srgbClr val="E6E8F0"/>
-                      </a:solidFill>
-                      <a:prstDash val="solid"/>
-                      <a:round/>
-                      <a:headEnd type="none" w="med" len="med"/>
-                      <a:tailEnd type="none" w="med" len="med"/>
-                    </a:lnT>
-                    <a:lnB w="6350" cap="flat" cmpd="sng" algn="ctr">
-                      <a:solidFill>
-                        <a:srgbClr val="E6E8F0"/>
-                      </a:solidFill>
-                      <a:prstDash val="solid"/>
-                      <a:round/>
-                      <a:headEnd type="none" w="med" len="med"/>
-                      <a:tailEnd type="none" w="med" len="med"/>
-                    </a:lnB>
-                    <a:solidFill>
-                      <a:srgbClr val="F5F7FE"/>
-                    </a:solidFill>
-                  </a:tcPr>
-                </a:tc>
-                <a:tc>
-                  <a:txBody>
-                    <a:bodyPr/>
-                    <a:lstStyle/>
-                    <a:p>
-                      <a:pPr algn="ctr" indent="0" marL="0">
-                        <a:buNone/>
-                      </a:pPr>
-                      <a:r>
-                        <a:rPr lang="en-US" sz="1250" dirty="0">
-                          <a:solidFill>
-                            <a:srgbClr val="4A5568"/>
-                          </a:solidFill>
-                          <a:latin typeface="Calibri" pitchFamily="34" charset="0"/>
-                          <a:ea typeface="Calibri" pitchFamily="34" charset="-122"/>
-                          <a:cs typeface="Calibri" pitchFamily="34" charset="-120"/>
-                        </a:rPr>
-                        <a:t>Haiku 4.5</a:t>
-                      </a:r>
-                      <a:endParaRPr lang="en-US" sz="1250" dirty="0">
-                        <a:latin typeface="Calibri" charset="0"/>
-                        <a:ea typeface="Calibri" charset="0"/>
-                        <a:cs typeface="Calibri" charset="0"/>
-                      </a:endParaRPr>
-                    </a:p>
-                  </a:txBody>
-                  <a:tcPr marL="76200" marR="76200" marT="25400" marB="25400" anchor="ctr">
-                    <a:lnL w="6350" cap="flat" cmpd="sng" algn="ctr">
-                      <a:solidFill>
-                        <a:srgbClr val="E6E8F0"/>
-                      </a:solidFill>
-                      <a:prstDash val="solid"/>
-                      <a:round/>
-                      <a:headEnd type="none" w="med" len="med"/>
-                      <a:tailEnd type="none" w="med" len="med"/>
-                    </a:lnL>
-                    <a:lnR w="6350" cap="flat" cmpd="sng" algn="ctr">
-                      <a:solidFill>
-                        <a:srgbClr val="E6E8F0"/>
-                      </a:solidFill>
-                      <a:prstDash val="solid"/>
-                      <a:round/>
-                      <a:headEnd type="none" w="med" len="med"/>
-                      <a:tailEnd type="none" w="med" len="med"/>
-                    </a:lnR>
-                    <a:lnT w="6350" cap="flat" cmpd="sng" algn="ctr">
-                      <a:solidFill>
-                        <a:srgbClr val="E6E8F0"/>
-                      </a:solidFill>
-                      <a:prstDash val="solid"/>
-                      <a:round/>
-                      <a:headEnd type="none" w="med" len="med"/>
-                      <a:tailEnd type="none" w="med" len="med"/>
-                    </a:lnT>
-                    <a:lnB w="6350" cap="flat" cmpd="sng" algn="ctr">
-                      <a:solidFill>
-                        <a:srgbClr val="E6E8F0"/>
-                      </a:solidFill>
-                      <a:prstDash val="solid"/>
-                      <a:round/>
-                      <a:headEnd type="none" w="med" len="med"/>
-                      <a:tailEnd type="none" w="med" len="med"/>
-                    </a:lnB>
-                    <a:solidFill>
-                      <a:srgbClr val="F5F7FE"/>
-                    </a:solidFill>
-                  </a:tcPr>
-                </a:tc>
-                <a:tc>
-                  <a:txBody>
-                    <a:bodyPr/>
-                    <a:lstStyle/>
-                    <a:p>
-                      <a:pPr algn="r" indent="0" marL="0">
-                        <a:buNone/>
-                      </a:pPr>
-                      <a:r>
-                        <a:rPr lang="en-US" sz="1250" dirty="0">
-                          <a:solidFill>
-                            <a:srgbClr val="4A5568"/>
-                          </a:solidFill>
-                          <a:latin typeface="Calibri" pitchFamily="34" charset="0"/>
-                          <a:ea typeface="Calibri" pitchFamily="34" charset="-122"/>
-                          <a:cs typeface="Calibri" pitchFamily="34" charset="-120"/>
-                        </a:rPr>
-                        <a:t>RM1.64</a:t>
-                      </a:r>
-                      <a:endParaRPr lang="en-US" sz="1250" dirty="0">
-                        <a:latin typeface="Calibri" charset="0"/>
-                        <a:ea typeface="Calibri" charset="0"/>
-                        <a:cs typeface="Calibri" charset="0"/>
-                      </a:endParaRPr>
-                    </a:p>
-                  </a:txBody>
-                  <a:tcPr marL="76200" marR="76200" marT="25400" marB="25400" anchor="ctr">
-                    <a:lnL w="6350" cap="flat" cmpd="sng" algn="ctr">
-                      <a:solidFill>
-                        <a:srgbClr val="E6E8F0"/>
-                      </a:solidFill>
-                      <a:prstDash val="solid"/>
-                      <a:round/>
-                      <a:headEnd type="none" w="med" len="med"/>
-                      <a:tailEnd type="none" w="med" len="med"/>
-                    </a:lnL>
-                    <a:lnR w="6350" cap="flat" cmpd="sng" algn="ctr">
-                      <a:solidFill>
-                        <a:srgbClr val="E6E8F0"/>
-                      </a:solidFill>
-                      <a:prstDash val="solid"/>
-                      <a:round/>
-                      <a:headEnd type="none" w="med" len="med"/>
-                      <a:tailEnd type="none" w="med" len="med"/>
-                    </a:lnR>
-                    <a:lnT w="6350" cap="flat" cmpd="sng" algn="ctr">
-                      <a:solidFill>
-                        <a:srgbClr val="E6E8F0"/>
-                      </a:solidFill>
-                      <a:prstDash val="solid"/>
-                      <a:round/>
-                      <a:headEnd type="none" w="med" len="med"/>
-                      <a:tailEnd type="none" w="med" len="med"/>
-                    </a:lnT>
-                    <a:lnB w="6350" cap="flat" cmpd="sng" algn="ctr">
-                      <a:solidFill>
-                        <a:srgbClr val="E6E8F0"/>
-                      </a:solidFill>
-                      <a:prstDash val="solid"/>
-                      <a:round/>
-                      <a:headEnd type="none" w="med" len="med"/>
-                      <a:tailEnd type="none" w="med" len="med"/>
-                    </a:lnB>
-                    <a:solidFill>
-                      <a:srgbClr val="F5F7FE"/>
-                    </a:solidFill>
-                  </a:tcPr>
-                </a:tc>
-                <a:tc>
-                  <a:txBody>
-                    <a:bodyPr/>
-                    <a:lstStyle/>
-                    <a:p>
-                      <a:pPr algn="r" indent="0" marL="0">
-                        <a:buNone/>
-                      </a:pPr>
-                      <a:r>
-                        <a:rPr lang="en-US" sz="1250" dirty="0">
-                          <a:solidFill>
-                            <a:srgbClr val="4A5568"/>
-                          </a:solidFill>
-                          <a:latin typeface="Calibri" pitchFamily="34" charset="0"/>
-                          <a:ea typeface="Calibri" pitchFamily="34" charset="-122"/>
-                          <a:cs typeface="Calibri" pitchFamily="34" charset="-120"/>
-                        </a:rPr>
-                        <a:t>~RM0.04</a:t>
-                      </a:r>
-                      <a:endParaRPr lang="en-US" sz="1250" dirty="0">
-                        <a:latin typeface="Calibri" charset="0"/>
-                        <a:ea typeface="Calibri" charset="0"/>
-                        <a:cs typeface="Calibri" charset="0"/>
-                      </a:endParaRPr>
-                    </a:p>
-                  </a:txBody>
-                  <a:tcPr marL="76200" marR="76200" marT="25400" marB="25400" anchor="ctr">
-                    <a:lnL w="6350" cap="flat" cmpd="sng" algn="ctr">
-                      <a:solidFill>
-                        <a:srgbClr val="E6E8F0"/>
-                      </a:solidFill>
-                      <a:prstDash val="solid"/>
-                      <a:round/>
-                      <a:headEnd type="none" w="med" len="med"/>
-                      <a:tailEnd type="none" w="med" len="med"/>
-                    </a:lnL>
-                    <a:lnR w="6350" cap="flat" cmpd="sng" algn="ctr">
-                      <a:solidFill>
-                        <a:srgbClr val="E6E8F0"/>
-                      </a:solidFill>
-                      <a:prstDash val="solid"/>
-                      <a:round/>
-                      <a:headEnd type="none" w="med" len="med"/>
-                      <a:tailEnd type="none" w="med" len="med"/>
-                    </a:lnR>
-                    <a:lnT w="6350" cap="flat" cmpd="sng" algn="ctr">
-                      <a:solidFill>
-                        <a:srgbClr val="E6E8F0"/>
-                      </a:solidFill>
-                      <a:prstDash val="solid"/>
-                      <a:round/>
-                      <a:headEnd type="none" w="med" len="med"/>
-                      <a:tailEnd type="none" w="med" len="med"/>
-                    </a:lnT>
-                    <a:lnB w="6350" cap="flat" cmpd="sng" algn="ctr">
-                      <a:solidFill>
-                        <a:srgbClr val="E6E8F0"/>
-                      </a:solidFill>
-                      <a:prstDash val="solid"/>
-                      <a:round/>
-                      <a:headEnd type="none" w="med" len="med"/>
-                      <a:tailEnd type="none" w="med" len="med"/>
-                    </a:lnB>
-                    <a:solidFill>
-                      <a:srgbClr val="F5F7FE"/>
-                    </a:solidFill>
-                  </a:tcPr>
-                </a:tc>
-                <a:tc>
-                  <a:txBody>
-                    <a:bodyPr/>
-                    <a:lstStyle/>
-                    <a:p>
-                      <a:pPr algn="r" indent="0" marL="0">
-                        <a:buNone/>
-                      </a:pPr>
-                      <a:r>
-                        <a:rPr lang="en-US" sz="1250" dirty="0">
-                          <a:solidFill>
-                            <a:srgbClr val="4A5568"/>
-                          </a:solidFill>
-                          <a:latin typeface="Calibri" pitchFamily="34" charset="0"/>
-                          <a:ea typeface="Calibri" pitchFamily="34" charset="-122"/>
-                          <a:cs typeface="Calibri" pitchFamily="34" charset="-120"/>
-                        </a:rPr>
-                        <a:t>~RM0.04</a:t>
-                      </a:r>
-                      <a:endParaRPr lang="en-US" sz="1250" dirty="0">
-                        <a:latin typeface="Calibri" charset="0"/>
-                        <a:ea typeface="Calibri" charset="0"/>
-                        <a:cs typeface="Calibri" charset="0"/>
-                      </a:endParaRPr>
-                    </a:p>
-                  </a:txBody>
-                  <a:tcPr marL="76200" marR="76200" marT="25400" marB="25400" anchor="ctr">
-                    <a:lnL w="6350" cap="flat" cmpd="sng" algn="ctr">
-                      <a:solidFill>
-                        <a:srgbClr val="E6E8F0"/>
-                      </a:solidFill>
-                      <a:prstDash val="solid"/>
-                      <a:round/>
-                      <a:headEnd type="none" w="med" len="med"/>
-                      <a:tailEnd type="none" w="med" len="med"/>
-                    </a:lnL>
-                    <a:lnR w="6350" cap="flat" cmpd="sng" algn="ctr">
-                      <a:solidFill>
-                        <a:srgbClr val="E6E8F0"/>
-                      </a:solidFill>
-                      <a:prstDash val="solid"/>
-                      <a:round/>
-                      <a:headEnd type="none" w="med" len="med"/>
-                      <a:tailEnd type="none" w="med" len="med"/>
-                    </a:lnR>
-                    <a:lnT w="6350" cap="flat" cmpd="sng" algn="ctr">
-                      <a:solidFill>
-                        <a:srgbClr val="E6E8F0"/>
-                      </a:solidFill>
-                      <a:prstDash val="solid"/>
-                      <a:round/>
-                      <a:headEnd type="none" w="med" len="med"/>
-                      <a:tailEnd type="none" w="med" len="med"/>
-                    </a:lnT>
-                    <a:lnB w="6350" cap="flat" cmpd="sng" algn="ctr">
-                      <a:solidFill>
-                        <a:srgbClr val="E6E8F0"/>
-                      </a:solidFill>
-                      <a:prstDash val="solid"/>
-                      <a:round/>
-                      <a:headEnd type="none" w="med" len="med"/>
-                      <a:tailEnd type="none" w="med" len="med"/>
-                    </a:lnB>
-                    <a:solidFill>
-                      <a:srgbClr val="F5F7FE"/>
-                    </a:solidFill>
-                  </a:tcPr>
-                </a:tc>
-                <a:tc>
-                  <a:txBody>
-                    <a:bodyPr/>
-                    <a:lstStyle/>
-                    <a:p>
-                      <a:pPr algn="r" indent="0" marL="0">
-                        <a:buNone/>
-                      </a:pPr>
-                      <a:r>
-                        <a:rPr lang="en-US" sz="1250" b="1" dirty="0">
-                          <a:solidFill>
-                            <a:srgbClr val="16A34A"/>
-                          </a:solidFill>
-                          <a:latin typeface="Calibri" pitchFamily="34" charset="0"/>
-                          <a:ea typeface="Calibri" pitchFamily="34" charset="-122"/>
-                          <a:cs typeface="Calibri" pitchFamily="34" charset="-120"/>
-                        </a:rPr>
-                        <a:t>97%</a:t>
-                      </a:r>
-                      <a:endParaRPr lang="en-US" sz="1250" dirty="0">
-                        <a:latin typeface="Calibri" charset="0"/>
-                        <a:ea typeface="Calibri" charset="0"/>
-                        <a:cs typeface="Calibri" charset="0"/>
-                      </a:endParaRPr>
-                    </a:p>
-                  </a:txBody>
-                  <a:tcPr marL="76200" marR="76200" marT="25400" marB="25400" anchor="ctr">
-                    <a:lnL w="6350" cap="flat" cmpd="sng" algn="ctr">
-                      <a:solidFill>
-                        <a:srgbClr val="E6E8F0"/>
-                      </a:solidFill>
-                      <a:prstDash val="solid"/>
-                      <a:round/>
-                      <a:headEnd type="none" w="med" len="med"/>
-                      <a:tailEnd type="none" w="med" len="med"/>
-                    </a:lnL>
-                    <a:lnR w="6350" cap="flat" cmpd="sng" algn="ctr">
-                      <a:solidFill>
-                        <a:srgbClr val="E6E8F0"/>
-                      </a:solidFill>
-                      <a:prstDash val="solid"/>
-                      <a:round/>
-                      <a:headEnd type="none" w="med" len="med"/>
-                      <a:tailEnd type="none" w="med" len="med"/>
-                    </a:lnR>
-                    <a:lnT w="6350" cap="flat" cmpd="sng" algn="ctr">
-                      <a:solidFill>
-                        <a:srgbClr val="E6E8F0"/>
-                      </a:solidFill>
-                      <a:prstDash val="solid"/>
-                      <a:round/>
-                      <a:headEnd type="none" w="med" len="med"/>
-                      <a:tailEnd type="none" w="med" len="med"/>
-                    </a:lnT>
-                    <a:lnB w="6350" cap="flat" cmpd="sng" algn="ctr">
-                      <a:solidFill>
-                        <a:srgbClr val="E6E8F0"/>
-                      </a:solidFill>
-                      <a:prstDash val="solid"/>
-                      <a:round/>
-                      <a:headEnd type="none" w="med" len="med"/>
-                      <a:tailEnd type="none" w="med" len="med"/>
-                    </a:lnB>
-                    <a:solidFill>
-                      <a:srgbClr val="F5F7FE"/>
                     </a:solidFill>
                   </a:tcPr>
                 </a:tc>
@@ -25397,7 +25565,7 @@
                       <a:tailEnd type="none" w="med" len="med"/>
                     </a:lnB>
                     <a:solidFill>
-                      <a:srgbClr val="FFFFFF"/>
+                      <a:srgbClr val="F5F7FE"/>
                     </a:solidFill>
                   </a:tcPr>
                 </a:tc>
@@ -25465,7 +25633,7 @@
                       <a:tailEnd type="none" w="med" len="med"/>
                     </a:lnB>
                     <a:solidFill>
-                      <a:srgbClr val="FFFFFF"/>
+                      <a:srgbClr val="F5F7FE"/>
                     </a:solidFill>
                   </a:tcPr>
                 </a:tc>
@@ -25486,7 +25654,7 @@
                           <a:ea typeface="Calibri" pitchFamily="34" charset="-122"/>
                           <a:cs typeface="Calibri" pitchFamily="34" charset="-120"/>
                         </a:rPr>
-                        <a:t>RM2.05</a:t>
+                        <a:t>RM2.25</a:t>
                       </a:r>
                       <a:endParaRPr lang="en-US" sz="1250" dirty="0">
                         <a:latin typeface="Calibri" charset="0"/>
@@ -25533,7 +25701,7 @@
                       <a:tailEnd type="none" w="med" len="med"/>
                     </a:lnB>
                     <a:solidFill>
-                      <a:srgbClr val="FFFFFF"/>
+                      <a:srgbClr val="F5F7FE"/>
                     </a:solidFill>
                   </a:tcPr>
                 </a:tc>
@@ -25601,7 +25769,7 @@
                       <a:tailEnd type="none" w="med" len="med"/>
                     </a:lnB>
                     <a:solidFill>
-                      <a:srgbClr val="FFFFFF"/>
+                      <a:srgbClr val="F5F7FE"/>
                     </a:solidFill>
                   </a:tcPr>
                 </a:tc>
@@ -25669,7 +25837,7 @@
                       <a:tailEnd type="none" w="med" len="med"/>
                     </a:lnB>
                     <a:solidFill>
-                      <a:srgbClr val="FFFFFF"/>
+                      <a:srgbClr val="F5F7FE"/>
                     </a:solidFill>
                   </a:tcPr>
                 </a:tc>
@@ -25690,7 +25858,7 @@
                           <a:ea typeface="Calibri" pitchFamily="34" charset="-122"/>
                           <a:cs typeface="Calibri" pitchFamily="34" charset="-120"/>
                         </a:rPr>
-                        <a:t>78%</a:t>
+                        <a:t>80%</a:t>
                       </a:r>
                       <a:endParaRPr lang="en-US" sz="1250" dirty="0">
                         <a:latin typeface="Calibri" charset="0"/>
@@ -25737,7 +25905,7 @@
                       <a:tailEnd type="none" w="med" len="med"/>
                     </a:lnB>
                     <a:solidFill>
-                      <a:srgbClr val="FFFFFF"/>
+                      <a:srgbClr val="F5F7FE"/>
                     </a:solidFill>
                   </a:tcPr>
                 </a:tc>
@@ -26016,7 +26184,7 @@
                 <a:ea typeface="Calibri" pitchFamily="34" charset="-122"/>
                 <a:cs typeface="Calibri" pitchFamily="34" charset="-120"/>
               </a:rPr>
-              <a:t>RM4.09</a:t>
+              <a:t>RM2.85</a:t>
             </a:r>
             <a:pPr algn="l" indent="0" marL="0">
               <a:lnSpc>
@@ -26050,7 +26218,7 @@
                 <a:ea typeface="Calibri" pitchFamily="34" charset="-122"/>
                 <a:cs typeface="Calibri" pitchFamily="34" charset="-120"/>
               </a:rPr>
-              <a:t>86% even in the worst case.</a:t>
+              <a:t>80% even in the worst case.</a:t>
             </a:r>
             <a:endParaRPr lang="en-US" sz="1250" dirty="0"/>
           </a:p>

</xml_diff>

<commit_message>
Sync credit pricing to migration 0175 (stored USD cents)
Matches the committed credit_prices seed: screening 69c/RM2.82,
AI Rank 60c/RM2.45, AI Insight 60c/RM2.45 (restored as a sellable
credit), interview questions 9c/RM0.37, job draft 55c/RM2.25; per-item
min_qty 10/10/10/50/10. Top-up margins (AI + Stripe, partner is
plan-only) 80-91%; partner-share notes clarified as subscription-only;
included-value multiples ~3x.

Co-Authored-By: Claude Opus 4.8 <noreply@anthropic.com>
Claude-Session: https://claude.ai/code/session_0176R35qPk2mhGFwXaB3Lv9s
</commit_message>
<xml_diff>
--- a/docs/aster-pricing.pptx
+++ b/docs/aster-pricing.pptx
@@ -6069,7 +6069,7 @@
                 <a:ea typeface="Calibri" pitchFamily="34" charset="-122"/>
                 <a:cs typeface="Calibri" pitchFamily="34" charset="-120"/>
               </a:rPr>
-              <a:t>Partner share = 10% of every sale. Assumes typical AI usage at the plan allowance and ~5 / 25 / 70 video interviews/mo; monthly card billing (annual lowers the Stripe fee). Platform share amortises toward zero with scale. Realistic usage runs lower, so margins run higher.</a:t>
+              <a:t>Partner share = 10% of each subscription sale (not credit top-ups). Assumes typical AI usage at the plan allowance and ~5 / 25 / 70 video interviews/mo; monthly card billing (annual lowers the Stripe fee). Platform share amortises toward zero with scale. Realistic usage runs lower, so margins run higher.</a:t>
             </a:r>
             <a:endParaRPr lang="en-US" sz="950" dirty="0"/>
           </a:p>
@@ -6271,7 +6271,7 @@
         </p:nvSpPr>
         <p:spPr>
           <a:xfrm>
-            <a:off x="548640" y="1554480"/>
+            <a:off x="548640" y="1508760"/>
             <a:ext cx="11064240" cy="640080"/>
           </a:xfrm>
           <a:prstGeom prst="rect">
@@ -6296,34 +6296,1710 @@
                 <a:ea typeface="Calibri" pitchFamily="34" charset="-122"/>
                 <a:cs typeface="Calibri" pitchFamily="34" charset="-120"/>
               </a:rPr>
-              <a:t>Once an account exhausts its allowance, every extra action sells at the list rate. Cost here includes AI inference, the one-time Stripe fee (on each credit's minimum top-up) and the 10% partner share. Growth accounts that buy top-ups lift blended margin.</a:t>
+              <a:t>Once an account exhausts its allowance, every extra action sells at the list rate against a few sen of AI plus one Stripe fee per top-up. The 10% partner share applies to plan sales only, not top-ups, so credits are the highest-margin revenue.</a:t>
             </a:r>
             <a:endParaRPr lang="en-US" sz="1400" dirty="0"/>
           </a:p>
         </p:txBody>
       </p:sp>
-      <p:sp>
-        <p:nvSpPr>
-          <p:cNvPr id="5" name="Shape 3"/>
+      <p:graphicFrame>
+        <p:nvGraphicFramePr>
+          <p:cNvPr id="12" name="Table 0"/>
+          <p:cNvGraphicFramePr>
+            <a:graphicFrameLocks noGrp="1"/>
+          </p:cNvGraphicFramePr>
+          <p:nvPr>
+            <p:extLst>
+              <p:ext uri="{D42A27DB-BD31-4B8C-83A1-F6EECF244321}">
+                <p14:modId xmlns:p14="http://schemas.microsoft.com/office/powerpoint/2010/main" val="1579011935"/>
+              </p:ext>
+            </p:extLst>
+          </p:nvPr>
+        </p:nvGraphicFramePr>
+        <p:xfrm>
+          <a:off x="548640" y="2286000"/>
+          <a:ext cx="7680960" cy="914400"/>
+        </p:xfrm>
+        <a:graphic>
+          <a:graphicData uri="http://schemas.openxmlformats.org/drawingml/2006/table">
+            <a:tbl>
+              <a:tblPr/>
+              <a:tblGrid>
+                <a:gridCol w="2743200"/>
+                <a:gridCol w="1371600"/>
+                <a:gridCol w="2194560"/>
+                <a:gridCol w="1371600"/>
+              </a:tblGrid>
+              <a:tr h="548640">
+                <a:tc>
+                  <a:txBody>
+                    <a:bodyPr/>
+                    <a:lstStyle/>
+                    <a:p>
+                      <a:pPr algn="l" indent="0" marL="0">
+                        <a:buNone/>
+                      </a:pPr>
+                      <a:r>
+                        <a:rPr lang="en-US" sz="1250" b="1" dirty="0">
+                          <a:solidFill>
+                            <a:srgbClr val="FFFFFF"/>
+                          </a:solidFill>
+                          <a:latin typeface="Calibri" pitchFamily="34" charset="0"/>
+                          <a:ea typeface="Calibri" pitchFamily="34" charset="-122"/>
+                          <a:cs typeface="Calibri" pitchFamily="34" charset="-120"/>
+                        </a:rPr>
+                        <a:t>Credit</a:t>
+                      </a:r>
+                      <a:endParaRPr lang="en-US" sz="1250" dirty="0">
+                        <a:latin typeface="Calibri" charset="0"/>
+                        <a:ea typeface="Calibri" charset="0"/>
+                        <a:cs typeface="Calibri" charset="0"/>
+                      </a:endParaRPr>
+                    </a:p>
+                  </a:txBody>
+                  <a:tcPr marL="101600" marR="101600" marT="25400" marB="25400" anchor="ctr">
+                    <a:lnL w="6350" cap="flat" cmpd="sng" algn="ctr">
+                      <a:solidFill>
+                        <a:srgbClr val="E6E8F0"/>
+                      </a:solidFill>
+                      <a:prstDash val="solid"/>
+                      <a:round/>
+                      <a:headEnd type="none" w="med" len="med"/>
+                      <a:tailEnd type="none" w="med" len="med"/>
+                    </a:lnL>
+                    <a:lnR w="6350" cap="flat" cmpd="sng" algn="ctr">
+                      <a:solidFill>
+                        <a:srgbClr val="E6E8F0"/>
+                      </a:solidFill>
+                      <a:prstDash val="solid"/>
+                      <a:round/>
+                      <a:headEnd type="none" w="med" len="med"/>
+                      <a:tailEnd type="none" w="med" len="med"/>
+                    </a:lnR>
+                    <a:lnT w="6350" cap="flat" cmpd="sng" algn="ctr">
+                      <a:solidFill>
+                        <a:srgbClr val="E6E8F0"/>
+                      </a:solidFill>
+                      <a:prstDash val="solid"/>
+                      <a:round/>
+                      <a:headEnd type="none" w="med" len="med"/>
+                      <a:tailEnd type="none" w="med" len="med"/>
+                    </a:lnT>
+                    <a:lnB w="6350" cap="flat" cmpd="sng" algn="ctr">
+                      <a:solidFill>
+                        <a:srgbClr val="E6E8F0"/>
+                      </a:solidFill>
+                      <a:prstDash val="solid"/>
+                      <a:round/>
+                      <a:headEnd type="none" w="med" len="med"/>
+                      <a:tailEnd type="none" w="med" len="med"/>
+                    </a:lnB>
+                    <a:solidFill>
+                      <a:srgbClr val="0A1FC2"/>
+                    </a:solidFill>
+                  </a:tcPr>
+                </a:tc>
+                <a:tc>
+                  <a:txBody>
+                    <a:bodyPr/>
+                    <a:lstStyle/>
+                    <a:p>
+                      <a:pPr algn="r" indent="0" marL="0">
+                        <a:buNone/>
+                      </a:pPr>
+                      <a:r>
+                        <a:rPr lang="en-US" sz="1250" b="1" dirty="0">
+                          <a:solidFill>
+                            <a:srgbClr val="FFFFFF"/>
+                          </a:solidFill>
+                          <a:latin typeface="Calibri" pitchFamily="34" charset="0"/>
+                          <a:ea typeface="Calibri" pitchFamily="34" charset="-122"/>
+                          <a:cs typeface="Calibri" pitchFamily="34" charset="-120"/>
+                        </a:rPr>
+                        <a:t>Price</a:t>
+                      </a:r>
+                      <a:endParaRPr lang="en-US" sz="1250" dirty="0">
+                        <a:latin typeface="Calibri" charset="0"/>
+                        <a:ea typeface="Calibri" charset="0"/>
+                        <a:cs typeface="Calibri" charset="0"/>
+                      </a:endParaRPr>
+                    </a:p>
+                  </a:txBody>
+                  <a:tcPr marL="101600" marR="101600" marT="25400" marB="25400" anchor="ctr">
+                    <a:lnL w="6350" cap="flat" cmpd="sng" algn="ctr">
+                      <a:solidFill>
+                        <a:srgbClr val="E6E8F0"/>
+                      </a:solidFill>
+                      <a:prstDash val="solid"/>
+                      <a:round/>
+                      <a:headEnd type="none" w="med" len="med"/>
+                      <a:tailEnd type="none" w="med" len="med"/>
+                    </a:lnL>
+                    <a:lnR w="6350" cap="flat" cmpd="sng" algn="ctr">
+                      <a:solidFill>
+                        <a:srgbClr val="E6E8F0"/>
+                      </a:solidFill>
+                      <a:prstDash val="solid"/>
+                      <a:round/>
+                      <a:headEnd type="none" w="med" len="med"/>
+                      <a:tailEnd type="none" w="med" len="med"/>
+                    </a:lnR>
+                    <a:lnT w="6350" cap="flat" cmpd="sng" algn="ctr">
+                      <a:solidFill>
+                        <a:srgbClr val="E6E8F0"/>
+                      </a:solidFill>
+                      <a:prstDash val="solid"/>
+                      <a:round/>
+                      <a:headEnd type="none" w="med" len="med"/>
+                      <a:tailEnd type="none" w="med" len="med"/>
+                    </a:lnT>
+                    <a:lnB w="6350" cap="flat" cmpd="sng" algn="ctr">
+                      <a:solidFill>
+                        <a:srgbClr val="E6E8F0"/>
+                      </a:solidFill>
+                      <a:prstDash val="solid"/>
+                      <a:round/>
+                      <a:headEnd type="none" w="med" len="med"/>
+                      <a:tailEnd type="none" w="med" len="med"/>
+                    </a:lnB>
+                    <a:solidFill>
+                      <a:srgbClr val="0A1FC2"/>
+                    </a:solidFill>
+                  </a:tcPr>
+                </a:tc>
+                <a:tc>
+                  <a:txBody>
+                    <a:bodyPr/>
+                    <a:lstStyle/>
+                    <a:p>
+                      <a:pPr algn="r" indent="0" marL="0">
+                        <a:buNone/>
+                      </a:pPr>
+                      <a:r>
+                        <a:rPr lang="en-US" sz="1250" b="1" dirty="0">
+                          <a:solidFill>
+                            <a:srgbClr val="FFFFFF"/>
+                          </a:solidFill>
+                          <a:latin typeface="Calibri" pitchFamily="34" charset="0"/>
+                          <a:ea typeface="Calibri" pitchFamily="34" charset="-122"/>
+                          <a:cs typeface="Calibri" pitchFamily="34" charset="-120"/>
+                        </a:rPr>
+                        <a:t>Cost (AI + Stripe)</a:t>
+                      </a:r>
+                      <a:endParaRPr lang="en-US" sz="1250" dirty="0">
+                        <a:latin typeface="Calibri" charset="0"/>
+                        <a:ea typeface="Calibri" charset="0"/>
+                        <a:cs typeface="Calibri" charset="0"/>
+                      </a:endParaRPr>
+                    </a:p>
+                  </a:txBody>
+                  <a:tcPr marL="101600" marR="101600" marT="25400" marB="25400" anchor="ctr">
+                    <a:lnL w="6350" cap="flat" cmpd="sng" algn="ctr">
+                      <a:solidFill>
+                        <a:srgbClr val="E6E8F0"/>
+                      </a:solidFill>
+                      <a:prstDash val="solid"/>
+                      <a:round/>
+                      <a:headEnd type="none" w="med" len="med"/>
+                      <a:tailEnd type="none" w="med" len="med"/>
+                    </a:lnL>
+                    <a:lnR w="6350" cap="flat" cmpd="sng" algn="ctr">
+                      <a:solidFill>
+                        <a:srgbClr val="E6E8F0"/>
+                      </a:solidFill>
+                      <a:prstDash val="solid"/>
+                      <a:round/>
+                      <a:headEnd type="none" w="med" len="med"/>
+                      <a:tailEnd type="none" w="med" len="med"/>
+                    </a:lnR>
+                    <a:lnT w="6350" cap="flat" cmpd="sng" algn="ctr">
+                      <a:solidFill>
+                        <a:srgbClr val="E6E8F0"/>
+                      </a:solidFill>
+                      <a:prstDash val="solid"/>
+                      <a:round/>
+                      <a:headEnd type="none" w="med" len="med"/>
+                      <a:tailEnd type="none" w="med" len="med"/>
+                    </a:lnT>
+                    <a:lnB w="6350" cap="flat" cmpd="sng" algn="ctr">
+                      <a:solidFill>
+                        <a:srgbClr val="E6E8F0"/>
+                      </a:solidFill>
+                      <a:prstDash val="solid"/>
+                      <a:round/>
+                      <a:headEnd type="none" w="med" len="med"/>
+                      <a:tailEnd type="none" w="med" len="med"/>
+                    </a:lnB>
+                    <a:solidFill>
+                      <a:srgbClr val="0A1FC2"/>
+                    </a:solidFill>
+                  </a:tcPr>
+                </a:tc>
+                <a:tc>
+                  <a:txBody>
+                    <a:bodyPr/>
+                    <a:lstStyle/>
+                    <a:p>
+                      <a:pPr algn="ctr" indent="0" marL="0">
+                        <a:buNone/>
+                      </a:pPr>
+                      <a:r>
+                        <a:rPr lang="en-US" sz="1250" b="1" dirty="0">
+                          <a:solidFill>
+                            <a:srgbClr val="FFFFFF"/>
+                          </a:solidFill>
+                          <a:latin typeface="Calibri" pitchFamily="34" charset="0"/>
+                          <a:ea typeface="Calibri" pitchFamily="34" charset="-122"/>
+                          <a:cs typeface="Calibri" pitchFamily="34" charset="-120"/>
+                        </a:rPr>
+                        <a:t>Gross margin</a:t>
+                      </a:r>
+                      <a:endParaRPr lang="en-US" sz="1250" dirty="0">
+                        <a:latin typeface="Calibri" charset="0"/>
+                        <a:ea typeface="Calibri" charset="0"/>
+                        <a:cs typeface="Calibri" charset="0"/>
+                      </a:endParaRPr>
+                    </a:p>
+                  </a:txBody>
+                  <a:tcPr marL="101600" marR="101600" marT="25400" marB="25400" anchor="ctr">
+                    <a:lnL w="6350" cap="flat" cmpd="sng" algn="ctr">
+                      <a:solidFill>
+                        <a:srgbClr val="E6E8F0"/>
+                      </a:solidFill>
+                      <a:prstDash val="solid"/>
+                      <a:round/>
+                      <a:headEnd type="none" w="med" len="med"/>
+                      <a:tailEnd type="none" w="med" len="med"/>
+                    </a:lnL>
+                    <a:lnR w="6350" cap="flat" cmpd="sng" algn="ctr">
+                      <a:solidFill>
+                        <a:srgbClr val="E6E8F0"/>
+                      </a:solidFill>
+                      <a:prstDash val="solid"/>
+                      <a:round/>
+                      <a:headEnd type="none" w="med" len="med"/>
+                      <a:tailEnd type="none" w="med" len="med"/>
+                    </a:lnR>
+                    <a:lnT w="6350" cap="flat" cmpd="sng" algn="ctr">
+                      <a:solidFill>
+                        <a:srgbClr val="E6E8F0"/>
+                      </a:solidFill>
+                      <a:prstDash val="solid"/>
+                      <a:round/>
+                      <a:headEnd type="none" w="med" len="med"/>
+                      <a:tailEnd type="none" w="med" len="med"/>
+                    </a:lnT>
+                    <a:lnB w="6350" cap="flat" cmpd="sng" algn="ctr">
+                      <a:solidFill>
+                        <a:srgbClr val="E6E8F0"/>
+                      </a:solidFill>
+                      <a:prstDash val="solid"/>
+                      <a:round/>
+                      <a:headEnd type="none" w="med" len="med"/>
+                      <a:tailEnd type="none" w="med" len="med"/>
+                    </a:lnB>
+                    <a:solidFill>
+                      <a:srgbClr val="0B2AE0"/>
+                    </a:solidFill>
+                  </a:tcPr>
+                </a:tc>
+              </a:tr>
+              <a:tr h="548640">
+                <a:tc>
+                  <a:txBody>
+                    <a:bodyPr/>
+                    <a:lstStyle/>
+                    <a:p>
+                      <a:pPr algn="l" indent="0" marL="0">
+                        <a:buNone/>
+                      </a:pPr>
+                      <a:r>
+                        <a:rPr lang="en-US" sz="1250" b="1" dirty="0">
+                          <a:solidFill>
+                            <a:srgbClr val="12132A"/>
+                          </a:solidFill>
+                          <a:latin typeface="Calibri" pitchFamily="34" charset="0"/>
+                          <a:ea typeface="Calibri" pitchFamily="34" charset="-122"/>
+                          <a:cs typeface="Calibri" pitchFamily="34" charset="-120"/>
+                        </a:rPr>
+                        <a:t>Resume / applicant screening</a:t>
+                      </a:r>
+                      <a:endParaRPr lang="en-US" sz="1250" dirty="0">
+                        <a:latin typeface="Calibri" charset="0"/>
+                        <a:ea typeface="Calibri" charset="0"/>
+                        <a:cs typeface="Calibri" charset="0"/>
+                      </a:endParaRPr>
+                    </a:p>
+                  </a:txBody>
+                  <a:tcPr marL="101600" marR="101600" marT="25400" marB="25400" anchor="ctr">
+                    <a:lnL w="6350" cap="flat" cmpd="sng" algn="ctr">
+                      <a:solidFill>
+                        <a:srgbClr val="E6E8F0"/>
+                      </a:solidFill>
+                      <a:prstDash val="solid"/>
+                      <a:round/>
+                      <a:headEnd type="none" w="med" len="med"/>
+                      <a:tailEnd type="none" w="med" len="med"/>
+                    </a:lnL>
+                    <a:lnR w="6350" cap="flat" cmpd="sng" algn="ctr">
+                      <a:solidFill>
+                        <a:srgbClr val="E6E8F0"/>
+                      </a:solidFill>
+                      <a:prstDash val="solid"/>
+                      <a:round/>
+                      <a:headEnd type="none" w="med" len="med"/>
+                      <a:tailEnd type="none" w="med" len="med"/>
+                    </a:lnR>
+                    <a:lnT w="6350" cap="flat" cmpd="sng" algn="ctr">
+                      <a:solidFill>
+                        <a:srgbClr val="E6E8F0"/>
+                      </a:solidFill>
+                      <a:prstDash val="solid"/>
+                      <a:round/>
+                      <a:headEnd type="none" w="med" len="med"/>
+                      <a:tailEnd type="none" w="med" len="med"/>
+                    </a:lnT>
+                    <a:lnB w="6350" cap="flat" cmpd="sng" algn="ctr">
+                      <a:solidFill>
+                        <a:srgbClr val="E6E8F0"/>
+                      </a:solidFill>
+                      <a:prstDash val="solid"/>
+                      <a:round/>
+                      <a:headEnd type="none" w="med" len="med"/>
+                      <a:tailEnd type="none" w="med" len="med"/>
+                    </a:lnB>
+                    <a:solidFill>
+                      <a:srgbClr val="FFFFFF"/>
+                    </a:solidFill>
+                  </a:tcPr>
+                </a:tc>
+                <a:tc>
+                  <a:txBody>
+                    <a:bodyPr/>
+                    <a:lstStyle/>
+                    <a:p>
+                      <a:pPr algn="r" indent="0" marL="0">
+                        <a:buNone/>
+                      </a:pPr>
+                      <a:r>
+                        <a:rPr lang="en-US" sz="1250" dirty="0">
+                          <a:solidFill>
+                            <a:srgbClr val="4A5568"/>
+                          </a:solidFill>
+                          <a:latin typeface="Calibri" pitchFamily="34" charset="0"/>
+                          <a:ea typeface="Calibri" pitchFamily="34" charset="-122"/>
+                          <a:cs typeface="Calibri" pitchFamily="34" charset="-120"/>
+                        </a:rPr>
+                        <a:t>RM2.82</a:t>
+                      </a:r>
+                      <a:endParaRPr lang="en-US" sz="1250" dirty="0">
+                        <a:latin typeface="Calibri" charset="0"/>
+                        <a:ea typeface="Calibri" charset="0"/>
+                        <a:cs typeface="Calibri" charset="0"/>
+                      </a:endParaRPr>
+                    </a:p>
+                  </a:txBody>
+                  <a:tcPr marL="101600" marR="101600" marT="25400" marB="25400" anchor="ctr">
+                    <a:lnL w="6350" cap="flat" cmpd="sng" algn="ctr">
+                      <a:solidFill>
+                        <a:srgbClr val="E6E8F0"/>
+                      </a:solidFill>
+                      <a:prstDash val="solid"/>
+                      <a:round/>
+                      <a:headEnd type="none" w="med" len="med"/>
+                      <a:tailEnd type="none" w="med" len="med"/>
+                    </a:lnL>
+                    <a:lnR w="6350" cap="flat" cmpd="sng" algn="ctr">
+                      <a:solidFill>
+                        <a:srgbClr val="E6E8F0"/>
+                      </a:solidFill>
+                      <a:prstDash val="solid"/>
+                      <a:round/>
+                      <a:headEnd type="none" w="med" len="med"/>
+                      <a:tailEnd type="none" w="med" len="med"/>
+                    </a:lnR>
+                    <a:lnT w="6350" cap="flat" cmpd="sng" algn="ctr">
+                      <a:solidFill>
+                        <a:srgbClr val="E6E8F0"/>
+                      </a:solidFill>
+                      <a:prstDash val="solid"/>
+                      <a:round/>
+                      <a:headEnd type="none" w="med" len="med"/>
+                      <a:tailEnd type="none" w="med" len="med"/>
+                    </a:lnT>
+                    <a:lnB w="6350" cap="flat" cmpd="sng" algn="ctr">
+                      <a:solidFill>
+                        <a:srgbClr val="E6E8F0"/>
+                      </a:solidFill>
+                      <a:prstDash val="solid"/>
+                      <a:round/>
+                      <a:headEnd type="none" w="med" len="med"/>
+                      <a:tailEnd type="none" w="med" len="med"/>
+                    </a:lnB>
+                    <a:solidFill>
+                      <a:srgbClr val="FFFFFF"/>
+                    </a:solidFill>
+                  </a:tcPr>
+                </a:tc>
+                <a:tc>
+                  <a:txBody>
+                    <a:bodyPr/>
+                    <a:lstStyle/>
+                    <a:p>
+                      <a:pPr algn="r" indent="0" marL="0">
+                        <a:buNone/>
+                      </a:pPr>
+                      <a:r>
+                        <a:rPr lang="en-US" sz="1250" dirty="0">
+                          <a:solidFill>
+                            <a:srgbClr val="4A5568"/>
+                          </a:solidFill>
+                          <a:latin typeface="Calibri" pitchFamily="34" charset="0"/>
+                          <a:ea typeface="Calibri" pitchFamily="34" charset="-122"/>
+                          <a:cs typeface="Calibri" pitchFamily="34" charset="-120"/>
+                        </a:rPr>
+                        <a:t>RM0.34</a:t>
+                      </a:r>
+                      <a:endParaRPr lang="en-US" sz="1250" dirty="0">
+                        <a:latin typeface="Calibri" charset="0"/>
+                        <a:ea typeface="Calibri" charset="0"/>
+                        <a:cs typeface="Calibri" charset="0"/>
+                      </a:endParaRPr>
+                    </a:p>
+                  </a:txBody>
+                  <a:tcPr marL="101600" marR="101600" marT="25400" marB="25400" anchor="ctr">
+                    <a:lnL w="6350" cap="flat" cmpd="sng" algn="ctr">
+                      <a:solidFill>
+                        <a:srgbClr val="E6E8F0"/>
+                      </a:solidFill>
+                      <a:prstDash val="solid"/>
+                      <a:round/>
+                      <a:headEnd type="none" w="med" len="med"/>
+                      <a:tailEnd type="none" w="med" len="med"/>
+                    </a:lnL>
+                    <a:lnR w="6350" cap="flat" cmpd="sng" algn="ctr">
+                      <a:solidFill>
+                        <a:srgbClr val="E6E8F0"/>
+                      </a:solidFill>
+                      <a:prstDash val="solid"/>
+                      <a:round/>
+                      <a:headEnd type="none" w="med" len="med"/>
+                      <a:tailEnd type="none" w="med" len="med"/>
+                    </a:lnR>
+                    <a:lnT w="6350" cap="flat" cmpd="sng" algn="ctr">
+                      <a:solidFill>
+                        <a:srgbClr val="E6E8F0"/>
+                      </a:solidFill>
+                      <a:prstDash val="solid"/>
+                      <a:round/>
+                      <a:headEnd type="none" w="med" len="med"/>
+                      <a:tailEnd type="none" w="med" len="med"/>
+                    </a:lnT>
+                    <a:lnB w="6350" cap="flat" cmpd="sng" algn="ctr">
+                      <a:solidFill>
+                        <a:srgbClr val="E6E8F0"/>
+                      </a:solidFill>
+                      <a:prstDash val="solid"/>
+                      <a:round/>
+                      <a:headEnd type="none" w="med" len="med"/>
+                      <a:tailEnd type="none" w="med" len="med"/>
+                    </a:lnB>
+                    <a:solidFill>
+                      <a:srgbClr val="FFFFFF"/>
+                    </a:solidFill>
+                  </a:tcPr>
+                </a:tc>
+                <a:tc>
+                  <a:txBody>
+                    <a:bodyPr/>
+                    <a:lstStyle/>
+                    <a:p>
+                      <a:pPr algn="ctr" indent="0" marL="0">
+                        <a:buNone/>
+                      </a:pPr>
+                      <a:r>
+                        <a:rPr lang="en-US" sz="1250" b="1" dirty="0">
+                          <a:solidFill>
+                            <a:srgbClr val="16A34A"/>
+                          </a:solidFill>
+                          <a:latin typeface="Calibri" pitchFamily="34" charset="0"/>
+                          <a:ea typeface="Calibri" pitchFamily="34" charset="-122"/>
+                          <a:cs typeface="Calibri" pitchFamily="34" charset="-120"/>
+                        </a:rPr>
+                        <a:t>88%</a:t>
+                      </a:r>
+                      <a:endParaRPr lang="en-US" sz="1250" dirty="0">
+                        <a:latin typeface="Calibri" charset="0"/>
+                        <a:ea typeface="Calibri" charset="0"/>
+                        <a:cs typeface="Calibri" charset="0"/>
+                      </a:endParaRPr>
+                    </a:p>
+                  </a:txBody>
+                  <a:tcPr marL="101600" marR="101600" marT="25400" marB="25400" anchor="ctr">
+                    <a:lnL w="6350" cap="flat" cmpd="sng" algn="ctr">
+                      <a:solidFill>
+                        <a:srgbClr val="E6E8F0"/>
+                      </a:solidFill>
+                      <a:prstDash val="solid"/>
+                      <a:round/>
+                      <a:headEnd type="none" w="med" len="med"/>
+                      <a:tailEnd type="none" w="med" len="med"/>
+                    </a:lnL>
+                    <a:lnR w="6350" cap="flat" cmpd="sng" algn="ctr">
+                      <a:solidFill>
+                        <a:srgbClr val="E6E8F0"/>
+                      </a:solidFill>
+                      <a:prstDash val="solid"/>
+                      <a:round/>
+                      <a:headEnd type="none" w="med" len="med"/>
+                      <a:tailEnd type="none" w="med" len="med"/>
+                    </a:lnR>
+                    <a:lnT w="6350" cap="flat" cmpd="sng" algn="ctr">
+                      <a:solidFill>
+                        <a:srgbClr val="E6E8F0"/>
+                      </a:solidFill>
+                      <a:prstDash val="solid"/>
+                      <a:round/>
+                      <a:headEnd type="none" w="med" len="med"/>
+                      <a:tailEnd type="none" w="med" len="med"/>
+                    </a:lnT>
+                    <a:lnB w="6350" cap="flat" cmpd="sng" algn="ctr">
+                      <a:solidFill>
+                        <a:srgbClr val="E6E8F0"/>
+                      </a:solidFill>
+                      <a:prstDash val="solid"/>
+                      <a:round/>
+                      <a:headEnd type="none" w="med" len="med"/>
+                      <a:tailEnd type="none" w="med" len="med"/>
+                    </a:lnB>
+                    <a:solidFill>
+                      <a:srgbClr val="FFFFFF"/>
+                    </a:solidFill>
+                  </a:tcPr>
+                </a:tc>
+              </a:tr>
+              <a:tr h="548640">
+                <a:tc>
+                  <a:txBody>
+                    <a:bodyPr/>
+                    <a:lstStyle/>
+                    <a:p>
+                      <a:pPr algn="l" indent="0" marL="0">
+                        <a:buNone/>
+                      </a:pPr>
+                      <a:r>
+                        <a:rPr lang="en-US" sz="1250" b="1" dirty="0">
+                          <a:solidFill>
+                            <a:srgbClr val="12132A"/>
+                          </a:solidFill>
+                          <a:latin typeface="Calibri" pitchFamily="34" charset="0"/>
+                          <a:ea typeface="Calibri" pitchFamily="34" charset="-122"/>
+                          <a:cs typeface="Calibri" pitchFamily="34" charset="-120"/>
+                        </a:rPr>
+                        <a:t>AI Rank</a:t>
+                      </a:r>
+                      <a:endParaRPr lang="en-US" sz="1250" dirty="0">
+                        <a:latin typeface="Calibri" charset="0"/>
+                        <a:ea typeface="Calibri" charset="0"/>
+                        <a:cs typeface="Calibri" charset="0"/>
+                      </a:endParaRPr>
+                    </a:p>
+                  </a:txBody>
+                  <a:tcPr marL="101600" marR="101600" marT="25400" marB="25400" anchor="ctr">
+                    <a:lnL w="6350" cap="flat" cmpd="sng" algn="ctr">
+                      <a:solidFill>
+                        <a:srgbClr val="E6E8F0"/>
+                      </a:solidFill>
+                      <a:prstDash val="solid"/>
+                      <a:round/>
+                      <a:headEnd type="none" w="med" len="med"/>
+                      <a:tailEnd type="none" w="med" len="med"/>
+                    </a:lnL>
+                    <a:lnR w="6350" cap="flat" cmpd="sng" algn="ctr">
+                      <a:solidFill>
+                        <a:srgbClr val="E6E8F0"/>
+                      </a:solidFill>
+                      <a:prstDash val="solid"/>
+                      <a:round/>
+                      <a:headEnd type="none" w="med" len="med"/>
+                      <a:tailEnd type="none" w="med" len="med"/>
+                    </a:lnR>
+                    <a:lnT w="6350" cap="flat" cmpd="sng" algn="ctr">
+                      <a:solidFill>
+                        <a:srgbClr val="E6E8F0"/>
+                      </a:solidFill>
+                      <a:prstDash val="solid"/>
+                      <a:round/>
+                      <a:headEnd type="none" w="med" len="med"/>
+                      <a:tailEnd type="none" w="med" len="med"/>
+                    </a:lnT>
+                    <a:lnB w="6350" cap="flat" cmpd="sng" algn="ctr">
+                      <a:solidFill>
+                        <a:srgbClr val="E6E8F0"/>
+                      </a:solidFill>
+                      <a:prstDash val="solid"/>
+                      <a:round/>
+                      <a:headEnd type="none" w="med" len="med"/>
+                      <a:tailEnd type="none" w="med" len="med"/>
+                    </a:lnB>
+                    <a:solidFill>
+                      <a:srgbClr val="F5F7FE"/>
+                    </a:solidFill>
+                  </a:tcPr>
+                </a:tc>
+                <a:tc>
+                  <a:txBody>
+                    <a:bodyPr/>
+                    <a:lstStyle/>
+                    <a:p>
+                      <a:pPr algn="r" indent="0" marL="0">
+                        <a:buNone/>
+                      </a:pPr>
+                      <a:r>
+                        <a:rPr lang="en-US" sz="1250" dirty="0">
+                          <a:solidFill>
+                            <a:srgbClr val="4A5568"/>
+                          </a:solidFill>
+                          <a:latin typeface="Calibri" pitchFamily="34" charset="0"/>
+                          <a:ea typeface="Calibri" pitchFamily="34" charset="-122"/>
+                          <a:cs typeface="Calibri" pitchFamily="34" charset="-120"/>
+                        </a:rPr>
+                        <a:t>RM2.45</a:t>
+                      </a:r>
+                      <a:endParaRPr lang="en-US" sz="1250" dirty="0">
+                        <a:latin typeface="Calibri" charset="0"/>
+                        <a:ea typeface="Calibri" charset="0"/>
+                        <a:cs typeface="Calibri" charset="0"/>
+                      </a:endParaRPr>
+                    </a:p>
+                  </a:txBody>
+                  <a:tcPr marL="101600" marR="101600" marT="25400" marB="25400" anchor="ctr">
+                    <a:lnL w="6350" cap="flat" cmpd="sng" algn="ctr">
+                      <a:solidFill>
+                        <a:srgbClr val="E6E8F0"/>
+                      </a:solidFill>
+                      <a:prstDash val="solid"/>
+                      <a:round/>
+                      <a:headEnd type="none" w="med" len="med"/>
+                      <a:tailEnd type="none" w="med" len="med"/>
+                    </a:lnL>
+                    <a:lnR w="6350" cap="flat" cmpd="sng" algn="ctr">
+                      <a:solidFill>
+                        <a:srgbClr val="E6E8F0"/>
+                      </a:solidFill>
+                      <a:prstDash val="solid"/>
+                      <a:round/>
+                      <a:headEnd type="none" w="med" len="med"/>
+                      <a:tailEnd type="none" w="med" len="med"/>
+                    </a:lnR>
+                    <a:lnT w="6350" cap="flat" cmpd="sng" algn="ctr">
+                      <a:solidFill>
+                        <a:srgbClr val="E6E8F0"/>
+                      </a:solidFill>
+                      <a:prstDash val="solid"/>
+                      <a:round/>
+                      <a:headEnd type="none" w="med" len="med"/>
+                      <a:tailEnd type="none" w="med" len="med"/>
+                    </a:lnT>
+                    <a:lnB w="6350" cap="flat" cmpd="sng" algn="ctr">
+                      <a:solidFill>
+                        <a:srgbClr val="E6E8F0"/>
+                      </a:solidFill>
+                      <a:prstDash val="solid"/>
+                      <a:round/>
+                      <a:headEnd type="none" w="med" len="med"/>
+                      <a:tailEnd type="none" w="med" len="med"/>
+                    </a:lnB>
+                    <a:solidFill>
+                      <a:srgbClr val="F5F7FE"/>
+                    </a:solidFill>
+                  </a:tcPr>
+                </a:tc>
+                <a:tc>
+                  <a:txBody>
+                    <a:bodyPr/>
+                    <a:lstStyle/>
+                    <a:p>
+                      <a:pPr algn="r" indent="0" marL="0">
+                        <a:buNone/>
+                      </a:pPr>
+                      <a:r>
+                        <a:rPr lang="en-US" sz="1250" dirty="0">
+                          <a:solidFill>
+                            <a:srgbClr val="4A5568"/>
+                          </a:solidFill>
+                          <a:latin typeface="Calibri" pitchFamily="34" charset="0"/>
+                          <a:ea typeface="Calibri" pitchFamily="34" charset="-122"/>
+                          <a:cs typeface="Calibri" pitchFamily="34" charset="-120"/>
+                        </a:rPr>
+                        <a:t>RM0.37</a:t>
+                      </a:r>
+                      <a:endParaRPr lang="en-US" sz="1250" dirty="0">
+                        <a:latin typeface="Calibri" charset="0"/>
+                        <a:ea typeface="Calibri" charset="0"/>
+                        <a:cs typeface="Calibri" charset="0"/>
+                      </a:endParaRPr>
+                    </a:p>
+                  </a:txBody>
+                  <a:tcPr marL="101600" marR="101600" marT="25400" marB="25400" anchor="ctr">
+                    <a:lnL w="6350" cap="flat" cmpd="sng" algn="ctr">
+                      <a:solidFill>
+                        <a:srgbClr val="E6E8F0"/>
+                      </a:solidFill>
+                      <a:prstDash val="solid"/>
+                      <a:round/>
+                      <a:headEnd type="none" w="med" len="med"/>
+                      <a:tailEnd type="none" w="med" len="med"/>
+                    </a:lnL>
+                    <a:lnR w="6350" cap="flat" cmpd="sng" algn="ctr">
+                      <a:solidFill>
+                        <a:srgbClr val="E6E8F0"/>
+                      </a:solidFill>
+                      <a:prstDash val="solid"/>
+                      <a:round/>
+                      <a:headEnd type="none" w="med" len="med"/>
+                      <a:tailEnd type="none" w="med" len="med"/>
+                    </a:lnR>
+                    <a:lnT w="6350" cap="flat" cmpd="sng" algn="ctr">
+                      <a:solidFill>
+                        <a:srgbClr val="E6E8F0"/>
+                      </a:solidFill>
+                      <a:prstDash val="solid"/>
+                      <a:round/>
+                      <a:headEnd type="none" w="med" len="med"/>
+                      <a:tailEnd type="none" w="med" len="med"/>
+                    </a:lnT>
+                    <a:lnB w="6350" cap="flat" cmpd="sng" algn="ctr">
+                      <a:solidFill>
+                        <a:srgbClr val="E6E8F0"/>
+                      </a:solidFill>
+                      <a:prstDash val="solid"/>
+                      <a:round/>
+                      <a:headEnd type="none" w="med" len="med"/>
+                      <a:tailEnd type="none" w="med" len="med"/>
+                    </a:lnB>
+                    <a:solidFill>
+                      <a:srgbClr val="F5F7FE"/>
+                    </a:solidFill>
+                  </a:tcPr>
+                </a:tc>
+                <a:tc>
+                  <a:txBody>
+                    <a:bodyPr/>
+                    <a:lstStyle/>
+                    <a:p>
+                      <a:pPr algn="ctr" indent="0" marL="0">
+                        <a:buNone/>
+                      </a:pPr>
+                      <a:r>
+                        <a:rPr lang="en-US" sz="1250" b="1" dirty="0">
+                          <a:solidFill>
+                            <a:srgbClr val="16A34A"/>
+                          </a:solidFill>
+                          <a:latin typeface="Calibri" pitchFamily="34" charset="0"/>
+                          <a:ea typeface="Calibri" pitchFamily="34" charset="-122"/>
+                          <a:cs typeface="Calibri" pitchFamily="34" charset="-120"/>
+                        </a:rPr>
+                        <a:t>85%</a:t>
+                      </a:r>
+                      <a:endParaRPr lang="en-US" sz="1250" dirty="0">
+                        <a:latin typeface="Calibri" charset="0"/>
+                        <a:ea typeface="Calibri" charset="0"/>
+                        <a:cs typeface="Calibri" charset="0"/>
+                      </a:endParaRPr>
+                    </a:p>
+                  </a:txBody>
+                  <a:tcPr marL="101600" marR="101600" marT="25400" marB="25400" anchor="ctr">
+                    <a:lnL w="6350" cap="flat" cmpd="sng" algn="ctr">
+                      <a:solidFill>
+                        <a:srgbClr val="E6E8F0"/>
+                      </a:solidFill>
+                      <a:prstDash val="solid"/>
+                      <a:round/>
+                      <a:headEnd type="none" w="med" len="med"/>
+                      <a:tailEnd type="none" w="med" len="med"/>
+                    </a:lnL>
+                    <a:lnR w="6350" cap="flat" cmpd="sng" algn="ctr">
+                      <a:solidFill>
+                        <a:srgbClr val="E6E8F0"/>
+                      </a:solidFill>
+                      <a:prstDash val="solid"/>
+                      <a:round/>
+                      <a:headEnd type="none" w="med" len="med"/>
+                      <a:tailEnd type="none" w="med" len="med"/>
+                    </a:lnR>
+                    <a:lnT w="6350" cap="flat" cmpd="sng" algn="ctr">
+                      <a:solidFill>
+                        <a:srgbClr val="E6E8F0"/>
+                      </a:solidFill>
+                      <a:prstDash val="solid"/>
+                      <a:round/>
+                      <a:headEnd type="none" w="med" len="med"/>
+                      <a:tailEnd type="none" w="med" len="med"/>
+                    </a:lnT>
+                    <a:lnB w="6350" cap="flat" cmpd="sng" algn="ctr">
+                      <a:solidFill>
+                        <a:srgbClr val="E6E8F0"/>
+                      </a:solidFill>
+                      <a:prstDash val="solid"/>
+                      <a:round/>
+                      <a:headEnd type="none" w="med" len="med"/>
+                      <a:tailEnd type="none" w="med" len="med"/>
+                    </a:lnB>
+                    <a:solidFill>
+                      <a:srgbClr val="F5F7FE"/>
+                    </a:solidFill>
+                  </a:tcPr>
+                </a:tc>
+              </a:tr>
+              <a:tr h="548640">
+                <a:tc>
+                  <a:txBody>
+                    <a:bodyPr/>
+                    <a:lstStyle/>
+                    <a:p>
+                      <a:pPr algn="l" indent="0" marL="0">
+                        <a:buNone/>
+                      </a:pPr>
+                      <a:r>
+                        <a:rPr lang="en-US" sz="1250" b="1" dirty="0">
+                          <a:solidFill>
+                            <a:srgbClr val="12132A"/>
+                          </a:solidFill>
+                          <a:latin typeface="Calibri" pitchFamily="34" charset="0"/>
+                          <a:ea typeface="Calibri" pitchFamily="34" charset="-122"/>
+                          <a:cs typeface="Calibri" pitchFamily="34" charset="-120"/>
+                        </a:rPr>
+                        <a:t>AI Insight</a:t>
+                      </a:r>
+                      <a:endParaRPr lang="en-US" sz="1250" dirty="0">
+                        <a:latin typeface="Calibri" charset="0"/>
+                        <a:ea typeface="Calibri" charset="0"/>
+                        <a:cs typeface="Calibri" charset="0"/>
+                      </a:endParaRPr>
+                    </a:p>
+                  </a:txBody>
+                  <a:tcPr marL="101600" marR="101600" marT="25400" marB="25400" anchor="ctr">
+                    <a:lnL w="6350" cap="flat" cmpd="sng" algn="ctr">
+                      <a:solidFill>
+                        <a:srgbClr val="E6E8F0"/>
+                      </a:solidFill>
+                      <a:prstDash val="solid"/>
+                      <a:round/>
+                      <a:headEnd type="none" w="med" len="med"/>
+                      <a:tailEnd type="none" w="med" len="med"/>
+                    </a:lnL>
+                    <a:lnR w="6350" cap="flat" cmpd="sng" algn="ctr">
+                      <a:solidFill>
+                        <a:srgbClr val="E6E8F0"/>
+                      </a:solidFill>
+                      <a:prstDash val="solid"/>
+                      <a:round/>
+                      <a:headEnd type="none" w="med" len="med"/>
+                      <a:tailEnd type="none" w="med" len="med"/>
+                    </a:lnR>
+                    <a:lnT w="6350" cap="flat" cmpd="sng" algn="ctr">
+                      <a:solidFill>
+                        <a:srgbClr val="E6E8F0"/>
+                      </a:solidFill>
+                      <a:prstDash val="solid"/>
+                      <a:round/>
+                      <a:headEnd type="none" w="med" len="med"/>
+                      <a:tailEnd type="none" w="med" len="med"/>
+                    </a:lnT>
+                    <a:lnB w="6350" cap="flat" cmpd="sng" algn="ctr">
+                      <a:solidFill>
+                        <a:srgbClr val="E6E8F0"/>
+                      </a:solidFill>
+                      <a:prstDash val="solid"/>
+                      <a:round/>
+                      <a:headEnd type="none" w="med" len="med"/>
+                      <a:tailEnd type="none" w="med" len="med"/>
+                    </a:lnB>
+                    <a:solidFill>
+                      <a:srgbClr val="FFFFFF"/>
+                    </a:solidFill>
+                  </a:tcPr>
+                </a:tc>
+                <a:tc>
+                  <a:txBody>
+                    <a:bodyPr/>
+                    <a:lstStyle/>
+                    <a:p>
+                      <a:pPr algn="r" indent="0" marL="0">
+                        <a:buNone/>
+                      </a:pPr>
+                      <a:r>
+                        <a:rPr lang="en-US" sz="1250" dirty="0">
+                          <a:solidFill>
+                            <a:srgbClr val="4A5568"/>
+                          </a:solidFill>
+                          <a:latin typeface="Calibri" pitchFamily="34" charset="0"/>
+                          <a:ea typeface="Calibri" pitchFamily="34" charset="-122"/>
+                          <a:cs typeface="Calibri" pitchFamily="34" charset="-120"/>
+                        </a:rPr>
+                        <a:t>RM2.45</a:t>
+                      </a:r>
+                      <a:endParaRPr lang="en-US" sz="1250" dirty="0">
+                        <a:latin typeface="Calibri" charset="0"/>
+                        <a:ea typeface="Calibri" charset="0"/>
+                        <a:cs typeface="Calibri" charset="0"/>
+                      </a:endParaRPr>
+                    </a:p>
+                  </a:txBody>
+                  <a:tcPr marL="101600" marR="101600" marT="25400" marB="25400" anchor="ctr">
+                    <a:lnL w="6350" cap="flat" cmpd="sng" algn="ctr">
+                      <a:solidFill>
+                        <a:srgbClr val="E6E8F0"/>
+                      </a:solidFill>
+                      <a:prstDash val="solid"/>
+                      <a:round/>
+                      <a:headEnd type="none" w="med" len="med"/>
+                      <a:tailEnd type="none" w="med" len="med"/>
+                    </a:lnL>
+                    <a:lnR w="6350" cap="flat" cmpd="sng" algn="ctr">
+                      <a:solidFill>
+                        <a:srgbClr val="E6E8F0"/>
+                      </a:solidFill>
+                      <a:prstDash val="solid"/>
+                      <a:round/>
+                      <a:headEnd type="none" w="med" len="med"/>
+                      <a:tailEnd type="none" w="med" len="med"/>
+                    </a:lnR>
+                    <a:lnT w="6350" cap="flat" cmpd="sng" algn="ctr">
+                      <a:solidFill>
+                        <a:srgbClr val="E6E8F0"/>
+                      </a:solidFill>
+                      <a:prstDash val="solid"/>
+                      <a:round/>
+                      <a:headEnd type="none" w="med" len="med"/>
+                      <a:tailEnd type="none" w="med" len="med"/>
+                    </a:lnT>
+                    <a:lnB w="6350" cap="flat" cmpd="sng" algn="ctr">
+                      <a:solidFill>
+                        <a:srgbClr val="E6E8F0"/>
+                      </a:solidFill>
+                      <a:prstDash val="solid"/>
+                      <a:round/>
+                      <a:headEnd type="none" w="med" len="med"/>
+                      <a:tailEnd type="none" w="med" len="med"/>
+                    </a:lnB>
+                    <a:solidFill>
+                      <a:srgbClr val="FFFFFF"/>
+                    </a:solidFill>
+                  </a:tcPr>
+                </a:tc>
+                <a:tc>
+                  <a:txBody>
+                    <a:bodyPr/>
+                    <a:lstStyle/>
+                    <a:p>
+                      <a:pPr algn="r" indent="0" marL="0">
+                        <a:buNone/>
+                      </a:pPr>
+                      <a:r>
+                        <a:rPr lang="en-US" sz="1250" dirty="0">
+                          <a:solidFill>
+                            <a:srgbClr val="4A5568"/>
+                          </a:solidFill>
+                          <a:latin typeface="Calibri" pitchFamily="34" charset="0"/>
+                          <a:ea typeface="Calibri" pitchFamily="34" charset="-122"/>
+                          <a:cs typeface="Calibri" pitchFamily="34" charset="-120"/>
+                        </a:rPr>
+                        <a:t>RM0.21</a:t>
+                      </a:r>
+                      <a:endParaRPr lang="en-US" sz="1250" dirty="0">
+                        <a:latin typeface="Calibri" charset="0"/>
+                        <a:ea typeface="Calibri" charset="0"/>
+                        <a:cs typeface="Calibri" charset="0"/>
+                      </a:endParaRPr>
+                    </a:p>
+                  </a:txBody>
+                  <a:tcPr marL="101600" marR="101600" marT="25400" marB="25400" anchor="ctr">
+                    <a:lnL w="6350" cap="flat" cmpd="sng" algn="ctr">
+                      <a:solidFill>
+                        <a:srgbClr val="E6E8F0"/>
+                      </a:solidFill>
+                      <a:prstDash val="solid"/>
+                      <a:round/>
+                      <a:headEnd type="none" w="med" len="med"/>
+                      <a:tailEnd type="none" w="med" len="med"/>
+                    </a:lnL>
+                    <a:lnR w="6350" cap="flat" cmpd="sng" algn="ctr">
+                      <a:solidFill>
+                        <a:srgbClr val="E6E8F0"/>
+                      </a:solidFill>
+                      <a:prstDash val="solid"/>
+                      <a:round/>
+                      <a:headEnd type="none" w="med" len="med"/>
+                      <a:tailEnd type="none" w="med" len="med"/>
+                    </a:lnR>
+                    <a:lnT w="6350" cap="flat" cmpd="sng" algn="ctr">
+                      <a:solidFill>
+                        <a:srgbClr val="E6E8F0"/>
+                      </a:solidFill>
+                      <a:prstDash val="solid"/>
+                      <a:round/>
+                      <a:headEnd type="none" w="med" len="med"/>
+                      <a:tailEnd type="none" w="med" len="med"/>
+                    </a:lnT>
+                    <a:lnB w="6350" cap="flat" cmpd="sng" algn="ctr">
+                      <a:solidFill>
+                        <a:srgbClr val="E6E8F0"/>
+                      </a:solidFill>
+                      <a:prstDash val="solid"/>
+                      <a:round/>
+                      <a:headEnd type="none" w="med" len="med"/>
+                      <a:tailEnd type="none" w="med" len="med"/>
+                    </a:lnB>
+                    <a:solidFill>
+                      <a:srgbClr val="FFFFFF"/>
+                    </a:solidFill>
+                  </a:tcPr>
+                </a:tc>
+                <a:tc>
+                  <a:txBody>
+                    <a:bodyPr/>
+                    <a:lstStyle/>
+                    <a:p>
+                      <a:pPr algn="ctr" indent="0" marL="0">
+                        <a:buNone/>
+                      </a:pPr>
+                      <a:r>
+                        <a:rPr lang="en-US" sz="1250" b="1" dirty="0">
+                          <a:solidFill>
+                            <a:srgbClr val="16A34A"/>
+                          </a:solidFill>
+                          <a:latin typeface="Calibri" pitchFamily="34" charset="0"/>
+                          <a:ea typeface="Calibri" pitchFamily="34" charset="-122"/>
+                          <a:cs typeface="Calibri" pitchFamily="34" charset="-120"/>
+                        </a:rPr>
+                        <a:t>91%</a:t>
+                      </a:r>
+                      <a:endParaRPr lang="en-US" sz="1250" dirty="0">
+                        <a:latin typeface="Calibri" charset="0"/>
+                        <a:ea typeface="Calibri" charset="0"/>
+                        <a:cs typeface="Calibri" charset="0"/>
+                      </a:endParaRPr>
+                    </a:p>
+                  </a:txBody>
+                  <a:tcPr marL="101600" marR="101600" marT="25400" marB="25400" anchor="ctr">
+                    <a:lnL w="6350" cap="flat" cmpd="sng" algn="ctr">
+                      <a:solidFill>
+                        <a:srgbClr val="E6E8F0"/>
+                      </a:solidFill>
+                      <a:prstDash val="solid"/>
+                      <a:round/>
+                      <a:headEnd type="none" w="med" len="med"/>
+                      <a:tailEnd type="none" w="med" len="med"/>
+                    </a:lnL>
+                    <a:lnR w="6350" cap="flat" cmpd="sng" algn="ctr">
+                      <a:solidFill>
+                        <a:srgbClr val="E6E8F0"/>
+                      </a:solidFill>
+                      <a:prstDash val="solid"/>
+                      <a:round/>
+                      <a:headEnd type="none" w="med" len="med"/>
+                      <a:tailEnd type="none" w="med" len="med"/>
+                    </a:lnR>
+                    <a:lnT w="6350" cap="flat" cmpd="sng" algn="ctr">
+                      <a:solidFill>
+                        <a:srgbClr val="E6E8F0"/>
+                      </a:solidFill>
+                      <a:prstDash val="solid"/>
+                      <a:round/>
+                      <a:headEnd type="none" w="med" len="med"/>
+                      <a:tailEnd type="none" w="med" len="med"/>
+                    </a:lnT>
+                    <a:lnB w="6350" cap="flat" cmpd="sng" algn="ctr">
+                      <a:solidFill>
+                        <a:srgbClr val="E6E8F0"/>
+                      </a:solidFill>
+                      <a:prstDash val="solid"/>
+                      <a:round/>
+                      <a:headEnd type="none" w="med" len="med"/>
+                      <a:tailEnd type="none" w="med" len="med"/>
+                    </a:lnB>
+                    <a:solidFill>
+                      <a:srgbClr val="FFFFFF"/>
+                    </a:solidFill>
+                  </a:tcPr>
+                </a:tc>
+              </a:tr>
+              <a:tr h="548640">
+                <a:tc>
+                  <a:txBody>
+                    <a:bodyPr/>
+                    <a:lstStyle/>
+                    <a:p>
+                      <a:pPr algn="l" indent="0" marL="0">
+                        <a:buNone/>
+                      </a:pPr>
+                      <a:r>
+                        <a:rPr lang="en-US" sz="1250" b="1" dirty="0">
+                          <a:solidFill>
+                            <a:srgbClr val="12132A"/>
+                          </a:solidFill>
+                          <a:latin typeface="Calibri" pitchFamily="34" charset="0"/>
+                          <a:ea typeface="Calibri" pitchFamily="34" charset="-122"/>
+                          <a:cs typeface="Calibri" pitchFamily="34" charset="-120"/>
+                        </a:rPr>
+                        <a:t>Interview questions</a:t>
+                      </a:r>
+                      <a:endParaRPr lang="en-US" sz="1250" dirty="0">
+                        <a:latin typeface="Calibri" charset="0"/>
+                        <a:ea typeface="Calibri" charset="0"/>
+                        <a:cs typeface="Calibri" charset="0"/>
+                      </a:endParaRPr>
+                    </a:p>
+                  </a:txBody>
+                  <a:tcPr marL="101600" marR="101600" marT="25400" marB="25400" anchor="ctr">
+                    <a:lnL w="6350" cap="flat" cmpd="sng" algn="ctr">
+                      <a:solidFill>
+                        <a:srgbClr val="E6E8F0"/>
+                      </a:solidFill>
+                      <a:prstDash val="solid"/>
+                      <a:round/>
+                      <a:headEnd type="none" w="med" len="med"/>
+                      <a:tailEnd type="none" w="med" len="med"/>
+                    </a:lnL>
+                    <a:lnR w="6350" cap="flat" cmpd="sng" algn="ctr">
+                      <a:solidFill>
+                        <a:srgbClr val="E6E8F0"/>
+                      </a:solidFill>
+                      <a:prstDash val="solid"/>
+                      <a:round/>
+                      <a:headEnd type="none" w="med" len="med"/>
+                      <a:tailEnd type="none" w="med" len="med"/>
+                    </a:lnR>
+                    <a:lnT w="6350" cap="flat" cmpd="sng" algn="ctr">
+                      <a:solidFill>
+                        <a:srgbClr val="E6E8F0"/>
+                      </a:solidFill>
+                      <a:prstDash val="solid"/>
+                      <a:round/>
+                      <a:headEnd type="none" w="med" len="med"/>
+                      <a:tailEnd type="none" w="med" len="med"/>
+                    </a:lnT>
+                    <a:lnB w="6350" cap="flat" cmpd="sng" algn="ctr">
+                      <a:solidFill>
+                        <a:srgbClr val="E6E8F0"/>
+                      </a:solidFill>
+                      <a:prstDash val="solid"/>
+                      <a:round/>
+                      <a:headEnd type="none" w="med" len="med"/>
+                      <a:tailEnd type="none" w="med" len="med"/>
+                    </a:lnB>
+                    <a:solidFill>
+                      <a:srgbClr val="F5F7FE"/>
+                    </a:solidFill>
+                  </a:tcPr>
+                </a:tc>
+                <a:tc>
+                  <a:txBody>
+                    <a:bodyPr/>
+                    <a:lstStyle/>
+                    <a:p>
+                      <a:pPr algn="r" indent="0" marL="0">
+                        <a:buNone/>
+                      </a:pPr>
+                      <a:r>
+                        <a:rPr lang="en-US" sz="1250" dirty="0">
+                          <a:solidFill>
+                            <a:srgbClr val="4A5568"/>
+                          </a:solidFill>
+                          <a:latin typeface="Calibri" pitchFamily="34" charset="0"/>
+                          <a:ea typeface="Calibri" pitchFamily="34" charset="-122"/>
+                          <a:cs typeface="Calibri" pitchFamily="34" charset="-120"/>
+                        </a:rPr>
+                        <a:t>RM0.37</a:t>
+                      </a:r>
+                      <a:endParaRPr lang="en-US" sz="1250" dirty="0">
+                        <a:latin typeface="Calibri" charset="0"/>
+                        <a:ea typeface="Calibri" charset="0"/>
+                        <a:cs typeface="Calibri" charset="0"/>
+                      </a:endParaRPr>
+                    </a:p>
+                  </a:txBody>
+                  <a:tcPr marL="101600" marR="101600" marT="25400" marB="25400" anchor="ctr">
+                    <a:lnL w="6350" cap="flat" cmpd="sng" algn="ctr">
+                      <a:solidFill>
+                        <a:srgbClr val="E6E8F0"/>
+                      </a:solidFill>
+                      <a:prstDash val="solid"/>
+                      <a:round/>
+                      <a:headEnd type="none" w="med" len="med"/>
+                      <a:tailEnd type="none" w="med" len="med"/>
+                    </a:lnL>
+                    <a:lnR w="6350" cap="flat" cmpd="sng" algn="ctr">
+                      <a:solidFill>
+                        <a:srgbClr val="E6E8F0"/>
+                      </a:solidFill>
+                      <a:prstDash val="solid"/>
+                      <a:round/>
+                      <a:headEnd type="none" w="med" len="med"/>
+                      <a:tailEnd type="none" w="med" len="med"/>
+                    </a:lnR>
+                    <a:lnT w="6350" cap="flat" cmpd="sng" algn="ctr">
+                      <a:solidFill>
+                        <a:srgbClr val="E6E8F0"/>
+                      </a:solidFill>
+                      <a:prstDash val="solid"/>
+                      <a:round/>
+                      <a:headEnd type="none" w="med" len="med"/>
+                      <a:tailEnd type="none" w="med" len="med"/>
+                    </a:lnT>
+                    <a:lnB w="6350" cap="flat" cmpd="sng" algn="ctr">
+                      <a:solidFill>
+                        <a:srgbClr val="E6E8F0"/>
+                      </a:solidFill>
+                      <a:prstDash val="solid"/>
+                      <a:round/>
+                      <a:headEnd type="none" w="med" len="med"/>
+                      <a:tailEnd type="none" w="med" len="med"/>
+                    </a:lnB>
+                    <a:solidFill>
+                      <a:srgbClr val="F5F7FE"/>
+                    </a:solidFill>
+                  </a:tcPr>
+                </a:tc>
+                <a:tc>
+                  <a:txBody>
+                    <a:bodyPr/>
+                    <a:lstStyle/>
+                    <a:p>
+                      <a:pPr algn="r" indent="0" marL="0">
+                        <a:buNone/>
+                      </a:pPr>
+                      <a:r>
+                        <a:rPr lang="en-US" sz="1250" dirty="0">
+                          <a:solidFill>
+                            <a:srgbClr val="4A5568"/>
+                          </a:solidFill>
+                          <a:latin typeface="Calibri" pitchFamily="34" charset="0"/>
+                          <a:ea typeface="Calibri" pitchFamily="34" charset="-122"/>
+                          <a:cs typeface="Calibri" pitchFamily="34" charset="-120"/>
+                        </a:rPr>
+                        <a:t>RM0.07</a:t>
+                      </a:r>
+                      <a:endParaRPr lang="en-US" sz="1250" dirty="0">
+                        <a:latin typeface="Calibri" charset="0"/>
+                        <a:ea typeface="Calibri" charset="0"/>
+                        <a:cs typeface="Calibri" charset="0"/>
+                      </a:endParaRPr>
+                    </a:p>
+                  </a:txBody>
+                  <a:tcPr marL="101600" marR="101600" marT="25400" marB="25400" anchor="ctr">
+                    <a:lnL w="6350" cap="flat" cmpd="sng" algn="ctr">
+                      <a:solidFill>
+                        <a:srgbClr val="E6E8F0"/>
+                      </a:solidFill>
+                      <a:prstDash val="solid"/>
+                      <a:round/>
+                      <a:headEnd type="none" w="med" len="med"/>
+                      <a:tailEnd type="none" w="med" len="med"/>
+                    </a:lnL>
+                    <a:lnR w="6350" cap="flat" cmpd="sng" algn="ctr">
+                      <a:solidFill>
+                        <a:srgbClr val="E6E8F0"/>
+                      </a:solidFill>
+                      <a:prstDash val="solid"/>
+                      <a:round/>
+                      <a:headEnd type="none" w="med" len="med"/>
+                      <a:tailEnd type="none" w="med" len="med"/>
+                    </a:lnR>
+                    <a:lnT w="6350" cap="flat" cmpd="sng" algn="ctr">
+                      <a:solidFill>
+                        <a:srgbClr val="E6E8F0"/>
+                      </a:solidFill>
+                      <a:prstDash val="solid"/>
+                      <a:round/>
+                      <a:headEnd type="none" w="med" len="med"/>
+                      <a:tailEnd type="none" w="med" len="med"/>
+                    </a:lnT>
+                    <a:lnB w="6350" cap="flat" cmpd="sng" algn="ctr">
+                      <a:solidFill>
+                        <a:srgbClr val="E6E8F0"/>
+                      </a:solidFill>
+                      <a:prstDash val="solid"/>
+                      <a:round/>
+                      <a:headEnd type="none" w="med" len="med"/>
+                      <a:tailEnd type="none" w="med" len="med"/>
+                    </a:lnB>
+                    <a:solidFill>
+                      <a:srgbClr val="F5F7FE"/>
+                    </a:solidFill>
+                  </a:tcPr>
+                </a:tc>
+                <a:tc>
+                  <a:txBody>
+                    <a:bodyPr/>
+                    <a:lstStyle/>
+                    <a:p>
+                      <a:pPr algn="ctr" indent="0" marL="0">
+                        <a:buNone/>
+                      </a:pPr>
+                      <a:r>
+                        <a:rPr lang="en-US" sz="1250" b="1" dirty="0">
+                          <a:solidFill>
+                            <a:srgbClr val="16A34A"/>
+                          </a:solidFill>
+                          <a:latin typeface="Calibri" pitchFamily="34" charset="0"/>
+                          <a:ea typeface="Calibri" pitchFamily="34" charset="-122"/>
+                          <a:cs typeface="Calibri" pitchFamily="34" charset="-120"/>
+                        </a:rPr>
+                        <a:t>81%</a:t>
+                      </a:r>
+                      <a:endParaRPr lang="en-US" sz="1250" dirty="0">
+                        <a:latin typeface="Calibri" charset="0"/>
+                        <a:ea typeface="Calibri" charset="0"/>
+                        <a:cs typeface="Calibri" charset="0"/>
+                      </a:endParaRPr>
+                    </a:p>
+                  </a:txBody>
+                  <a:tcPr marL="101600" marR="101600" marT="25400" marB="25400" anchor="ctr">
+                    <a:lnL w="6350" cap="flat" cmpd="sng" algn="ctr">
+                      <a:solidFill>
+                        <a:srgbClr val="E6E8F0"/>
+                      </a:solidFill>
+                      <a:prstDash val="solid"/>
+                      <a:round/>
+                      <a:headEnd type="none" w="med" len="med"/>
+                      <a:tailEnd type="none" w="med" len="med"/>
+                    </a:lnL>
+                    <a:lnR w="6350" cap="flat" cmpd="sng" algn="ctr">
+                      <a:solidFill>
+                        <a:srgbClr val="E6E8F0"/>
+                      </a:solidFill>
+                      <a:prstDash val="solid"/>
+                      <a:round/>
+                      <a:headEnd type="none" w="med" len="med"/>
+                      <a:tailEnd type="none" w="med" len="med"/>
+                    </a:lnR>
+                    <a:lnT w="6350" cap="flat" cmpd="sng" algn="ctr">
+                      <a:solidFill>
+                        <a:srgbClr val="E6E8F0"/>
+                      </a:solidFill>
+                      <a:prstDash val="solid"/>
+                      <a:round/>
+                      <a:headEnd type="none" w="med" len="med"/>
+                      <a:tailEnd type="none" w="med" len="med"/>
+                    </a:lnT>
+                    <a:lnB w="6350" cap="flat" cmpd="sng" algn="ctr">
+                      <a:solidFill>
+                        <a:srgbClr val="E6E8F0"/>
+                      </a:solidFill>
+                      <a:prstDash val="solid"/>
+                      <a:round/>
+                      <a:headEnd type="none" w="med" len="med"/>
+                      <a:tailEnd type="none" w="med" len="med"/>
+                    </a:lnB>
+                    <a:solidFill>
+                      <a:srgbClr val="F5F7FE"/>
+                    </a:solidFill>
+                  </a:tcPr>
+                </a:tc>
+              </a:tr>
+              <a:tr h="548640">
+                <a:tc>
+                  <a:txBody>
+                    <a:bodyPr/>
+                    <a:lstStyle/>
+                    <a:p>
+                      <a:pPr algn="l" indent="0" marL="0">
+                        <a:buNone/>
+                      </a:pPr>
+                      <a:r>
+                        <a:rPr lang="en-US" sz="1250" b="1" dirty="0">
+                          <a:solidFill>
+                            <a:srgbClr val="12132A"/>
+                          </a:solidFill>
+                          <a:latin typeface="Calibri" pitchFamily="34" charset="0"/>
+                          <a:ea typeface="Calibri" pitchFamily="34" charset="-122"/>
+                          <a:cs typeface="Calibri" pitchFamily="34" charset="-120"/>
+                        </a:rPr>
+                        <a:t>Job draft</a:t>
+                      </a:r>
+                      <a:endParaRPr lang="en-US" sz="1250" dirty="0">
+                        <a:latin typeface="Calibri" charset="0"/>
+                        <a:ea typeface="Calibri" charset="0"/>
+                        <a:cs typeface="Calibri" charset="0"/>
+                      </a:endParaRPr>
+                    </a:p>
+                  </a:txBody>
+                  <a:tcPr marL="101600" marR="101600" marT="25400" marB="25400" anchor="ctr">
+                    <a:lnL w="6350" cap="flat" cmpd="sng" algn="ctr">
+                      <a:solidFill>
+                        <a:srgbClr val="E6E8F0"/>
+                      </a:solidFill>
+                      <a:prstDash val="solid"/>
+                      <a:round/>
+                      <a:headEnd type="none" w="med" len="med"/>
+                      <a:tailEnd type="none" w="med" len="med"/>
+                    </a:lnL>
+                    <a:lnR w="6350" cap="flat" cmpd="sng" algn="ctr">
+                      <a:solidFill>
+                        <a:srgbClr val="E6E8F0"/>
+                      </a:solidFill>
+                      <a:prstDash val="solid"/>
+                      <a:round/>
+                      <a:headEnd type="none" w="med" len="med"/>
+                      <a:tailEnd type="none" w="med" len="med"/>
+                    </a:lnR>
+                    <a:lnT w="6350" cap="flat" cmpd="sng" algn="ctr">
+                      <a:solidFill>
+                        <a:srgbClr val="E6E8F0"/>
+                      </a:solidFill>
+                      <a:prstDash val="solid"/>
+                      <a:round/>
+                      <a:headEnd type="none" w="med" len="med"/>
+                      <a:tailEnd type="none" w="med" len="med"/>
+                    </a:lnT>
+                    <a:lnB w="6350" cap="flat" cmpd="sng" algn="ctr">
+                      <a:solidFill>
+                        <a:srgbClr val="E6E8F0"/>
+                      </a:solidFill>
+                      <a:prstDash val="solid"/>
+                      <a:round/>
+                      <a:headEnd type="none" w="med" len="med"/>
+                      <a:tailEnd type="none" w="med" len="med"/>
+                    </a:lnB>
+                    <a:solidFill>
+                      <a:srgbClr val="FFFFFF"/>
+                    </a:solidFill>
+                  </a:tcPr>
+                </a:tc>
+                <a:tc>
+                  <a:txBody>
+                    <a:bodyPr/>
+                    <a:lstStyle/>
+                    <a:p>
+                      <a:pPr algn="r" indent="0" marL="0">
+                        <a:buNone/>
+                      </a:pPr>
+                      <a:r>
+                        <a:rPr lang="en-US" sz="1250" dirty="0">
+                          <a:solidFill>
+                            <a:srgbClr val="4A5568"/>
+                          </a:solidFill>
+                          <a:latin typeface="Calibri" pitchFamily="34" charset="0"/>
+                          <a:ea typeface="Calibri" pitchFamily="34" charset="-122"/>
+                          <a:cs typeface="Calibri" pitchFamily="34" charset="-120"/>
+                        </a:rPr>
+                        <a:t>RM2.25</a:t>
+                      </a:r>
+                      <a:endParaRPr lang="en-US" sz="1250" dirty="0">
+                        <a:latin typeface="Calibri" charset="0"/>
+                        <a:ea typeface="Calibri" charset="0"/>
+                        <a:cs typeface="Calibri" charset="0"/>
+                      </a:endParaRPr>
+                    </a:p>
+                  </a:txBody>
+                  <a:tcPr marL="101600" marR="101600" marT="25400" marB="25400" anchor="ctr">
+                    <a:lnL w="6350" cap="flat" cmpd="sng" algn="ctr">
+                      <a:solidFill>
+                        <a:srgbClr val="E6E8F0"/>
+                      </a:solidFill>
+                      <a:prstDash val="solid"/>
+                      <a:round/>
+                      <a:headEnd type="none" w="med" len="med"/>
+                      <a:tailEnd type="none" w="med" len="med"/>
+                    </a:lnL>
+                    <a:lnR w="6350" cap="flat" cmpd="sng" algn="ctr">
+                      <a:solidFill>
+                        <a:srgbClr val="E6E8F0"/>
+                      </a:solidFill>
+                      <a:prstDash val="solid"/>
+                      <a:round/>
+                      <a:headEnd type="none" w="med" len="med"/>
+                      <a:tailEnd type="none" w="med" len="med"/>
+                    </a:lnR>
+                    <a:lnT w="6350" cap="flat" cmpd="sng" algn="ctr">
+                      <a:solidFill>
+                        <a:srgbClr val="E6E8F0"/>
+                      </a:solidFill>
+                      <a:prstDash val="solid"/>
+                      <a:round/>
+                      <a:headEnd type="none" w="med" len="med"/>
+                      <a:tailEnd type="none" w="med" len="med"/>
+                    </a:lnT>
+                    <a:lnB w="6350" cap="flat" cmpd="sng" algn="ctr">
+                      <a:solidFill>
+                        <a:srgbClr val="E6E8F0"/>
+                      </a:solidFill>
+                      <a:prstDash val="solid"/>
+                      <a:round/>
+                      <a:headEnd type="none" w="med" len="med"/>
+                      <a:tailEnd type="none" w="med" len="med"/>
+                    </a:lnB>
+                    <a:solidFill>
+                      <a:srgbClr val="FFFFFF"/>
+                    </a:solidFill>
+                  </a:tcPr>
+                </a:tc>
+                <a:tc>
+                  <a:txBody>
+                    <a:bodyPr/>
+                    <a:lstStyle/>
+                    <a:p>
+                      <a:pPr algn="r" indent="0" marL="0">
+                        <a:buNone/>
+                      </a:pPr>
+                      <a:r>
+                        <a:rPr lang="en-US" sz="1250" dirty="0">
+                          <a:solidFill>
+                            <a:srgbClr val="4A5568"/>
+                          </a:solidFill>
+                          <a:latin typeface="Calibri" pitchFamily="34" charset="0"/>
+                          <a:ea typeface="Calibri" pitchFamily="34" charset="-122"/>
+                          <a:cs typeface="Calibri" pitchFamily="34" charset="-120"/>
+                        </a:rPr>
+                        <a:t>RM0.46</a:t>
+                      </a:r>
+                      <a:endParaRPr lang="en-US" sz="1250" dirty="0">
+                        <a:latin typeface="Calibri" charset="0"/>
+                        <a:ea typeface="Calibri" charset="0"/>
+                        <a:cs typeface="Calibri" charset="0"/>
+                      </a:endParaRPr>
+                    </a:p>
+                  </a:txBody>
+                  <a:tcPr marL="101600" marR="101600" marT="25400" marB="25400" anchor="ctr">
+                    <a:lnL w="6350" cap="flat" cmpd="sng" algn="ctr">
+                      <a:solidFill>
+                        <a:srgbClr val="E6E8F0"/>
+                      </a:solidFill>
+                      <a:prstDash val="solid"/>
+                      <a:round/>
+                      <a:headEnd type="none" w="med" len="med"/>
+                      <a:tailEnd type="none" w="med" len="med"/>
+                    </a:lnL>
+                    <a:lnR w="6350" cap="flat" cmpd="sng" algn="ctr">
+                      <a:solidFill>
+                        <a:srgbClr val="E6E8F0"/>
+                      </a:solidFill>
+                      <a:prstDash val="solid"/>
+                      <a:round/>
+                      <a:headEnd type="none" w="med" len="med"/>
+                      <a:tailEnd type="none" w="med" len="med"/>
+                    </a:lnR>
+                    <a:lnT w="6350" cap="flat" cmpd="sng" algn="ctr">
+                      <a:solidFill>
+                        <a:srgbClr val="E6E8F0"/>
+                      </a:solidFill>
+                      <a:prstDash val="solid"/>
+                      <a:round/>
+                      <a:headEnd type="none" w="med" len="med"/>
+                      <a:tailEnd type="none" w="med" len="med"/>
+                    </a:lnT>
+                    <a:lnB w="6350" cap="flat" cmpd="sng" algn="ctr">
+                      <a:solidFill>
+                        <a:srgbClr val="E6E8F0"/>
+                      </a:solidFill>
+                      <a:prstDash val="solid"/>
+                      <a:round/>
+                      <a:headEnd type="none" w="med" len="med"/>
+                      <a:tailEnd type="none" w="med" len="med"/>
+                    </a:lnB>
+                    <a:solidFill>
+                      <a:srgbClr val="FFFFFF"/>
+                    </a:solidFill>
+                  </a:tcPr>
+                </a:tc>
+                <a:tc>
+                  <a:txBody>
+                    <a:bodyPr/>
+                    <a:lstStyle/>
+                    <a:p>
+                      <a:pPr algn="ctr" indent="0" marL="0">
+                        <a:buNone/>
+                      </a:pPr>
+                      <a:r>
+                        <a:rPr lang="en-US" sz="1250" b="1" dirty="0">
+                          <a:solidFill>
+                            <a:srgbClr val="16A34A"/>
+                          </a:solidFill>
+                          <a:latin typeface="Calibri" pitchFamily="34" charset="0"/>
+                          <a:ea typeface="Calibri" pitchFamily="34" charset="-122"/>
+                          <a:cs typeface="Calibri" pitchFamily="34" charset="-120"/>
+                        </a:rPr>
+                        <a:t>80%</a:t>
+                      </a:r>
+                      <a:endParaRPr lang="en-US" sz="1250" dirty="0">
+                        <a:latin typeface="Calibri" charset="0"/>
+                        <a:ea typeface="Calibri" charset="0"/>
+                        <a:cs typeface="Calibri" charset="0"/>
+                      </a:endParaRPr>
+                    </a:p>
+                  </a:txBody>
+                  <a:tcPr marL="101600" marR="101600" marT="25400" marB="25400" anchor="ctr">
+                    <a:lnL w="6350" cap="flat" cmpd="sng" algn="ctr">
+                      <a:solidFill>
+                        <a:srgbClr val="E6E8F0"/>
+                      </a:solidFill>
+                      <a:prstDash val="solid"/>
+                      <a:round/>
+                      <a:headEnd type="none" w="med" len="med"/>
+                      <a:tailEnd type="none" w="med" len="med"/>
+                    </a:lnL>
+                    <a:lnR w="6350" cap="flat" cmpd="sng" algn="ctr">
+                      <a:solidFill>
+                        <a:srgbClr val="E6E8F0"/>
+                      </a:solidFill>
+                      <a:prstDash val="solid"/>
+                      <a:round/>
+                      <a:headEnd type="none" w="med" len="med"/>
+                      <a:tailEnd type="none" w="med" len="med"/>
+                    </a:lnR>
+                    <a:lnT w="6350" cap="flat" cmpd="sng" algn="ctr">
+                      <a:solidFill>
+                        <a:srgbClr val="E6E8F0"/>
+                      </a:solidFill>
+                      <a:prstDash val="solid"/>
+                      <a:round/>
+                      <a:headEnd type="none" w="med" len="med"/>
+                      <a:tailEnd type="none" w="med" len="med"/>
+                    </a:lnT>
+                    <a:lnB w="6350" cap="flat" cmpd="sng" algn="ctr">
+                      <a:solidFill>
+                        <a:srgbClr val="E6E8F0"/>
+                      </a:solidFill>
+                      <a:prstDash val="solid"/>
+                      <a:round/>
+                      <a:headEnd type="none" w="med" len="med"/>
+                      <a:tailEnd type="none" w="med" len="med"/>
+                    </a:lnB>
+                    <a:solidFill>
+                      <a:srgbClr val="FFFFFF"/>
+                    </a:solidFill>
+                  </a:tcPr>
+                </a:tc>
+              </a:tr>
+            </a:tbl>
+          </a:graphicData>
+        </a:graphic>
+      </p:graphicFrame>
+      <p:sp>
+        <p:nvSpPr>
+          <p:cNvPr id="6" name="Shape 3"/>
           <p:cNvSpPr/>
           <p:nvPr/>
         </p:nvSpPr>
         <p:spPr>
           <a:xfrm>
-            <a:off x="548640" y="2468880"/>
-            <a:ext cx="2651760" cy="2788920"/>
+            <a:off x="8412480" y="2286000"/>
+            <a:ext cx="3227832" cy="3291840"/>
           </a:xfrm>
           <a:prstGeom prst="roundRect">
             <a:avLst>
-              <a:gd name="adj" fmla="val 4138"/>
+              <a:gd name="adj" fmla="val 3399"/>
             </a:avLst>
           </a:prstGeom>
           <a:solidFill>
-            <a:srgbClr val="FFFFFF"/>
+            <a:srgbClr val="0B2AE0"/>
           </a:solidFill>
           <a:ln w="12700">
             <a:solidFill>
-              <a:srgbClr val="DEDEE3"/>
+              <a:srgbClr val="0B2AE0"/>
             </a:solidFill>
             <a:prstDash val="solid"/>
           </a:ln>
@@ -6338,14 +8014,14 @@
       </p:sp>
       <p:sp>
         <p:nvSpPr>
-          <p:cNvPr id="6" name="Text 4"/>
+          <p:cNvPr id="7" name="Text 4"/>
           <p:cNvSpPr/>
           <p:nvPr/>
         </p:nvSpPr>
         <p:spPr>
           <a:xfrm>
-            <a:off x="768096" y="2697480"/>
-            <a:ext cx="2249424" cy="457200"/>
+            <a:off x="8641080" y="2487168"/>
+            <a:ext cx="2743200" cy="274320"/>
           </a:xfrm>
           <a:prstGeom prst="rect">
             <a:avLst/>
@@ -6361,30 +8037,30 @@
               <a:buNone/>
             </a:pPr>
             <a:r>
-              <a:rPr lang="en-US" sz="1500" b="1" dirty="0">
+              <a:rPr lang="en-US" sz="1100" b="1" spc="150" kern="0" dirty="0">
                 <a:solidFill>
-                  <a:srgbClr val="12132A"/>
+                  <a:srgbClr val="CADCFC"/>
                 </a:solidFill>
                 <a:latin typeface="Calibri" pitchFamily="34" charset="0"/>
                 <a:ea typeface="Calibri" pitchFamily="34" charset="-122"/>
                 <a:cs typeface="Calibri" pitchFamily="34" charset="-120"/>
               </a:rPr>
-              <a:t>Screening</a:t>
+              <a:t>EVERY TOP-UP</a:t>
             </a:r>
-            <a:endParaRPr lang="en-US" sz="1500" dirty="0"/>
+            <a:endParaRPr lang="en-US" sz="1100" dirty="0"/>
           </a:p>
         </p:txBody>
       </p:sp>
       <p:sp>
         <p:nvSpPr>
-          <p:cNvPr id="7" name="Text 5"/>
+          <p:cNvPr id="8" name="Text 5"/>
           <p:cNvSpPr/>
           <p:nvPr/>
         </p:nvSpPr>
         <p:spPr>
           <a:xfrm>
-            <a:off x="768096" y="3218688"/>
-            <a:ext cx="2212848" cy="731520"/>
+            <a:off x="8641080" y="2788920"/>
+            <a:ext cx="2743200" cy="731520"/>
           </a:xfrm>
           <a:prstGeom prst="rect">
             <a:avLst/>
@@ -6402,13 +8078,13 @@
             <a:r>
               <a:rPr lang="en-US" sz="4000" b="1" dirty="0">
                 <a:solidFill>
-                  <a:srgbClr val="16A34A"/>
+                  <a:srgbClr val="FFFFFF"/>
                 </a:solidFill>
                 <a:latin typeface="Calibri" pitchFamily="34" charset="0"/>
                 <a:ea typeface="Calibri" pitchFamily="34" charset="-122"/>
                 <a:cs typeface="Calibri" pitchFamily="34" charset="-120"/>
               </a:rPr>
-              <a:t>78%</a:t>
+              <a:t>80–91%</a:t>
             </a:r>
             <a:endParaRPr lang="en-US" sz="4000" dirty="0"/>
           </a:p>
@@ -6416,14 +8092,14 @@
       </p:sp>
       <p:sp>
         <p:nvSpPr>
-          <p:cNvPr id="8" name="Text 6"/>
+          <p:cNvPr id="9" name="Text 6"/>
           <p:cNvSpPr/>
           <p:nvPr/>
         </p:nvSpPr>
         <p:spPr>
           <a:xfrm>
-            <a:off x="768096" y="3986784"/>
-            <a:ext cx="2212848" cy="274320"/>
+            <a:off x="8641080" y="3566160"/>
+            <a:ext cx="2743200" cy="274320"/>
           </a:xfrm>
           <a:prstGeom prst="rect">
             <a:avLst/>
@@ -6439,30 +8115,30 @@
               <a:buNone/>
             </a:pPr>
             <a:r>
-              <a:rPr lang="en-US" sz="1050" dirty="0">
+              <a:rPr lang="en-US" sz="1300" dirty="0">
                 <a:solidFill>
-                  <a:srgbClr val="6B7280"/>
+                  <a:srgbClr val="CADCFC"/>
                 </a:solidFill>
                 <a:latin typeface="Calibri" pitchFamily="34" charset="0"/>
                 <a:ea typeface="Calibri" pitchFamily="34" charset="-122"/>
                 <a:cs typeface="Calibri" pitchFamily="34" charset="-120"/>
               </a:rPr>
-              <a:t>gross margin at list</a:t>
+              <a:t>gross margin</a:t>
             </a:r>
-            <a:endParaRPr lang="en-US" sz="1050" dirty="0"/>
+            <a:endParaRPr lang="en-US" sz="1300" dirty="0"/>
           </a:p>
         </p:txBody>
       </p:sp>
       <p:sp>
         <p:nvSpPr>
-          <p:cNvPr id="9" name="Shape 7"/>
+          <p:cNvPr id="10" name="Shape 7"/>
           <p:cNvSpPr/>
           <p:nvPr/>
         </p:nvSpPr>
         <p:spPr>
           <a:xfrm>
-            <a:off x="768096" y="4352544"/>
-            <a:ext cx="2212848" cy="0"/>
+            <a:off x="8641080" y="4005072"/>
+            <a:ext cx="2788920" cy="0"/>
           </a:xfrm>
           <a:prstGeom prst="line">
             <a:avLst/>
@@ -6470,7 +8146,7 @@
           <a:noFill/>
           <a:ln w="12700">
             <a:solidFill>
-              <a:srgbClr val="DEDEE3"/>
+              <a:srgbClr val="3550EE"/>
             </a:solidFill>
             <a:prstDash val="solid"/>
           </a:ln>
@@ -6478,14 +8154,14 @@
       </p:sp>
       <p:sp>
         <p:nvSpPr>
-          <p:cNvPr id="10" name="Text 8"/>
+          <p:cNvPr id="11" name="Text 8"/>
           <p:cNvSpPr/>
           <p:nvPr/>
         </p:nvSpPr>
         <p:spPr>
           <a:xfrm>
-            <a:off x="768096" y="4462272"/>
-            <a:ext cx="2249424" cy="640080"/>
+            <a:off x="8641080" y="4160520"/>
+            <a:ext cx="2788920" cy="1280160"/>
           </a:xfrm>
           <a:prstGeom prst="rect">
             <a:avLst/>
@@ -6498,90 +8174,18 @@
           <a:lstStyle/>
           <a:p>
             <a:pPr algn="l" indent="0" marL="0">
-              <a:lnSpc>
-                <a:spcPct val="110000"/>
-              </a:lnSpc>
               <a:buNone/>
             </a:pPr>
             <a:r>
               <a:rPr lang="en-US" sz="1250" dirty="0">
                 <a:solidFill>
-                  <a:srgbClr val="4A5568"/>
+                  <a:srgbClr val="CADCFC"/>
                 </a:solidFill>
                 <a:latin typeface="Calibri" pitchFamily="34" charset="0"/>
                 <a:ea typeface="Calibri" pitchFamily="34" charset="-122"/>
                 <a:cs typeface="Calibri" pitchFamily="34" charset="-120"/>
               </a:rPr>
-              <a:t>Price </a:t>
-            </a:r>
-            <a:pPr algn="l" indent="0" marL="0">
-              <a:lnSpc>
-                <a:spcPct val="110000"/>
-              </a:lnSpc>
-              <a:buNone/>
-            </a:pPr>
-            <a:r>
-              <a:rPr lang="en-US" sz="1250" b="1" dirty="0">
-                <a:solidFill>
-                  <a:srgbClr val="12132A"/>
-                </a:solidFill>
-                <a:latin typeface="Calibri" pitchFamily="34" charset="0"/>
-                <a:ea typeface="Calibri" pitchFamily="34" charset="-122"/>
-                <a:cs typeface="Calibri" pitchFamily="34" charset="-120"/>
-              </a:rPr>
-              <a:t>RM2.85</a:t>
-            </a:r>
-            <a:pPr algn="l" indent="0" marL="0">
-              <a:lnSpc>
-                <a:spcPct val="110000"/>
-              </a:lnSpc>
-              <a:buNone/>
-            </a:pPr>
-            <a:r>
-              <a:rPr lang="en-US" sz="1250" dirty="0">
-                <a:solidFill>
-                  <a:srgbClr val="000000"/>
-                </a:solidFill>
-                <a:latin typeface="Calibri" pitchFamily="34" charset="0"/>
-                <a:ea typeface="Calibri" pitchFamily="34" charset="-122"/>
-                <a:cs typeface="Calibri" pitchFamily="34" charset="-120"/>
-              </a:rPr>
-              <a:t>
-</a:t>
-            </a:r>
-            <a:pPr algn="l" indent="0" marL="0">
-              <a:lnSpc>
-                <a:spcPct val="110000"/>
-              </a:lnSpc>
-              <a:buNone/>
-            </a:pPr>
-            <a:r>
-              <a:rPr lang="en-US" sz="1250" dirty="0">
-                <a:solidFill>
-                  <a:srgbClr val="4A5568"/>
-                </a:solidFill>
-                <a:latin typeface="Calibri" pitchFamily="34" charset="0"/>
-                <a:ea typeface="Calibri" pitchFamily="34" charset="-122"/>
-                <a:cs typeface="Calibri" pitchFamily="34" charset="-120"/>
-              </a:rPr>
-              <a:t>Cost </a:t>
-            </a:r>
-            <a:pPr algn="l" indent="0" marL="0">
-              <a:lnSpc>
-                <a:spcPct val="110000"/>
-              </a:lnSpc>
-              <a:buNone/>
-            </a:pPr>
-            <a:r>
-              <a:rPr lang="en-US" sz="1250" b="1" dirty="0">
-                <a:solidFill>
-                  <a:srgbClr val="12132A"/>
-                </a:solidFill>
-                <a:latin typeface="Calibri" pitchFamily="34" charset="0"/>
-                <a:ea typeface="Calibri" pitchFamily="34" charset="-122"/>
-                <a:cs typeface="Calibri" pitchFamily="34" charset="-120"/>
-              </a:rPr>
-              <a:t>RM0.64</a:t>
+              <a:t>The 10% partner share is not charged on top-ups, so credit sales carry the fattest margin of any revenue line.</a:t>
             </a:r>
             <a:endParaRPr lang="en-US" sz="1250" dirty="0"/>
           </a:p>
@@ -6589,868 +8193,13 @@
       </p:sp>
       <p:sp>
         <p:nvSpPr>
-          <p:cNvPr id="11" name="Shape 9"/>
+          <p:cNvPr id="12" name="Text 9"/>
           <p:cNvSpPr/>
           <p:nvPr/>
         </p:nvSpPr>
         <p:spPr>
           <a:xfrm>
-            <a:off x="3392424" y="2468880"/>
-            <a:ext cx="2651760" cy="2788920"/>
-          </a:xfrm>
-          <a:prstGeom prst="roundRect">
-            <a:avLst>
-              <a:gd name="adj" fmla="val 4138"/>
-            </a:avLst>
-          </a:prstGeom>
-          <a:solidFill>
-            <a:srgbClr val="FFFFFF"/>
-          </a:solidFill>
-          <a:ln w="12700">
-            <a:solidFill>
-              <a:srgbClr val="DEDEE3"/>
-            </a:solidFill>
-            <a:prstDash val="solid"/>
-          </a:ln>
-          <a:effectLst>
-            <a:outerShdw sx="100000" sy="100000" kx="0" ky="0" algn="bl" rotWithShape="0" blurRad="101600" dist="25400" dir="5400000">
-              <a:srgbClr val="9AA0B5">
-                <a:alpha val="18000"/>
-              </a:srgbClr>
-            </a:outerShdw>
-          </a:effectLst>
-        </p:spPr>
-      </p:sp>
-      <p:sp>
-        <p:nvSpPr>
-          <p:cNvPr id="12" name="Text 10"/>
-          <p:cNvSpPr/>
-          <p:nvPr/>
-        </p:nvSpPr>
-        <p:spPr>
-          <a:xfrm>
-            <a:off x="3611880" y="2697480"/>
-            <a:ext cx="2249424" cy="457200"/>
-          </a:xfrm>
-          <a:prstGeom prst="rect">
-            <a:avLst/>
-          </a:prstGeom>
-          <a:noFill/>
-          <a:ln/>
-        </p:spPr>
-        <p:txBody>
-          <a:bodyPr wrap="square" lIns="0" tIns="0" rIns="0" bIns="0" rtlCol="0" anchor="ctr"/>
-          <a:lstStyle/>
-          <a:p>
-            <a:pPr algn="l" indent="0" marL="0">
-              <a:buNone/>
-            </a:pPr>
-            <a:r>
-              <a:rPr lang="en-US" sz="1500" b="1" dirty="0">
-                <a:solidFill>
-                  <a:srgbClr val="12132A"/>
-                </a:solidFill>
-                <a:latin typeface="Calibri" pitchFamily="34" charset="0"/>
-                <a:ea typeface="Calibri" pitchFamily="34" charset="-122"/>
-                <a:cs typeface="Calibri" pitchFamily="34" charset="-120"/>
-              </a:rPr>
-              <a:t>AI Rank</a:t>
-            </a:r>
-            <a:endParaRPr lang="en-US" sz="1500" dirty="0"/>
-          </a:p>
-        </p:txBody>
-      </p:sp>
-      <p:sp>
-        <p:nvSpPr>
-          <p:cNvPr id="13" name="Text 11"/>
-          <p:cNvSpPr/>
-          <p:nvPr/>
-        </p:nvSpPr>
-        <p:spPr>
-          <a:xfrm>
-            <a:off x="3611880" y="3218688"/>
-            <a:ext cx="2212848" cy="731520"/>
-          </a:xfrm>
-          <a:prstGeom prst="rect">
-            <a:avLst/>
-          </a:prstGeom>
-          <a:noFill/>
-          <a:ln/>
-        </p:spPr>
-        <p:txBody>
-          <a:bodyPr wrap="square" lIns="0" tIns="0" rIns="0" bIns="0" rtlCol="0" anchor="ctr"/>
-          <a:lstStyle/>
-          <a:p>
-            <a:pPr algn="l" indent="0" marL="0">
-              <a:buNone/>
-            </a:pPr>
-            <a:r>
-              <a:rPr lang="en-US" sz="4000" b="1" dirty="0">
-                <a:solidFill>
-                  <a:srgbClr val="16A34A"/>
-                </a:solidFill>
-                <a:latin typeface="Calibri" pitchFamily="34" charset="0"/>
-                <a:ea typeface="Calibri" pitchFamily="34" charset="-122"/>
-                <a:cs typeface="Calibri" pitchFamily="34" charset="-120"/>
-              </a:rPr>
-              <a:t>75%</a:t>
-            </a:r>
-            <a:endParaRPr lang="en-US" sz="4000" dirty="0"/>
-          </a:p>
-        </p:txBody>
-      </p:sp>
-      <p:sp>
-        <p:nvSpPr>
-          <p:cNvPr id="14" name="Text 12"/>
-          <p:cNvSpPr/>
-          <p:nvPr/>
-        </p:nvSpPr>
-        <p:spPr>
-          <a:xfrm>
-            <a:off x="3611880" y="3986784"/>
-            <a:ext cx="2212848" cy="274320"/>
-          </a:xfrm>
-          <a:prstGeom prst="rect">
-            <a:avLst/>
-          </a:prstGeom>
-          <a:noFill/>
-          <a:ln/>
-        </p:spPr>
-        <p:txBody>
-          <a:bodyPr wrap="square" lIns="0" tIns="0" rIns="0" bIns="0" rtlCol="0" anchor="ctr"/>
-          <a:lstStyle/>
-          <a:p>
-            <a:pPr algn="l" indent="0" marL="0">
-              <a:buNone/>
-            </a:pPr>
-            <a:r>
-              <a:rPr lang="en-US" sz="1050" dirty="0">
-                <a:solidFill>
-                  <a:srgbClr val="6B7280"/>
-                </a:solidFill>
-                <a:latin typeface="Calibri" pitchFamily="34" charset="0"/>
-                <a:ea typeface="Calibri" pitchFamily="34" charset="-122"/>
-                <a:cs typeface="Calibri" pitchFamily="34" charset="-120"/>
-              </a:rPr>
-              <a:t>gross margin at list</a:t>
-            </a:r>
-            <a:endParaRPr lang="en-US" sz="1050" dirty="0"/>
-          </a:p>
-        </p:txBody>
-      </p:sp>
-      <p:sp>
-        <p:nvSpPr>
-          <p:cNvPr id="15" name="Shape 13"/>
-          <p:cNvSpPr/>
-          <p:nvPr/>
-        </p:nvSpPr>
-        <p:spPr>
-          <a:xfrm>
-            <a:off x="3611880" y="4352544"/>
-            <a:ext cx="2212848" cy="0"/>
-          </a:xfrm>
-          <a:prstGeom prst="line">
-            <a:avLst/>
-          </a:prstGeom>
-          <a:noFill/>
-          <a:ln w="12700">
-            <a:solidFill>
-              <a:srgbClr val="DEDEE3"/>
-            </a:solidFill>
-            <a:prstDash val="solid"/>
-          </a:ln>
-        </p:spPr>
-      </p:sp>
-      <p:sp>
-        <p:nvSpPr>
-          <p:cNvPr id="16" name="Text 14"/>
-          <p:cNvSpPr/>
-          <p:nvPr/>
-        </p:nvSpPr>
-        <p:spPr>
-          <a:xfrm>
-            <a:off x="3611880" y="4462272"/>
-            <a:ext cx="2249424" cy="640080"/>
-          </a:xfrm>
-          <a:prstGeom prst="rect">
-            <a:avLst/>
-          </a:prstGeom>
-          <a:noFill/>
-          <a:ln/>
-        </p:spPr>
-        <p:txBody>
-          <a:bodyPr wrap="square" lIns="0" tIns="0" rIns="0" bIns="0" rtlCol="0" anchor="t"/>
-          <a:lstStyle/>
-          <a:p>
-            <a:pPr algn="l" indent="0" marL="0">
-              <a:lnSpc>
-                <a:spcPct val="110000"/>
-              </a:lnSpc>
-              <a:buNone/>
-            </a:pPr>
-            <a:r>
-              <a:rPr lang="en-US" sz="1250" dirty="0">
-                <a:solidFill>
-                  <a:srgbClr val="4A5568"/>
-                </a:solidFill>
-                <a:latin typeface="Calibri" pitchFamily="34" charset="0"/>
-                <a:ea typeface="Calibri" pitchFamily="34" charset="-122"/>
-                <a:cs typeface="Calibri" pitchFamily="34" charset="-120"/>
-              </a:rPr>
-              <a:t>Price </a:t>
-            </a:r>
-            <a:pPr algn="l" indent="0" marL="0">
-              <a:lnSpc>
-                <a:spcPct val="110000"/>
-              </a:lnSpc>
-              <a:buNone/>
-            </a:pPr>
-            <a:r>
-              <a:rPr lang="en-US" sz="1250" b="1" dirty="0">
-                <a:solidFill>
-                  <a:srgbClr val="12132A"/>
-                </a:solidFill>
-                <a:latin typeface="Calibri" pitchFamily="34" charset="0"/>
-                <a:ea typeface="Calibri" pitchFamily="34" charset="-122"/>
-                <a:cs typeface="Calibri" pitchFamily="34" charset="-120"/>
-              </a:rPr>
-              <a:t>RM2.45</a:t>
-            </a:r>
-            <a:pPr algn="l" indent="0" marL="0">
-              <a:lnSpc>
-                <a:spcPct val="110000"/>
-              </a:lnSpc>
-              <a:buNone/>
-            </a:pPr>
-            <a:r>
-              <a:rPr lang="en-US" sz="1250" dirty="0">
-                <a:solidFill>
-                  <a:srgbClr val="000000"/>
-                </a:solidFill>
-                <a:latin typeface="Calibri" pitchFamily="34" charset="0"/>
-                <a:ea typeface="Calibri" pitchFamily="34" charset="-122"/>
-                <a:cs typeface="Calibri" pitchFamily="34" charset="-120"/>
-              </a:rPr>
-              <a:t>
-</a:t>
-            </a:r>
-            <a:pPr algn="l" indent="0" marL="0">
-              <a:lnSpc>
-                <a:spcPct val="110000"/>
-              </a:lnSpc>
-              <a:buNone/>
-            </a:pPr>
-            <a:r>
-              <a:rPr lang="en-US" sz="1250" dirty="0">
-                <a:solidFill>
-                  <a:srgbClr val="4A5568"/>
-                </a:solidFill>
-                <a:latin typeface="Calibri" pitchFamily="34" charset="0"/>
-                <a:ea typeface="Calibri" pitchFamily="34" charset="-122"/>
-                <a:cs typeface="Calibri" pitchFamily="34" charset="-120"/>
-              </a:rPr>
-              <a:t>Cost </a:t>
-            </a:r>
-            <a:pPr algn="l" indent="0" marL="0">
-              <a:lnSpc>
-                <a:spcPct val="110000"/>
-              </a:lnSpc>
-              <a:buNone/>
-            </a:pPr>
-            <a:r>
-              <a:rPr lang="en-US" sz="1250" b="1" dirty="0">
-                <a:solidFill>
-                  <a:srgbClr val="12132A"/>
-                </a:solidFill>
-                <a:latin typeface="Calibri" pitchFamily="34" charset="0"/>
-                <a:ea typeface="Calibri" pitchFamily="34" charset="-122"/>
-                <a:cs typeface="Calibri" pitchFamily="34" charset="-120"/>
-              </a:rPr>
-              <a:t>RM0.62</a:t>
-            </a:r>
-            <a:endParaRPr lang="en-US" sz="1250" dirty="0"/>
-          </a:p>
-        </p:txBody>
-      </p:sp>
-      <p:sp>
-        <p:nvSpPr>
-          <p:cNvPr id="17" name="Shape 15"/>
-          <p:cNvSpPr/>
-          <p:nvPr/>
-        </p:nvSpPr>
-        <p:spPr>
-          <a:xfrm>
-            <a:off x="6236208" y="2468880"/>
-            <a:ext cx="2651760" cy="2788920"/>
-          </a:xfrm>
-          <a:prstGeom prst="roundRect">
-            <a:avLst>
-              <a:gd name="adj" fmla="val 4138"/>
-            </a:avLst>
-          </a:prstGeom>
-          <a:solidFill>
-            <a:srgbClr val="FFFFFF"/>
-          </a:solidFill>
-          <a:ln w="12700">
-            <a:solidFill>
-              <a:srgbClr val="DEDEE3"/>
-            </a:solidFill>
-            <a:prstDash val="solid"/>
-          </a:ln>
-          <a:effectLst>
-            <a:outerShdw sx="100000" sy="100000" kx="0" ky="0" algn="bl" rotWithShape="0" blurRad="101600" dist="25400" dir="5400000">
-              <a:srgbClr val="9AA0B5">
-                <a:alpha val="18000"/>
-              </a:srgbClr>
-            </a:outerShdw>
-          </a:effectLst>
-        </p:spPr>
-      </p:sp>
-      <p:sp>
-        <p:nvSpPr>
-          <p:cNvPr id="18" name="Text 16"/>
-          <p:cNvSpPr/>
-          <p:nvPr/>
-        </p:nvSpPr>
-        <p:spPr>
-          <a:xfrm>
-            <a:off x="6455664" y="2697480"/>
-            <a:ext cx="2249424" cy="457200"/>
-          </a:xfrm>
-          <a:prstGeom prst="rect">
-            <a:avLst/>
-          </a:prstGeom>
-          <a:noFill/>
-          <a:ln/>
-        </p:spPr>
-        <p:txBody>
-          <a:bodyPr wrap="square" lIns="0" tIns="0" rIns="0" bIns="0" rtlCol="0" anchor="ctr"/>
-          <a:lstStyle/>
-          <a:p>
-            <a:pPr algn="l" indent="0" marL="0">
-              <a:buNone/>
-            </a:pPr>
-            <a:r>
-              <a:rPr lang="en-US" sz="1500" b="1" dirty="0">
-                <a:solidFill>
-                  <a:srgbClr val="12132A"/>
-                </a:solidFill>
-                <a:latin typeface="Calibri" pitchFamily="34" charset="0"/>
-                <a:ea typeface="Calibri" pitchFamily="34" charset="-122"/>
-                <a:cs typeface="Calibri" pitchFamily="34" charset="-120"/>
-              </a:rPr>
-              <a:t>Interview Q</a:t>
-            </a:r>
-            <a:endParaRPr lang="en-US" sz="1500" dirty="0"/>
-          </a:p>
-        </p:txBody>
-      </p:sp>
-      <p:sp>
-        <p:nvSpPr>
-          <p:cNvPr id="19" name="Text 17"/>
-          <p:cNvSpPr/>
-          <p:nvPr/>
-        </p:nvSpPr>
-        <p:spPr>
-          <a:xfrm>
-            <a:off x="6455664" y="3218688"/>
-            <a:ext cx="2212848" cy="731520"/>
-          </a:xfrm>
-          <a:prstGeom prst="rect">
-            <a:avLst/>
-          </a:prstGeom>
-          <a:noFill/>
-          <a:ln/>
-        </p:spPr>
-        <p:txBody>
-          <a:bodyPr wrap="square" lIns="0" tIns="0" rIns="0" bIns="0" rtlCol="0" anchor="ctr"/>
-          <a:lstStyle/>
-          <a:p>
-            <a:pPr algn="l" indent="0" marL="0">
-              <a:buNone/>
-            </a:pPr>
-            <a:r>
-              <a:rPr lang="en-US" sz="4000" b="1" dirty="0">
-                <a:solidFill>
-                  <a:srgbClr val="16A34A"/>
-                </a:solidFill>
-                <a:latin typeface="Calibri" pitchFamily="34" charset="0"/>
-                <a:ea typeface="Calibri" pitchFamily="34" charset="-122"/>
-                <a:cs typeface="Calibri" pitchFamily="34" charset="-120"/>
-              </a:rPr>
-              <a:t>73%</a:t>
-            </a:r>
-            <a:endParaRPr lang="en-US" sz="4000" dirty="0"/>
-          </a:p>
-        </p:txBody>
-      </p:sp>
-      <p:sp>
-        <p:nvSpPr>
-          <p:cNvPr id="20" name="Text 18"/>
-          <p:cNvSpPr/>
-          <p:nvPr/>
-        </p:nvSpPr>
-        <p:spPr>
-          <a:xfrm>
-            <a:off x="6455664" y="3986784"/>
-            <a:ext cx="2212848" cy="274320"/>
-          </a:xfrm>
-          <a:prstGeom prst="rect">
-            <a:avLst/>
-          </a:prstGeom>
-          <a:noFill/>
-          <a:ln/>
-        </p:spPr>
-        <p:txBody>
-          <a:bodyPr wrap="square" lIns="0" tIns="0" rIns="0" bIns="0" rtlCol="0" anchor="ctr"/>
-          <a:lstStyle/>
-          <a:p>
-            <a:pPr algn="l" indent="0" marL="0">
-              <a:buNone/>
-            </a:pPr>
-            <a:r>
-              <a:rPr lang="en-US" sz="1050" dirty="0">
-                <a:solidFill>
-                  <a:srgbClr val="6B7280"/>
-                </a:solidFill>
-                <a:latin typeface="Calibri" pitchFamily="34" charset="0"/>
-                <a:ea typeface="Calibri" pitchFamily="34" charset="-122"/>
-                <a:cs typeface="Calibri" pitchFamily="34" charset="-120"/>
-              </a:rPr>
-              <a:t>gross margin at list</a:t>
-            </a:r>
-            <a:endParaRPr lang="en-US" sz="1050" dirty="0"/>
-          </a:p>
-        </p:txBody>
-      </p:sp>
-      <p:sp>
-        <p:nvSpPr>
-          <p:cNvPr id="21" name="Shape 19"/>
-          <p:cNvSpPr/>
-          <p:nvPr/>
-        </p:nvSpPr>
-        <p:spPr>
-          <a:xfrm>
-            <a:off x="6455664" y="4352544"/>
-            <a:ext cx="2212848" cy="0"/>
-          </a:xfrm>
-          <a:prstGeom prst="line">
-            <a:avLst/>
-          </a:prstGeom>
-          <a:noFill/>
-          <a:ln w="12700">
-            <a:solidFill>
-              <a:srgbClr val="DEDEE3"/>
-            </a:solidFill>
-            <a:prstDash val="solid"/>
-          </a:ln>
-        </p:spPr>
-      </p:sp>
-      <p:sp>
-        <p:nvSpPr>
-          <p:cNvPr id="22" name="Text 20"/>
-          <p:cNvSpPr/>
-          <p:nvPr/>
-        </p:nvSpPr>
-        <p:spPr>
-          <a:xfrm>
-            <a:off x="6455664" y="4462272"/>
-            <a:ext cx="2249424" cy="640080"/>
-          </a:xfrm>
-          <a:prstGeom prst="rect">
-            <a:avLst/>
-          </a:prstGeom>
-          <a:noFill/>
-          <a:ln/>
-        </p:spPr>
-        <p:txBody>
-          <a:bodyPr wrap="square" lIns="0" tIns="0" rIns="0" bIns="0" rtlCol="0" anchor="t"/>
-          <a:lstStyle/>
-          <a:p>
-            <a:pPr algn="l" indent="0" marL="0">
-              <a:lnSpc>
-                <a:spcPct val="110000"/>
-              </a:lnSpc>
-              <a:buNone/>
-            </a:pPr>
-            <a:r>
-              <a:rPr lang="en-US" sz="1250" dirty="0">
-                <a:solidFill>
-                  <a:srgbClr val="4A5568"/>
-                </a:solidFill>
-                <a:latin typeface="Calibri" pitchFamily="34" charset="0"/>
-                <a:ea typeface="Calibri" pitchFamily="34" charset="-122"/>
-                <a:cs typeface="Calibri" pitchFamily="34" charset="-120"/>
-              </a:rPr>
-              <a:t>Price </a:t>
-            </a:r>
-            <a:pPr algn="l" indent="0" marL="0">
-              <a:lnSpc>
-                <a:spcPct val="110000"/>
-              </a:lnSpc>
-              <a:buNone/>
-            </a:pPr>
-            <a:r>
-              <a:rPr lang="en-US" sz="1250" b="1" dirty="0">
-                <a:solidFill>
-                  <a:srgbClr val="12132A"/>
-                </a:solidFill>
-                <a:latin typeface="Calibri" pitchFamily="34" charset="0"/>
-                <a:ea typeface="Calibri" pitchFamily="34" charset="-122"/>
-                <a:cs typeface="Calibri" pitchFamily="34" charset="-120"/>
-              </a:rPr>
-              <a:t>RM0.40</a:t>
-            </a:r>
-            <a:pPr algn="l" indent="0" marL="0">
-              <a:lnSpc>
-                <a:spcPct val="110000"/>
-              </a:lnSpc>
-              <a:buNone/>
-            </a:pPr>
-            <a:r>
-              <a:rPr lang="en-US" sz="1250" dirty="0">
-                <a:solidFill>
-                  <a:srgbClr val="000000"/>
-                </a:solidFill>
-                <a:latin typeface="Calibri" pitchFamily="34" charset="0"/>
-                <a:ea typeface="Calibri" pitchFamily="34" charset="-122"/>
-                <a:cs typeface="Calibri" pitchFamily="34" charset="-120"/>
-              </a:rPr>
-              <a:t>
-</a:t>
-            </a:r>
-            <a:pPr algn="l" indent="0" marL="0">
-              <a:lnSpc>
-                <a:spcPct val="110000"/>
-              </a:lnSpc>
-              <a:buNone/>
-            </a:pPr>
-            <a:r>
-              <a:rPr lang="en-US" sz="1250" dirty="0">
-                <a:solidFill>
-                  <a:srgbClr val="4A5568"/>
-                </a:solidFill>
-                <a:latin typeface="Calibri" pitchFamily="34" charset="0"/>
-                <a:ea typeface="Calibri" pitchFamily="34" charset="-122"/>
-                <a:cs typeface="Calibri" pitchFamily="34" charset="-120"/>
-              </a:rPr>
-              <a:t>Cost </a:t>
-            </a:r>
-            <a:pPr algn="l" indent="0" marL="0">
-              <a:lnSpc>
-                <a:spcPct val="110000"/>
-              </a:lnSpc>
-              <a:buNone/>
-            </a:pPr>
-            <a:r>
-              <a:rPr lang="en-US" sz="1250" b="1" dirty="0">
-                <a:solidFill>
-                  <a:srgbClr val="12132A"/>
-                </a:solidFill>
-                <a:latin typeface="Calibri" pitchFamily="34" charset="0"/>
-                <a:ea typeface="Calibri" pitchFamily="34" charset="-122"/>
-                <a:cs typeface="Calibri" pitchFamily="34" charset="-120"/>
-              </a:rPr>
-              <a:t>RM0.11</a:t>
-            </a:r>
-            <a:endParaRPr lang="en-US" sz="1250" dirty="0"/>
-          </a:p>
-        </p:txBody>
-      </p:sp>
-      <p:sp>
-        <p:nvSpPr>
-          <p:cNvPr id="23" name="Shape 21"/>
-          <p:cNvSpPr/>
-          <p:nvPr/>
-        </p:nvSpPr>
-        <p:spPr>
-          <a:xfrm>
-            <a:off x="9079992" y="2468880"/>
-            <a:ext cx="2651760" cy="2788920"/>
-          </a:xfrm>
-          <a:prstGeom prst="roundRect">
-            <a:avLst>
-              <a:gd name="adj" fmla="val 4138"/>
-            </a:avLst>
-          </a:prstGeom>
-          <a:solidFill>
-            <a:srgbClr val="FFFFFF"/>
-          </a:solidFill>
-          <a:ln w="12700">
-            <a:solidFill>
-              <a:srgbClr val="DEDEE3"/>
-            </a:solidFill>
-            <a:prstDash val="solid"/>
-          </a:ln>
-          <a:effectLst>
-            <a:outerShdw sx="100000" sy="100000" kx="0" ky="0" algn="bl" rotWithShape="0" blurRad="101600" dist="25400" dir="5400000">
-              <a:srgbClr val="9AA0B5">
-                <a:alpha val="18000"/>
-              </a:srgbClr>
-            </a:outerShdw>
-          </a:effectLst>
-        </p:spPr>
-      </p:sp>
-      <p:sp>
-        <p:nvSpPr>
-          <p:cNvPr id="24" name="Text 22"/>
-          <p:cNvSpPr/>
-          <p:nvPr/>
-        </p:nvSpPr>
-        <p:spPr>
-          <a:xfrm>
-            <a:off x="9299448" y="2697480"/>
-            <a:ext cx="2249424" cy="457200"/>
-          </a:xfrm>
-          <a:prstGeom prst="rect">
-            <a:avLst/>
-          </a:prstGeom>
-          <a:noFill/>
-          <a:ln/>
-        </p:spPr>
-        <p:txBody>
-          <a:bodyPr wrap="square" lIns="0" tIns="0" rIns="0" bIns="0" rtlCol="0" anchor="ctr"/>
-          <a:lstStyle/>
-          <a:p>
-            <a:pPr algn="l" indent="0" marL="0">
-              <a:buNone/>
-            </a:pPr>
-            <a:r>
-              <a:rPr lang="en-US" sz="1500" b="1" dirty="0">
-                <a:solidFill>
-                  <a:srgbClr val="12132A"/>
-                </a:solidFill>
-                <a:latin typeface="Calibri" pitchFamily="34" charset="0"/>
-                <a:ea typeface="Calibri" pitchFamily="34" charset="-122"/>
-                <a:cs typeface="Calibri" pitchFamily="34" charset="-120"/>
-              </a:rPr>
-              <a:t>Job draft</a:t>
-            </a:r>
-            <a:endParaRPr lang="en-US" sz="1500" dirty="0"/>
-          </a:p>
-        </p:txBody>
-      </p:sp>
-      <p:sp>
-        <p:nvSpPr>
-          <p:cNvPr id="25" name="Text 23"/>
-          <p:cNvSpPr/>
-          <p:nvPr/>
-        </p:nvSpPr>
-        <p:spPr>
-          <a:xfrm>
-            <a:off x="9299448" y="3218688"/>
-            <a:ext cx="2212848" cy="731520"/>
-          </a:xfrm>
-          <a:prstGeom prst="rect">
-            <a:avLst/>
-          </a:prstGeom>
-          <a:noFill/>
-          <a:ln/>
-        </p:spPr>
-        <p:txBody>
-          <a:bodyPr wrap="square" lIns="0" tIns="0" rIns="0" bIns="0" rtlCol="0" anchor="ctr"/>
-          <a:lstStyle/>
-          <a:p>
-            <a:pPr algn="l" indent="0" marL="0">
-              <a:buNone/>
-            </a:pPr>
-            <a:r>
-              <a:rPr lang="en-US" sz="4000" b="1" dirty="0">
-                <a:solidFill>
-                  <a:srgbClr val="16A34A"/>
-                </a:solidFill>
-                <a:latin typeface="Calibri" pitchFamily="34" charset="0"/>
-                <a:ea typeface="Calibri" pitchFamily="34" charset="-122"/>
-                <a:cs typeface="Calibri" pitchFamily="34" charset="-120"/>
-              </a:rPr>
-              <a:t>69%</a:t>
-            </a:r>
-            <a:endParaRPr lang="en-US" sz="4000" dirty="0"/>
-          </a:p>
-        </p:txBody>
-      </p:sp>
-      <p:sp>
-        <p:nvSpPr>
-          <p:cNvPr id="26" name="Text 24"/>
-          <p:cNvSpPr/>
-          <p:nvPr/>
-        </p:nvSpPr>
-        <p:spPr>
-          <a:xfrm>
-            <a:off x="9299448" y="3986784"/>
-            <a:ext cx="2212848" cy="274320"/>
-          </a:xfrm>
-          <a:prstGeom prst="rect">
-            <a:avLst/>
-          </a:prstGeom>
-          <a:noFill/>
-          <a:ln/>
-        </p:spPr>
-        <p:txBody>
-          <a:bodyPr wrap="square" lIns="0" tIns="0" rIns="0" bIns="0" rtlCol="0" anchor="ctr"/>
-          <a:lstStyle/>
-          <a:p>
-            <a:pPr algn="l" indent="0" marL="0">
-              <a:buNone/>
-            </a:pPr>
-            <a:r>
-              <a:rPr lang="en-US" sz="1050" dirty="0">
-                <a:solidFill>
-                  <a:srgbClr val="6B7280"/>
-                </a:solidFill>
-                <a:latin typeface="Calibri" pitchFamily="34" charset="0"/>
-                <a:ea typeface="Calibri" pitchFamily="34" charset="-122"/>
-                <a:cs typeface="Calibri" pitchFamily="34" charset="-120"/>
-              </a:rPr>
-              <a:t>gross margin at list</a:t>
-            </a:r>
-            <a:endParaRPr lang="en-US" sz="1050" dirty="0"/>
-          </a:p>
-        </p:txBody>
-      </p:sp>
-      <p:sp>
-        <p:nvSpPr>
-          <p:cNvPr id="27" name="Shape 25"/>
-          <p:cNvSpPr/>
-          <p:nvPr/>
-        </p:nvSpPr>
-        <p:spPr>
-          <a:xfrm>
-            <a:off x="9299448" y="4352544"/>
-            <a:ext cx="2212848" cy="0"/>
-          </a:xfrm>
-          <a:prstGeom prst="line">
-            <a:avLst/>
-          </a:prstGeom>
-          <a:noFill/>
-          <a:ln w="12700">
-            <a:solidFill>
-              <a:srgbClr val="DEDEE3"/>
-            </a:solidFill>
-            <a:prstDash val="solid"/>
-          </a:ln>
-        </p:spPr>
-      </p:sp>
-      <p:sp>
-        <p:nvSpPr>
-          <p:cNvPr id="28" name="Text 26"/>
-          <p:cNvSpPr/>
-          <p:nvPr/>
-        </p:nvSpPr>
-        <p:spPr>
-          <a:xfrm>
-            <a:off x="9299448" y="4462272"/>
-            <a:ext cx="2249424" cy="640080"/>
-          </a:xfrm>
-          <a:prstGeom prst="rect">
-            <a:avLst/>
-          </a:prstGeom>
-          <a:noFill/>
-          <a:ln/>
-        </p:spPr>
-        <p:txBody>
-          <a:bodyPr wrap="square" lIns="0" tIns="0" rIns="0" bIns="0" rtlCol="0" anchor="t"/>
-          <a:lstStyle/>
-          <a:p>
-            <a:pPr algn="l" indent="0" marL="0">
-              <a:lnSpc>
-                <a:spcPct val="110000"/>
-              </a:lnSpc>
-              <a:buNone/>
-            </a:pPr>
-            <a:r>
-              <a:rPr lang="en-US" sz="1250" dirty="0">
-                <a:solidFill>
-                  <a:srgbClr val="4A5568"/>
-                </a:solidFill>
-                <a:latin typeface="Calibri" pitchFamily="34" charset="0"/>
-                <a:ea typeface="Calibri" pitchFamily="34" charset="-122"/>
-                <a:cs typeface="Calibri" pitchFamily="34" charset="-120"/>
-              </a:rPr>
-              <a:t>Price </a:t>
-            </a:r>
-            <a:pPr algn="l" indent="0" marL="0">
-              <a:lnSpc>
-                <a:spcPct val="110000"/>
-              </a:lnSpc>
-              <a:buNone/>
-            </a:pPr>
-            <a:r>
-              <a:rPr lang="en-US" sz="1250" b="1" dirty="0">
-                <a:solidFill>
-                  <a:srgbClr val="12132A"/>
-                </a:solidFill>
-                <a:latin typeface="Calibri" pitchFamily="34" charset="0"/>
-                <a:ea typeface="Calibri" pitchFamily="34" charset="-122"/>
-                <a:cs typeface="Calibri" pitchFamily="34" charset="-120"/>
-              </a:rPr>
-              <a:t>RM2.25</a:t>
-            </a:r>
-            <a:pPr algn="l" indent="0" marL="0">
-              <a:lnSpc>
-                <a:spcPct val="110000"/>
-              </a:lnSpc>
-              <a:buNone/>
-            </a:pPr>
-            <a:r>
-              <a:rPr lang="en-US" sz="1250" dirty="0">
-                <a:solidFill>
-                  <a:srgbClr val="000000"/>
-                </a:solidFill>
-                <a:latin typeface="Calibri" pitchFamily="34" charset="0"/>
-                <a:ea typeface="Calibri" pitchFamily="34" charset="-122"/>
-                <a:cs typeface="Calibri" pitchFamily="34" charset="-120"/>
-              </a:rPr>
-              <a:t>
-</a:t>
-            </a:r>
-            <a:pPr algn="l" indent="0" marL="0">
-              <a:lnSpc>
-                <a:spcPct val="110000"/>
-              </a:lnSpc>
-              <a:buNone/>
-            </a:pPr>
-            <a:r>
-              <a:rPr lang="en-US" sz="1250" dirty="0">
-                <a:solidFill>
-                  <a:srgbClr val="4A5568"/>
-                </a:solidFill>
-                <a:latin typeface="Calibri" pitchFamily="34" charset="0"/>
-                <a:ea typeface="Calibri" pitchFamily="34" charset="-122"/>
-                <a:cs typeface="Calibri" pitchFamily="34" charset="-120"/>
-              </a:rPr>
-              <a:t>Cost </a:t>
-            </a:r>
-            <a:pPr algn="l" indent="0" marL="0">
-              <a:lnSpc>
-                <a:spcPct val="110000"/>
-              </a:lnSpc>
-              <a:buNone/>
-            </a:pPr>
-            <a:r>
-              <a:rPr lang="en-US" sz="1250" b="1" dirty="0">
-                <a:solidFill>
-                  <a:srgbClr val="12132A"/>
-                </a:solidFill>
-                <a:latin typeface="Calibri" pitchFamily="34" charset="0"/>
-                <a:ea typeface="Calibri" pitchFamily="34" charset="-122"/>
-                <a:cs typeface="Calibri" pitchFamily="34" charset="-120"/>
-              </a:rPr>
-              <a:t>RM0.69</a:t>
-            </a:r>
-            <a:endParaRPr lang="en-US" sz="1250" dirty="0"/>
-          </a:p>
-        </p:txBody>
-      </p:sp>
-      <p:sp>
-        <p:nvSpPr>
-          <p:cNvPr id="29" name="Text 27"/>
-          <p:cNvSpPr/>
-          <p:nvPr/>
-        </p:nvSpPr>
-        <p:spPr>
-          <a:xfrm>
-            <a:off x="548640" y="5577840"/>
+            <a:off x="548640" y="5852160"/>
             <a:ext cx="10972800" cy="274320"/>
           </a:xfrm>
           <a:prstGeom prst="rect">
@@ -7467,7 +8216,7 @@
               <a:buNone/>
             </a:pPr>
             <a:r>
-              <a:rPr lang="en-US" sz="1100" i="1" dirty="0">
+              <a:rPr lang="en-US" sz="1000" i="1" dirty="0">
                 <a:solidFill>
                   <a:srgbClr val="6B7280"/>
                 </a:solidFill>
@@ -7475,15 +8224,15 @@
                 <a:ea typeface="Calibri" pitchFamily="34" charset="-122"/>
                 <a:cs typeface="Calibri" pitchFamily="34" charset="-120"/>
               </a:rPr>
-              <a:t>Cost = AI inference + Stripe (3% + RM1 per top-up) + 10% partner share, on each credit's minimum top-up. Even after all three, top-ups clear ~70% margin.</a:t>
+              <a:t>Cost = AI inference + Stripe (3% + RM1 on each credit's minimum top-up: 10 / 10 / 10 / 50 / 10). Prices stored as USD cents, shown in MYR.</a:t>
             </a:r>
-            <a:endParaRPr lang="en-US" sz="1100" dirty="0"/>
+            <a:endParaRPr lang="en-US" sz="1000" dirty="0"/>
           </a:p>
         </p:txBody>
       </p:sp>
       <p:sp>
         <p:nvSpPr>
-          <p:cNvPr id="30" name="Text 28"/>
+          <p:cNvPr id="13" name="Text 10"/>
           <p:cNvSpPr/>
           <p:nvPr/>
         </p:nvSpPr>
@@ -7522,7 +8271,7 @@
       </p:sp>
       <p:sp>
         <p:nvSpPr>
-          <p:cNvPr id="31" name="Text 29"/>
+          <p:cNvPr id="14" name="Text 11"/>
           <p:cNvSpPr/>
           <p:nvPr/>
         </p:nvSpPr>
@@ -10469,7 +11218,7 @@
                 <a:ea typeface="Calibri" pitchFamily="34" charset="-122"/>
                 <a:cs typeface="Calibri" pitchFamily="34" charset="-120"/>
               </a:rPr>
-              <a:t>~62% </a:t>
+              <a:t>~64% </a:t>
             </a:r>
             <a:pPr algn="l" indent="0" marL="0">
               <a:buNone/>
@@ -12346,7 +13095,7 @@
                 <a:ea typeface="Calibri" pitchFamily="34" charset="-122"/>
                 <a:cs typeface="Calibri" pitchFamily="34" charset="-120"/>
               </a:rPr>
-              <a:t>80–90%</a:t>
+              <a:t>80–98%</a:t>
             </a:r>
             <a:endParaRPr lang="en-US" sz="3000" dirty="0"/>
           </a:p>
@@ -12522,7 +13271,7 @@
                 <a:ea typeface="Calibri" pitchFamily="34" charset="-122"/>
                 <a:cs typeface="Calibri" pitchFamily="34" charset="-120"/>
               </a:rPr>
-              <a:t>Each tier bundles enough screening and AI credits to run its open roles. The bundle is worth 2–3× the plan price at list credit rates, which anchors upgrades.</a:t>
+              <a:t>Each tier bundles enough screening and AI credits to run its open roles. The bundle is worth ~3× the plan price at list credit rates, which anchors upgrades.</a:t>
             </a:r>
             <a:endParaRPr lang="en-US" sz="1250" dirty="0"/>
           </a:p>
@@ -12659,7 +13408,7 @@
                 <a:ea typeface="Calibri" pitchFamily="34" charset="-122"/>
                 <a:cs typeface="Calibri" pitchFamily="34" charset="-120"/>
               </a:rPr>
-              <a:t>Overage sells at RM0.40–RM2.85 per action against a few sen of AI cost. This is where blended margin expands as accounts grow.</a:t>
+              <a:t>Overage sells at RM0.37–RM2.82 per action against a few sen of AI cost. This is where blended margin expands as accounts grow.</a:t>
             </a:r>
             <a:endParaRPr lang="en-US" sz="1250" dirty="0"/>
           </a:p>
@@ -20522,7 +21271,7 @@
                 <a:ea typeface="Calibri" pitchFamily="34" charset="-122"/>
                 <a:cs typeface="Calibri" pitchFamily="34" charset="-120"/>
               </a:rPr>
-              <a:t>The included AI is worth 2–3× the plan price</a:t>
+              <a:t>The included AI is worth ~3× the plan price</a:t>
             </a:r>
             <a:endParaRPr lang="en-US" sz="3400" dirty="0"/>
           </a:p>
@@ -20673,7 +21422,7 @@
                 <a:ea typeface="Calibri" pitchFamily="34" charset="-122"/>
                 <a:cs typeface="Calibri" pitchFamily="34" charset="-120"/>
               </a:rPr>
-              <a:t>3.3×</a:t>
+              <a:t>3.4×</a:t>
             </a:r>
             <a:endParaRPr lang="en-US" sz="2400" dirty="0"/>
           </a:p>
@@ -20790,7 +21539,7 @@
                 <a:ea typeface="Calibri" pitchFamily="34" charset="-122"/>
                 <a:cs typeface="Calibri" pitchFamily="34" charset="-120"/>
               </a:rPr>
-              <a:t>RM328</a:t>
+              <a:t>RM337</a:t>
             </a:r>
             <a:endParaRPr lang="en-US" sz="2800" dirty="0"/>
           </a:p>
@@ -21003,7 +21752,7 @@
                 <a:ea typeface="Calibri" pitchFamily="34" charset="-122"/>
                 <a:cs typeface="Calibri" pitchFamily="34" charset="-120"/>
               </a:rPr>
-              <a:t>2.8×</a:t>
+              <a:t>3.1×</a:t>
             </a:r>
             <a:endParaRPr lang="en-US" sz="2400" dirty="0"/>
           </a:p>
@@ -21120,7 +21869,7 @@
                 <a:ea typeface="Calibri" pitchFamily="34" charset="-122"/>
                 <a:cs typeface="Calibri" pitchFamily="34" charset="-120"/>
               </a:rPr>
-              <a:t>RM1,653</a:t>
+              <a:t>RM1,881</a:t>
             </a:r>
             <a:endParaRPr lang="en-US" sz="2800" dirty="0"/>
           </a:p>
@@ -21333,7 +22082,7 @@
                 <a:ea typeface="Calibri" pitchFamily="34" charset="-122"/>
                 <a:cs typeface="Calibri" pitchFamily="34" charset="-120"/>
               </a:rPr>
-              <a:t>2.4×</a:t>
+              <a:t>2.9×</a:t>
             </a:r>
             <a:endParaRPr lang="en-US" sz="2400" dirty="0"/>
           </a:p>
@@ -21450,7 +22199,7 @@
                 <a:ea typeface="Calibri" pitchFamily="34" charset="-122"/>
                 <a:cs typeface="Calibri" pitchFamily="34" charset="-120"/>
               </a:rPr>
-              <a:t>RM3,420</a:t>
+              <a:t>RM4,119</a:t>
             </a:r>
             <a:endParaRPr lang="en-US" sz="2800" dirty="0"/>
           </a:p>
@@ -21590,7 +22339,7 @@
                 <a:ea typeface="Calibri" pitchFamily="34" charset="-122"/>
                 <a:cs typeface="Calibri" pitchFamily="34" charset="-120"/>
               </a:rPr>
-              <a:t>Included value = monthly allowance priced at list credit rates (RM2.85 screening · RM2.45 AI Rank · RM0.40 questions). AI Insight allowance not valued here.</a:t>
+              <a:t>Included value = monthly allowance priced at list credit rates (RM2.82 screening · RM2.45 AI Rank / Insight · RM0.37 questions).</a:t>
             </a:r>
             <a:endParaRPr lang="en-US" sz="1050" dirty="0"/>
           </a:p>
@@ -22103,7 +22852,7 @@
                           <a:ea typeface="Calibri" pitchFamily="34" charset="-122"/>
                           <a:cs typeface="Calibri" pitchFamily="34" charset="-120"/>
                         </a:rPr>
-                        <a:t>RM2.85</a:t>
+                        <a:t>RM2.82</a:t>
                       </a:r>
                       <a:endParaRPr lang="en-US" sz="1250" dirty="0">
                         <a:latin typeface="Calibri" charset="0"/>
@@ -22447,7 +23196,7 @@
                           <a:ea typeface="Calibri" pitchFamily="34" charset="-122"/>
                           <a:cs typeface="Calibri" pitchFamily="34" charset="-120"/>
                         </a:rPr>
-                        <a:t>Interview questions</a:t>
+                        <a:t>AI Insight</a:t>
                       </a:r>
                       <a:endParaRPr lang="en-US" sz="1250" dirty="0">
                         <a:latin typeface="Calibri" charset="0"/>
@@ -22515,7 +23264,7 @@
                           <a:ea typeface="Calibri" pitchFamily="34" charset="-122"/>
                           <a:cs typeface="Calibri" pitchFamily="34" charset="-120"/>
                         </a:rPr>
-                        <a:t>RM0.40</a:t>
+                        <a:t>RM2.45</a:t>
                       </a:r>
                       <a:endParaRPr lang="en-US" sz="1250" dirty="0">
                         <a:latin typeface="Calibri" charset="0"/>
@@ -22563,6 +23312,212 @@
                     </a:lnB>
                     <a:solidFill>
                       <a:srgbClr val="FFFFFF"/>
+                    </a:solidFill>
+                  </a:tcPr>
+                </a:tc>
+                <a:tc>
+                  <a:txBody>
+                    <a:bodyPr/>
+                    <a:lstStyle/>
+                    <a:p>
+                      <a:pPr algn="ctr" indent="0" marL="0">
+                        <a:buNone/>
+                      </a:pPr>
+                      <a:r>
+                        <a:rPr lang="en-US" sz="1250" dirty="0">
+                          <a:solidFill>
+                            <a:srgbClr val="12132A"/>
+                          </a:solidFill>
+                          <a:latin typeface="Calibri" pitchFamily="34" charset="0"/>
+                          <a:ea typeface="Calibri" pitchFamily="34" charset="-122"/>
+                          <a:cs typeface="Calibri" pitchFamily="34" charset="-120"/>
+                        </a:rPr>
+                        <a:t>10</a:t>
+                      </a:r>
+                      <a:endParaRPr lang="en-US" sz="1250" dirty="0">
+                        <a:latin typeface="Calibri" charset="0"/>
+                        <a:ea typeface="Calibri" charset="0"/>
+                        <a:cs typeface="Calibri" charset="0"/>
+                      </a:endParaRPr>
+                    </a:p>
+                  </a:txBody>
+                  <a:tcPr marL="101600" marR="101600" marT="25400" marB="25400" anchor="ctr">
+                    <a:lnL w="6350" cap="flat" cmpd="sng" algn="ctr">
+                      <a:solidFill>
+                        <a:srgbClr val="E6E8F0"/>
+                      </a:solidFill>
+                      <a:prstDash val="solid"/>
+                      <a:round/>
+                      <a:headEnd type="none" w="med" len="med"/>
+                      <a:tailEnd type="none" w="med" len="med"/>
+                    </a:lnL>
+                    <a:lnR w="6350" cap="flat" cmpd="sng" algn="ctr">
+                      <a:solidFill>
+                        <a:srgbClr val="E6E8F0"/>
+                      </a:solidFill>
+                      <a:prstDash val="solid"/>
+                      <a:round/>
+                      <a:headEnd type="none" w="med" len="med"/>
+                      <a:tailEnd type="none" w="med" len="med"/>
+                    </a:lnR>
+                    <a:lnT w="6350" cap="flat" cmpd="sng" algn="ctr">
+                      <a:solidFill>
+                        <a:srgbClr val="E6E8F0"/>
+                      </a:solidFill>
+                      <a:prstDash val="solid"/>
+                      <a:round/>
+                      <a:headEnd type="none" w="med" len="med"/>
+                      <a:tailEnd type="none" w="med" len="med"/>
+                    </a:lnT>
+                    <a:lnB w="6350" cap="flat" cmpd="sng" algn="ctr">
+                      <a:solidFill>
+                        <a:srgbClr val="E6E8F0"/>
+                      </a:solidFill>
+                      <a:prstDash val="solid"/>
+                      <a:round/>
+                      <a:headEnd type="none" w="med" len="med"/>
+                      <a:tailEnd type="none" w="med" len="med"/>
+                    </a:lnB>
+                    <a:solidFill>
+                      <a:srgbClr val="FFFFFF"/>
+                    </a:solidFill>
+                  </a:tcPr>
+                </a:tc>
+              </a:tr>
+              <a:tr h="512064">
+                <a:tc>
+                  <a:txBody>
+                    <a:bodyPr/>
+                    <a:lstStyle/>
+                    <a:p>
+                      <a:pPr algn="l" indent="0" marL="0">
+                        <a:buNone/>
+                      </a:pPr>
+                      <a:r>
+                        <a:rPr lang="en-US" sz="1250" dirty="0">
+                          <a:solidFill>
+                            <a:srgbClr val="12132A"/>
+                          </a:solidFill>
+                          <a:latin typeface="Calibri" pitchFamily="34" charset="0"/>
+                          <a:ea typeface="Calibri" pitchFamily="34" charset="-122"/>
+                          <a:cs typeface="Calibri" pitchFamily="34" charset="-120"/>
+                        </a:rPr>
+                        <a:t>Interview questions</a:t>
+                      </a:r>
+                      <a:endParaRPr lang="en-US" sz="1250" dirty="0">
+                        <a:latin typeface="Calibri" charset="0"/>
+                        <a:ea typeface="Calibri" charset="0"/>
+                        <a:cs typeface="Calibri" charset="0"/>
+                      </a:endParaRPr>
+                    </a:p>
+                  </a:txBody>
+                  <a:tcPr marL="101600" marR="101600" marT="25400" marB="25400" anchor="ctr">
+                    <a:lnL w="6350" cap="flat" cmpd="sng" algn="ctr">
+                      <a:solidFill>
+                        <a:srgbClr val="E6E8F0"/>
+                      </a:solidFill>
+                      <a:prstDash val="solid"/>
+                      <a:round/>
+                      <a:headEnd type="none" w="med" len="med"/>
+                      <a:tailEnd type="none" w="med" len="med"/>
+                    </a:lnL>
+                    <a:lnR w="6350" cap="flat" cmpd="sng" algn="ctr">
+                      <a:solidFill>
+                        <a:srgbClr val="E6E8F0"/>
+                      </a:solidFill>
+                      <a:prstDash val="solid"/>
+                      <a:round/>
+                      <a:headEnd type="none" w="med" len="med"/>
+                      <a:tailEnd type="none" w="med" len="med"/>
+                    </a:lnR>
+                    <a:lnT w="6350" cap="flat" cmpd="sng" algn="ctr">
+                      <a:solidFill>
+                        <a:srgbClr val="E6E8F0"/>
+                      </a:solidFill>
+                      <a:prstDash val="solid"/>
+                      <a:round/>
+                      <a:headEnd type="none" w="med" len="med"/>
+                      <a:tailEnd type="none" w="med" len="med"/>
+                    </a:lnT>
+                    <a:lnB w="6350" cap="flat" cmpd="sng" algn="ctr">
+                      <a:solidFill>
+                        <a:srgbClr val="E6E8F0"/>
+                      </a:solidFill>
+                      <a:prstDash val="solid"/>
+                      <a:round/>
+                      <a:headEnd type="none" w="med" len="med"/>
+                      <a:tailEnd type="none" w="med" len="med"/>
+                    </a:lnB>
+                    <a:solidFill>
+                      <a:srgbClr val="F5F7FE"/>
+                    </a:solidFill>
+                  </a:tcPr>
+                </a:tc>
+                <a:tc>
+                  <a:txBody>
+                    <a:bodyPr/>
+                    <a:lstStyle/>
+                    <a:p>
+                      <a:pPr algn="r" indent="0" marL="0">
+                        <a:buNone/>
+                      </a:pPr>
+                      <a:r>
+                        <a:rPr lang="en-US" sz="1250" b="1" dirty="0">
+                          <a:solidFill>
+                            <a:srgbClr val="0B2AE0"/>
+                          </a:solidFill>
+                          <a:latin typeface="Calibri" pitchFamily="34" charset="0"/>
+                          <a:ea typeface="Calibri" pitchFamily="34" charset="-122"/>
+                          <a:cs typeface="Calibri" pitchFamily="34" charset="-120"/>
+                        </a:rPr>
+                        <a:t>RM0.37</a:t>
+                      </a:r>
+                      <a:endParaRPr lang="en-US" sz="1250" dirty="0">
+                        <a:latin typeface="Calibri" charset="0"/>
+                        <a:ea typeface="Calibri" charset="0"/>
+                        <a:cs typeface="Calibri" charset="0"/>
+                      </a:endParaRPr>
+                    </a:p>
+                  </a:txBody>
+                  <a:tcPr marL="101600" marR="101600" marT="25400" marB="25400" anchor="ctr">
+                    <a:lnL w="6350" cap="flat" cmpd="sng" algn="ctr">
+                      <a:solidFill>
+                        <a:srgbClr val="E6E8F0"/>
+                      </a:solidFill>
+                      <a:prstDash val="solid"/>
+                      <a:round/>
+                      <a:headEnd type="none" w="med" len="med"/>
+                      <a:tailEnd type="none" w="med" len="med"/>
+                    </a:lnL>
+                    <a:lnR w="6350" cap="flat" cmpd="sng" algn="ctr">
+                      <a:solidFill>
+                        <a:srgbClr val="E6E8F0"/>
+                      </a:solidFill>
+                      <a:prstDash val="solid"/>
+                      <a:round/>
+                      <a:headEnd type="none" w="med" len="med"/>
+                      <a:tailEnd type="none" w="med" len="med"/>
+                    </a:lnR>
+                    <a:lnT w="6350" cap="flat" cmpd="sng" algn="ctr">
+                      <a:solidFill>
+                        <a:srgbClr val="E6E8F0"/>
+                      </a:solidFill>
+                      <a:prstDash val="solid"/>
+                      <a:round/>
+                      <a:headEnd type="none" w="med" len="med"/>
+                      <a:tailEnd type="none" w="med" len="med"/>
+                    </a:lnT>
+                    <a:lnB w="6350" cap="flat" cmpd="sng" algn="ctr">
+                      <a:solidFill>
+                        <a:srgbClr val="E6E8F0"/>
+                      </a:solidFill>
+                      <a:prstDash val="solid"/>
+                      <a:round/>
+                      <a:headEnd type="none" w="med" len="med"/>
+                      <a:tailEnd type="none" w="med" len="med"/>
+                    </a:lnB>
+                    <a:solidFill>
+                      <a:srgbClr val="F5F7FE"/>
                     </a:solidFill>
                   </a:tcPr>
                 </a:tc>
@@ -22630,7 +23585,7 @@
                       <a:tailEnd type="none" w="med" len="med"/>
                     </a:lnB>
                     <a:solidFill>
-                      <a:srgbClr val="FFFFFF"/>
+                      <a:srgbClr val="F5F7FE"/>
                     </a:solidFill>
                   </a:tcPr>
                 </a:tc>
@@ -22700,7 +23655,7 @@
                       <a:tailEnd type="none" w="med" len="med"/>
                     </a:lnB>
                     <a:solidFill>
-                      <a:srgbClr val="F5F7FE"/>
+                      <a:srgbClr val="FFFFFF"/>
                     </a:solidFill>
                   </a:tcPr>
                 </a:tc>
@@ -22768,7 +23723,7 @@
                       <a:tailEnd type="none" w="med" len="med"/>
                     </a:lnB>
                     <a:solidFill>
-                      <a:srgbClr val="F5F7FE"/>
+                      <a:srgbClr val="FFFFFF"/>
                     </a:solidFill>
                   </a:tcPr>
                 </a:tc>
@@ -22836,7 +23791,7 @@
                       <a:tailEnd type="none" w="med" len="med"/>
                     </a:lnB>
                     <a:solidFill>
-                      <a:srgbClr val="F5F7FE"/>
+                      <a:srgbClr val="FFFFFF"/>
                     </a:solidFill>
                   </a:tcPr>
                 </a:tc>
@@ -23597,7 +24552,7 @@
                 <a:ea typeface="Calibri" pitchFamily="34" charset="-122"/>
                 <a:cs typeface="Calibri" pitchFamily="34" charset="-120"/>
               </a:rPr>
-              <a:t>Minimum top-up per credit is shown above. Each top-up is one Stripe charge; that fee is folded into the credit margins on slide 11.</a:t>
+              <a:t>Prices are stored once as USD cents and shown here in MYR. Minimum top-up per credit is above; each top-up is one Stripe charge, folded into the credit margins on slide 11.</a:t>
             </a:r>
             <a:endParaRPr lang="en-US" sz="1000" dirty="0"/>
           </a:p>
@@ -24424,7 +25379,7 @@
                           <a:ea typeface="Calibri" pitchFamily="34" charset="-122"/>
                           <a:cs typeface="Calibri" pitchFamily="34" charset="-120"/>
                         </a:rPr>
-                        <a:t>RM2.85</a:t>
+                        <a:t>RM2.82</a:t>
                       </a:r>
                       <a:endParaRPr lang="en-US" sz="1250" dirty="0">
                         <a:latin typeface="Calibri" charset="0"/>
@@ -25108,7 +26063,7 @@
                           <a:ea typeface="Calibri" pitchFamily="34" charset="-122"/>
                           <a:cs typeface="Calibri" pitchFamily="34" charset="-120"/>
                         </a:rPr>
-                        <a:t>Interview questions</a:t>
+                        <a:t>AI Insight</a:t>
                       </a:r>
                       <a:endParaRPr lang="en-US" sz="1250" dirty="0">
                         <a:latin typeface="Calibri" charset="0"/>
@@ -25244,7 +26199,7 @@
                           <a:ea typeface="Calibri" pitchFamily="34" charset="-122"/>
                           <a:cs typeface="Calibri" pitchFamily="34" charset="-120"/>
                         </a:rPr>
-                        <a:t>RM0.40</a:t>
+                        <a:t>RM2.45</a:t>
                       </a:r>
                       <a:endParaRPr lang="en-US" sz="1250" dirty="0">
                         <a:latin typeface="Calibri" charset="0"/>
@@ -25380,7 +26335,7 @@
                           <a:ea typeface="Calibri" pitchFamily="34" charset="-122"/>
                           <a:cs typeface="Calibri" pitchFamily="34" charset="-120"/>
                         </a:rPr>
-                        <a:t>~RM0.04</a:t>
+                        <a:t>~RM0.05</a:t>
                       </a:r>
                       <a:endParaRPr lang="en-US" sz="1250" dirty="0">
                         <a:latin typeface="Calibri" charset="0"/>
@@ -25448,7 +26403,7 @@
                           <a:ea typeface="Calibri" pitchFamily="34" charset="-122"/>
                           <a:cs typeface="Calibri" pitchFamily="34" charset="-120"/>
                         </a:rPr>
-                        <a:t>90%</a:t>
+                        <a:t>98%</a:t>
                       </a:r>
                       <a:endParaRPr lang="en-US" sz="1250" dirty="0">
                         <a:latin typeface="Calibri" charset="0"/>
@@ -25496,6 +26451,416 @@
                     </a:lnB>
                     <a:solidFill>
                       <a:srgbClr val="FFFFFF"/>
+                    </a:solidFill>
+                  </a:tcPr>
+                </a:tc>
+              </a:tr>
+              <a:tr h="457200">
+                <a:tc>
+                  <a:txBody>
+                    <a:bodyPr/>
+                    <a:lstStyle/>
+                    <a:p>
+                      <a:pPr algn="l" indent="0" marL="0">
+                        <a:buNone/>
+                      </a:pPr>
+                      <a:r>
+                        <a:rPr lang="en-US" sz="1250" b="1" dirty="0">
+                          <a:solidFill>
+                            <a:srgbClr val="12132A"/>
+                          </a:solidFill>
+                          <a:latin typeface="Calibri" pitchFamily="34" charset="0"/>
+                          <a:ea typeface="Calibri" pitchFamily="34" charset="-122"/>
+                          <a:cs typeface="Calibri" pitchFamily="34" charset="-120"/>
+                        </a:rPr>
+                        <a:t>Interview questions</a:t>
+                      </a:r>
+                      <a:endParaRPr lang="en-US" sz="1250" dirty="0">
+                        <a:latin typeface="Calibri" charset="0"/>
+                        <a:ea typeface="Calibri" charset="0"/>
+                        <a:cs typeface="Calibri" charset="0"/>
+                      </a:endParaRPr>
+                    </a:p>
+                  </a:txBody>
+                  <a:tcPr marL="76200" marR="76200" marT="25400" marB="25400" anchor="ctr">
+                    <a:lnL w="6350" cap="flat" cmpd="sng" algn="ctr">
+                      <a:solidFill>
+                        <a:srgbClr val="E6E8F0"/>
+                      </a:solidFill>
+                      <a:prstDash val="solid"/>
+                      <a:round/>
+                      <a:headEnd type="none" w="med" len="med"/>
+                      <a:tailEnd type="none" w="med" len="med"/>
+                    </a:lnL>
+                    <a:lnR w="6350" cap="flat" cmpd="sng" algn="ctr">
+                      <a:solidFill>
+                        <a:srgbClr val="E6E8F0"/>
+                      </a:solidFill>
+                      <a:prstDash val="solid"/>
+                      <a:round/>
+                      <a:headEnd type="none" w="med" len="med"/>
+                      <a:tailEnd type="none" w="med" len="med"/>
+                    </a:lnR>
+                    <a:lnT w="6350" cap="flat" cmpd="sng" algn="ctr">
+                      <a:solidFill>
+                        <a:srgbClr val="E6E8F0"/>
+                      </a:solidFill>
+                      <a:prstDash val="solid"/>
+                      <a:round/>
+                      <a:headEnd type="none" w="med" len="med"/>
+                      <a:tailEnd type="none" w="med" len="med"/>
+                    </a:lnT>
+                    <a:lnB w="6350" cap="flat" cmpd="sng" algn="ctr">
+                      <a:solidFill>
+                        <a:srgbClr val="E6E8F0"/>
+                      </a:solidFill>
+                      <a:prstDash val="solid"/>
+                      <a:round/>
+                      <a:headEnd type="none" w="med" len="med"/>
+                      <a:tailEnd type="none" w="med" len="med"/>
+                    </a:lnB>
+                    <a:solidFill>
+                      <a:srgbClr val="F5F7FE"/>
+                    </a:solidFill>
+                  </a:tcPr>
+                </a:tc>
+                <a:tc>
+                  <a:txBody>
+                    <a:bodyPr/>
+                    <a:lstStyle/>
+                    <a:p>
+                      <a:pPr algn="ctr" indent="0" marL="0">
+                        <a:buNone/>
+                      </a:pPr>
+                      <a:r>
+                        <a:rPr lang="en-US" sz="1250" dirty="0">
+                          <a:solidFill>
+                            <a:srgbClr val="4A5568"/>
+                          </a:solidFill>
+                          <a:latin typeface="Calibri" pitchFamily="34" charset="0"/>
+                          <a:ea typeface="Calibri" pitchFamily="34" charset="-122"/>
+                          <a:cs typeface="Calibri" pitchFamily="34" charset="-120"/>
+                        </a:rPr>
+                        <a:t>Haiku 4.5</a:t>
+                      </a:r>
+                      <a:endParaRPr lang="en-US" sz="1250" dirty="0">
+                        <a:latin typeface="Calibri" charset="0"/>
+                        <a:ea typeface="Calibri" charset="0"/>
+                        <a:cs typeface="Calibri" charset="0"/>
+                      </a:endParaRPr>
+                    </a:p>
+                  </a:txBody>
+                  <a:tcPr marL="76200" marR="76200" marT="25400" marB="25400" anchor="ctr">
+                    <a:lnL w="6350" cap="flat" cmpd="sng" algn="ctr">
+                      <a:solidFill>
+                        <a:srgbClr val="E6E8F0"/>
+                      </a:solidFill>
+                      <a:prstDash val="solid"/>
+                      <a:round/>
+                      <a:headEnd type="none" w="med" len="med"/>
+                      <a:tailEnd type="none" w="med" len="med"/>
+                    </a:lnL>
+                    <a:lnR w="6350" cap="flat" cmpd="sng" algn="ctr">
+                      <a:solidFill>
+                        <a:srgbClr val="E6E8F0"/>
+                      </a:solidFill>
+                      <a:prstDash val="solid"/>
+                      <a:round/>
+                      <a:headEnd type="none" w="med" len="med"/>
+                      <a:tailEnd type="none" w="med" len="med"/>
+                    </a:lnR>
+                    <a:lnT w="6350" cap="flat" cmpd="sng" algn="ctr">
+                      <a:solidFill>
+                        <a:srgbClr val="E6E8F0"/>
+                      </a:solidFill>
+                      <a:prstDash val="solid"/>
+                      <a:round/>
+                      <a:headEnd type="none" w="med" len="med"/>
+                      <a:tailEnd type="none" w="med" len="med"/>
+                    </a:lnT>
+                    <a:lnB w="6350" cap="flat" cmpd="sng" algn="ctr">
+                      <a:solidFill>
+                        <a:srgbClr val="E6E8F0"/>
+                      </a:solidFill>
+                      <a:prstDash val="solid"/>
+                      <a:round/>
+                      <a:headEnd type="none" w="med" len="med"/>
+                      <a:tailEnd type="none" w="med" len="med"/>
+                    </a:lnB>
+                    <a:solidFill>
+                      <a:srgbClr val="F5F7FE"/>
+                    </a:solidFill>
+                  </a:tcPr>
+                </a:tc>
+                <a:tc>
+                  <a:txBody>
+                    <a:bodyPr/>
+                    <a:lstStyle/>
+                    <a:p>
+                      <a:pPr algn="r" indent="0" marL="0">
+                        <a:buNone/>
+                      </a:pPr>
+                      <a:r>
+                        <a:rPr lang="en-US" sz="1250" dirty="0">
+                          <a:solidFill>
+                            <a:srgbClr val="4A5568"/>
+                          </a:solidFill>
+                          <a:latin typeface="Calibri" pitchFamily="34" charset="0"/>
+                          <a:ea typeface="Calibri" pitchFamily="34" charset="-122"/>
+                          <a:cs typeface="Calibri" pitchFamily="34" charset="-120"/>
+                        </a:rPr>
+                        <a:t>RM0.37</a:t>
+                      </a:r>
+                      <a:endParaRPr lang="en-US" sz="1250" dirty="0">
+                        <a:latin typeface="Calibri" charset="0"/>
+                        <a:ea typeface="Calibri" charset="0"/>
+                        <a:cs typeface="Calibri" charset="0"/>
+                      </a:endParaRPr>
+                    </a:p>
+                  </a:txBody>
+                  <a:tcPr marL="76200" marR="76200" marT="25400" marB="25400" anchor="ctr">
+                    <a:lnL w="6350" cap="flat" cmpd="sng" algn="ctr">
+                      <a:solidFill>
+                        <a:srgbClr val="E6E8F0"/>
+                      </a:solidFill>
+                      <a:prstDash val="solid"/>
+                      <a:round/>
+                      <a:headEnd type="none" w="med" len="med"/>
+                      <a:tailEnd type="none" w="med" len="med"/>
+                    </a:lnL>
+                    <a:lnR w="6350" cap="flat" cmpd="sng" algn="ctr">
+                      <a:solidFill>
+                        <a:srgbClr val="E6E8F0"/>
+                      </a:solidFill>
+                      <a:prstDash val="solid"/>
+                      <a:round/>
+                      <a:headEnd type="none" w="med" len="med"/>
+                      <a:tailEnd type="none" w="med" len="med"/>
+                    </a:lnR>
+                    <a:lnT w="6350" cap="flat" cmpd="sng" algn="ctr">
+                      <a:solidFill>
+                        <a:srgbClr val="E6E8F0"/>
+                      </a:solidFill>
+                      <a:prstDash val="solid"/>
+                      <a:round/>
+                      <a:headEnd type="none" w="med" len="med"/>
+                      <a:tailEnd type="none" w="med" len="med"/>
+                    </a:lnT>
+                    <a:lnB w="6350" cap="flat" cmpd="sng" algn="ctr">
+                      <a:solidFill>
+                        <a:srgbClr val="E6E8F0"/>
+                      </a:solidFill>
+                      <a:prstDash val="solid"/>
+                      <a:round/>
+                      <a:headEnd type="none" w="med" len="med"/>
+                      <a:tailEnd type="none" w="med" len="med"/>
+                    </a:lnB>
+                    <a:solidFill>
+                      <a:srgbClr val="F5F7FE"/>
+                    </a:solidFill>
+                  </a:tcPr>
+                </a:tc>
+                <a:tc>
+                  <a:txBody>
+                    <a:bodyPr/>
+                    <a:lstStyle/>
+                    <a:p>
+                      <a:pPr algn="r" indent="0" marL="0">
+                        <a:buNone/>
+                      </a:pPr>
+                      <a:r>
+                        <a:rPr lang="en-US" sz="1250" dirty="0">
+                          <a:solidFill>
+                            <a:srgbClr val="4A5568"/>
+                          </a:solidFill>
+                          <a:latin typeface="Calibri" pitchFamily="34" charset="0"/>
+                          <a:ea typeface="Calibri" pitchFamily="34" charset="-122"/>
+                          <a:cs typeface="Calibri" pitchFamily="34" charset="-120"/>
+                        </a:rPr>
+                        <a:t>~RM0.04</a:t>
+                      </a:r>
+                      <a:endParaRPr lang="en-US" sz="1250" dirty="0">
+                        <a:latin typeface="Calibri" charset="0"/>
+                        <a:ea typeface="Calibri" charset="0"/>
+                        <a:cs typeface="Calibri" charset="0"/>
+                      </a:endParaRPr>
+                    </a:p>
+                  </a:txBody>
+                  <a:tcPr marL="76200" marR="76200" marT="25400" marB="25400" anchor="ctr">
+                    <a:lnL w="6350" cap="flat" cmpd="sng" algn="ctr">
+                      <a:solidFill>
+                        <a:srgbClr val="E6E8F0"/>
+                      </a:solidFill>
+                      <a:prstDash val="solid"/>
+                      <a:round/>
+                      <a:headEnd type="none" w="med" len="med"/>
+                      <a:tailEnd type="none" w="med" len="med"/>
+                    </a:lnL>
+                    <a:lnR w="6350" cap="flat" cmpd="sng" algn="ctr">
+                      <a:solidFill>
+                        <a:srgbClr val="E6E8F0"/>
+                      </a:solidFill>
+                      <a:prstDash val="solid"/>
+                      <a:round/>
+                      <a:headEnd type="none" w="med" len="med"/>
+                      <a:tailEnd type="none" w="med" len="med"/>
+                    </a:lnR>
+                    <a:lnT w="6350" cap="flat" cmpd="sng" algn="ctr">
+                      <a:solidFill>
+                        <a:srgbClr val="E6E8F0"/>
+                      </a:solidFill>
+                      <a:prstDash val="solid"/>
+                      <a:round/>
+                      <a:headEnd type="none" w="med" len="med"/>
+                      <a:tailEnd type="none" w="med" len="med"/>
+                    </a:lnT>
+                    <a:lnB w="6350" cap="flat" cmpd="sng" algn="ctr">
+                      <a:solidFill>
+                        <a:srgbClr val="E6E8F0"/>
+                      </a:solidFill>
+                      <a:prstDash val="solid"/>
+                      <a:round/>
+                      <a:headEnd type="none" w="med" len="med"/>
+                      <a:tailEnd type="none" w="med" len="med"/>
+                    </a:lnB>
+                    <a:solidFill>
+                      <a:srgbClr val="F5F7FE"/>
+                    </a:solidFill>
+                  </a:tcPr>
+                </a:tc>
+                <a:tc>
+                  <a:txBody>
+                    <a:bodyPr/>
+                    <a:lstStyle/>
+                    <a:p>
+                      <a:pPr algn="r" indent="0" marL="0">
+                        <a:buNone/>
+                      </a:pPr>
+                      <a:r>
+                        <a:rPr lang="en-US" sz="1250" dirty="0">
+                          <a:solidFill>
+                            <a:srgbClr val="4A5568"/>
+                          </a:solidFill>
+                          <a:latin typeface="Calibri" pitchFamily="34" charset="0"/>
+                          <a:ea typeface="Calibri" pitchFamily="34" charset="-122"/>
+                          <a:cs typeface="Calibri" pitchFamily="34" charset="-120"/>
+                        </a:rPr>
+                        <a:t>~RM0.04</a:t>
+                      </a:r>
+                      <a:endParaRPr lang="en-US" sz="1250" dirty="0">
+                        <a:latin typeface="Calibri" charset="0"/>
+                        <a:ea typeface="Calibri" charset="0"/>
+                        <a:cs typeface="Calibri" charset="0"/>
+                      </a:endParaRPr>
+                    </a:p>
+                  </a:txBody>
+                  <a:tcPr marL="76200" marR="76200" marT="25400" marB="25400" anchor="ctr">
+                    <a:lnL w="6350" cap="flat" cmpd="sng" algn="ctr">
+                      <a:solidFill>
+                        <a:srgbClr val="E6E8F0"/>
+                      </a:solidFill>
+                      <a:prstDash val="solid"/>
+                      <a:round/>
+                      <a:headEnd type="none" w="med" len="med"/>
+                      <a:tailEnd type="none" w="med" len="med"/>
+                    </a:lnL>
+                    <a:lnR w="6350" cap="flat" cmpd="sng" algn="ctr">
+                      <a:solidFill>
+                        <a:srgbClr val="E6E8F0"/>
+                      </a:solidFill>
+                      <a:prstDash val="solid"/>
+                      <a:round/>
+                      <a:headEnd type="none" w="med" len="med"/>
+                      <a:tailEnd type="none" w="med" len="med"/>
+                    </a:lnR>
+                    <a:lnT w="6350" cap="flat" cmpd="sng" algn="ctr">
+                      <a:solidFill>
+                        <a:srgbClr val="E6E8F0"/>
+                      </a:solidFill>
+                      <a:prstDash val="solid"/>
+                      <a:round/>
+                      <a:headEnd type="none" w="med" len="med"/>
+                      <a:tailEnd type="none" w="med" len="med"/>
+                    </a:lnT>
+                    <a:lnB w="6350" cap="flat" cmpd="sng" algn="ctr">
+                      <a:solidFill>
+                        <a:srgbClr val="E6E8F0"/>
+                      </a:solidFill>
+                      <a:prstDash val="solid"/>
+                      <a:round/>
+                      <a:headEnd type="none" w="med" len="med"/>
+                      <a:tailEnd type="none" w="med" len="med"/>
+                    </a:lnB>
+                    <a:solidFill>
+                      <a:srgbClr val="F5F7FE"/>
+                    </a:solidFill>
+                  </a:tcPr>
+                </a:tc>
+                <a:tc>
+                  <a:txBody>
+                    <a:bodyPr/>
+                    <a:lstStyle/>
+                    <a:p>
+                      <a:pPr algn="r" indent="0" marL="0">
+                        <a:buNone/>
+                      </a:pPr>
+                      <a:r>
+                        <a:rPr lang="en-US" sz="1250" b="1" dirty="0">
+                          <a:solidFill>
+                            <a:srgbClr val="16A34A"/>
+                          </a:solidFill>
+                          <a:latin typeface="Calibri" pitchFamily="34" charset="0"/>
+                          <a:ea typeface="Calibri" pitchFamily="34" charset="-122"/>
+                          <a:cs typeface="Calibri" pitchFamily="34" charset="-120"/>
+                        </a:rPr>
+                        <a:t>89%</a:t>
+                      </a:r>
+                      <a:endParaRPr lang="en-US" sz="1250" dirty="0">
+                        <a:latin typeface="Calibri" charset="0"/>
+                        <a:ea typeface="Calibri" charset="0"/>
+                        <a:cs typeface="Calibri" charset="0"/>
+                      </a:endParaRPr>
+                    </a:p>
+                  </a:txBody>
+                  <a:tcPr marL="76200" marR="76200" marT="25400" marB="25400" anchor="ctr">
+                    <a:lnL w="6350" cap="flat" cmpd="sng" algn="ctr">
+                      <a:solidFill>
+                        <a:srgbClr val="E6E8F0"/>
+                      </a:solidFill>
+                      <a:prstDash val="solid"/>
+                      <a:round/>
+                      <a:headEnd type="none" w="med" len="med"/>
+                      <a:tailEnd type="none" w="med" len="med"/>
+                    </a:lnL>
+                    <a:lnR w="6350" cap="flat" cmpd="sng" algn="ctr">
+                      <a:solidFill>
+                        <a:srgbClr val="E6E8F0"/>
+                      </a:solidFill>
+                      <a:prstDash val="solid"/>
+                      <a:round/>
+                      <a:headEnd type="none" w="med" len="med"/>
+                      <a:tailEnd type="none" w="med" len="med"/>
+                    </a:lnR>
+                    <a:lnT w="6350" cap="flat" cmpd="sng" algn="ctr">
+                      <a:solidFill>
+                        <a:srgbClr val="E6E8F0"/>
+                      </a:solidFill>
+                      <a:prstDash val="solid"/>
+                      <a:round/>
+                      <a:headEnd type="none" w="med" len="med"/>
+                      <a:tailEnd type="none" w="med" len="med"/>
+                    </a:lnT>
+                    <a:lnB w="6350" cap="flat" cmpd="sng" algn="ctr">
+                      <a:solidFill>
+                        <a:srgbClr val="E6E8F0"/>
+                      </a:solidFill>
+                      <a:prstDash val="solid"/>
+                      <a:round/>
+                      <a:headEnd type="none" w="med" len="med"/>
+                      <a:tailEnd type="none" w="med" len="med"/>
+                    </a:lnB>
+                    <a:solidFill>
+                      <a:srgbClr val="F5F7FE"/>
                     </a:solidFill>
                   </a:tcPr>
                 </a:tc>
@@ -25565,7 +26930,7 @@
                       <a:tailEnd type="none" w="med" len="med"/>
                     </a:lnB>
                     <a:solidFill>
-                      <a:srgbClr val="F5F7FE"/>
+                      <a:srgbClr val="FFFFFF"/>
                     </a:solidFill>
                   </a:tcPr>
                 </a:tc>
@@ -25633,7 +26998,7 @@
                       <a:tailEnd type="none" w="med" len="med"/>
                     </a:lnB>
                     <a:solidFill>
-                      <a:srgbClr val="F5F7FE"/>
+                      <a:srgbClr val="FFFFFF"/>
                     </a:solidFill>
                   </a:tcPr>
                 </a:tc>
@@ -25701,7 +27066,7 @@
                       <a:tailEnd type="none" w="med" len="med"/>
                     </a:lnB>
                     <a:solidFill>
-                      <a:srgbClr val="F5F7FE"/>
+                      <a:srgbClr val="FFFFFF"/>
                     </a:solidFill>
                   </a:tcPr>
                 </a:tc>
@@ -25769,7 +27134,7 @@
                       <a:tailEnd type="none" w="med" len="med"/>
                     </a:lnB>
                     <a:solidFill>
-                      <a:srgbClr val="F5F7FE"/>
+                      <a:srgbClr val="FFFFFF"/>
                     </a:solidFill>
                   </a:tcPr>
                 </a:tc>
@@ -25837,7 +27202,7 @@
                       <a:tailEnd type="none" w="med" len="med"/>
                     </a:lnB>
                     <a:solidFill>
-                      <a:srgbClr val="F5F7FE"/>
+                      <a:srgbClr val="FFFFFF"/>
                     </a:solidFill>
                   </a:tcPr>
                 </a:tc>
@@ -25905,7 +27270,7 @@
                       <a:tailEnd type="none" w="med" len="med"/>
                     </a:lnB>
                     <a:solidFill>
-                      <a:srgbClr val="F5F7FE"/>
+                      <a:srgbClr val="FFFFFF"/>
                     </a:solidFill>
                   </a:tcPr>
                 </a:tc>
@@ -26184,7 +27549,7 @@
                 <a:ea typeface="Calibri" pitchFamily="34" charset="-122"/>
                 <a:cs typeface="Calibri" pitchFamily="34" charset="-120"/>
               </a:rPr>
-              <a:t>RM2.85</a:t>
+              <a:t>RM2.82</a:t>
             </a:r>
             <a:pPr algn="l" indent="0" marL="0">
               <a:lnSpc>
@@ -28677,7 +30042,7 @@
                           <a:ea typeface="Calibri" pitchFamily="34" charset="-122"/>
                           <a:cs typeface="Calibri" pitchFamily="34" charset="-120"/>
                         </a:rPr>
-                        <a:t>10% of each sale</a:t>
+                        <a:t>10% of each plan sale</a:t>
                       </a:r>
                       <a:endParaRPr lang="en-US" sz="1200" dirty="0">
                         <a:latin typeface="Calibri" charset="0"/>

</xml_diff>

<commit_message>
Update pricing deck: Enterprise BYO-AI (no credit discount) + RM30k floor + code-synced credits
Co-Authored-By: Claude Opus 4.8 <noreply@anthropic.com>
Claude-Session: https://claude.ai/code/session_0176R35qPk2mhGFwXaB3Lv9s
</commit_message>
<xml_diff>
--- a/docs/aster-pricing.pptx
+++ b/docs/aster-pricing.pptx
@@ -19,9 +19,10 @@
     <p:sldId id="267" r:id="rId13"/>
     <p:sldId id="268" r:id="rId14"/>
     <p:sldId id="269" r:id="rId15"/>
+    <p:sldId id="270" r:id="rId16"/>
   </p:sldIdLst>
   <p:notesMasterIdLst>
-    <p:notesMasterId r:id="rId16"/>
+    <p:notesMasterId r:id="rId17"/>
   </p:notesMasterIdLst>
   <p:sldSz cx="12192000" cy="6858000"/>
   <p:notesSz cx="6858000" cy="12192000"/>
@@ -979,6 +980,94 @@
             <a:fld id="{F7021451-1387-4CA6-816F-3879F97B5CBC}" type="slidenum">
               <a:rPr lang="en-US"/>
               <a:t>14</a:t>
+            </a:fld>
+            <a:endParaRPr lang="en-US"/>
+          </a:p>
+        </p:txBody>
+      </p:sp>
+    </p:spTree>
+    <p:extLst>
+      <p:ext uri="{BB962C8B-B14F-4D97-AF65-F5344CB8AC3E}">
+        <p14:creationId xmlns:p14="http://schemas.microsoft.com/office/powerpoint/2010/main" val="1024086991"/>
+      </p:ext>
+    </p:extLst>
+  </p:cSld>
+  <p:clrMapOvr>
+    <a:masterClrMapping/>
+  </p:clrMapOvr>
+</p:notes>
+</file>
+
+<file path=ppt/notesSlides/notesSlide15.xml><?xml version="1.0" encoding="utf-8"?>
+<p:notes xmlns:a="http://schemas.openxmlformats.org/drawingml/2006/main" xmlns:r="http://schemas.openxmlformats.org/officeDocument/2006/relationships" xmlns:p="http://schemas.openxmlformats.org/presentationml/2006/main">
+  <p:cSld>
+    <p:spTree>
+      <p:nvGrpSpPr>
+        <p:cNvPr id="1" name=""/>
+        <p:cNvGrpSpPr/>
+        <p:nvPr/>
+      </p:nvGrpSpPr>
+      <p:grpSpPr>
+        <a:xfrm>
+          <a:off x="0" y="0"/>
+          <a:ext cx="0" cy="0"/>
+          <a:chOff x="0" y="0"/>
+          <a:chExt cx="0" cy="0"/>
+        </a:xfrm>
+      </p:grpSpPr>
+      <p:sp>
+        <p:nvSpPr>
+          <p:cNvPr id="2" name="Slide Image Placeholder 1"/>
+          <p:cNvSpPr>
+            <a:spLocks noGrp="1" noRot="1" noChangeAspect="1"/>
+          </p:cNvSpPr>
+          <p:nvPr>
+            <p:ph type="sldImg"/>
+          </p:nvPr>
+        </p:nvSpPr>
+        <p:spPr/>
+      </p:sp>
+      <p:sp>
+        <p:nvSpPr>
+          <p:cNvPr id="3" name="Notes Placeholder 2"/>
+          <p:cNvSpPr>
+            <a:spLocks noGrp="1"/>
+          </p:cNvSpPr>
+          <p:nvPr>
+            <p:ph type="body" idx="1"/>
+          </p:nvPr>
+        </p:nvSpPr>
+        <p:spPr/>
+        <p:txBody>
+          <a:bodyPr/>
+          <a:lstStyle/>
+          <a:p>
+            <a:r>
+              <a:rPr lang="en-US" dirty="0"/>
+              <a:t/>
+            </a:r>
+            <a:endParaRPr lang="en-US" dirty="0"/>
+          </a:p>
+        </p:txBody>
+      </p:sp>
+      <p:sp>
+        <p:nvSpPr>
+          <p:cNvPr id="4" name="Slide Number Placeholder 3"/>
+          <p:cNvSpPr>
+            <a:spLocks noGrp="1"/>
+          </p:cNvSpPr>
+          <p:nvPr>
+            <p:ph type="sldNum" sz="quarter" idx="10"/>
+          </p:nvPr>
+        </p:nvSpPr>
+        <p:spPr/>
+        <p:txBody>
+          <a:bodyPr/>
+          <a:lstStyle/>
+          <a:p>
+            <a:fld id="{F7021451-1387-4CA6-816F-3879F97B5CBC}" type="slidenum">
+              <a:rPr lang="en-US"/>
+              <a:t>15</a:t>
             </a:fld>
             <a:endParaRPr lang="en-US"/>
           </a:p>
@@ -8373,6 +8462,1514 @@
                 <a:ea typeface="Calibri" pitchFamily="34" charset="-122"/>
                 <a:cs typeface="Calibri" pitchFamily="34" charset="-120"/>
               </a:rPr>
+              <a:t>CUSTOM LICENSING</a:t>
+            </a:r>
+            <a:endParaRPr lang="en-US" sz="1200" dirty="0"/>
+          </a:p>
+        </p:txBody>
+      </p:sp>
+      <p:sp>
+        <p:nvSpPr>
+          <p:cNvPr id="3" name="Text 1"/>
+          <p:cNvSpPr/>
+          <p:nvPr/>
+        </p:nvSpPr>
+        <p:spPr>
+          <a:xfrm>
+            <a:off x="548640" y="777240"/>
+            <a:ext cx="11064240" cy="822960"/>
+          </a:xfrm>
+          <a:prstGeom prst="rect">
+            <a:avLst/>
+          </a:prstGeom>
+          <a:noFill/>
+          <a:ln/>
+        </p:spPr>
+        <p:txBody>
+          <a:bodyPr wrap="square" lIns="0" tIns="0" rIns="0" bIns="0" rtlCol="0" anchor="ctr"/>
+          <a:lstStyle/>
+          <a:p>
+            <a:pPr algn="l" indent="0" marL="0">
+              <a:buNone/>
+            </a:pPr>
+            <a:r>
+              <a:rPr lang="en-US" sz="3400" b="1" dirty="0">
+                <a:solidFill>
+                  <a:srgbClr val="12132A"/>
+                </a:solidFill>
+                <a:latin typeface="Calibri" pitchFamily="34" charset="0"/>
+                <a:ea typeface="Calibri" pitchFamily="34" charset="-122"/>
+                <a:cs typeface="Calibri" pitchFamily="34" charset="-120"/>
+              </a:rPr>
+              <a:t>Enterprise pricing</a:t>
+            </a:r>
+            <a:endParaRPr lang="en-US" sz="3400" dirty="0"/>
+          </a:p>
+        </p:txBody>
+      </p:sp>
+      <p:sp>
+        <p:nvSpPr>
+          <p:cNvPr id="4" name="Text 2"/>
+          <p:cNvSpPr/>
+          <p:nvPr/>
+        </p:nvSpPr>
+        <p:spPr>
+          <a:xfrm>
+            <a:off x="548640" y="1463040"/>
+            <a:ext cx="11064240" cy="548640"/>
+          </a:xfrm>
+          <a:prstGeom prst="rect">
+            <a:avLst/>
+          </a:prstGeom>
+          <a:noFill/>
+          <a:ln/>
+        </p:spPr>
+        <p:txBody>
+          <a:bodyPr wrap="square" lIns="0" tIns="0" rIns="0" bIns="0" rtlCol="0" anchor="ctr"/>
+          <a:lstStyle/>
+          <a:p>
+            <a:pPr algn="l" indent="0" marL="0">
+              <a:buNone/>
+            </a:pPr>
+            <a:r>
+              <a:rPr lang="en-US" sz="1350" dirty="0">
+                <a:solidFill>
+                  <a:srgbClr val="4A5568"/>
+                </a:solidFill>
+                <a:latin typeface="Calibri" pitchFamily="34" charset="0"/>
+                <a:ea typeface="Calibri" pitchFamily="34" charset="-122"/>
+                <a:cs typeface="Calibri" pitchFamily="34" charset="-120"/>
+              </a:rPr>
+              <a:t>Enterprise is a custom annual licence, floored at RM30,000 / mo and scaled by volume. The customer runs AI on its own account, so we license the platform, compliance and support, not usage.</a:t>
+            </a:r>
+            <a:endParaRPr lang="en-US" sz="1350" dirty="0"/>
+          </a:p>
+        </p:txBody>
+      </p:sp>
+      <p:sp>
+        <p:nvSpPr>
+          <p:cNvPr id="5" name="Shape 3"/>
+          <p:cNvSpPr/>
+          <p:nvPr/>
+        </p:nvSpPr>
+        <p:spPr>
+          <a:xfrm>
+            <a:off x="594360" y="2167128"/>
+            <a:ext cx="384048" cy="384048"/>
+          </a:xfrm>
+          <a:prstGeom prst="ellipse">
+            <a:avLst/>
+          </a:prstGeom>
+          <a:solidFill>
+            <a:srgbClr val="0B2AE0"/>
+          </a:solidFill>
+          <a:ln/>
+        </p:spPr>
+      </p:sp>
+      <p:sp>
+        <p:nvSpPr>
+          <p:cNvPr id="6" name="Text 4"/>
+          <p:cNvSpPr/>
+          <p:nvPr/>
+        </p:nvSpPr>
+        <p:spPr>
+          <a:xfrm>
+            <a:off x="594360" y="2157984"/>
+            <a:ext cx="384048" cy="384048"/>
+          </a:xfrm>
+          <a:prstGeom prst="rect">
+            <a:avLst/>
+          </a:prstGeom>
+          <a:noFill/>
+          <a:ln/>
+        </p:spPr>
+        <p:txBody>
+          <a:bodyPr wrap="square" lIns="0" tIns="0" rIns="0" bIns="0" rtlCol="0" anchor="ctr"/>
+          <a:lstStyle/>
+          <a:p>
+            <a:pPr algn="ctr" indent="0" marL="0">
+              <a:buNone/>
+            </a:pPr>
+            <a:r>
+              <a:rPr lang="en-US" sz="1500" b="1" dirty="0">
+                <a:solidFill>
+                  <a:srgbClr val="FFFFFF"/>
+                </a:solidFill>
+                <a:latin typeface="Calibri" pitchFamily="34" charset="0"/>
+                <a:ea typeface="Calibri" pitchFamily="34" charset="-122"/>
+                <a:cs typeface="Calibri" pitchFamily="34" charset="-120"/>
+              </a:rPr>
+              <a:t>1</a:t>
+            </a:r>
+            <a:endParaRPr lang="en-US" sz="1500" dirty="0"/>
+          </a:p>
+        </p:txBody>
+      </p:sp>
+      <p:sp>
+        <p:nvSpPr>
+          <p:cNvPr id="7" name="Text 5"/>
+          <p:cNvSpPr/>
+          <p:nvPr/>
+        </p:nvSpPr>
+        <p:spPr>
+          <a:xfrm>
+            <a:off x="1143000" y="2103120"/>
+            <a:ext cx="5943600" cy="274320"/>
+          </a:xfrm>
+          <a:prstGeom prst="rect">
+            <a:avLst/>
+          </a:prstGeom>
+          <a:noFill/>
+          <a:ln/>
+        </p:spPr>
+        <p:txBody>
+          <a:bodyPr wrap="square" lIns="0" tIns="0" rIns="0" bIns="0" rtlCol="0" anchor="ctr"/>
+          <a:lstStyle/>
+          <a:p>
+            <a:pPr algn="l" indent="0" marL="0">
+              <a:buNone/>
+            </a:pPr>
+            <a:r>
+              <a:rPr lang="en-US" sz="1450" b="1" dirty="0">
+                <a:solidFill>
+                  <a:srgbClr val="12132A"/>
+                </a:solidFill>
+                <a:latin typeface="Calibri" pitchFamily="34" charset="0"/>
+                <a:ea typeface="Calibri" pitchFamily="34" charset="-122"/>
+                <a:cs typeface="Calibri" pitchFamily="34" charset="-120"/>
+              </a:rPr>
+              <a:t>Floor</a:t>
+            </a:r>
+            <a:endParaRPr lang="en-US" sz="1450" dirty="0"/>
+          </a:p>
+        </p:txBody>
+      </p:sp>
+      <p:sp>
+        <p:nvSpPr>
+          <p:cNvPr id="8" name="Text 6"/>
+          <p:cNvSpPr/>
+          <p:nvPr/>
+        </p:nvSpPr>
+        <p:spPr>
+          <a:xfrm>
+            <a:off x="1143000" y="2404872"/>
+            <a:ext cx="5943600" cy="502920"/>
+          </a:xfrm>
+          <a:prstGeom prst="rect">
+            <a:avLst/>
+          </a:prstGeom>
+          <a:noFill/>
+          <a:ln/>
+        </p:spPr>
+        <p:txBody>
+          <a:bodyPr wrap="square" lIns="0" tIns="0" rIns="0" bIns="0" rtlCol="0" anchor="ctr"/>
+          <a:lstStyle/>
+          <a:p>
+            <a:pPr algn="l" indent="0" marL="0">
+              <a:buNone/>
+            </a:pPr>
+            <a:r>
+              <a:rPr lang="en-US" sz="1200" dirty="0">
+                <a:solidFill>
+                  <a:srgbClr val="4A5568"/>
+                </a:solidFill>
+                <a:latin typeface="Calibri" pitchFamily="34" charset="0"/>
+                <a:ea typeface="Calibri" pitchFamily="34" charset="-122"/>
+                <a:cs typeface="Calibri" pitchFamily="34" charset="-120"/>
+              </a:rPr>
+              <a:t>RM30,000 / mo (RM360k / yr), annual commitment.</a:t>
+            </a:r>
+            <a:endParaRPr lang="en-US" sz="1200" dirty="0"/>
+          </a:p>
+        </p:txBody>
+      </p:sp>
+      <p:sp>
+        <p:nvSpPr>
+          <p:cNvPr id="9" name="Shape 7"/>
+          <p:cNvSpPr/>
+          <p:nvPr/>
+        </p:nvSpPr>
+        <p:spPr>
+          <a:xfrm>
+            <a:off x="594360" y="3035808"/>
+            <a:ext cx="384048" cy="384048"/>
+          </a:xfrm>
+          <a:prstGeom prst="ellipse">
+            <a:avLst/>
+          </a:prstGeom>
+          <a:solidFill>
+            <a:srgbClr val="0B2AE0"/>
+          </a:solidFill>
+          <a:ln/>
+        </p:spPr>
+      </p:sp>
+      <p:sp>
+        <p:nvSpPr>
+          <p:cNvPr id="10" name="Text 8"/>
+          <p:cNvSpPr/>
+          <p:nvPr/>
+        </p:nvSpPr>
+        <p:spPr>
+          <a:xfrm>
+            <a:off x="594360" y="3026664"/>
+            <a:ext cx="384048" cy="384048"/>
+          </a:xfrm>
+          <a:prstGeom prst="rect">
+            <a:avLst/>
+          </a:prstGeom>
+          <a:noFill/>
+          <a:ln/>
+        </p:spPr>
+        <p:txBody>
+          <a:bodyPr wrap="square" lIns="0" tIns="0" rIns="0" bIns="0" rtlCol="0" anchor="ctr"/>
+          <a:lstStyle/>
+          <a:p>
+            <a:pPr algn="ctr" indent="0" marL="0">
+              <a:buNone/>
+            </a:pPr>
+            <a:r>
+              <a:rPr lang="en-US" sz="1500" b="1" dirty="0">
+                <a:solidFill>
+                  <a:srgbClr val="FFFFFF"/>
+                </a:solidFill>
+                <a:latin typeface="Calibri" pitchFamily="34" charset="0"/>
+                <a:ea typeface="Calibri" pitchFamily="34" charset="-122"/>
+                <a:cs typeface="Calibri" pitchFamily="34" charset="-120"/>
+              </a:rPr>
+              <a:t>2</a:t>
+            </a:r>
+            <a:endParaRPr lang="en-US" sz="1500" dirty="0"/>
+          </a:p>
+        </p:txBody>
+      </p:sp>
+      <p:sp>
+        <p:nvSpPr>
+          <p:cNvPr id="11" name="Text 9"/>
+          <p:cNvSpPr/>
+          <p:nvPr/>
+        </p:nvSpPr>
+        <p:spPr>
+          <a:xfrm>
+            <a:off x="1143000" y="2971800"/>
+            <a:ext cx="5943600" cy="274320"/>
+          </a:xfrm>
+          <a:prstGeom prst="rect">
+            <a:avLst/>
+          </a:prstGeom>
+          <a:noFill/>
+          <a:ln/>
+        </p:spPr>
+        <p:txBody>
+          <a:bodyPr wrap="square" lIns="0" tIns="0" rIns="0" bIns="0" rtlCol="0" anchor="ctr"/>
+          <a:lstStyle/>
+          <a:p>
+            <a:pPr algn="l" indent="0" marL="0">
+              <a:buNone/>
+            </a:pPr>
+            <a:r>
+              <a:rPr lang="en-US" sz="1450" b="1" dirty="0">
+                <a:solidFill>
+                  <a:srgbClr val="12132A"/>
+                </a:solidFill>
+                <a:latin typeface="Calibri" pitchFamily="34" charset="0"/>
+                <a:ea typeface="Calibri" pitchFamily="34" charset="-122"/>
+                <a:cs typeface="Calibri" pitchFamily="34" charset="-120"/>
+              </a:rPr>
+              <a:t>Scales by volume</a:t>
+            </a:r>
+            <a:endParaRPr lang="en-US" sz="1450" dirty="0"/>
+          </a:p>
+        </p:txBody>
+      </p:sp>
+      <p:sp>
+        <p:nvSpPr>
+          <p:cNvPr id="12" name="Text 10"/>
+          <p:cNvSpPr/>
+          <p:nvPr/>
+        </p:nvSpPr>
+        <p:spPr>
+          <a:xfrm>
+            <a:off x="1143000" y="3273552"/>
+            <a:ext cx="5943600" cy="502920"/>
+          </a:xfrm>
+          <a:prstGeom prst="rect">
+            <a:avLst/>
+          </a:prstGeom>
+          <a:noFill/>
+          <a:ln/>
+        </p:spPr>
+        <p:txBody>
+          <a:bodyPr wrap="square" lIns="0" tIns="0" rIns="0" bIns="0" rtlCol="0" anchor="ctr"/>
+          <a:lstStyle/>
+          <a:p>
+            <a:pPr algn="l" indent="0" marL="0">
+              <a:buNone/>
+            </a:pPr>
+            <a:r>
+              <a:rPr lang="en-US" sz="1200" dirty="0">
+                <a:solidFill>
+                  <a:srgbClr val="4A5568"/>
+                </a:solidFill>
+                <a:latin typeface="Calibri" pitchFamily="34" charset="0"/>
+                <a:ea typeface="Calibri" pitchFamily="34" charset="-122"/>
+                <a:cs typeface="Calibri" pitchFamily="34" charset="-120"/>
+              </a:rPr>
+              <a:t>Open roles / annual hires, hiring seats, number of entities &amp; regions.</a:t>
+            </a:r>
+            <a:endParaRPr lang="en-US" sz="1200" dirty="0"/>
+          </a:p>
+        </p:txBody>
+      </p:sp>
+      <p:sp>
+        <p:nvSpPr>
+          <p:cNvPr id="13" name="Shape 11"/>
+          <p:cNvSpPr/>
+          <p:nvPr/>
+        </p:nvSpPr>
+        <p:spPr>
+          <a:xfrm>
+            <a:off x="594360" y="3904488"/>
+            <a:ext cx="384048" cy="384048"/>
+          </a:xfrm>
+          <a:prstGeom prst="ellipse">
+            <a:avLst/>
+          </a:prstGeom>
+          <a:solidFill>
+            <a:srgbClr val="0B2AE0"/>
+          </a:solidFill>
+          <a:ln/>
+        </p:spPr>
+      </p:sp>
+      <p:sp>
+        <p:nvSpPr>
+          <p:cNvPr id="14" name="Text 12"/>
+          <p:cNvSpPr/>
+          <p:nvPr/>
+        </p:nvSpPr>
+        <p:spPr>
+          <a:xfrm>
+            <a:off x="594360" y="3895344"/>
+            <a:ext cx="384048" cy="384048"/>
+          </a:xfrm>
+          <a:prstGeom prst="rect">
+            <a:avLst/>
+          </a:prstGeom>
+          <a:noFill/>
+          <a:ln/>
+        </p:spPr>
+        <p:txBody>
+          <a:bodyPr wrap="square" lIns="0" tIns="0" rIns="0" bIns="0" rtlCol="0" anchor="ctr"/>
+          <a:lstStyle/>
+          <a:p>
+            <a:pPr algn="ctr" indent="0" marL="0">
+              <a:buNone/>
+            </a:pPr>
+            <a:r>
+              <a:rPr lang="en-US" sz="1500" b="1" dirty="0">
+                <a:solidFill>
+                  <a:srgbClr val="FFFFFF"/>
+                </a:solidFill>
+                <a:latin typeface="Calibri" pitchFamily="34" charset="0"/>
+                <a:ea typeface="Calibri" pitchFamily="34" charset="-122"/>
+                <a:cs typeface="Calibri" pitchFamily="34" charset="-120"/>
+              </a:rPr>
+              <a:t>3</a:t>
+            </a:r>
+            <a:endParaRPr lang="en-US" sz="1500" dirty="0"/>
+          </a:p>
+        </p:txBody>
+      </p:sp>
+      <p:sp>
+        <p:nvSpPr>
+          <p:cNvPr id="15" name="Text 13"/>
+          <p:cNvSpPr/>
+          <p:nvPr/>
+        </p:nvSpPr>
+        <p:spPr>
+          <a:xfrm>
+            <a:off x="1143000" y="3840480"/>
+            <a:ext cx="5943600" cy="274320"/>
+          </a:xfrm>
+          <a:prstGeom prst="rect">
+            <a:avLst/>
+          </a:prstGeom>
+          <a:noFill/>
+          <a:ln/>
+        </p:spPr>
+        <p:txBody>
+          <a:bodyPr wrap="square" lIns="0" tIns="0" rIns="0" bIns="0" rtlCol="0" anchor="ctr"/>
+          <a:lstStyle/>
+          <a:p>
+            <a:pPr algn="l" indent="0" marL="0">
+              <a:buNone/>
+            </a:pPr>
+            <a:r>
+              <a:rPr lang="en-US" sz="1450" b="1" dirty="0">
+                <a:solidFill>
+                  <a:srgbClr val="12132A"/>
+                </a:solidFill>
+                <a:latin typeface="Calibri" pitchFamily="34" charset="0"/>
+                <a:ea typeface="Calibri" pitchFamily="34" charset="-122"/>
+                <a:cs typeface="Calibri" pitchFamily="34" charset="-120"/>
+              </a:rPr>
+              <a:t>Included</a:t>
+            </a:r>
+            <a:endParaRPr lang="en-US" sz="1450" dirty="0"/>
+          </a:p>
+        </p:txBody>
+      </p:sp>
+      <p:sp>
+        <p:nvSpPr>
+          <p:cNvPr id="16" name="Text 14"/>
+          <p:cNvSpPr/>
+          <p:nvPr/>
+        </p:nvSpPr>
+        <p:spPr>
+          <a:xfrm>
+            <a:off x="1143000" y="4142232"/>
+            <a:ext cx="5943600" cy="502920"/>
+          </a:xfrm>
+          <a:prstGeom prst="rect">
+            <a:avLst/>
+          </a:prstGeom>
+          <a:noFill/>
+          <a:ln/>
+        </p:spPr>
+        <p:txBody>
+          <a:bodyPr wrap="square" lIns="0" tIns="0" rIns="0" bIns="0" rtlCol="0" anchor="ctr"/>
+          <a:lstStyle/>
+          <a:p>
+            <a:pPr algn="l" indent="0" marL="0">
+              <a:buNone/>
+            </a:pPr>
+            <a:r>
+              <a:rPr lang="en-US" sz="1200" dirty="0">
+                <a:solidFill>
+                  <a:srgbClr val="4A5568"/>
+                </a:solidFill>
+                <a:latin typeface="Calibri" pitchFamily="34" charset="0"/>
+                <a:ea typeface="Calibri" pitchFamily="34" charset="-122"/>
+                <a:cs typeface="Calibri" pitchFamily="34" charset="-120"/>
+              </a:rPr>
+              <a:t>Unlimited jobs &amp; seats, SSO, audit logs, white-label career site, dedicated CSM + SLA.</a:t>
+            </a:r>
+            <a:endParaRPr lang="en-US" sz="1200" dirty="0"/>
+          </a:p>
+        </p:txBody>
+      </p:sp>
+      <p:sp>
+        <p:nvSpPr>
+          <p:cNvPr id="17" name="Shape 15"/>
+          <p:cNvSpPr/>
+          <p:nvPr/>
+        </p:nvSpPr>
+        <p:spPr>
+          <a:xfrm>
+            <a:off x="594360" y="4773168"/>
+            <a:ext cx="384048" cy="384048"/>
+          </a:xfrm>
+          <a:prstGeom prst="ellipse">
+            <a:avLst/>
+          </a:prstGeom>
+          <a:solidFill>
+            <a:srgbClr val="0B2AE0"/>
+          </a:solidFill>
+          <a:ln/>
+        </p:spPr>
+      </p:sp>
+      <p:sp>
+        <p:nvSpPr>
+          <p:cNvPr id="18" name="Text 16"/>
+          <p:cNvSpPr/>
+          <p:nvPr/>
+        </p:nvSpPr>
+        <p:spPr>
+          <a:xfrm>
+            <a:off x="594360" y="4764024"/>
+            <a:ext cx="384048" cy="384048"/>
+          </a:xfrm>
+          <a:prstGeom prst="rect">
+            <a:avLst/>
+          </a:prstGeom>
+          <a:noFill/>
+          <a:ln/>
+        </p:spPr>
+        <p:txBody>
+          <a:bodyPr wrap="square" lIns="0" tIns="0" rIns="0" bIns="0" rtlCol="0" anchor="ctr"/>
+          <a:lstStyle/>
+          <a:p>
+            <a:pPr algn="ctr" indent="0" marL="0">
+              <a:buNone/>
+            </a:pPr>
+            <a:r>
+              <a:rPr lang="en-US" sz="1500" b="1" dirty="0">
+                <a:solidFill>
+                  <a:srgbClr val="FFFFFF"/>
+                </a:solidFill>
+                <a:latin typeface="Calibri" pitchFamily="34" charset="0"/>
+                <a:ea typeface="Calibri" pitchFamily="34" charset="-122"/>
+                <a:cs typeface="Calibri" pitchFamily="34" charset="-120"/>
+              </a:rPr>
+              <a:t>4</a:t>
+            </a:r>
+            <a:endParaRPr lang="en-US" sz="1500" dirty="0"/>
+          </a:p>
+        </p:txBody>
+      </p:sp>
+      <p:sp>
+        <p:nvSpPr>
+          <p:cNvPr id="19" name="Text 17"/>
+          <p:cNvSpPr/>
+          <p:nvPr/>
+        </p:nvSpPr>
+        <p:spPr>
+          <a:xfrm>
+            <a:off x="1143000" y="4709160"/>
+            <a:ext cx="5943600" cy="274320"/>
+          </a:xfrm>
+          <a:prstGeom prst="rect">
+            <a:avLst/>
+          </a:prstGeom>
+          <a:noFill/>
+          <a:ln/>
+        </p:spPr>
+        <p:txBody>
+          <a:bodyPr wrap="square" lIns="0" tIns="0" rIns="0" bIns="0" rtlCol="0" anchor="ctr"/>
+          <a:lstStyle/>
+          <a:p>
+            <a:pPr algn="l" indent="0" marL="0">
+              <a:buNone/>
+            </a:pPr>
+            <a:r>
+              <a:rPr lang="en-US" sz="1450" b="1" dirty="0">
+                <a:solidFill>
+                  <a:srgbClr val="12132A"/>
+                </a:solidFill>
+                <a:latin typeface="Calibri" pitchFamily="34" charset="0"/>
+                <a:ea typeface="Calibri" pitchFamily="34" charset="-122"/>
+                <a:cs typeface="Calibri" pitchFamily="34" charset="-120"/>
+              </a:rPr>
+              <a:t>Own AI account</a:t>
+            </a:r>
+            <a:endParaRPr lang="en-US" sz="1450" dirty="0"/>
+          </a:p>
+        </p:txBody>
+      </p:sp>
+      <p:sp>
+        <p:nvSpPr>
+          <p:cNvPr id="20" name="Text 18"/>
+          <p:cNvSpPr/>
+          <p:nvPr/>
+        </p:nvSpPr>
+        <p:spPr>
+          <a:xfrm>
+            <a:off x="1143000" y="5010912"/>
+            <a:ext cx="5943600" cy="502920"/>
+          </a:xfrm>
+          <a:prstGeom prst="rect">
+            <a:avLst/>
+          </a:prstGeom>
+          <a:noFill/>
+          <a:ln/>
+        </p:spPr>
+        <p:txBody>
+          <a:bodyPr wrap="square" lIns="0" tIns="0" rIns="0" bIns="0" rtlCol="0" anchor="ctr"/>
+          <a:lstStyle/>
+          <a:p>
+            <a:pPr algn="l" indent="0" marL="0">
+              <a:buNone/>
+            </a:pPr>
+            <a:r>
+              <a:rPr lang="en-US" sz="1200" dirty="0">
+                <a:solidFill>
+                  <a:srgbClr val="4A5568"/>
+                </a:solidFill>
+                <a:latin typeface="Calibri" pitchFamily="34" charset="0"/>
+                <a:ea typeface="Calibri" pitchFamily="34" charset="-122"/>
+                <a:cs typeface="Calibri" pitchFamily="34" charset="-120"/>
+              </a:rPr>
+              <a:t>AI billed directly to the customer by Anthropic, so no AI COGS to Aster.</a:t>
+            </a:r>
+            <a:endParaRPr lang="en-US" sz="1200" dirty="0"/>
+          </a:p>
+        </p:txBody>
+      </p:sp>
+      <p:graphicFrame>
+        <p:nvGraphicFramePr>
+          <p:cNvPr id="13" name="Table 0"/>
+          <p:cNvGraphicFramePr>
+            <a:graphicFrameLocks noGrp="1"/>
+          </p:cNvGraphicFramePr>
+          <p:nvPr>
+            <p:extLst>
+              <p:ext uri="{D42A27DB-BD31-4B8C-83A1-F6EECF244321}">
+                <p14:modId xmlns:p14="http://schemas.microsoft.com/office/powerpoint/2010/main" val="1579011935"/>
+              </p:ext>
+            </p:extLst>
+          </p:nvPr>
+        </p:nvGraphicFramePr>
+        <p:xfrm>
+          <a:off x="7452360" y="2148840"/>
+          <a:ext cx="4187952" cy="914400"/>
+        </p:xfrm>
+        <a:graphic>
+          <a:graphicData uri="http://schemas.openxmlformats.org/drawingml/2006/table">
+            <a:tbl>
+              <a:tblPr/>
+              <a:tblGrid>
+                <a:gridCol w="2907792"/>
+                <a:gridCol w="1280160"/>
+              </a:tblGrid>
+              <a:tr h="502920">
+                <a:tc>
+                  <a:txBody>
+                    <a:bodyPr/>
+                    <a:lstStyle/>
+                    <a:p>
+                      <a:pPr algn="l" indent="0" marL="0">
+                        <a:buNone/>
+                      </a:pPr>
+                      <a:r>
+                        <a:rPr lang="en-US" sz="1200" b="1" dirty="0">
+                          <a:solidFill>
+                            <a:srgbClr val="FFFFFF"/>
+                          </a:solidFill>
+                          <a:latin typeface="Calibri" pitchFamily="34" charset="0"/>
+                          <a:ea typeface="Calibri" pitchFamily="34" charset="-122"/>
+                          <a:cs typeface="Calibri" pitchFamily="34" charset="-120"/>
+                        </a:rPr>
+                        <a:t>Band</a:t>
+                      </a:r>
+                      <a:endParaRPr lang="en-US" sz="1200" dirty="0">
+                        <a:latin typeface="Calibri" charset="0"/>
+                        <a:ea typeface="Calibri" charset="0"/>
+                        <a:cs typeface="Calibri" charset="0"/>
+                      </a:endParaRPr>
+                    </a:p>
+                  </a:txBody>
+                  <a:tcPr marL="76200" marR="76200" marT="25400" marB="25400" anchor="ctr">
+                    <a:lnL w="6350" cap="flat" cmpd="sng" algn="ctr">
+                      <a:solidFill>
+                        <a:srgbClr val="E6E8F0"/>
+                      </a:solidFill>
+                      <a:prstDash val="solid"/>
+                      <a:round/>
+                      <a:headEnd type="none" w="med" len="med"/>
+                      <a:tailEnd type="none" w="med" len="med"/>
+                    </a:lnL>
+                    <a:lnR w="6350" cap="flat" cmpd="sng" algn="ctr">
+                      <a:solidFill>
+                        <a:srgbClr val="E6E8F0"/>
+                      </a:solidFill>
+                      <a:prstDash val="solid"/>
+                      <a:round/>
+                      <a:headEnd type="none" w="med" len="med"/>
+                      <a:tailEnd type="none" w="med" len="med"/>
+                    </a:lnR>
+                    <a:lnT w="6350" cap="flat" cmpd="sng" algn="ctr">
+                      <a:solidFill>
+                        <a:srgbClr val="E6E8F0"/>
+                      </a:solidFill>
+                      <a:prstDash val="solid"/>
+                      <a:round/>
+                      <a:headEnd type="none" w="med" len="med"/>
+                      <a:tailEnd type="none" w="med" len="med"/>
+                    </a:lnT>
+                    <a:lnB w="6350" cap="flat" cmpd="sng" algn="ctr">
+                      <a:solidFill>
+                        <a:srgbClr val="E6E8F0"/>
+                      </a:solidFill>
+                      <a:prstDash val="solid"/>
+                      <a:round/>
+                      <a:headEnd type="none" w="med" len="med"/>
+                      <a:tailEnd type="none" w="med" len="med"/>
+                    </a:lnB>
+                    <a:solidFill>
+                      <a:srgbClr val="0A1FC2"/>
+                    </a:solidFill>
+                  </a:tcPr>
+                </a:tc>
+                <a:tc>
+                  <a:txBody>
+                    <a:bodyPr/>
+                    <a:lstStyle/>
+                    <a:p>
+                      <a:pPr algn="r" indent="0" marL="0">
+                        <a:buNone/>
+                      </a:pPr>
+                      <a:r>
+                        <a:rPr lang="en-US" sz="1200" b="1" dirty="0">
+                          <a:solidFill>
+                            <a:srgbClr val="FFFFFF"/>
+                          </a:solidFill>
+                          <a:latin typeface="Calibri" pitchFamily="34" charset="0"/>
+                          <a:ea typeface="Calibri" pitchFamily="34" charset="-122"/>
+                          <a:cs typeface="Calibri" pitchFamily="34" charset="-120"/>
+                        </a:rPr>
+                        <a:t>Licence / mo</a:t>
+                      </a:r>
+                      <a:endParaRPr lang="en-US" sz="1200" dirty="0">
+                        <a:latin typeface="Calibri" charset="0"/>
+                        <a:ea typeface="Calibri" charset="0"/>
+                        <a:cs typeface="Calibri" charset="0"/>
+                      </a:endParaRPr>
+                    </a:p>
+                  </a:txBody>
+                  <a:tcPr marL="76200" marR="76200" marT="25400" marB="25400" anchor="ctr">
+                    <a:lnL w="6350" cap="flat" cmpd="sng" algn="ctr">
+                      <a:solidFill>
+                        <a:srgbClr val="E6E8F0"/>
+                      </a:solidFill>
+                      <a:prstDash val="solid"/>
+                      <a:round/>
+                      <a:headEnd type="none" w="med" len="med"/>
+                      <a:tailEnd type="none" w="med" len="med"/>
+                    </a:lnL>
+                    <a:lnR w="6350" cap="flat" cmpd="sng" algn="ctr">
+                      <a:solidFill>
+                        <a:srgbClr val="E6E8F0"/>
+                      </a:solidFill>
+                      <a:prstDash val="solid"/>
+                      <a:round/>
+                      <a:headEnd type="none" w="med" len="med"/>
+                      <a:tailEnd type="none" w="med" len="med"/>
+                    </a:lnR>
+                    <a:lnT w="6350" cap="flat" cmpd="sng" algn="ctr">
+                      <a:solidFill>
+                        <a:srgbClr val="E6E8F0"/>
+                      </a:solidFill>
+                      <a:prstDash val="solid"/>
+                      <a:round/>
+                      <a:headEnd type="none" w="med" len="med"/>
+                      <a:tailEnd type="none" w="med" len="med"/>
+                    </a:lnT>
+                    <a:lnB w="6350" cap="flat" cmpd="sng" algn="ctr">
+                      <a:solidFill>
+                        <a:srgbClr val="E6E8F0"/>
+                      </a:solidFill>
+                      <a:prstDash val="solid"/>
+                      <a:round/>
+                      <a:headEnd type="none" w="med" len="med"/>
+                      <a:tailEnd type="none" w="med" len="med"/>
+                    </a:lnB>
+                    <a:solidFill>
+                      <a:srgbClr val="0A1FC2"/>
+                    </a:solidFill>
+                  </a:tcPr>
+                </a:tc>
+              </a:tr>
+              <a:tr h="502920">
+                <a:tc>
+                  <a:txBody>
+                    <a:bodyPr/>
+                    <a:lstStyle/>
+                    <a:p>
+                      <a:pPr algn="l" indent="0" marL="0">
+                        <a:buNone/>
+                      </a:pPr>
+                      <a:r>
+                        <a:rPr lang="en-US" sz="1150" dirty="0">
+                          <a:solidFill>
+                            <a:srgbClr val="12132A"/>
+                          </a:solidFill>
+                          <a:latin typeface="Calibri" pitchFamily="34" charset="0"/>
+                          <a:ea typeface="Calibri" pitchFamily="34" charset="-122"/>
+                          <a:cs typeface="Calibri" pitchFamily="34" charset="-120"/>
+                        </a:rPr>
+                        <a:t>Standard — 1 entity, ≤ ~50 roles</a:t>
+                      </a:r>
+                      <a:endParaRPr lang="en-US" sz="1150" dirty="0">
+                        <a:latin typeface="Calibri" charset="0"/>
+                        <a:ea typeface="Calibri" charset="0"/>
+                        <a:cs typeface="Calibri" charset="0"/>
+                      </a:endParaRPr>
+                    </a:p>
+                  </a:txBody>
+                  <a:tcPr marL="76200" marR="76200" marT="25400" marB="25400" anchor="ctr">
+                    <a:lnL w="6350" cap="flat" cmpd="sng" algn="ctr">
+                      <a:solidFill>
+                        <a:srgbClr val="E6E8F0"/>
+                      </a:solidFill>
+                      <a:prstDash val="solid"/>
+                      <a:round/>
+                      <a:headEnd type="none" w="med" len="med"/>
+                      <a:tailEnd type="none" w="med" len="med"/>
+                    </a:lnL>
+                    <a:lnR w="6350" cap="flat" cmpd="sng" algn="ctr">
+                      <a:solidFill>
+                        <a:srgbClr val="E6E8F0"/>
+                      </a:solidFill>
+                      <a:prstDash val="solid"/>
+                      <a:round/>
+                      <a:headEnd type="none" w="med" len="med"/>
+                      <a:tailEnd type="none" w="med" len="med"/>
+                    </a:lnR>
+                    <a:lnT w="6350" cap="flat" cmpd="sng" algn="ctr">
+                      <a:solidFill>
+                        <a:srgbClr val="E6E8F0"/>
+                      </a:solidFill>
+                      <a:prstDash val="solid"/>
+                      <a:round/>
+                      <a:headEnd type="none" w="med" len="med"/>
+                      <a:tailEnd type="none" w="med" len="med"/>
+                    </a:lnT>
+                    <a:lnB w="6350" cap="flat" cmpd="sng" algn="ctr">
+                      <a:solidFill>
+                        <a:srgbClr val="E6E8F0"/>
+                      </a:solidFill>
+                      <a:prstDash val="solid"/>
+                      <a:round/>
+                      <a:headEnd type="none" w="med" len="med"/>
+                      <a:tailEnd type="none" w="med" len="med"/>
+                    </a:lnB>
+                    <a:solidFill>
+                      <a:srgbClr val="FFFFFF"/>
+                    </a:solidFill>
+                  </a:tcPr>
+                </a:tc>
+                <a:tc>
+                  <a:txBody>
+                    <a:bodyPr/>
+                    <a:lstStyle/>
+                    <a:p>
+                      <a:pPr algn="r" indent="0" marL="0">
+                        <a:buNone/>
+                      </a:pPr>
+                      <a:r>
+                        <a:rPr lang="en-US" sz="1150" b="1" dirty="0">
+                          <a:solidFill>
+                            <a:srgbClr val="0B2AE0"/>
+                          </a:solidFill>
+                          <a:latin typeface="Calibri" pitchFamily="34" charset="0"/>
+                          <a:ea typeface="Calibri" pitchFamily="34" charset="-122"/>
+                          <a:cs typeface="Calibri" pitchFamily="34" charset="-120"/>
+                        </a:rPr>
+                        <a:t>RM30k</a:t>
+                      </a:r>
+                      <a:endParaRPr lang="en-US" sz="1150" dirty="0">
+                        <a:latin typeface="Calibri" charset="0"/>
+                        <a:ea typeface="Calibri" charset="0"/>
+                        <a:cs typeface="Calibri" charset="0"/>
+                      </a:endParaRPr>
+                    </a:p>
+                  </a:txBody>
+                  <a:tcPr marL="76200" marR="76200" marT="25400" marB="25400" anchor="ctr">
+                    <a:lnL w="6350" cap="flat" cmpd="sng" algn="ctr">
+                      <a:solidFill>
+                        <a:srgbClr val="E6E8F0"/>
+                      </a:solidFill>
+                      <a:prstDash val="solid"/>
+                      <a:round/>
+                      <a:headEnd type="none" w="med" len="med"/>
+                      <a:tailEnd type="none" w="med" len="med"/>
+                    </a:lnL>
+                    <a:lnR w="6350" cap="flat" cmpd="sng" algn="ctr">
+                      <a:solidFill>
+                        <a:srgbClr val="E6E8F0"/>
+                      </a:solidFill>
+                      <a:prstDash val="solid"/>
+                      <a:round/>
+                      <a:headEnd type="none" w="med" len="med"/>
+                      <a:tailEnd type="none" w="med" len="med"/>
+                    </a:lnR>
+                    <a:lnT w="6350" cap="flat" cmpd="sng" algn="ctr">
+                      <a:solidFill>
+                        <a:srgbClr val="E6E8F0"/>
+                      </a:solidFill>
+                      <a:prstDash val="solid"/>
+                      <a:round/>
+                      <a:headEnd type="none" w="med" len="med"/>
+                      <a:tailEnd type="none" w="med" len="med"/>
+                    </a:lnT>
+                    <a:lnB w="6350" cap="flat" cmpd="sng" algn="ctr">
+                      <a:solidFill>
+                        <a:srgbClr val="E6E8F0"/>
+                      </a:solidFill>
+                      <a:prstDash val="solid"/>
+                      <a:round/>
+                      <a:headEnd type="none" w="med" len="med"/>
+                      <a:tailEnd type="none" w="med" len="med"/>
+                    </a:lnB>
+                    <a:solidFill>
+                      <a:srgbClr val="FFFFFF"/>
+                    </a:solidFill>
+                  </a:tcPr>
+                </a:tc>
+              </a:tr>
+              <a:tr h="502920">
+                <a:tc>
+                  <a:txBody>
+                    <a:bodyPr/>
+                    <a:lstStyle/>
+                    <a:p>
+                      <a:pPr algn="l" indent="0" marL="0">
+                        <a:buNone/>
+                      </a:pPr>
+                      <a:r>
+                        <a:rPr lang="en-US" sz="1150" dirty="0">
+                          <a:solidFill>
+                            <a:srgbClr val="12132A"/>
+                          </a:solidFill>
+                          <a:latin typeface="Calibri" pitchFamily="34" charset="0"/>
+                          <a:ea typeface="Calibri" pitchFamily="34" charset="-122"/>
+                          <a:cs typeface="Calibri" pitchFamily="34" charset="-120"/>
+                        </a:rPr>
+                        <a:t>Growth — multi-team, ≤ ~150 roles</a:t>
+                      </a:r>
+                      <a:endParaRPr lang="en-US" sz="1150" dirty="0">
+                        <a:latin typeface="Calibri" charset="0"/>
+                        <a:ea typeface="Calibri" charset="0"/>
+                        <a:cs typeface="Calibri" charset="0"/>
+                      </a:endParaRPr>
+                    </a:p>
+                  </a:txBody>
+                  <a:tcPr marL="76200" marR="76200" marT="25400" marB="25400" anchor="ctr">
+                    <a:lnL w="6350" cap="flat" cmpd="sng" algn="ctr">
+                      <a:solidFill>
+                        <a:srgbClr val="E6E8F0"/>
+                      </a:solidFill>
+                      <a:prstDash val="solid"/>
+                      <a:round/>
+                      <a:headEnd type="none" w="med" len="med"/>
+                      <a:tailEnd type="none" w="med" len="med"/>
+                    </a:lnL>
+                    <a:lnR w="6350" cap="flat" cmpd="sng" algn="ctr">
+                      <a:solidFill>
+                        <a:srgbClr val="E6E8F0"/>
+                      </a:solidFill>
+                      <a:prstDash val="solid"/>
+                      <a:round/>
+                      <a:headEnd type="none" w="med" len="med"/>
+                      <a:tailEnd type="none" w="med" len="med"/>
+                    </a:lnR>
+                    <a:lnT w="6350" cap="flat" cmpd="sng" algn="ctr">
+                      <a:solidFill>
+                        <a:srgbClr val="E6E8F0"/>
+                      </a:solidFill>
+                      <a:prstDash val="solid"/>
+                      <a:round/>
+                      <a:headEnd type="none" w="med" len="med"/>
+                      <a:tailEnd type="none" w="med" len="med"/>
+                    </a:lnT>
+                    <a:lnB w="6350" cap="flat" cmpd="sng" algn="ctr">
+                      <a:solidFill>
+                        <a:srgbClr val="E6E8F0"/>
+                      </a:solidFill>
+                      <a:prstDash val="solid"/>
+                      <a:round/>
+                      <a:headEnd type="none" w="med" len="med"/>
+                      <a:tailEnd type="none" w="med" len="med"/>
+                    </a:lnB>
+                    <a:solidFill>
+                      <a:srgbClr val="F5F7FE"/>
+                    </a:solidFill>
+                  </a:tcPr>
+                </a:tc>
+                <a:tc>
+                  <a:txBody>
+                    <a:bodyPr/>
+                    <a:lstStyle/>
+                    <a:p>
+                      <a:pPr algn="r" indent="0" marL="0">
+                        <a:buNone/>
+                      </a:pPr>
+                      <a:r>
+                        <a:rPr lang="en-US" sz="1150" b="1" dirty="0">
+                          <a:solidFill>
+                            <a:srgbClr val="0B2AE0"/>
+                          </a:solidFill>
+                          <a:latin typeface="Calibri" pitchFamily="34" charset="0"/>
+                          <a:ea typeface="Calibri" pitchFamily="34" charset="-122"/>
+                          <a:cs typeface="Calibri" pitchFamily="34" charset="-120"/>
+                        </a:rPr>
+                        <a:t>RM45–60k</a:t>
+                      </a:r>
+                      <a:endParaRPr lang="en-US" sz="1150" dirty="0">
+                        <a:latin typeface="Calibri" charset="0"/>
+                        <a:ea typeface="Calibri" charset="0"/>
+                        <a:cs typeface="Calibri" charset="0"/>
+                      </a:endParaRPr>
+                    </a:p>
+                  </a:txBody>
+                  <a:tcPr marL="76200" marR="76200" marT="25400" marB="25400" anchor="ctr">
+                    <a:lnL w="6350" cap="flat" cmpd="sng" algn="ctr">
+                      <a:solidFill>
+                        <a:srgbClr val="E6E8F0"/>
+                      </a:solidFill>
+                      <a:prstDash val="solid"/>
+                      <a:round/>
+                      <a:headEnd type="none" w="med" len="med"/>
+                      <a:tailEnd type="none" w="med" len="med"/>
+                    </a:lnL>
+                    <a:lnR w="6350" cap="flat" cmpd="sng" algn="ctr">
+                      <a:solidFill>
+                        <a:srgbClr val="E6E8F0"/>
+                      </a:solidFill>
+                      <a:prstDash val="solid"/>
+                      <a:round/>
+                      <a:headEnd type="none" w="med" len="med"/>
+                      <a:tailEnd type="none" w="med" len="med"/>
+                    </a:lnR>
+                    <a:lnT w="6350" cap="flat" cmpd="sng" algn="ctr">
+                      <a:solidFill>
+                        <a:srgbClr val="E6E8F0"/>
+                      </a:solidFill>
+                      <a:prstDash val="solid"/>
+                      <a:round/>
+                      <a:headEnd type="none" w="med" len="med"/>
+                      <a:tailEnd type="none" w="med" len="med"/>
+                    </a:lnT>
+                    <a:lnB w="6350" cap="flat" cmpd="sng" algn="ctr">
+                      <a:solidFill>
+                        <a:srgbClr val="E6E8F0"/>
+                      </a:solidFill>
+                      <a:prstDash val="solid"/>
+                      <a:round/>
+                      <a:headEnd type="none" w="med" len="med"/>
+                      <a:tailEnd type="none" w="med" len="med"/>
+                    </a:lnB>
+                    <a:solidFill>
+                      <a:srgbClr val="F5F7FE"/>
+                    </a:solidFill>
+                  </a:tcPr>
+                </a:tc>
+              </a:tr>
+              <a:tr h="502920">
+                <a:tc>
+                  <a:txBody>
+                    <a:bodyPr/>
+                    <a:lstStyle/>
+                    <a:p>
+                      <a:pPr algn="l" indent="0" marL="0">
+                        <a:buNone/>
+                      </a:pPr>
+                      <a:r>
+                        <a:rPr lang="en-US" sz="1150" dirty="0">
+                          <a:solidFill>
+                            <a:srgbClr val="12132A"/>
+                          </a:solidFill>
+                          <a:latin typeface="Calibri" pitchFamily="34" charset="0"/>
+                          <a:ea typeface="Calibri" pitchFamily="34" charset="-122"/>
+                          <a:cs typeface="Calibri" pitchFamily="34" charset="-120"/>
+                        </a:rPr>
+                        <a:t>Group — multi-entity, 250+ roles</a:t>
+                      </a:r>
+                      <a:endParaRPr lang="en-US" sz="1150" dirty="0">
+                        <a:latin typeface="Calibri" charset="0"/>
+                        <a:ea typeface="Calibri" charset="0"/>
+                        <a:cs typeface="Calibri" charset="0"/>
+                      </a:endParaRPr>
+                    </a:p>
+                  </a:txBody>
+                  <a:tcPr marL="76200" marR="76200" marT="25400" marB="25400" anchor="ctr">
+                    <a:lnL w="6350" cap="flat" cmpd="sng" algn="ctr">
+                      <a:solidFill>
+                        <a:srgbClr val="E6E8F0"/>
+                      </a:solidFill>
+                      <a:prstDash val="solid"/>
+                      <a:round/>
+                      <a:headEnd type="none" w="med" len="med"/>
+                      <a:tailEnd type="none" w="med" len="med"/>
+                    </a:lnL>
+                    <a:lnR w="6350" cap="flat" cmpd="sng" algn="ctr">
+                      <a:solidFill>
+                        <a:srgbClr val="E6E8F0"/>
+                      </a:solidFill>
+                      <a:prstDash val="solid"/>
+                      <a:round/>
+                      <a:headEnd type="none" w="med" len="med"/>
+                      <a:tailEnd type="none" w="med" len="med"/>
+                    </a:lnR>
+                    <a:lnT w="6350" cap="flat" cmpd="sng" algn="ctr">
+                      <a:solidFill>
+                        <a:srgbClr val="E6E8F0"/>
+                      </a:solidFill>
+                      <a:prstDash val="solid"/>
+                      <a:round/>
+                      <a:headEnd type="none" w="med" len="med"/>
+                      <a:tailEnd type="none" w="med" len="med"/>
+                    </a:lnT>
+                    <a:lnB w="6350" cap="flat" cmpd="sng" algn="ctr">
+                      <a:solidFill>
+                        <a:srgbClr val="E6E8F0"/>
+                      </a:solidFill>
+                      <a:prstDash val="solid"/>
+                      <a:round/>
+                      <a:headEnd type="none" w="med" len="med"/>
+                      <a:tailEnd type="none" w="med" len="med"/>
+                    </a:lnB>
+                    <a:solidFill>
+                      <a:srgbClr val="FFFFFF"/>
+                    </a:solidFill>
+                  </a:tcPr>
+                </a:tc>
+                <a:tc>
+                  <a:txBody>
+                    <a:bodyPr/>
+                    <a:lstStyle/>
+                    <a:p>
+                      <a:pPr algn="r" indent="0" marL="0">
+                        <a:buNone/>
+                      </a:pPr>
+                      <a:r>
+                        <a:rPr lang="en-US" sz="1150" b="1" dirty="0">
+                          <a:solidFill>
+                            <a:srgbClr val="0B2AE0"/>
+                          </a:solidFill>
+                          <a:latin typeface="Calibri" pitchFamily="34" charset="0"/>
+                          <a:ea typeface="Calibri" pitchFamily="34" charset="-122"/>
+                          <a:cs typeface="Calibri" pitchFamily="34" charset="-120"/>
+                        </a:rPr>
+                        <a:t>RM75k+</a:t>
+                      </a:r>
+                      <a:endParaRPr lang="en-US" sz="1150" dirty="0">
+                        <a:latin typeface="Calibri" charset="0"/>
+                        <a:ea typeface="Calibri" charset="0"/>
+                        <a:cs typeface="Calibri" charset="0"/>
+                      </a:endParaRPr>
+                    </a:p>
+                  </a:txBody>
+                  <a:tcPr marL="76200" marR="76200" marT="25400" marB="25400" anchor="ctr">
+                    <a:lnL w="6350" cap="flat" cmpd="sng" algn="ctr">
+                      <a:solidFill>
+                        <a:srgbClr val="E6E8F0"/>
+                      </a:solidFill>
+                      <a:prstDash val="solid"/>
+                      <a:round/>
+                      <a:headEnd type="none" w="med" len="med"/>
+                      <a:tailEnd type="none" w="med" len="med"/>
+                    </a:lnL>
+                    <a:lnR w="6350" cap="flat" cmpd="sng" algn="ctr">
+                      <a:solidFill>
+                        <a:srgbClr val="E6E8F0"/>
+                      </a:solidFill>
+                      <a:prstDash val="solid"/>
+                      <a:round/>
+                      <a:headEnd type="none" w="med" len="med"/>
+                      <a:tailEnd type="none" w="med" len="med"/>
+                    </a:lnR>
+                    <a:lnT w="6350" cap="flat" cmpd="sng" algn="ctr">
+                      <a:solidFill>
+                        <a:srgbClr val="E6E8F0"/>
+                      </a:solidFill>
+                      <a:prstDash val="solid"/>
+                      <a:round/>
+                      <a:headEnd type="none" w="med" len="med"/>
+                      <a:tailEnd type="none" w="med" len="med"/>
+                    </a:lnT>
+                    <a:lnB w="6350" cap="flat" cmpd="sng" algn="ctr">
+                      <a:solidFill>
+                        <a:srgbClr val="E6E8F0"/>
+                      </a:solidFill>
+                      <a:prstDash val="solid"/>
+                      <a:round/>
+                      <a:headEnd type="none" w="med" len="med"/>
+                      <a:tailEnd type="none" w="med" len="med"/>
+                    </a:lnB>
+                    <a:solidFill>
+                      <a:srgbClr val="FFFFFF"/>
+                    </a:solidFill>
+                  </a:tcPr>
+                </a:tc>
+              </a:tr>
+            </a:tbl>
+          </a:graphicData>
+        </a:graphic>
+      </p:graphicFrame>
+      <p:sp>
+        <p:nvSpPr>
+          <p:cNvPr id="22" name="Shape 19"/>
+          <p:cNvSpPr/>
+          <p:nvPr/>
+        </p:nvSpPr>
+        <p:spPr>
+          <a:xfrm>
+            <a:off x="7452360" y="4297680"/>
+            <a:ext cx="4187952" cy="1417320"/>
+          </a:xfrm>
+          <a:prstGeom prst="roundRect">
+            <a:avLst>
+              <a:gd name="adj" fmla="val 7742"/>
+            </a:avLst>
+          </a:prstGeom>
+          <a:solidFill>
+            <a:srgbClr val="DCFCE7"/>
+          </a:solidFill>
+          <a:ln w="12700">
+            <a:solidFill>
+              <a:srgbClr val="BBE6C6"/>
+            </a:solidFill>
+            <a:prstDash val="solid"/>
+          </a:ln>
+          <a:effectLst>
+            <a:outerShdw sx="100000" sy="100000" kx="0" ky="0" algn="bl" rotWithShape="0" blurRad="101600" dist="25400" dir="5400000">
+              <a:srgbClr val="9AA0B5">
+                <a:alpha val="18000"/>
+              </a:srgbClr>
+            </a:outerShdw>
+          </a:effectLst>
+        </p:spPr>
+      </p:sp>
+      <p:sp>
+        <p:nvSpPr>
+          <p:cNvPr id="23" name="Text 20"/>
+          <p:cNvSpPr/>
+          <p:nvPr/>
+        </p:nvSpPr>
+        <p:spPr>
+          <a:xfrm>
+            <a:off x="7680960" y="4480560"/>
+            <a:ext cx="3749040" cy="411480"/>
+          </a:xfrm>
+          <a:prstGeom prst="rect">
+            <a:avLst/>
+          </a:prstGeom>
+          <a:noFill/>
+          <a:ln/>
+        </p:spPr>
+        <p:txBody>
+          <a:bodyPr wrap="square" lIns="0" tIns="0" rIns="0" bIns="0" rtlCol="0" anchor="ctr"/>
+          <a:lstStyle/>
+          <a:p>
+            <a:pPr algn="l" indent="0" marL="0">
+              <a:buNone/>
+            </a:pPr>
+            <a:r>
+              <a:rPr lang="en-US" sz="1700" b="1" dirty="0">
+                <a:solidFill>
+                  <a:srgbClr val="166534"/>
+                </a:solidFill>
+                <a:latin typeface="Calibri" pitchFamily="34" charset="0"/>
+                <a:ea typeface="Calibri" pitchFamily="34" charset="-122"/>
+                <a:cs typeface="Calibri" pitchFamily="34" charset="-120"/>
+              </a:rPr>
+              <a:t>~75–85% gross margin</a:t>
+            </a:r>
+            <a:endParaRPr lang="en-US" sz="1700" dirty="0"/>
+          </a:p>
+        </p:txBody>
+      </p:sp>
+      <p:sp>
+        <p:nvSpPr>
+          <p:cNvPr id="24" name="Text 21"/>
+          <p:cNvSpPr/>
+          <p:nvPr/>
+        </p:nvSpPr>
+        <p:spPr>
+          <a:xfrm>
+            <a:off x="7680960" y="4919472"/>
+            <a:ext cx="3749040" cy="731520"/>
+          </a:xfrm>
+          <a:prstGeom prst="rect">
+            <a:avLst/>
+          </a:prstGeom>
+          <a:noFill/>
+          <a:ln/>
+        </p:spPr>
+        <p:txBody>
+          <a:bodyPr wrap="square" lIns="0" tIns="0" rIns="0" bIns="0" rtlCol="0" anchor="ctr"/>
+          <a:lstStyle/>
+          <a:p>
+            <a:pPr algn="l" indent="0" marL="0">
+              <a:buNone/>
+            </a:pPr>
+            <a:r>
+              <a:rPr lang="en-US" sz="1200" dirty="0">
+                <a:solidFill>
+                  <a:srgbClr val="1E6B3A"/>
+                </a:solidFill>
+                <a:latin typeface="Calibri" pitchFamily="34" charset="0"/>
+                <a:ea typeface="Calibri" pitchFamily="34" charset="-122"/>
+                <a:cs typeface="Calibri" pitchFamily="34" charset="-120"/>
+              </a:rPr>
+              <a:t>No AI COGS (customer's own account). The main cost is dedicated support, so the licence is near-pure margin.</a:t>
+            </a:r>
+            <a:endParaRPr lang="en-US" sz="1200" dirty="0"/>
+          </a:p>
+        </p:txBody>
+      </p:sp>
+      <p:sp>
+        <p:nvSpPr>
+          <p:cNvPr id="25" name="Text 22"/>
+          <p:cNvSpPr/>
+          <p:nvPr/>
+        </p:nvSpPr>
+        <p:spPr>
+          <a:xfrm>
+            <a:off x="548640" y="6035040"/>
+            <a:ext cx="11064240" cy="274320"/>
+          </a:xfrm>
+          <a:prstGeom prst="rect">
+            <a:avLst/>
+          </a:prstGeom>
+          <a:noFill/>
+          <a:ln/>
+        </p:spPr>
+        <p:txBody>
+          <a:bodyPr wrap="square" lIns="0" tIns="0" rIns="0" bIns="0" rtlCol="0" anchor="ctr"/>
+          <a:lstStyle/>
+          <a:p>
+            <a:pPr algn="l" indent="0" marL="0">
+              <a:buNone/>
+            </a:pPr>
+            <a:r>
+              <a:rPr lang="en-US" sz="1000" i="1" dirty="0">
+                <a:solidFill>
+                  <a:srgbClr val="6B7280"/>
+                </a:solidFill>
+                <a:latin typeface="Calibri" pitchFamily="34" charset="0"/>
+                <a:ea typeface="Calibri" pitchFamily="34" charset="-122"/>
+                <a:cs typeface="Calibri" pitchFamily="34" charset="-120"/>
+              </a:rPr>
+              <a:t>Floor and bands are internal targets for negotiation; the customer-facing plan stays "custom / contact sales". Partner share (10%) applies only if the deal comes through a channel partner.</a:t>
+            </a:r>
+            <a:endParaRPr lang="en-US" sz="1000" dirty="0"/>
+          </a:p>
+        </p:txBody>
+      </p:sp>
+      <p:sp>
+        <p:nvSpPr>
+          <p:cNvPr id="26" name="Text 23"/>
+          <p:cNvSpPr/>
+          <p:nvPr/>
+        </p:nvSpPr>
+        <p:spPr>
+          <a:xfrm>
+            <a:off x="548640" y="6455664"/>
+            <a:ext cx="7315200" cy="274320"/>
+          </a:xfrm>
+          <a:prstGeom prst="rect">
+            <a:avLst/>
+          </a:prstGeom>
+          <a:noFill/>
+          <a:ln/>
+        </p:spPr>
+        <p:txBody>
+          <a:bodyPr wrap="square" lIns="0" tIns="0" rIns="0" bIns="0" rtlCol="0" anchor="ctr"/>
+          <a:lstStyle/>
+          <a:p>
+            <a:pPr algn="l" indent="0" marL="0">
+              <a:buNone/>
+            </a:pPr>
+            <a:r>
+              <a:rPr lang="en-US" sz="900" dirty="0">
+                <a:solidFill>
+                  <a:srgbClr val="6B7280"/>
+                </a:solidFill>
+                <a:latin typeface="Calibri" pitchFamily="34" charset="0"/>
+                <a:ea typeface="Calibri" pitchFamily="34" charset="-122"/>
+                <a:cs typeface="Calibri" pitchFamily="34" charset="-120"/>
+              </a:rPr>
+              <a:t>Aster  ·  Pricing model</a:t>
+            </a:r>
+            <a:endParaRPr lang="en-US" sz="900" dirty="0"/>
+          </a:p>
+        </p:txBody>
+      </p:sp>
+      <p:sp>
+        <p:nvSpPr>
+          <p:cNvPr id="27" name="Text 24"/>
+          <p:cNvSpPr/>
+          <p:nvPr/>
+        </p:nvSpPr>
+        <p:spPr>
+          <a:xfrm>
+            <a:off x="11338560" y="6455664"/>
+            <a:ext cx="365760" cy="274320"/>
+          </a:xfrm>
+          <a:prstGeom prst="rect">
+            <a:avLst/>
+          </a:prstGeom>
+          <a:noFill/>
+          <a:ln/>
+        </p:spPr>
+        <p:txBody>
+          <a:bodyPr wrap="square" lIns="0" tIns="0" rIns="0" bIns="0" rtlCol="0" anchor="ctr"/>
+          <a:lstStyle/>
+          <a:p>
+            <a:pPr algn="r" indent="0" marL="0">
+              <a:buNone/>
+            </a:pPr>
+            <a:r>
+              <a:rPr lang="en-US" sz="900" dirty="0">
+                <a:solidFill>
+                  <a:srgbClr val="6B7280"/>
+                </a:solidFill>
+                <a:latin typeface="Calibri" pitchFamily="34" charset="0"/>
+                <a:ea typeface="Calibri" pitchFamily="34" charset="-122"/>
+                <a:cs typeface="Calibri" pitchFamily="34" charset="-120"/>
+              </a:rPr>
+              <a:t>12</a:t>
+            </a:r>
+            <a:endParaRPr lang="en-US" sz="900" dirty="0"/>
+          </a:p>
+        </p:txBody>
+      </p:sp>
+    </p:spTree>
+  </p:cSld>
+  <p:clrMapOvr>
+    <a:masterClrMapping/>
+  </p:clrMapOvr>
+</p:sld>
+</file>
+
+<file path=ppt/slides/slide13.xml><?xml version="1.0" encoding="utf-8"?>
+<p:sld xmlns:a="http://schemas.openxmlformats.org/drawingml/2006/main" xmlns:r="http://schemas.openxmlformats.org/officeDocument/2006/relationships" xmlns:p="http://schemas.openxmlformats.org/presentationml/2006/main">
+  <p:cSld name="Slide 13">
+    <p:bg>
+      <p:bgPr>
+        <a:solidFill>
+          <a:srgbClr val="FFFFFF"/>
+        </a:solidFill>
+      </p:bgPr>
+    </p:bg>
+    <p:spTree>
+      <p:nvGrpSpPr>
+        <p:cNvPr id="1" name=""/>
+        <p:cNvGrpSpPr/>
+        <p:nvPr/>
+      </p:nvGrpSpPr>
+      <p:grpSpPr>
+        <a:xfrm>
+          <a:off x="0" y="0"/>
+          <a:ext cx="0" cy="0"/>
+          <a:chOff x="0" y="0"/>
+          <a:chExt cx="0" cy="0"/>
+        </a:xfrm>
+      </p:grpSpPr>
+      <p:sp>
+        <p:nvSpPr>
+          <p:cNvPr id="2" name="Text 0"/>
+          <p:cNvSpPr/>
+          <p:nvPr/>
+        </p:nvSpPr>
+        <p:spPr>
+          <a:xfrm>
+            <a:off x="548640" y="502920"/>
+            <a:ext cx="8229600" cy="274320"/>
+          </a:xfrm>
+          <a:prstGeom prst="rect">
+            <a:avLst/>
+          </a:prstGeom>
+          <a:noFill/>
+          <a:ln/>
+        </p:spPr>
+        <p:txBody>
+          <a:bodyPr wrap="square" lIns="0" tIns="0" rIns="0" bIns="0" rtlCol="0" anchor="ctr"/>
+          <a:lstStyle/>
+          <a:p>
+            <a:pPr algn="l" indent="0" marL="0">
+              <a:buNone/>
+            </a:pPr>
+            <a:r>
+              <a:rPr lang="en-US" sz="1200" b="1" spc="200" kern="0" dirty="0">
+                <a:solidFill>
+                  <a:srgbClr val="0B2AE0"/>
+                </a:solidFill>
+                <a:latin typeface="Calibri" pitchFamily="34" charset="0"/>
+                <a:ea typeface="Calibri" pitchFamily="34" charset="-122"/>
+                <a:cs typeface="Calibri" pitchFamily="34" charset="-120"/>
+              </a:rPr>
               <a:t>REVENUE MODEL</a:t>
             </a:r>
             <a:endParaRPr lang="en-US" sz="1200" dirty="0"/>
@@ -8420,7 +10017,7 @@
       </p:sp>
       <p:graphicFrame>
         <p:nvGraphicFramePr>
-          <p:cNvPr id="13" name="Table 0"/>
+          <p:cNvPr id="14" name="Table 0"/>
           <p:cNvGraphicFramePr>
             <a:graphicFrameLocks noGrp="1"/>
           </p:cNvGraphicFramePr>
@@ -9617,7 +11214,7 @@
                           <a:ea typeface="Calibri" pitchFamily="34" charset="-122"/>
                           <a:cs typeface="Calibri" pitchFamily="34" charset="-120"/>
                         </a:rPr>
-                        <a:t>2</a:t>
+                        <a:t>1</a:t>
                       </a:r>
                       <a:endParaRPr lang="en-US" sz="1250" dirty="0">
                         <a:latin typeface="Calibri" charset="0"/>
@@ -9685,7 +11282,7 @@
                           <a:ea typeface="Calibri" pitchFamily="34" charset="-122"/>
                           <a:cs typeface="Calibri" pitchFamily="34" charset="-120"/>
                         </a:rPr>
-                        <a:t>6</a:t>
+                        <a:t>3</a:t>
                       </a:r>
                       <a:endParaRPr lang="en-US" sz="1250" dirty="0">
                         <a:latin typeface="Calibri" charset="0"/>
@@ -9753,7 +11350,7 @@
                           <a:ea typeface="Calibri" pitchFamily="34" charset="-122"/>
                           <a:cs typeface="Calibri" pitchFamily="34" charset="-120"/>
                         </a:rPr>
-                        <a:t>15</a:t>
+                        <a:t>8</a:t>
                       </a:r>
                       <a:endParaRPr lang="en-US" sz="1250" dirty="0">
                         <a:latin typeface="Calibri" charset="0"/>
@@ -9891,7 +11488,7 @@
                           <a:ea typeface="Calibri" pitchFamily="34" charset="-122"/>
                           <a:cs typeface="Calibri" pitchFamily="34" charset="-120"/>
                         </a:rPr>
-                        <a:t>RM49,900</a:t>
+                        <a:t>RM67,900</a:t>
                       </a:r>
                       <a:endParaRPr lang="en-US" sz="1250" dirty="0">
                         <a:latin typeface="Calibri" charset="0"/>
@@ -9959,7 +11556,7 @@
                           <a:ea typeface="Calibri" pitchFamily="34" charset="-122"/>
                           <a:cs typeface="Calibri" pitchFamily="34" charset="-120"/>
                         </a:rPr>
-                        <a:t>RM124,785</a:t>
+                        <a:t>RM178,785</a:t>
                       </a:r>
                       <a:endParaRPr lang="en-US" sz="1250" dirty="0">
                         <a:latin typeface="Calibri" charset="0"/>
@@ -10027,7 +11624,7 @@
                           <a:ea typeface="Calibri" pitchFamily="34" charset="-122"/>
                           <a:cs typeface="Calibri" pitchFamily="34" charset="-120"/>
                         </a:rPr>
-                        <a:t>RM288,540</a:t>
+                        <a:t>RM438,540</a:t>
                       </a:r>
                       <a:endParaRPr lang="en-US" sz="1250" dirty="0">
                         <a:latin typeface="Calibri" charset="0"/>
@@ -10097,7 +11694,7 @@
                           <a:ea typeface="Calibri" pitchFamily="34" charset="-122"/>
                           <a:cs typeface="Calibri" pitchFamily="34" charset="-120"/>
                         </a:rPr>
-                        <a:t>+ Top-up uplift (≈15%)</a:t>
+                        <a:t>+ Top-up uplift (≈15% of SMB)</a:t>
                       </a:r>
                       <a:endParaRPr lang="en-US" sz="1250" dirty="0">
                         <a:latin typeface="Calibri" charset="0"/>
@@ -10165,7 +11762,7 @@
                           <a:ea typeface="Calibri" pitchFamily="34" charset="-122"/>
                           <a:cs typeface="Calibri" pitchFamily="34" charset="-120"/>
                         </a:rPr>
-                        <a:t>RM7,485</a:t>
+                        <a:t>RM5,685</a:t>
                       </a:r>
                       <a:endParaRPr lang="en-US" sz="1250" dirty="0">
                         <a:latin typeface="Calibri" charset="0"/>
@@ -10233,7 +11830,7 @@
                           <a:ea typeface="Calibri" pitchFamily="34" charset="-122"/>
                           <a:cs typeface="Calibri" pitchFamily="34" charset="-120"/>
                         </a:rPr>
-                        <a:t>RM18,718</a:t>
+                        <a:t>RM13,318</a:t>
                       </a:r>
                       <a:endParaRPr lang="en-US" sz="1250" dirty="0">
                         <a:latin typeface="Calibri" charset="0"/>
@@ -10301,7 +11898,7 @@
                           <a:ea typeface="Calibri" pitchFamily="34" charset="-122"/>
                           <a:cs typeface="Calibri" pitchFamily="34" charset="-120"/>
                         </a:rPr>
-                        <a:t>RM43,281</a:t>
+                        <a:t>RM29,781</a:t>
                       </a:r>
                       <a:endParaRPr lang="en-US" sz="1250" dirty="0">
                         <a:latin typeface="Calibri" charset="0"/>
@@ -10439,7 +12036,7 @@
                           <a:ea typeface="Calibri" pitchFamily="34" charset="-122"/>
                           <a:cs typeface="Calibri" pitchFamily="34" charset="-120"/>
                         </a:rPr>
-                        <a:t>RM57,385</a:t>
+                        <a:t>RM73,585</a:t>
                       </a:r>
                       <a:endParaRPr lang="en-US" sz="1400" dirty="0">
                         <a:latin typeface="Calibri" charset="0"/>
@@ -10507,7 +12104,7 @@
                           <a:ea typeface="Calibri" pitchFamily="34" charset="-122"/>
                           <a:cs typeface="Calibri" pitchFamily="34" charset="-120"/>
                         </a:rPr>
-                        <a:t>RM143,503</a:t>
+                        <a:t>RM192,103</a:t>
                       </a:r>
                       <a:endParaRPr lang="en-US" sz="1400" dirty="0">
                         <a:latin typeface="Calibri" charset="0"/>
@@ -10575,7 +12172,7 @@
                           <a:ea typeface="Calibri" pitchFamily="34" charset="-122"/>
                           <a:cs typeface="Calibri" pitchFamily="34" charset="-120"/>
                         </a:rPr>
-                        <a:t>RM331,821</a:t>
+                        <a:t>RM468,321</a:t>
                       </a:r>
                       <a:endParaRPr lang="en-US" sz="1400" dirty="0">
                         <a:latin typeface="Calibri" charset="0"/>
@@ -10713,7 +12310,7 @@
                           <a:ea typeface="Calibri" pitchFamily="34" charset="-122"/>
                           <a:cs typeface="Calibri" pitchFamily="34" charset="-120"/>
                         </a:rPr>
-                        <a:t>RM689K</a:t>
+                        <a:t>RM883K</a:t>
                       </a:r>
                       <a:endParaRPr lang="en-US" sz="1400" dirty="0">
                         <a:latin typeface="Calibri" charset="0"/>
@@ -10781,7 +12378,7 @@
                           <a:ea typeface="Calibri" pitchFamily="34" charset="-122"/>
                           <a:cs typeface="Calibri" pitchFamily="34" charset="-120"/>
                         </a:rPr>
-                        <a:t>RM1.72M</a:t>
+                        <a:t>RM2.31M</a:t>
                       </a:r>
                       <a:endParaRPr lang="en-US" sz="1400" dirty="0">
                         <a:latin typeface="Calibri" charset="0"/>
@@ -10849,7 +12446,7 @@
                           <a:ea typeface="Calibri" pitchFamily="34" charset="-122"/>
                           <a:cs typeface="Calibri" pitchFamily="34" charset="-120"/>
                         </a:rPr>
-                        <a:t>RM3.98M</a:t>
+                        <a:t>RM5.62M</a:t>
                       </a:r>
                       <a:endParaRPr lang="en-US" sz="1400" dirty="0">
                         <a:latin typeface="Calibri" charset="0"/>
@@ -11011,7 +12608,7 @@
                 <a:ea typeface="Calibri" pitchFamily="34" charset="-122"/>
                 <a:cs typeface="Calibri" pitchFamily="34" charset="-120"/>
               </a:rPr>
-              <a:t>RM1.72M</a:t>
+              <a:t>RM2.31M</a:t>
             </a:r>
             <a:endParaRPr lang="en-US" sz="4000" dirty="0"/>
           </a:p>
@@ -11112,7 +12709,7 @@
                 <a:ea typeface="Calibri" pitchFamily="34" charset="-122"/>
                 <a:cs typeface="Calibri" pitchFamily="34" charset="-120"/>
               </a:rPr>
-              <a:t>221 </a:t>
+              <a:t>218 </a:t>
             </a:r>
             <a:pPr algn="l" indent="0" marL="0">
               <a:buNone/>
@@ -11165,7 +12762,7 @@
                 <a:ea typeface="Calibri" pitchFamily="34" charset="-122"/>
                 <a:cs typeface="Calibri" pitchFamily="34" charset="-120"/>
               </a:rPr>
-              <a:t>RM649 </a:t>
+              <a:t>RM881 </a:t>
             </a:r>
             <a:pPr algn="l" indent="0" marL="0">
               <a:buNone/>
@@ -11218,7 +12815,7 @@
                 <a:ea typeface="Calibri" pitchFamily="34" charset="-122"/>
                 <a:cs typeface="Calibri" pitchFamily="34" charset="-120"/>
               </a:rPr>
-              <a:t>~64% </a:t>
+              <a:t>~68% </a:t>
             </a:r>
             <a:pPr algn="l" indent="0" marL="0">
               <a:buNone/>
@@ -11310,7 +12907,7 @@
                 <a:ea typeface="Calibri" pitchFamily="34" charset="-122"/>
                 <a:cs typeface="Calibri" pitchFamily="34" charset="-120"/>
               </a:rPr>
-              <a:t>Illustrative. Enterprise is a custom plan with no list price; modelled here at an assumed ~RM6,000/mo for the scenario only. ARR is gross revenue; the 10% partner share is captured in the margins on slide 10. Adjust mix, Enterprise deal size, and top-up rate as pricing is finalised.</a:t>
+              <a:t>Illustrative. Enterprise modelled at the RM30k/mo floor (slide 12); Enterprise buys no credit top-ups (own AI), so uplift is 15% of SMB subscription only. ARR is gross; the 10% partner share sits in the plan margins on slide 10.</a:t>
             </a:r>
             <a:endParaRPr lang="en-US" sz="1000" dirty="0"/>
           </a:p>
@@ -11388,7 +12985,7 @@
                 <a:ea typeface="Calibri" pitchFamily="34" charset="-122"/>
                 <a:cs typeface="Calibri" pitchFamily="34" charset="-120"/>
               </a:rPr>
-              <a:t>12</a:t>
+              <a:t>13</a:t>
             </a:r>
             <a:endParaRPr lang="en-US" sz="900" dirty="0"/>
           </a:p>
@@ -11402,9 +12999,9 @@
 </p:sld>
 </file>
 
-<file path=ppt/slides/slide13.xml><?xml version="1.0" encoding="utf-8"?>
+<file path=ppt/slides/slide14.xml><?xml version="1.0" encoding="utf-8"?>
 <p:sld xmlns:a="http://schemas.openxmlformats.org/drawingml/2006/main" xmlns:r="http://schemas.openxmlformats.org/officeDocument/2006/relationships" xmlns:p="http://schemas.openxmlformats.org/presentationml/2006/main">
-  <p:cSld name="Slide 13">
+  <p:cSld name="Slide 14">
     <p:bg>
       <p:bgPr>
         <a:solidFill>
@@ -11676,7 +13273,7 @@
                 <a:ea typeface="Calibri" pitchFamily="34" charset="-122"/>
                 <a:cs typeface="Calibri" pitchFamily="34" charset="-120"/>
               </a:rPr>
-              <a:t>Set the Enterprise floor and what the premium buys (SSO, audit, white-label).</a:t>
+              <a:t>Confirm the Enterprise floor (RM30k/mo) and volume bands on slide 12.</a:t>
             </a:r>
             <a:endParaRPr lang="en-US" sz="1250" dirty="0"/>
           </a:p>
@@ -12110,7 +13707,7 @@
                 <a:ea typeface="Calibri" pitchFamily="34" charset="-122"/>
                 <a:cs typeface="Calibri" pitchFamily="34" charset="-120"/>
               </a:rPr>
-              <a:t>13</a:t>
+              <a:t>14</a:t>
             </a:r>
             <a:endParaRPr lang="en-US" sz="900" dirty="0"/>
           </a:p>
@@ -12124,9 +13721,9 @@
 </p:sld>
 </file>
 
-<file path=ppt/slides/slide14.xml><?xml version="1.0" encoding="utf-8"?>
+<file path=ppt/slides/slide15.xml><?xml version="1.0" encoding="utf-8"?>
 <p:sld xmlns:a="http://schemas.openxmlformats.org/drawingml/2006/main" xmlns:r="http://schemas.openxmlformats.org/officeDocument/2006/relationships" xmlns:p="http://schemas.openxmlformats.org/presentationml/2006/main">
-  <p:cSld name="Slide 14">
+  <p:cSld name="Slide 15">
     <p:bg>
       <p:bgPr>
         <a:solidFill>
@@ -21083,7 +22680,7 @@
                 <a:ea typeface="Calibri" pitchFamily="34" charset="-122"/>
                 <a:cs typeface="Calibri" pitchFamily="34" charset="-120"/>
               </a:rPr>
-              <a:t>Job drafts are sold only as credits on every tier, including Enterprise, so drafting is pure add-on revenue.</a:t>
+              <a:t>Job drafts are sold only as credits, never bundled, so drafting is pure add-on revenue. Enterprise runs AI on its own account.</a:t>
             </a:r>
             <a:endParaRPr lang="en-US" sz="1000" dirty="0"/>
           </a:p>
@@ -23986,8 +25583,8 @@
         </p:nvSpPr>
         <p:spPr>
           <a:xfrm>
-            <a:off x="6858000" y="2331720"/>
-            <a:ext cx="3200400" cy="320040"/>
+            <a:off x="6858000" y="2249424"/>
+            <a:ext cx="1828800" cy="292608"/>
           </a:xfrm>
           <a:prstGeom prst="rect">
             <a:avLst/>
@@ -24025,8 +25622,8 @@
         </p:nvSpPr>
         <p:spPr>
           <a:xfrm>
-            <a:off x="10058400" y="2331720"/>
-            <a:ext cx="1371600" cy="320040"/>
+            <a:off x="8686800" y="2249424"/>
+            <a:ext cx="2743200" cy="292608"/>
           </a:xfrm>
           <a:prstGeom prst="rect">
             <a:avLst/>
@@ -24064,8 +25661,8 @@
         </p:nvSpPr>
         <p:spPr>
           <a:xfrm>
-            <a:off x="6858000" y="2715768"/>
-            <a:ext cx="3200400" cy="320040"/>
+            <a:off x="6858000" y="2587752"/>
+            <a:ext cx="1828800" cy="292608"/>
           </a:xfrm>
           <a:prstGeom prst="rect">
             <a:avLst/>
@@ -24103,8 +25700,8 @@
         </p:nvSpPr>
         <p:spPr>
           <a:xfrm>
-            <a:off x="10058400" y="2715768"/>
-            <a:ext cx="1371600" cy="320040"/>
+            <a:off x="8686800" y="2587752"/>
+            <a:ext cx="2743200" cy="292608"/>
           </a:xfrm>
           <a:prstGeom prst="rect">
             <a:avLst/>
@@ -24142,8 +25739,8 @@
         </p:nvSpPr>
         <p:spPr>
           <a:xfrm>
-            <a:off x="6858000" y="3099816"/>
-            <a:ext cx="3200400" cy="320040"/>
+            <a:off x="6858000" y="2926080"/>
+            <a:ext cx="1828800" cy="292608"/>
           </a:xfrm>
           <a:prstGeom prst="rect">
             <a:avLst/>
@@ -24167,7 +25764,7 @@
                 <a:ea typeface="Calibri" pitchFamily="34" charset="-122"/>
                 <a:cs typeface="Calibri" pitchFamily="34" charset="-120"/>
               </a:rPr>
-              <a:t>Elite / Enterprise</a:t>
+              <a:t>Elite</a:t>
             </a:r>
             <a:endParaRPr lang="en-US" sz="1300" dirty="0"/>
           </a:p>
@@ -24181,8 +25778,8 @@
         </p:nvSpPr>
         <p:spPr>
           <a:xfrm>
-            <a:off x="10058400" y="3099816"/>
-            <a:ext cx="1371600" cy="320040"/>
+            <a:off x="8686800" y="2926080"/>
+            <a:ext cx="2743200" cy="292608"/>
           </a:xfrm>
           <a:prstGeom prst="rect">
             <a:avLst/>
@@ -24214,7 +25811,85 @@
       </p:sp>
       <p:sp>
         <p:nvSpPr>
-          <p:cNvPr id="16" name="Shape 13"/>
+          <p:cNvPr id="16" name="Text 13"/>
+          <p:cNvSpPr/>
+          <p:nvPr/>
+        </p:nvSpPr>
+        <p:spPr>
+          <a:xfrm>
+            <a:off x="6858000" y="3264408"/>
+            <a:ext cx="1828800" cy="292608"/>
+          </a:xfrm>
+          <a:prstGeom prst="rect">
+            <a:avLst/>
+          </a:prstGeom>
+          <a:noFill/>
+          <a:ln/>
+        </p:spPr>
+        <p:txBody>
+          <a:bodyPr wrap="square" lIns="0" tIns="0" rIns="0" bIns="0" rtlCol="0" anchor="ctr"/>
+          <a:lstStyle/>
+          <a:p>
+            <a:pPr algn="l" indent="0" marL="0">
+              <a:buNone/>
+            </a:pPr>
+            <a:r>
+              <a:rPr lang="en-US" sz="1300" dirty="0">
+                <a:solidFill>
+                  <a:srgbClr val="4A5568"/>
+                </a:solidFill>
+                <a:latin typeface="Calibri" pitchFamily="34" charset="0"/>
+                <a:ea typeface="Calibri" pitchFamily="34" charset="-122"/>
+                <a:cs typeface="Calibri" pitchFamily="34" charset="-120"/>
+              </a:rPr>
+              <a:t>Enterprise</a:t>
+            </a:r>
+            <a:endParaRPr lang="en-US" sz="1300" dirty="0"/>
+          </a:p>
+        </p:txBody>
+      </p:sp>
+      <p:sp>
+        <p:nvSpPr>
+          <p:cNvPr id="17" name="Text 14"/>
+          <p:cNvSpPr/>
+          <p:nvPr/>
+        </p:nvSpPr>
+        <p:spPr>
+          <a:xfrm>
+            <a:off x="8686800" y="3264408"/>
+            <a:ext cx="2743200" cy="292608"/>
+          </a:xfrm>
+          <a:prstGeom prst="rect">
+            <a:avLst/>
+          </a:prstGeom>
+          <a:noFill/>
+          <a:ln/>
+        </p:spPr>
+        <p:txBody>
+          <a:bodyPr wrap="square" lIns="0" tIns="0" rIns="0" bIns="0" rtlCol="0" anchor="ctr"/>
+          <a:lstStyle/>
+          <a:p>
+            <a:pPr algn="r" indent="0" marL="0">
+              <a:buNone/>
+            </a:pPr>
+            <a:r>
+              <a:rPr lang="en-US" sz="1200" b="1" dirty="0">
+                <a:solidFill>
+                  <a:srgbClr val="0B2AE0"/>
+                </a:solidFill>
+                <a:latin typeface="Calibri" pitchFamily="34" charset="0"/>
+                <a:ea typeface="Calibri" pitchFamily="34" charset="-122"/>
+                <a:cs typeface="Calibri" pitchFamily="34" charset="-120"/>
+              </a:rPr>
+              <a:t>own AI account</a:t>
+            </a:r>
+            <a:endParaRPr lang="en-US" sz="1200" dirty="0"/>
+          </a:p>
+        </p:txBody>
+      </p:sp>
+      <p:sp>
+        <p:nvSpPr>
+          <p:cNvPr id="18" name="Shape 15"/>
           <p:cNvSpPr/>
           <p:nvPr/>
         </p:nvSpPr>
@@ -24248,7 +25923,7 @@
       </p:sp>
       <p:sp>
         <p:nvSpPr>
-          <p:cNvPr id="17" name="Text 14"/>
+          <p:cNvPr id="19" name="Text 16"/>
           <p:cNvSpPr/>
           <p:nvPr/>
         </p:nvSpPr>
@@ -24287,7 +25962,7 @@
       </p:sp>
       <p:sp>
         <p:nvSpPr>
-          <p:cNvPr id="18" name="Text 15"/>
+          <p:cNvPr id="20" name="Text 17"/>
           <p:cNvSpPr/>
           <p:nvPr/>
         </p:nvSpPr>
@@ -24326,7 +26001,7 @@
       </p:sp>
       <p:sp>
         <p:nvSpPr>
-          <p:cNvPr id="19" name="Text 16"/>
+          <p:cNvPr id="21" name="Text 18"/>
           <p:cNvSpPr/>
           <p:nvPr/>
         </p:nvSpPr>
@@ -24365,7 +26040,7 @@
       </p:sp>
       <p:sp>
         <p:nvSpPr>
-          <p:cNvPr id="20" name="Text 17"/>
+          <p:cNvPr id="22" name="Text 19"/>
           <p:cNvSpPr/>
           <p:nvPr/>
         </p:nvSpPr>
@@ -24404,7 +26079,7 @@
       </p:sp>
       <p:sp>
         <p:nvSpPr>
-          <p:cNvPr id="21" name="Text 18"/>
+          <p:cNvPr id="23" name="Text 20"/>
           <p:cNvSpPr/>
           <p:nvPr/>
         </p:nvSpPr>
@@ -24443,7 +26118,7 @@
       </p:sp>
       <p:sp>
         <p:nvSpPr>
-          <p:cNvPr id="22" name="Text 19"/>
+          <p:cNvPr id="24" name="Text 21"/>
           <p:cNvSpPr/>
           <p:nvPr/>
         </p:nvSpPr>
@@ -24482,7 +26157,7 @@
       </p:sp>
       <p:sp>
         <p:nvSpPr>
-          <p:cNvPr id="23" name="Text 20"/>
+          <p:cNvPr id="25" name="Text 22"/>
           <p:cNvSpPr/>
           <p:nvPr/>
         </p:nvSpPr>
@@ -24521,14 +26196,14 @@
       </p:sp>
       <p:sp>
         <p:nvSpPr>
-          <p:cNvPr id="24" name="Text 21"/>
+          <p:cNvPr id="26" name="Text 23"/>
           <p:cNvSpPr/>
           <p:nvPr/>
         </p:nvSpPr>
         <p:spPr>
           <a:xfrm>
-            <a:off x="548640" y="6035040"/>
-            <a:ext cx="11064240" cy="274320"/>
+            <a:off x="548640" y="5989320"/>
+            <a:ext cx="11064240" cy="365760"/>
           </a:xfrm>
           <a:prstGeom prst="rect">
             <a:avLst/>
@@ -24544,7 +26219,7 @@
               <a:buNone/>
             </a:pPr>
             <a:r>
-              <a:rPr lang="en-US" sz="1000" i="1" dirty="0">
+              <a:rPr lang="en-US" sz="950" i="1" dirty="0">
                 <a:solidFill>
                   <a:srgbClr val="6B7280"/>
                 </a:solidFill>
@@ -24552,15 +26227,15 @@
                 <a:ea typeface="Calibri" pitchFamily="34" charset="-122"/>
                 <a:cs typeface="Calibri" pitchFamily="34" charset="-120"/>
               </a:rPr>
-              <a:t>Prices are stored once as USD cents and shown here in MYR. Minimum top-up per credit is above; each top-up is one Stripe charge, folded into the credit margins on slide 11.</a:t>
+              <a:t>Prices stored as USD cents, shown in MYR. Enterprise connects its own AI account (billed directly by Anthropic), so it takes no credit discount. Min top-up per credit is above; each top-up is one Stripe charge, folded into slide 11's margins.</a:t>
             </a:r>
-            <a:endParaRPr lang="en-US" sz="1000" dirty="0"/>
+            <a:endParaRPr lang="en-US" sz="950" dirty="0"/>
           </a:p>
         </p:txBody>
       </p:sp>
       <p:sp>
         <p:nvSpPr>
-          <p:cNvPr id="25" name="Text 22"/>
+          <p:cNvPr id="27" name="Text 24"/>
           <p:cNvSpPr/>
           <p:nvPr/>
         </p:nvSpPr>
@@ -24599,7 +26274,7 @@
       </p:sp>
       <p:sp>
         <p:nvSpPr>
-          <p:cNvPr id="26" name="Text 23"/>
+          <p:cNvPr id="28" name="Text 25"/>
           <p:cNvSpPr/>
           <p:nvPr/>
         </p:nvSpPr>
@@ -28398,7 +30073,7 @@
                           <a:ea typeface="Calibri" pitchFamily="34" charset="-122"/>
                           <a:cs typeface="Calibri" pitchFamily="34" charset="-120"/>
                         </a:rPr>
-                        <a:t>Per action, from tokens</a:t>
+                        <a:t>Per action · Enterprise: own AI</a:t>
                       </a:r>
                       <a:endParaRPr lang="en-US" sz="1200" dirty="0">
                         <a:latin typeface="Calibri" charset="0"/>

</xml_diff>